<commit_message>
Update evidence deck with validated results + fresh held-out predictions
Deck rebuilt (UPI-free, lifecycle-aware): routing/failure/ETA examples reworked
(IMPS 5L cap guard replaces UPI 1L; caps/floors framed as deterministic guards);
in-flight slide now cites the measured streaming result (0.84->0.87) and the
recall/return legs; capability chips add charges + recall/return risk; status
slide carries the validated numbers (n=4,000: rail 0.55 probe vs 0.64 tree, ETA
199 vs 392; at initiation: ETA 186 vs 232, charges 97 vs 185) plus the cold-start
caveat; predictions slide shows 5 rows of the fresh held-out 100 (known accounts,
new payments: rail 0.59 / 0.64 clean, risk 0.53); close updates to 183 tests.

Fresh CSVs regenerated from the retrained UPI-free model (gitignored):
data/test_input_100.csv / data/test_predictions_100.csv. Gap-doc review checklist
closes the full-run item with the validated numbers + cold-start finding.

Co-Authored-By: Claude Opus 4.8 <noreply@anthropic.com>
</commit_message>
<xml_diff>
--- a/docs/txn_repr_evidence.pptx
+++ b/docs/txn_repr_evidence.pptx
@@ -2206,7 +2206,7 @@
                 <a:ea typeface="Calibri" pitchFamily="34" charset="-122"/>
                 <a:cs typeface="Calibri" pitchFamily="34" charset="-120"/>
               </a:rPr>
-              <a:t>One reusable model across RTGS · NEFT · IMPS · UPI · SWIFT</a:t>
+              <a:t>One reusable model across RTGS · NEFT · IMPS · SWIFT — reading the full ISO 20022 lifecycle (pain.001 → pacs.008 → camt.054)</a:t>
             </a:r>
             <a:endParaRPr lang="en-US" sz="1200" dirty="0"/>
           </a:p>
@@ -2345,13 +2345,13 @@
             <a:tbl>
               <a:tblPr/>
               <a:tblGrid>
-                <a:gridCol w="1737360"/>
-                <a:gridCol w="1143000"/>
-                <a:gridCol w="1234440"/>
-                <a:gridCol w="2057400"/>
-                <a:gridCol w="2084832"/>
-                <a:gridCol w="822960"/>
-                <a:gridCol w="2194560"/>
+                <a:gridCol w="1600200"/>
+                <a:gridCol w="1097280"/>
+                <a:gridCol w="1188720"/>
+                <a:gridCol w="1965960"/>
+                <a:gridCol w="1965960"/>
+                <a:gridCol w="1600200"/>
+                <a:gridCol w="1856232"/>
               </a:tblGrid>
               <a:tr h="502920">
                 <a:tc>
@@ -2849,7 +2849,7 @@
                           <a:ea typeface="Calibri" pitchFamily="34" charset="-122"/>
                           <a:cs typeface="Calibri" pitchFamily="34" charset="-120"/>
                         </a:rPr>
-                        <a:t>28,290 INR</a:t>
+                        <a:t>833 INR</a:t>
                       </a:r>
                       <a:endParaRPr lang="en-US" sz="1200" dirty="0">
                         <a:latin typeface="Calibri" charset="0"/>
@@ -2979,7 +2979,7 @@
                           <a:ea typeface="Calibri" pitchFamily="34" charset="-122"/>
                           <a:cs typeface="Calibri" pitchFamily="34" charset="-120"/>
                         </a:rPr>
-                        <a:t>UPI</a:t>
+                        <a:t>IMPS</a:t>
                       </a:r>
                       <a:endParaRPr lang="en-US" sz="1200" dirty="0">
                         <a:latin typeface="Calibri" charset="0"/>
@@ -3044,7 +3044,464 @@
                           <a:ea typeface="Calibri" pitchFamily="34" charset="-122"/>
                           <a:cs typeface="Calibri" pitchFamily="34" charset="-120"/>
                         </a:rPr>
-                        <a:t>UPI (1.00)</a:t>
+                        <a:t>IMPS (0.60)</a:t>
+                      </a:r>
+                      <a:endParaRPr lang="en-US" sz="1200" dirty="0">
+                        <a:latin typeface="Calibri" charset="0"/>
+                        <a:ea typeface="Calibri" charset="0"/>
+                        <a:cs typeface="Calibri" charset="0"/>
+                      </a:endParaRPr>
+                    </a:p>
+                  </a:txBody>
+                  <a:tcPr marL="91440" marR="91440" marT="45720" marB="45720" anchor="ctr">
+                    <a:lnL w="12700" cap="flat" cmpd="sng" algn="ctr">
+                      <a:solidFill>
+                        <a:srgbClr val="D8DEEC"/>
+                      </a:solidFill>
+                      <a:prstDash val="solid"/>
+                      <a:round/>
+                      <a:headEnd type="none" w="med" len="med"/>
+                      <a:tailEnd type="none" w="med" len="med"/>
+                    </a:lnL>
+                    <a:lnR w="12700" cap="flat" cmpd="sng" algn="ctr">
+                      <a:solidFill>
+                        <a:srgbClr val="D8DEEC"/>
+                      </a:solidFill>
+                      <a:prstDash val="solid"/>
+                      <a:round/>
+                      <a:headEnd type="none" w="med" len="med"/>
+                      <a:tailEnd type="none" w="med" len="med"/>
+                    </a:lnR>
+                    <a:lnT w="12700" cap="flat" cmpd="sng" algn="ctr">
+                      <a:solidFill>
+                        <a:srgbClr val="D8DEEC"/>
+                      </a:solidFill>
+                      <a:prstDash val="solid"/>
+                      <a:round/>
+                      <a:headEnd type="none" w="med" len="med"/>
+                      <a:tailEnd type="none" w="med" len="med"/>
+                    </a:lnT>
+                    <a:lnB w="12700" cap="flat" cmpd="sng" algn="ctr">
+                      <a:solidFill>
+                        <a:srgbClr val="D8DEEC"/>
+                      </a:solidFill>
+                      <a:prstDash val="solid"/>
+                      <a:round/>
+                      <a:headEnd type="none" w="med" len="med"/>
+                      <a:tailEnd type="none" w="med" len="med"/>
+                    </a:lnB>
+                  </a:tcPr>
+                </a:tc>
+                <a:tc>
+                  <a:txBody>
+                    <a:bodyPr/>
+                    <a:lstStyle/>
+                    <a:p>
+                      <a:pPr indent="0" marL="0">
+                        <a:buNone/>
+                      </a:pPr>
+                      <a:r>
+                        <a:rPr lang="en-US" sz="1200" dirty="0">
+                          <a:solidFill>
+                            <a:srgbClr val="1A1A2E"/>
+                          </a:solidFill>
+                          <a:latin typeface="Calibri" pitchFamily="34" charset="0"/>
+                          <a:ea typeface="Calibri" pitchFamily="34" charset="-122"/>
+                          <a:cs typeface="Calibri" pitchFamily="34" charset="-120"/>
+                        </a:rPr>
+                        <a:t>STP ✓</a:t>
+                      </a:r>
+                      <a:endParaRPr lang="en-US" sz="1200" dirty="0">
+                        <a:latin typeface="Calibri" charset="0"/>
+                        <a:ea typeface="Calibri" charset="0"/>
+                        <a:cs typeface="Calibri" charset="0"/>
+                      </a:endParaRPr>
+                    </a:p>
+                  </a:txBody>
+                  <a:tcPr marL="91440" marR="91440" marT="45720" marB="45720" anchor="ctr">
+                    <a:lnL w="12700" cap="flat" cmpd="sng" algn="ctr">
+                      <a:solidFill>
+                        <a:srgbClr val="D8DEEC"/>
+                      </a:solidFill>
+                      <a:prstDash val="solid"/>
+                      <a:round/>
+                      <a:headEnd type="none" w="med" len="med"/>
+                      <a:tailEnd type="none" w="med" len="med"/>
+                    </a:lnL>
+                    <a:lnR w="12700" cap="flat" cmpd="sng" algn="ctr">
+                      <a:solidFill>
+                        <a:srgbClr val="D8DEEC"/>
+                      </a:solidFill>
+                      <a:prstDash val="solid"/>
+                      <a:round/>
+                      <a:headEnd type="none" w="med" len="med"/>
+                      <a:tailEnd type="none" w="med" len="med"/>
+                    </a:lnR>
+                    <a:lnT w="12700" cap="flat" cmpd="sng" algn="ctr">
+                      <a:solidFill>
+                        <a:srgbClr val="D8DEEC"/>
+                      </a:solidFill>
+                      <a:prstDash val="solid"/>
+                      <a:round/>
+                      <a:headEnd type="none" w="med" len="med"/>
+                      <a:tailEnd type="none" w="med" len="med"/>
+                    </a:lnT>
+                    <a:lnB w="12700" cap="flat" cmpd="sng" algn="ctr">
+                      <a:solidFill>
+                        <a:srgbClr val="D8DEEC"/>
+                      </a:solidFill>
+                      <a:prstDash val="solid"/>
+                      <a:round/>
+                      <a:headEnd type="none" w="med" len="med"/>
+                      <a:tailEnd type="none" w="med" len="med"/>
+                    </a:lnB>
+                  </a:tcPr>
+                </a:tc>
+                <a:tc>
+                  <a:txBody>
+                    <a:bodyPr/>
+                    <a:lstStyle/>
+                    <a:p>
+                      <a:pPr indent="0" marL="0">
+                        <a:buNone/>
+                      </a:pPr>
+                      <a:r>
+                        <a:rPr lang="en-US" sz="1200" dirty="0">
+                          <a:solidFill>
+                            <a:srgbClr val="1A1A2E"/>
+                          </a:solidFill>
+                          <a:latin typeface="Calibri" pitchFamily="34" charset="0"/>
+                          <a:ea typeface="Calibri" pitchFamily="34" charset="-122"/>
+                          <a:cs typeface="Calibri" pitchFamily="34" charset="-120"/>
+                        </a:rPr>
+                        <a:t>5 min</a:t>
+                      </a:r>
+                      <a:endParaRPr lang="en-US" sz="1200" dirty="0">
+                        <a:latin typeface="Calibri" charset="0"/>
+                        <a:ea typeface="Calibri" charset="0"/>
+                        <a:cs typeface="Calibri" charset="0"/>
+                      </a:endParaRPr>
+                    </a:p>
+                  </a:txBody>
+                  <a:tcPr marL="91440" marR="91440" marT="45720" marB="45720" anchor="ctr">
+                    <a:lnL w="12700" cap="flat" cmpd="sng" algn="ctr">
+                      <a:solidFill>
+                        <a:srgbClr val="D8DEEC"/>
+                      </a:solidFill>
+                      <a:prstDash val="solid"/>
+                      <a:round/>
+                      <a:headEnd type="none" w="med" len="med"/>
+                      <a:tailEnd type="none" w="med" len="med"/>
+                    </a:lnL>
+                    <a:lnR w="12700" cap="flat" cmpd="sng" algn="ctr">
+                      <a:solidFill>
+                        <a:srgbClr val="D8DEEC"/>
+                      </a:solidFill>
+                      <a:prstDash val="solid"/>
+                      <a:round/>
+                      <a:headEnd type="none" w="med" len="med"/>
+                      <a:tailEnd type="none" w="med" len="med"/>
+                    </a:lnR>
+                    <a:lnT w="12700" cap="flat" cmpd="sng" algn="ctr">
+                      <a:solidFill>
+                        <a:srgbClr val="D8DEEC"/>
+                      </a:solidFill>
+                      <a:prstDash val="solid"/>
+                      <a:round/>
+                      <a:headEnd type="none" w="med" len="med"/>
+                      <a:tailEnd type="none" w="med" len="med"/>
+                    </a:lnT>
+                    <a:lnB w="12700" cap="flat" cmpd="sng" algn="ctr">
+                      <a:solidFill>
+                        <a:srgbClr val="D8DEEC"/>
+                      </a:solidFill>
+                      <a:prstDash val="solid"/>
+                      <a:round/>
+                      <a:headEnd type="none" w="med" len="med"/>
+                      <a:tailEnd type="none" w="med" len="med"/>
+                    </a:lnB>
+                  </a:tcPr>
+                </a:tc>
+                <a:tc>
+                  <a:txBody>
+                    <a:bodyPr/>
+                    <a:lstStyle/>
+                    <a:p>
+                      <a:pPr indent="0" marL="0">
+                        <a:buNone/>
+                      </a:pPr>
+                      <a:r>
+                        <a:rPr lang="en-US" sz="1200" dirty="0">
+                          <a:solidFill>
+                            <a:srgbClr val="1A1A2E"/>
+                          </a:solidFill>
+                          <a:latin typeface="Calibri" pitchFamily="34" charset="0"/>
+                          <a:ea typeface="Calibri" pitchFamily="34" charset="-122"/>
+                          <a:cs typeface="Calibri" pitchFamily="34" charset="-120"/>
+                        </a:rPr>
+                        <a:t>sla_breach 0.70</a:t>
+                      </a:r>
+                      <a:endParaRPr lang="en-US" sz="1200" dirty="0">
+                        <a:latin typeface="Calibri" charset="0"/>
+                        <a:ea typeface="Calibri" charset="0"/>
+                        <a:cs typeface="Calibri" charset="0"/>
+                      </a:endParaRPr>
+                    </a:p>
+                  </a:txBody>
+                  <a:tcPr marL="91440" marR="91440" marT="45720" marB="45720" anchor="ctr">
+                    <a:lnL w="12700" cap="flat" cmpd="sng" algn="ctr">
+                      <a:solidFill>
+                        <a:srgbClr val="D8DEEC"/>
+                      </a:solidFill>
+                      <a:prstDash val="solid"/>
+                      <a:round/>
+                      <a:headEnd type="none" w="med" len="med"/>
+                      <a:tailEnd type="none" w="med" len="med"/>
+                    </a:lnL>
+                    <a:lnR w="12700" cap="flat" cmpd="sng" algn="ctr">
+                      <a:solidFill>
+                        <a:srgbClr val="D8DEEC"/>
+                      </a:solidFill>
+                      <a:prstDash val="solid"/>
+                      <a:round/>
+                      <a:headEnd type="none" w="med" len="med"/>
+                      <a:tailEnd type="none" w="med" len="med"/>
+                    </a:lnR>
+                    <a:lnT w="12700" cap="flat" cmpd="sng" algn="ctr">
+                      <a:solidFill>
+                        <a:srgbClr val="D8DEEC"/>
+                      </a:solidFill>
+                      <a:prstDash val="solid"/>
+                      <a:round/>
+                      <a:headEnd type="none" w="med" len="med"/>
+                      <a:tailEnd type="none" w="med" len="med"/>
+                    </a:lnT>
+                    <a:lnB w="12700" cap="flat" cmpd="sng" algn="ctr">
+                      <a:solidFill>
+                        <a:srgbClr val="D8DEEC"/>
+                      </a:solidFill>
+                      <a:prstDash val="solid"/>
+                      <a:round/>
+                      <a:headEnd type="none" w="med" len="med"/>
+                      <a:tailEnd type="none" w="med" len="med"/>
+                    </a:lnB>
+                  </a:tcPr>
+                </a:tc>
+              </a:tr>
+              <a:tr h="502920">
+                <a:tc>
+                  <a:txBody>
+                    <a:bodyPr/>
+                    <a:lstStyle/>
+                    <a:p>
+                      <a:pPr indent="0" marL="0">
+                        <a:buNone/>
+                      </a:pPr>
+                      <a:r>
+                        <a:rPr lang="en-US" sz="1200" dirty="0">
+                          <a:solidFill>
+                            <a:srgbClr val="1A1A2E"/>
+                          </a:solidFill>
+                          <a:latin typeface="Calibri" pitchFamily="34" charset="0"/>
+                          <a:ea typeface="Calibri" pitchFamily="34" charset="-122"/>
+                          <a:cs typeface="Calibri" pitchFamily="34" charset="-120"/>
+                        </a:rPr>
+                        <a:t>250,799 INR</a:t>
+                      </a:r>
+                      <a:endParaRPr lang="en-US" sz="1200" dirty="0">
+                        <a:latin typeface="Calibri" charset="0"/>
+                        <a:ea typeface="Calibri" charset="0"/>
+                        <a:cs typeface="Calibri" charset="0"/>
+                      </a:endParaRPr>
+                    </a:p>
+                  </a:txBody>
+                  <a:tcPr marL="91440" marR="91440" marT="45720" marB="45720" anchor="ctr">
+                    <a:lnL w="12700" cap="flat" cmpd="sng" algn="ctr">
+                      <a:solidFill>
+                        <a:srgbClr val="D8DEEC"/>
+                      </a:solidFill>
+                      <a:prstDash val="solid"/>
+                      <a:round/>
+                      <a:headEnd type="none" w="med" len="med"/>
+                      <a:tailEnd type="none" w="med" len="med"/>
+                    </a:lnL>
+                    <a:lnR w="12700" cap="flat" cmpd="sng" algn="ctr">
+                      <a:solidFill>
+                        <a:srgbClr val="D8DEEC"/>
+                      </a:solidFill>
+                      <a:prstDash val="solid"/>
+                      <a:round/>
+                      <a:headEnd type="none" w="med" len="med"/>
+                      <a:tailEnd type="none" w="med" len="med"/>
+                    </a:lnR>
+                    <a:lnT w="12700" cap="flat" cmpd="sng" algn="ctr">
+                      <a:solidFill>
+                        <a:srgbClr val="D8DEEC"/>
+                      </a:solidFill>
+                      <a:prstDash val="solid"/>
+                      <a:round/>
+                      <a:headEnd type="none" w="med" len="med"/>
+                      <a:tailEnd type="none" w="med" len="med"/>
+                    </a:lnT>
+                    <a:lnB w="12700" cap="flat" cmpd="sng" algn="ctr">
+                      <a:solidFill>
+                        <a:srgbClr val="D8DEEC"/>
+                      </a:solidFill>
+                      <a:prstDash val="solid"/>
+                      <a:round/>
+                      <a:headEnd type="none" w="med" len="med"/>
+                      <a:tailEnd type="none" w="med" len="med"/>
+                    </a:lnB>
+                  </a:tcPr>
+                </a:tc>
+                <a:tc>
+                  <a:txBody>
+                    <a:bodyPr/>
+                    <a:lstStyle/>
+                    <a:p>
+                      <a:pPr indent="0" marL="0">
+                        <a:buNone/>
+                      </a:pPr>
+                      <a:r>
+                        <a:rPr lang="en-US" sz="1200" dirty="0">
+                          <a:solidFill>
+                            <a:srgbClr val="1A1A2E"/>
+                          </a:solidFill>
+                          <a:latin typeface="Calibri" pitchFamily="34" charset="0"/>
+                          <a:ea typeface="Calibri" pitchFamily="34" charset="-122"/>
+                          <a:cs typeface="Calibri" pitchFamily="34" charset="-120"/>
+                        </a:rPr>
+                        <a:t>domestic</a:t>
+                      </a:r>
+                      <a:endParaRPr lang="en-US" sz="1200" dirty="0">
+                        <a:latin typeface="Calibri" charset="0"/>
+                        <a:ea typeface="Calibri" charset="0"/>
+                        <a:cs typeface="Calibri" charset="0"/>
+                      </a:endParaRPr>
+                    </a:p>
+                  </a:txBody>
+                  <a:tcPr marL="91440" marR="91440" marT="45720" marB="45720" anchor="ctr">
+                    <a:lnL w="12700" cap="flat" cmpd="sng" algn="ctr">
+                      <a:solidFill>
+                        <a:srgbClr val="D8DEEC"/>
+                      </a:solidFill>
+                      <a:prstDash val="solid"/>
+                      <a:round/>
+                      <a:headEnd type="none" w="med" len="med"/>
+                      <a:tailEnd type="none" w="med" len="med"/>
+                    </a:lnL>
+                    <a:lnR w="12700" cap="flat" cmpd="sng" algn="ctr">
+                      <a:solidFill>
+                        <a:srgbClr val="D8DEEC"/>
+                      </a:solidFill>
+                      <a:prstDash val="solid"/>
+                      <a:round/>
+                      <a:headEnd type="none" w="med" len="med"/>
+                      <a:tailEnd type="none" w="med" len="med"/>
+                    </a:lnR>
+                    <a:lnT w="12700" cap="flat" cmpd="sng" algn="ctr">
+                      <a:solidFill>
+                        <a:srgbClr val="D8DEEC"/>
+                      </a:solidFill>
+                      <a:prstDash val="solid"/>
+                      <a:round/>
+                      <a:headEnd type="none" w="med" len="med"/>
+                      <a:tailEnd type="none" w="med" len="med"/>
+                    </a:lnT>
+                    <a:lnB w="12700" cap="flat" cmpd="sng" algn="ctr">
+                      <a:solidFill>
+                        <a:srgbClr val="D8DEEC"/>
+                      </a:solidFill>
+                      <a:prstDash val="solid"/>
+                      <a:round/>
+                      <a:headEnd type="none" w="med" len="med"/>
+                      <a:tailEnd type="none" w="med" len="med"/>
+                    </a:lnB>
+                  </a:tcPr>
+                </a:tc>
+                <a:tc>
+                  <a:txBody>
+                    <a:bodyPr/>
+                    <a:lstStyle/>
+                    <a:p>
+                      <a:pPr indent="0" marL="0">
+                        <a:buNone/>
+                      </a:pPr>
+                      <a:r>
+                        <a:rPr lang="en-US" sz="1200" dirty="0">
+                          <a:solidFill>
+                            <a:srgbClr val="1A1A2E"/>
+                          </a:solidFill>
+                          <a:latin typeface="Calibri" pitchFamily="34" charset="0"/>
+                          <a:ea typeface="Calibri" pitchFamily="34" charset="-122"/>
+                          <a:cs typeface="Calibri" pitchFamily="34" charset="-120"/>
+                        </a:rPr>
+                        <a:t>RTGS</a:t>
+                      </a:r>
+                      <a:endParaRPr lang="en-US" sz="1200" dirty="0">
+                        <a:latin typeface="Calibri" charset="0"/>
+                        <a:ea typeface="Calibri" charset="0"/>
+                        <a:cs typeface="Calibri" charset="0"/>
+                      </a:endParaRPr>
+                    </a:p>
+                  </a:txBody>
+                  <a:tcPr marL="91440" marR="91440" marT="45720" marB="45720" anchor="ctr">
+                    <a:lnL w="12700" cap="flat" cmpd="sng" algn="ctr">
+                      <a:solidFill>
+                        <a:srgbClr val="D8DEEC"/>
+                      </a:solidFill>
+                      <a:prstDash val="solid"/>
+                      <a:round/>
+                      <a:headEnd type="none" w="med" len="med"/>
+                      <a:tailEnd type="none" w="med" len="med"/>
+                    </a:lnL>
+                    <a:lnR w="12700" cap="flat" cmpd="sng" algn="ctr">
+                      <a:solidFill>
+                        <a:srgbClr val="D8DEEC"/>
+                      </a:solidFill>
+                      <a:prstDash val="solid"/>
+                      <a:round/>
+                      <a:headEnd type="none" w="med" len="med"/>
+                      <a:tailEnd type="none" w="med" len="med"/>
+                    </a:lnR>
+                    <a:lnT w="12700" cap="flat" cmpd="sng" algn="ctr">
+                      <a:solidFill>
+                        <a:srgbClr val="D8DEEC"/>
+                      </a:solidFill>
+                      <a:prstDash val="solid"/>
+                      <a:round/>
+                      <a:headEnd type="none" w="med" len="med"/>
+                      <a:tailEnd type="none" w="med" len="med"/>
+                    </a:lnT>
+                    <a:lnB w="12700" cap="flat" cmpd="sng" algn="ctr">
+                      <a:solidFill>
+                        <a:srgbClr val="D8DEEC"/>
+                      </a:solidFill>
+                      <a:prstDash val="solid"/>
+                      <a:round/>
+                      <a:headEnd type="none" w="med" len="med"/>
+                      <a:tailEnd type="none" w="med" len="med"/>
+                    </a:lnB>
+                  </a:tcPr>
+                </a:tc>
+                <a:tc>
+                  <a:txBody>
+                    <a:bodyPr/>
+                    <a:lstStyle/>
+                    <a:p>
+                      <a:pPr indent="0" marL="0">
+                        <a:buNone/>
+                      </a:pPr>
+                      <a:r>
+                        <a:rPr lang="en-US" sz="1200" dirty="0">
+                          <a:solidFill>
+                            <a:srgbClr val="2E7D32"/>
+                          </a:solidFill>
+                          <a:latin typeface="Calibri" pitchFamily="34" charset="0"/>
+                          <a:ea typeface="Calibri" pitchFamily="34" charset="-122"/>
+                          <a:cs typeface="Calibri" pitchFamily="34" charset="-120"/>
+                        </a:rPr>
+                        <a:t>RTGS (0.83)</a:t>
                       </a:r>
                       <a:endParaRPr lang="en-US" sz="1200" dirty="0">
                         <a:latin typeface="Calibri" charset="0"/>
@@ -3239,7 +3696,7 @@
                           <a:ea typeface="Calibri" pitchFamily="34" charset="-122"/>
                           <a:cs typeface="Calibri" pitchFamily="34" charset="-120"/>
                         </a:rPr>
-                        <a:t>sla_breach 0.84</a:t>
+                        <a:t>account_closed 0.61</a:t>
                       </a:r>
                       <a:endParaRPr lang="en-US" sz="1200" dirty="0">
                         <a:latin typeface="Calibri" charset="0"/>
@@ -3306,7 +3763,464 @@
                           <a:ea typeface="Calibri" pitchFamily="34" charset="-122"/>
                           <a:cs typeface="Calibri" pitchFamily="34" charset="-120"/>
                         </a:rPr>
-                        <a:t>4,220 INR</a:t>
+                        <a:t>248,884 INR</a:t>
+                      </a:r>
+                      <a:endParaRPr lang="en-US" sz="1200" dirty="0">
+                        <a:latin typeface="Calibri" charset="0"/>
+                        <a:ea typeface="Calibri" charset="0"/>
+                        <a:cs typeface="Calibri" charset="0"/>
+                      </a:endParaRPr>
+                    </a:p>
+                  </a:txBody>
+                  <a:tcPr marL="91440" marR="91440" marT="45720" marB="45720" anchor="ctr">
+                    <a:lnL w="12700" cap="flat" cmpd="sng" algn="ctr">
+                      <a:solidFill>
+                        <a:srgbClr val="D8DEEC"/>
+                      </a:solidFill>
+                      <a:prstDash val="solid"/>
+                      <a:round/>
+                      <a:headEnd type="none" w="med" len="med"/>
+                      <a:tailEnd type="none" w="med" len="med"/>
+                    </a:lnL>
+                    <a:lnR w="12700" cap="flat" cmpd="sng" algn="ctr">
+                      <a:solidFill>
+                        <a:srgbClr val="D8DEEC"/>
+                      </a:solidFill>
+                      <a:prstDash val="solid"/>
+                      <a:round/>
+                      <a:headEnd type="none" w="med" len="med"/>
+                      <a:tailEnd type="none" w="med" len="med"/>
+                    </a:lnR>
+                    <a:lnT w="12700" cap="flat" cmpd="sng" algn="ctr">
+                      <a:solidFill>
+                        <a:srgbClr val="D8DEEC"/>
+                      </a:solidFill>
+                      <a:prstDash val="solid"/>
+                      <a:round/>
+                      <a:headEnd type="none" w="med" len="med"/>
+                      <a:tailEnd type="none" w="med" len="med"/>
+                    </a:lnT>
+                    <a:lnB w="12700" cap="flat" cmpd="sng" algn="ctr">
+                      <a:solidFill>
+                        <a:srgbClr val="D8DEEC"/>
+                      </a:solidFill>
+                      <a:prstDash val="solid"/>
+                      <a:round/>
+                      <a:headEnd type="none" w="med" len="med"/>
+                      <a:tailEnd type="none" w="med" len="med"/>
+                    </a:lnB>
+                  </a:tcPr>
+                </a:tc>
+                <a:tc>
+                  <a:txBody>
+                    <a:bodyPr/>
+                    <a:lstStyle/>
+                    <a:p>
+                      <a:pPr indent="0" marL="0">
+                        <a:buNone/>
+                      </a:pPr>
+                      <a:r>
+                        <a:rPr lang="en-US" sz="1200" dirty="0">
+                          <a:solidFill>
+                            <a:srgbClr val="1A1A2E"/>
+                          </a:solidFill>
+                          <a:latin typeface="Calibri" pitchFamily="34" charset="0"/>
+                          <a:ea typeface="Calibri" pitchFamily="34" charset="-122"/>
+                          <a:cs typeface="Calibri" pitchFamily="34" charset="-120"/>
+                        </a:rPr>
+                        <a:t>x-border</a:t>
+                      </a:r>
+                      <a:endParaRPr lang="en-US" sz="1200" dirty="0">
+                        <a:latin typeface="Calibri" charset="0"/>
+                        <a:ea typeface="Calibri" charset="0"/>
+                        <a:cs typeface="Calibri" charset="0"/>
+                      </a:endParaRPr>
+                    </a:p>
+                  </a:txBody>
+                  <a:tcPr marL="91440" marR="91440" marT="45720" marB="45720" anchor="ctr">
+                    <a:lnL w="12700" cap="flat" cmpd="sng" algn="ctr">
+                      <a:solidFill>
+                        <a:srgbClr val="D8DEEC"/>
+                      </a:solidFill>
+                      <a:prstDash val="solid"/>
+                      <a:round/>
+                      <a:headEnd type="none" w="med" len="med"/>
+                      <a:tailEnd type="none" w="med" len="med"/>
+                    </a:lnL>
+                    <a:lnR w="12700" cap="flat" cmpd="sng" algn="ctr">
+                      <a:solidFill>
+                        <a:srgbClr val="D8DEEC"/>
+                      </a:solidFill>
+                      <a:prstDash val="solid"/>
+                      <a:round/>
+                      <a:headEnd type="none" w="med" len="med"/>
+                      <a:tailEnd type="none" w="med" len="med"/>
+                    </a:lnR>
+                    <a:lnT w="12700" cap="flat" cmpd="sng" algn="ctr">
+                      <a:solidFill>
+                        <a:srgbClr val="D8DEEC"/>
+                      </a:solidFill>
+                      <a:prstDash val="solid"/>
+                      <a:round/>
+                      <a:headEnd type="none" w="med" len="med"/>
+                      <a:tailEnd type="none" w="med" len="med"/>
+                    </a:lnT>
+                    <a:lnB w="12700" cap="flat" cmpd="sng" algn="ctr">
+                      <a:solidFill>
+                        <a:srgbClr val="D8DEEC"/>
+                      </a:solidFill>
+                      <a:prstDash val="solid"/>
+                      <a:round/>
+                      <a:headEnd type="none" w="med" len="med"/>
+                      <a:tailEnd type="none" w="med" len="med"/>
+                    </a:lnB>
+                  </a:tcPr>
+                </a:tc>
+                <a:tc>
+                  <a:txBody>
+                    <a:bodyPr/>
+                    <a:lstStyle/>
+                    <a:p>
+                      <a:pPr indent="0" marL="0">
+                        <a:buNone/>
+                      </a:pPr>
+                      <a:r>
+                        <a:rPr lang="en-US" sz="1200" dirty="0">
+                          <a:solidFill>
+                            <a:srgbClr val="1A1A2E"/>
+                          </a:solidFill>
+                          <a:latin typeface="Calibri" pitchFamily="34" charset="0"/>
+                          <a:ea typeface="Calibri" pitchFamily="34" charset="-122"/>
+                          <a:cs typeface="Calibri" pitchFamily="34" charset="-120"/>
+                        </a:rPr>
+                        <a:t>SWIFT</a:t>
+                      </a:r>
+                      <a:endParaRPr lang="en-US" sz="1200" dirty="0">
+                        <a:latin typeface="Calibri" charset="0"/>
+                        <a:ea typeface="Calibri" charset="0"/>
+                        <a:cs typeface="Calibri" charset="0"/>
+                      </a:endParaRPr>
+                    </a:p>
+                  </a:txBody>
+                  <a:tcPr marL="91440" marR="91440" marT="45720" marB="45720" anchor="ctr">
+                    <a:lnL w="12700" cap="flat" cmpd="sng" algn="ctr">
+                      <a:solidFill>
+                        <a:srgbClr val="D8DEEC"/>
+                      </a:solidFill>
+                      <a:prstDash val="solid"/>
+                      <a:round/>
+                      <a:headEnd type="none" w="med" len="med"/>
+                      <a:tailEnd type="none" w="med" len="med"/>
+                    </a:lnL>
+                    <a:lnR w="12700" cap="flat" cmpd="sng" algn="ctr">
+                      <a:solidFill>
+                        <a:srgbClr val="D8DEEC"/>
+                      </a:solidFill>
+                      <a:prstDash val="solid"/>
+                      <a:round/>
+                      <a:headEnd type="none" w="med" len="med"/>
+                      <a:tailEnd type="none" w="med" len="med"/>
+                    </a:lnR>
+                    <a:lnT w="12700" cap="flat" cmpd="sng" algn="ctr">
+                      <a:solidFill>
+                        <a:srgbClr val="D8DEEC"/>
+                      </a:solidFill>
+                      <a:prstDash val="solid"/>
+                      <a:round/>
+                      <a:headEnd type="none" w="med" len="med"/>
+                      <a:tailEnd type="none" w="med" len="med"/>
+                    </a:lnT>
+                    <a:lnB w="12700" cap="flat" cmpd="sng" algn="ctr">
+                      <a:solidFill>
+                        <a:srgbClr val="D8DEEC"/>
+                      </a:solidFill>
+                      <a:prstDash val="solid"/>
+                      <a:round/>
+                      <a:headEnd type="none" w="med" len="med"/>
+                      <a:tailEnd type="none" w="med" len="med"/>
+                    </a:lnB>
+                  </a:tcPr>
+                </a:tc>
+                <a:tc>
+                  <a:txBody>
+                    <a:bodyPr/>
+                    <a:lstStyle/>
+                    <a:p>
+                      <a:pPr indent="0" marL="0">
+                        <a:buNone/>
+                      </a:pPr>
+                      <a:r>
+                        <a:rPr lang="en-US" sz="1200" dirty="0">
+                          <a:solidFill>
+                            <a:srgbClr val="2E7D32"/>
+                          </a:solidFill>
+                          <a:latin typeface="Calibri" pitchFamily="34" charset="0"/>
+                          <a:ea typeface="Calibri" pitchFamily="34" charset="-122"/>
+                          <a:cs typeface="Calibri" pitchFamily="34" charset="-120"/>
+                        </a:rPr>
+                        <a:t>SWIFT (1.00)</a:t>
+                      </a:r>
+                      <a:endParaRPr lang="en-US" sz="1200" dirty="0">
+                        <a:latin typeface="Calibri" charset="0"/>
+                        <a:ea typeface="Calibri" charset="0"/>
+                        <a:cs typeface="Calibri" charset="0"/>
+                      </a:endParaRPr>
+                    </a:p>
+                  </a:txBody>
+                  <a:tcPr marL="91440" marR="91440" marT="45720" marB="45720" anchor="ctr">
+                    <a:lnL w="12700" cap="flat" cmpd="sng" algn="ctr">
+                      <a:solidFill>
+                        <a:srgbClr val="D8DEEC"/>
+                      </a:solidFill>
+                      <a:prstDash val="solid"/>
+                      <a:round/>
+                      <a:headEnd type="none" w="med" len="med"/>
+                      <a:tailEnd type="none" w="med" len="med"/>
+                    </a:lnL>
+                    <a:lnR w="12700" cap="flat" cmpd="sng" algn="ctr">
+                      <a:solidFill>
+                        <a:srgbClr val="D8DEEC"/>
+                      </a:solidFill>
+                      <a:prstDash val="solid"/>
+                      <a:round/>
+                      <a:headEnd type="none" w="med" len="med"/>
+                      <a:tailEnd type="none" w="med" len="med"/>
+                    </a:lnR>
+                    <a:lnT w="12700" cap="flat" cmpd="sng" algn="ctr">
+                      <a:solidFill>
+                        <a:srgbClr val="D8DEEC"/>
+                      </a:solidFill>
+                      <a:prstDash val="solid"/>
+                      <a:round/>
+                      <a:headEnd type="none" w="med" len="med"/>
+                      <a:tailEnd type="none" w="med" len="med"/>
+                    </a:lnT>
+                    <a:lnB w="12700" cap="flat" cmpd="sng" algn="ctr">
+                      <a:solidFill>
+                        <a:srgbClr val="D8DEEC"/>
+                      </a:solidFill>
+                      <a:prstDash val="solid"/>
+                      <a:round/>
+                      <a:headEnd type="none" w="med" len="med"/>
+                      <a:tailEnd type="none" w="med" len="med"/>
+                    </a:lnB>
+                  </a:tcPr>
+                </a:tc>
+                <a:tc>
+                  <a:txBody>
+                    <a:bodyPr/>
+                    <a:lstStyle/>
+                    <a:p>
+                      <a:pPr indent="0" marL="0">
+                        <a:buNone/>
+                      </a:pPr>
+                      <a:r>
+                        <a:rPr lang="en-US" sz="1200" dirty="0">
+                          <a:solidFill>
+                            <a:srgbClr val="1A1A2E"/>
+                          </a:solidFill>
+                          <a:latin typeface="Calibri" pitchFamily="34" charset="0"/>
+                          <a:ea typeface="Calibri" pitchFamily="34" charset="-122"/>
+                          <a:cs typeface="Calibri" pitchFamily="34" charset="-120"/>
+                        </a:rPr>
+                        <a:t>MANUAL_REVIEW</a:t>
+                      </a:r>
+                      <a:endParaRPr lang="en-US" sz="1200" dirty="0">
+                        <a:latin typeface="Calibri" charset="0"/>
+                        <a:ea typeface="Calibri" charset="0"/>
+                        <a:cs typeface="Calibri" charset="0"/>
+                      </a:endParaRPr>
+                    </a:p>
+                  </a:txBody>
+                  <a:tcPr marL="91440" marR="91440" marT="45720" marB="45720" anchor="ctr">
+                    <a:lnL w="12700" cap="flat" cmpd="sng" algn="ctr">
+                      <a:solidFill>
+                        <a:srgbClr val="D8DEEC"/>
+                      </a:solidFill>
+                      <a:prstDash val="solid"/>
+                      <a:round/>
+                      <a:headEnd type="none" w="med" len="med"/>
+                      <a:tailEnd type="none" w="med" len="med"/>
+                    </a:lnL>
+                    <a:lnR w="12700" cap="flat" cmpd="sng" algn="ctr">
+                      <a:solidFill>
+                        <a:srgbClr val="D8DEEC"/>
+                      </a:solidFill>
+                      <a:prstDash val="solid"/>
+                      <a:round/>
+                      <a:headEnd type="none" w="med" len="med"/>
+                      <a:tailEnd type="none" w="med" len="med"/>
+                    </a:lnR>
+                    <a:lnT w="12700" cap="flat" cmpd="sng" algn="ctr">
+                      <a:solidFill>
+                        <a:srgbClr val="D8DEEC"/>
+                      </a:solidFill>
+                      <a:prstDash val="solid"/>
+                      <a:round/>
+                      <a:headEnd type="none" w="med" len="med"/>
+                      <a:tailEnd type="none" w="med" len="med"/>
+                    </a:lnT>
+                    <a:lnB w="12700" cap="flat" cmpd="sng" algn="ctr">
+                      <a:solidFill>
+                        <a:srgbClr val="D8DEEC"/>
+                      </a:solidFill>
+                      <a:prstDash val="solid"/>
+                      <a:round/>
+                      <a:headEnd type="none" w="med" len="med"/>
+                      <a:tailEnd type="none" w="med" len="med"/>
+                    </a:lnB>
+                  </a:tcPr>
+                </a:tc>
+                <a:tc>
+                  <a:txBody>
+                    <a:bodyPr/>
+                    <a:lstStyle/>
+                    <a:p>
+                      <a:pPr indent="0" marL="0">
+                        <a:buNone/>
+                      </a:pPr>
+                      <a:r>
+                        <a:rPr lang="en-US" sz="1200" dirty="0">
+                          <a:solidFill>
+                            <a:srgbClr val="1A1A2E"/>
+                          </a:solidFill>
+                          <a:latin typeface="Calibri" pitchFamily="34" charset="0"/>
+                          <a:ea typeface="Calibri" pitchFamily="34" charset="-122"/>
+                          <a:cs typeface="Calibri" pitchFamily="34" charset="-120"/>
+                        </a:rPr>
+                        <a:t>996 min (true 1140)</a:t>
+                      </a:r>
+                      <a:endParaRPr lang="en-US" sz="1200" dirty="0">
+                        <a:latin typeface="Calibri" charset="0"/>
+                        <a:ea typeface="Calibri" charset="0"/>
+                        <a:cs typeface="Calibri" charset="0"/>
+                      </a:endParaRPr>
+                    </a:p>
+                  </a:txBody>
+                  <a:tcPr marL="91440" marR="91440" marT="45720" marB="45720" anchor="ctr">
+                    <a:lnL w="12700" cap="flat" cmpd="sng" algn="ctr">
+                      <a:solidFill>
+                        <a:srgbClr val="D8DEEC"/>
+                      </a:solidFill>
+                      <a:prstDash val="solid"/>
+                      <a:round/>
+                      <a:headEnd type="none" w="med" len="med"/>
+                      <a:tailEnd type="none" w="med" len="med"/>
+                    </a:lnL>
+                    <a:lnR w="12700" cap="flat" cmpd="sng" algn="ctr">
+                      <a:solidFill>
+                        <a:srgbClr val="D8DEEC"/>
+                      </a:solidFill>
+                      <a:prstDash val="solid"/>
+                      <a:round/>
+                      <a:headEnd type="none" w="med" len="med"/>
+                      <a:tailEnd type="none" w="med" len="med"/>
+                    </a:lnR>
+                    <a:lnT w="12700" cap="flat" cmpd="sng" algn="ctr">
+                      <a:solidFill>
+                        <a:srgbClr val="D8DEEC"/>
+                      </a:solidFill>
+                      <a:prstDash val="solid"/>
+                      <a:round/>
+                      <a:headEnd type="none" w="med" len="med"/>
+                      <a:tailEnd type="none" w="med" len="med"/>
+                    </a:lnT>
+                    <a:lnB w="12700" cap="flat" cmpd="sng" algn="ctr">
+                      <a:solidFill>
+                        <a:srgbClr val="D8DEEC"/>
+                      </a:solidFill>
+                      <a:prstDash val="solid"/>
+                      <a:round/>
+                      <a:headEnd type="none" w="med" len="med"/>
+                      <a:tailEnd type="none" w="med" len="med"/>
+                    </a:lnB>
+                  </a:tcPr>
+                </a:tc>
+                <a:tc>
+                  <a:txBody>
+                    <a:bodyPr/>
+                    <a:lstStyle/>
+                    <a:p>
+                      <a:pPr indent="0" marL="0">
+                        <a:buNone/>
+                      </a:pPr>
+                      <a:r>
+                        <a:rPr lang="en-US" sz="1200" dirty="0">
+                          <a:solidFill>
+                            <a:srgbClr val="1A1A2E"/>
+                          </a:solidFill>
+                          <a:latin typeface="Calibri" pitchFamily="34" charset="0"/>
+                          <a:ea typeface="Calibri" pitchFamily="34" charset="-122"/>
+                          <a:cs typeface="Calibri" pitchFamily="34" charset="-120"/>
+                        </a:rPr>
+                        <a:t>no_cover 1.00</a:t>
+                      </a:r>
+                      <a:endParaRPr lang="en-US" sz="1200" dirty="0">
+                        <a:latin typeface="Calibri" charset="0"/>
+                        <a:ea typeface="Calibri" charset="0"/>
+                        <a:cs typeface="Calibri" charset="0"/>
+                      </a:endParaRPr>
+                    </a:p>
+                  </a:txBody>
+                  <a:tcPr marL="91440" marR="91440" marT="45720" marB="45720" anchor="ctr">
+                    <a:lnL w="12700" cap="flat" cmpd="sng" algn="ctr">
+                      <a:solidFill>
+                        <a:srgbClr val="D8DEEC"/>
+                      </a:solidFill>
+                      <a:prstDash val="solid"/>
+                      <a:round/>
+                      <a:headEnd type="none" w="med" len="med"/>
+                      <a:tailEnd type="none" w="med" len="med"/>
+                    </a:lnL>
+                    <a:lnR w="12700" cap="flat" cmpd="sng" algn="ctr">
+                      <a:solidFill>
+                        <a:srgbClr val="D8DEEC"/>
+                      </a:solidFill>
+                      <a:prstDash val="solid"/>
+                      <a:round/>
+                      <a:headEnd type="none" w="med" len="med"/>
+                      <a:tailEnd type="none" w="med" len="med"/>
+                    </a:lnR>
+                    <a:lnT w="12700" cap="flat" cmpd="sng" algn="ctr">
+                      <a:solidFill>
+                        <a:srgbClr val="D8DEEC"/>
+                      </a:solidFill>
+                      <a:prstDash val="solid"/>
+                      <a:round/>
+                      <a:headEnd type="none" w="med" len="med"/>
+                      <a:tailEnd type="none" w="med" len="med"/>
+                    </a:lnT>
+                    <a:lnB w="12700" cap="flat" cmpd="sng" algn="ctr">
+                      <a:solidFill>
+                        <a:srgbClr val="D8DEEC"/>
+                      </a:solidFill>
+                      <a:prstDash val="solid"/>
+                      <a:round/>
+                      <a:headEnd type="none" w="med" len="med"/>
+                      <a:tailEnd type="none" w="med" len="med"/>
+                    </a:lnB>
+                  </a:tcPr>
+                </a:tc>
+              </a:tr>
+              <a:tr h="502920">
+                <a:tc>
+                  <a:txBody>
+                    <a:bodyPr/>
+                    <a:lstStyle/>
+                    <a:p>
+                      <a:pPr indent="0" marL="0">
+                        <a:buNone/>
+                      </a:pPr>
+                      <a:r>
+                        <a:rPr lang="en-US" sz="1200" dirty="0">
+                          <a:solidFill>
+                            <a:srgbClr val="1A1A2E"/>
+                          </a:solidFill>
+                          <a:latin typeface="Calibri" pitchFamily="34" charset="0"/>
+                          <a:ea typeface="Calibri" pitchFamily="34" charset="-122"/>
+                          <a:cs typeface="Calibri" pitchFamily="34" charset="-120"/>
+                        </a:rPr>
+                        <a:t>7,796 INR</a:t>
                       </a:r>
                       <a:endParaRPr lang="en-US" sz="1200" dirty="0">
                         <a:latin typeface="Calibri" charset="0"/>
@@ -3436,7 +4350,7 @@
                           <a:ea typeface="Calibri" pitchFamily="34" charset="-122"/>
                           <a:cs typeface="Calibri" pitchFamily="34" charset="-120"/>
                         </a:rPr>
-                        <a:t>IMPS</a:t>
+                        <a:t>RTGS *</a:t>
                       </a:r>
                       <a:endParaRPr lang="en-US" sz="1200" dirty="0">
                         <a:latin typeface="Calibri" charset="0"/>
@@ -3495,13 +4409,13 @@
                       <a:r>
                         <a:rPr lang="en-US" sz="1200" dirty="0">
                           <a:solidFill>
-                            <a:srgbClr val="2E7D32"/>
+                            <a:srgbClr val="C98A00"/>
                           </a:solidFill>
                           <a:latin typeface="Calibri" pitchFamily="34" charset="0"/>
                           <a:ea typeface="Calibri" pitchFamily="34" charset="-122"/>
                           <a:cs typeface="Calibri" pitchFamily="34" charset="-120"/>
                         </a:rPr>
-                        <a:t>IMPS (0.62)</a:t>
+                        <a:t>IMPS (0.60)</a:t>
                       </a:r>
                       <a:endParaRPr lang="en-US" sz="1200" dirty="0">
                         <a:latin typeface="Calibri" charset="0"/>
@@ -3566,7 +4480,7 @@
                           <a:ea typeface="Calibri" pitchFamily="34" charset="-122"/>
                           <a:cs typeface="Calibri" pitchFamily="34" charset="-120"/>
                         </a:rPr>
-                        <a:t>REJECTED</a:t>
+                        <a:t>REJECTED ✓</a:t>
                       </a:r>
                       <a:endParaRPr lang="en-US" sz="1200" dirty="0">
                         <a:latin typeface="Calibri" charset="0"/>
@@ -3631,7 +4545,7 @@
                           <a:ea typeface="Calibri" pitchFamily="34" charset="-122"/>
                           <a:cs typeface="Calibri" pitchFamily="34" charset="-120"/>
                         </a:rPr>
-                        <a:t>0 min</a:t>
+                        <a:t>28 min</a:t>
                       </a:r>
                       <a:endParaRPr lang="en-US" sz="1200" dirty="0">
                         <a:latin typeface="Calibri" charset="0"/>
@@ -3696,7 +4610,7 @@
                           <a:ea typeface="Calibri" pitchFamily="34" charset="-122"/>
                           <a:cs typeface="Calibri" pitchFamily="34" charset="-120"/>
                         </a:rPr>
-                        <a:t>sanctions_hit 0.96</a:t>
+                        <a:t>below_min 0.63</a:t>
                       </a:r>
                       <a:endParaRPr lang="en-US" sz="1200" dirty="0">
                         <a:latin typeface="Calibri" charset="0"/>
@@ -3763,7 +4677,7 @@
                           <a:ea typeface="Calibri" pitchFamily="34" charset="-122"/>
                           <a:cs typeface="Calibri" pitchFamily="34" charset="-120"/>
                         </a:rPr>
-                        <a:t>285,371 INR</a:t>
+                        <a:t>13,137 INR</a:t>
                       </a:r>
                       <a:endParaRPr lang="en-US" sz="1200" dirty="0">
                         <a:latin typeface="Calibri" charset="0"/>
@@ -3893,7 +4807,7 @@
                           <a:ea typeface="Calibri" pitchFamily="34" charset="-122"/>
                           <a:cs typeface="Calibri" pitchFamily="34" charset="-120"/>
                         </a:rPr>
-                        <a:t>NEFT</a:t>
+                        <a:t>IMPS</a:t>
                       </a:r>
                       <a:endParaRPr lang="en-US" sz="1200" dirty="0">
                         <a:latin typeface="Calibri" charset="0"/>
@@ -3958,7 +4872,7 @@
                           <a:ea typeface="Calibri" pitchFamily="34" charset="-122"/>
                           <a:cs typeface="Calibri" pitchFamily="34" charset="-120"/>
                         </a:rPr>
-                        <a:t>RTGS (0.81)</a:t>
+                        <a:t>NEFT (0.67)</a:t>
                       </a:r>
                       <a:endParaRPr lang="en-US" sz="1200" dirty="0">
                         <a:latin typeface="Calibri" charset="0"/>
@@ -4023,7 +4937,7 @@
                           <a:ea typeface="Calibri" pitchFamily="34" charset="-122"/>
                           <a:cs typeface="Calibri" pitchFamily="34" charset="-120"/>
                         </a:rPr>
-                        <a:t>REJECTED</a:t>
+                        <a:t>MANUAL_REVIEW</a:t>
                       </a:r>
                       <a:endParaRPr lang="en-US" sz="1200" dirty="0">
                         <a:latin typeface="Calibri" charset="0"/>
@@ -4088,7 +5002,7 @@
                           <a:ea typeface="Calibri" pitchFamily="34" charset="-122"/>
                           <a:cs typeface="Calibri" pitchFamily="34" charset="-120"/>
                         </a:rPr>
-                        <a:t>48 min</a:t>
+                        <a:t>819 min</a:t>
                       </a:r>
                       <a:endParaRPr lang="en-US" sz="1200" dirty="0">
                         <a:latin typeface="Calibri" charset="0"/>
@@ -4153,7 +5067,7 @@
                           <a:ea typeface="Calibri" pitchFamily="34" charset="-122"/>
                           <a:cs typeface="Calibri" pitchFamily="34" charset="-120"/>
                         </a:rPr>
-                        <a:t>below_min 0.70</a:t>
+                        <a:t>sla_breach 0.83</a:t>
                       </a:r>
                       <a:endParaRPr lang="en-US" sz="1200" dirty="0">
                         <a:latin typeface="Calibri" charset="0"/>
@@ -4202,920 +5116,6 @@
                   </a:tcPr>
                 </a:tc>
               </a:tr>
-              <a:tr h="502920">
-                <a:tc>
-                  <a:txBody>
-                    <a:bodyPr/>
-                    <a:lstStyle/>
-                    <a:p>
-                      <a:pPr indent="0" marL="0">
-                        <a:buNone/>
-                      </a:pPr>
-                      <a:r>
-                        <a:rPr lang="en-US" sz="1200" dirty="0">
-                          <a:solidFill>
-                            <a:srgbClr val="1A1A2E"/>
-                          </a:solidFill>
-                          <a:latin typeface="Calibri" pitchFamily="34" charset="0"/>
-                          <a:ea typeface="Calibri" pitchFamily="34" charset="-122"/>
-                          <a:cs typeface="Calibri" pitchFamily="34" charset="-120"/>
-                        </a:rPr>
-                        <a:t>274,523 INR</a:t>
-                      </a:r>
-                      <a:endParaRPr lang="en-US" sz="1200" dirty="0">
-                        <a:latin typeface="Calibri" charset="0"/>
-                        <a:ea typeface="Calibri" charset="0"/>
-                        <a:cs typeface="Calibri" charset="0"/>
-                      </a:endParaRPr>
-                    </a:p>
-                  </a:txBody>
-                  <a:tcPr marL="91440" marR="91440" marT="45720" marB="45720" anchor="ctr">
-                    <a:lnL w="12700" cap="flat" cmpd="sng" algn="ctr">
-                      <a:solidFill>
-                        <a:srgbClr val="D8DEEC"/>
-                      </a:solidFill>
-                      <a:prstDash val="solid"/>
-                      <a:round/>
-                      <a:headEnd type="none" w="med" len="med"/>
-                      <a:tailEnd type="none" w="med" len="med"/>
-                    </a:lnL>
-                    <a:lnR w="12700" cap="flat" cmpd="sng" algn="ctr">
-                      <a:solidFill>
-                        <a:srgbClr val="D8DEEC"/>
-                      </a:solidFill>
-                      <a:prstDash val="solid"/>
-                      <a:round/>
-                      <a:headEnd type="none" w="med" len="med"/>
-                      <a:tailEnd type="none" w="med" len="med"/>
-                    </a:lnR>
-                    <a:lnT w="12700" cap="flat" cmpd="sng" algn="ctr">
-                      <a:solidFill>
-                        <a:srgbClr val="D8DEEC"/>
-                      </a:solidFill>
-                      <a:prstDash val="solid"/>
-                      <a:round/>
-                      <a:headEnd type="none" w="med" len="med"/>
-                      <a:tailEnd type="none" w="med" len="med"/>
-                    </a:lnT>
-                    <a:lnB w="12700" cap="flat" cmpd="sng" algn="ctr">
-                      <a:solidFill>
-                        <a:srgbClr val="D8DEEC"/>
-                      </a:solidFill>
-                      <a:prstDash val="solid"/>
-                      <a:round/>
-                      <a:headEnd type="none" w="med" len="med"/>
-                      <a:tailEnd type="none" w="med" len="med"/>
-                    </a:lnB>
-                  </a:tcPr>
-                </a:tc>
-                <a:tc>
-                  <a:txBody>
-                    <a:bodyPr/>
-                    <a:lstStyle/>
-                    <a:p>
-                      <a:pPr indent="0" marL="0">
-                        <a:buNone/>
-                      </a:pPr>
-                      <a:r>
-                        <a:rPr lang="en-US" sz="1200" dirty="0">
-                          <a:solidFill>
-                            <a:srgbClr val="1A1A2E"/>
-                          </a:solidFill>
-                          <a:latin typeface="Calibri" pitchFamily="34" charset="0"/>
-                          <a:ea typeface="Calibri" pitchFamily="34" charset="-122"/>
-                          <a:cs typeface="Calibri" pitchFamily="34" charset="-120"/>
-                        </a:rPr>
-                        <a:t>x-border</a:t>
-                      </a:r>
-                      <a:endParaRPr lang="en-US" sz="1200" dirty="0">
-                        <a:latin typeface="Calibri" charset="0"/>
-                        <a:ea typeface="Calibri" charset="0"/>
-                        <a:cs typeface="Calibri" charset="0"/>
-                      </a:endParaRPr>
-                    </a:p>
-                  </a:txBody>
-                  <a:tcPr marL="91440" marR="91440" marT="45720" marB="45720" anchor="ctr">
-                    <a:lnL w="12700" cap="flat" cmpd="sng" algn="ctr">
-                      <a:solidFill>
-                        <a:srgbClr val="D8DEEC"/>
-                      </a:solidFill>
-                      <a:prstDash val="solid"/>
-                      <a:round/>
-                      <a:headEnd type="none" w="med" len="med"/>
-                      <a:tailEnd type="none" w="med" len="med"/>
-                    </a:lnL>
-                    <a:lnR w="12700" cap="flat" cmpd="sng" algn="ctr">
-                      <a:solidFill>
-                        <a:srgbClr val="D8DEEC"/>
-                      </a:solidFill>
-                      <a:prstDash val="solid"/>
-                      <a:round/>
-                      <a:headEnd type="none" w="med" len="med"/>
-                      <a:tailEnd type="none" w="med" len="med"/>
-                    </a:lnR>
-                    <a:lnT w="12700" cap="flat" cmpd="sng" algn="ctr">
-                      <a:solidFill>
-                        <a:srgbClr val="D8DEEC"/>
-                      </a:solidFill>
-                      <a:prstDash val="solid"/>
-                      <a:round/>
-                      <a:headEnd type="none" w="med" len="med"/>
-                      <a:tailEnd type="none" w="med" len="med"/>
-                    </a:lnT>
-                    <a:lnB w="12700" cap="flat" cmpd="sng" algn="ctr">
-                      <a:solidFill>
-                        <a:srgbClr val="D8DEEC"/>
-                      </a:solidFill>
-                      <a:prstDash val="solid"/>
-                      <a:round/>
-                      <a:headEnd type="none" w="med" len="med"/>
-                      <a:tailEnd type="none" w="med" len="med"/>
-                    </a:lnB>
-                  </a:tcPr>
-                </a:tc>
-                <a:tc>
-                  <a:txBody>
-                    <a:bodyPr/>
-                    <a:lstStyle/>
-                    <a:p>
-                      <a:pPr indent="0" marL="0">
-                        <a:buNone/>
-                      </a:pPr>
-                      <a:r>
-                        <a:rPr lang="en-US" sz="1200" dirty="0">
-                          <a:solidFill>
-                            <a:srgbClr val="1A1A2E"/>
-                          </a:solidFill>
-                          <a:latin typeface="Calibri" pitchFamily="34" charset="0"/>
-                          <a:ea typeface="Calibri" pitchFamily="34" charset="-122"/>
-                          <a:cs typeface="Calibri" pitchFamily="34" charset="-120"/>
-                        </a:rPr>
-                        <a:t>SWIFT</a:t>
-                      </a:r>
-                      <a:endParaRPr lang="en-US" sz="1200" dirty="0">
-                        <a:latin typeface="Calibri" charset="0"/>
-                        <a:ea typeface="Calibri" charset="0"/>
-                        <a:cs typeface="Calibri" charset="0"/>
-                      </a:endParaRPr>
-                    </a:p>
-                  </a:txBody>
-                  <a:tcPr marL="91440" marR="91440" marT="45720" marB="45720" anchor="ctr">
-                    <a:lnL w="12700" cap="flat" cmpd="sng" algn="ctr">
-                      <a:solidFill>
-                        <a:srgbClr val="D8DEEC"/>
-                      </a:solidFill>
-                      <a:prstDash val="solid"/>
-                      <a:round/>
-                      <a:headEnd type="none" w="med" len="med"/>
-                      <a:tailEnd type="none" w="med" len="med"/>
-                    </a:lnL>
-                    <a:lnR w="12700" cap="flat" cmpd="sng" algn="ctr">
-                      <a:solidFill>
-                        <a:srgbClr val="D8DEEC"/>
-                      </a:solidFill>
-                      <a:prstDash val="solid"/>
-                      <a:round/>
-                      <a:headEnd type="none" w="med" len="med"/>
-                      <a:tailEnd type="none" w="med" len="med"/>
-                    </a:lnR>
-                    <a:lnT w="12700" cap="flat" cmpd="sng" algn="ctr">
-                      <a:solidFill>
-                        <a:srgbClr val="D8DEEC"/>
-                      </a:solidFill>
-                      <a:prstDash val="solid"/>
-                      <a:round/>
-                      <a:headEnd type="none" w="med" len="med"/>
-                      <a:tailEnd type="none" w="med" len="med"/>
-                    </a:lnT>
-                    <a:lnB w="12700" cap="flat" cmpd="sng" algn="ctr">
-                      <a:solidFill>
-                        <a:srgbClr val="D8DEEC"/>
-                      </a:solidFill>
-                      <a:prstDash val="solid"/>
-                      <a:round/>
-                      <a:headEnd type="none" w="med" len="med"/>
-                      <a:tailEnd type="none" w="med" len="med"/>
-                    </a:lnB>
-                  </a:tcPr>
-                </a:tc>
-                <a:tc>
-                  <a:txBody>
-                    <a:bodyPr/>
-                    <a:lstStyle/>
-                    <a:p>
-                      <a:pPr indent="0" marL="0">
-                        <a:buNone/>
-                      </a:pPr>
-                      <a:r>
-                        <a:rPr lang="en-US" sz="1200" dirty="0">
-                          <a:solidFill>
-                            <a:srgbClr val="2E7D32"/>
-                          </a:solidFill>
-                          <a:latin typeface="Calibri" pitchFamily="34" charset="0"/>
-                          <a:ea typeface="Calibri" pitchFamily="34" charset="-122"/>
-                          <a:cs typeface="Calibri" pitchFamily="34" charset="-120"/>
-                        </a:rPr>
-                        <a:t>SWIFT (1.00)</a:t>
-                      </a:r>
-                      <a:endParaRPr lang="en-US" sz="1200" dirty="0">
-                        <a:latin typeface="Calibri" charset="0"/>
-                        <a:ea typeface="Calibri" charset="0"/>
-                        <a:cs typeface="Calibri" charset="0"/>
-                      </a:endParaRPr>
-                    </a:p>
-                  </a:txBody>
-                  <a:tcPr marL="91440" marR="91440" marT="45720" marB="45720" anchor="ctr">
-                    <a:lnL w="12700" cap="flat" cmpd="sng" algn="ctr">
-                      <a:solidFill>
-                        <a:srgbClr val="D8DEEC"/>
-                      </a:solidFill>
-                      <a:prstDash val="solid"/>
-                      <a:round/>
-                      <a:headEnd type="none" w="med" len="med"/>
-                      <a:tailEnd type="none" w="med" len="med"/>
-                    </a:lnL>
-                    <a:lnR w="12700" cap="flat" cmpd="sng" algn="ctr">
-                      <a:solidFill>
-                        <a:srgbClr val="D8DEEC"/>
-                      </a:solidFill>
-                      <a:prstDash val="solid"/>
-                      <a:round/>
-                      <a:headEnd type="none" w="med" len="med"/>
-                      <a:tailEnd type="none" w="med" len="med"/>
-                    </a:lnR>
-                    <a:lnT w="12700" cap="flat" cmpd="sng" algn="ctr">
-                      <a:solidFill>
-                        <a:srgbClr val="D8DEEC"/>
-                      </a:solidFill>
-                      <a:prstDash val="solid"/>
-                      <a:round/>
-                      <a:headEnd type="none" w="med" len="med"/>
-                      <a:tailEnd type="none" w="med" len="med"/>
-                    </a:lnT>
-                    <a:lnB w="12700" cap="flat" cmpd="sng" algn="ctr">
-                      <a:solidFill>
-                        <a:srgbClr val="D8DEEC"/>
-                      </a:solidFill>
-                      <a:prstDash val="solid"/>
-                      <a:round/>
-                      <a:headEnd type="none" w="med" len="med"/>
-                      <a:tailEnd type="none" w="med" len="med"/>
-                    </a:lnB>
-                  </a:tcPr>
-                </a:tc>
-                <a:tc>
-                  <a:txBody>
-                    <a:bodyPr/>
-                    <a:lstStyle/>
-                    <a:p>
-                      <a:pPr indent="0" marL="0">
-                        <a:buNone/>
-                      </a:pPr>
-                      <a:r>
-                        <a:rPr lang="en-US" sz="1200" dirty="0">
-                          <a:solidFill>
-                            <a:srgbClr val="1A1A2E"/>
-                          </a:solidFill>
-                          <a:latin typeface="Calibri" pitchFamily="34" charset="0"/>
-                          <a:ea typeface="Calibri" pitchFamily="34" charset="-122"/>
-                          <a:cs typeface="Calibri" pitchFamily="34" charset="-120"/>
-                        </a:rPr>
-                        <a:t>REPAIRED</a:t>
-                      </a:r>
-                      <a:endParaRPr lang="en-US" sz="1200" dirty="0">
-                        <a:latin typeface="Calibri" charset="0"/>
-                        <a:ea typeface="Calibri" charset="0"/>
-                        <a:cs typeface="Calibri" charset="0"/>
-                      </a:endParaRPr>
-                    </a:p>
-                  </a:txBody>
-                  <a:tcPr marL="91440" marR="91440" marT="45720" marB="45720" anchor="ctr">
-                    <a:lnL w="12700" cap="flat" cmpd="sng" algn="ctr">
-                      <a:solidFill>
-                        <a:srgbClr val="D8DEEC"/>
-                      </a:solidFill>
-                      <a:prstDash val="solid"/>
-                      <a:round/>
-                      <a:headEnd type="none" w="med" len="med"/>
-                      <a:tailEnd type="none" w="med" len="med"/>
-                    </a:lnL>
-                    <a:lnR w="12700" cap="flat" cmpd="sng" algn="ctr">
-                      <a:solidFill>
-                        <a:srgbClr val="D8DEEC"/>
-                      </a:solidFill>
-                      <a:prstDash val="solid"/>
-                      <a:round/>
-                      <a:headEnd type="none" w="med" len="med"/>
-                      <a:tailEnd type="none" w="med" len="med"/>
-                    </a:lnR>
-                    <a:lnT w="12700" cap="flat" cmpd="sng" algn="ctr">
-                      <a:solidFill>
-                        <a:srgbClr val="D8DEEC"/>
-                      </a:solidFill>
-                      <a:prstDash val="solid"/>
-                      <a:round/>
-                      <a:headEnd type="none" w="med" len="med"/>
-                      <a:tailEnd type="none" w="med" len="med"/>
-                    </a:lnT>
-                    <a:lnB w="12700" cap="flat" cmpd="sng" algn="ctr">
-                      <a:solidFill>
-                        <a:srgbClr val="D8DEEC"/>
-                      </a:solidFill>
-                      <a:prstDash val="solid"/>
-                      <a:round/>
-                      <a:headEnd type="none" w="med" len="med"/>
-                      <a:tailEnd type="none" w="med" len="med"/>
-                    </a:lnB>
-                  </a:tcPr>
-                </a:tc>
-                <a:tc>
-                  <a:txBody>
-                    <a:bodyPr/>
-                    <a:lstStyle/>
-                    <a:p>
-                      <a:pPr indent="0" marL="0">
-                        <a:buNone/>
-                      </a:pPr>
-                      <a:r>
-                        <a:rPr lang="en-US" sz="1200" dirty="0">
-                          <a:solidFill>
-                            <a:srgbClr val="1A1A2E"/>
-                          </a:solidFill>
-                          <a:latin typeface="Calibri" pitchFamily="34" charset="0"/>
-                          <a:ea typeface="Calibri" pitchFamily="34" charset="-122"/>
-                          <a:cs typeface="Calibri" pitchFamily="34" charset="-120"/>
-                        </a:rPr>
-                        <a:t>1085 min</a:t>
-                      </a:r>
-                      <a:endParaRPr lang="en-US" sz="1200" dirty="0">
-                        <a:latin typeface="Calibri" charset="0"/>
-                        <a:ea typeface="Calibri" charset="0"/>
-                        <a:cs typeface="Calibri" charset="0"/>
-                      </a:endParaRPr>
-                    </a:p>
-                  </a:txBody>
-                  <a:tcPr marL="91440" marR="91440" marT="45720" marB="45720" anchor="ctr">
-                    <a:lnL w="12700" cap="flat" cmpd="sng" algn="ctr">
-                      <a:solidFill>
-                        <a:srgbClr val="D8DEEC"/>
-                      </a:solidFill>
-                      <a:prstDash val="solid"/>
-                      <a:round/>
-                      <a:headEnd type="none" w="med" len="med"/>
-                      <a:tailEnd type="none" w="med" len="med"/>
-                    </a:lnL>
-                    <a:lnR w="12700" cap="flat" cmpd="sng" algn="ctr">
-                      <a:solidFill>
-                        <a:srgbClr val="D8DEEC"/>
-                      </a:solidFill>
-                      <a:prstDash val="solid"/>
-                      <a:round/>
-                      <a:headEnd type="none" w="med" len="med"/>
-                      <a:tailEnd type="none" w="med" len="med"/>
-                    </a:lnR>
-                    <a:lnT w="12700" cap="flat" cmpd="sng" algn="ctr">
-                      <a:solidFill>
-                        <a:srgbClr val="D8DEEC"/>
-                      </a:solidFill>
-                      <a:prstDash val="solid"/>
-                      <a:round/>
-                      <a:headEnd type="none" w="med" len="med"/>
-                      <a:tailEnd type="none" w="med" len="med"/>
-                    </a:lnT>
-                    <a:lnB w="12700" cap="flat" cmpd="sng" algn="ctr">
-                      <a:solidFill>
-                        <a:srgbClr val="D8DEEC"/>
-                      </a:solidFill>
-                      <a:prstDash val="solid"/>
-                      <a:round/>
-                      <a:headEnd type="none" w="med" len="med"/>
-                      <a:tailEnd type="none" w="med" len="med"/>
-                    </a:lnB>
-                  </a:tcPr>
-                </a:tc>
-                <a:tc>
-                  <a:txBody>
-                    <a:bodyPr/>
-                    <a:lstStyle/>
-                    <a:p>
-                      <a:pPr indent="0" marL="0">
-                        <a:buNone/>
-                      </a:pPr>
-                      <a:r>
-                        <a:rPr lang="en-US" sz="1200" dirty="0">
-                          <a:solidFill>
-                            <a:srgbClr val="1A1A2E"/>
-                          </a:solidFill>
-                          <a:latin typeface="Calibri" pitchFamily="34" charset="0"/>
-                          <a:ea typeface="Calibri" pitchFamily="34" charset="-122"/>
-                          <a:cs typeface="Calibri" pitchFamily="34" charset="-120"/>
-                        </a:rPr>
-                        <a:t>no_cover 0.96</a:t>
-                      </a:r>
-                      <a:endParaRPr lang="en-US" sz="1200" dirty="0">
-                        <a:latin typeface="Calibri" charset="0"/>
-                        <a:ea typeface="Calibri" charset="0"/>
-                        <a:cs typeface="Calibri" charset="0"/>
-                      </a:endParaRPr>
-                    </a:p>
-                  </a:txBody>
-                  <a:tcPr marL="91440" marR="91440" marT="45720" marB="45720" anchor="ctr">
-                    <a:lnL w="12700" cap="flat" cmpd="sng" algn="ctr">
-                      <a:solidFill>
-                        <a:srgbClr val="D8DEEC"/>
-                      </a:solidFill>
-                      <a:prstDash val="solid"/>
-                      <a:round/>
-                      <a:headEnd type="none" w="med" len="med"/>
-                      <a:tailEnd type="none" w="med" len="med"/>
-                    </a:lnL>
-                    <a:lnR w="12700" cap="flat" cmpd="sng" algn="ctr">
-                      <a:solidFill>
-                        <a:srgbClr val="D8DEEC"/>
-                      </a:solidFill>
-                      <a:prstDash val="solid"/>
-                      <a:round/>
-                      <a:headEnd type="none" w="med" len="med"/>
-                      <a:tailEnd type="none" w="med" len="med"/>
-                    </a:lnR>
-                    <a:lnT w="12700" cap="flat" cmpd="sng" algn="ctr">
-                      <a:solidFill>
-                        <a:srgbClr val="D8DEEC"/>
-                      </a:solidFill>
-                      <a:prstDash val="solid"/>
-                      <a:round/>
-                      <a:headEnd type="none" w="med" len="med"/>
-                      <a:tailEnd type="none" w="med" len="med"/>
-                    </a:lnT>
-                    <a:lnB w="12700" cap="flat" cmpd="sng" algn="ctr">
-                      <a:solidFill>
-                        <a:srgbClr val="D8DEEC"/>
-                      </a:solidFill>
-                      <a:prstDash val="solid"/>
-                      <a:round/>
-                      <a:headEnd type="none" w="med" len="med"/>
-                      <a:tailEnd type="none" w="med" len="med"/>
-                    </a:lnB>
-                  </a:tcPr>
-                </a:tc>
-              </a:tr>
-              <a:tr h="502920">
-                <a:tc>
-                  <a:txBody>
-                    <a:bodyPr/>
-                    <a:lstStyle/>
-                    <a:p>
-                      <a:pPr indent="0" marL="0">
-                        <a:buNone/>
-                      </a:pPr>
-                      <a:r>
-                        <a:rPr lang="en-US" sz="1200" dirty="0">
-                          <a:solidFill>
-                            <a:srgbClr val="1A1A2E"/>
-                          </a:solidFill>
-                          <a:latin typeface="Calibri" pitchFamily="34" charset="0"/>
-                          <a:ea typeface="Calibri" pitchFamily="34" charset="-122"/>
-                          <a:cs typeface="Calibri" pitchFamily="34" charset="-120"/>
-                        </a:rPr>
-                        <a:t>3,774 INR</a:t>
-                      </a:r>
-                      <a:endParaRPr lang="en-US" sz="1200" dirty="0">
-                        <a:latin typeface="Calibri" charset="0"/>
-                        <a:ea typeface="Calibri" charset="0"/>
-                        <a:cs typeface="Calibri" charset="0"/>
-                      </a:endParaRPr>
-                    </a:p>
-                  </a:txBody>
-                  <a:tcPr marL="91440" marR="91440" marT="45720" marB="45720" anchor="ctr">
-                    <a:lnL w="12700" cap="flat" cmpd="sng" algn="ctr">
-                      <a:solidFill>
-                        <a:srgbClr val="D8DEEC"/>
-                      </a:solidFill>
-                      <a:prstDash val="solid"/>
-                      <a:round/>
-                      <a:headEnd type="none" w="med" len="med"/>
-                      <a:tailEnd type="none" w="med" len="med"/>
-                    </a:lnL>
-                    <a:lnR w="12700" cap="flat" cmpd="sng" algn="ctr">
-                      <a:solidFill>
-                        <a:srgbClr val="D8DEEC"/>
-                      </a:solidFill>
-                      <a:prstDash val="solid"/>
-                      <a:round/>
-                      <a:headEnd type="none" w="med" len="med"/>
-                      <a:tailEnd type="none" w="med" len="med"/>
-                    </a:lnR>
-                    <a:lnT w="12700" cap="flat" cmpd="sng" algn="ctr">
-                      <a:solidFill>
-                        <a:srgbClr val="D8DEEC"/>
-                      </a:solidFill>
-                      <a:prstDash val="solid"/>
-                      <a:round/>
-                      <a:headEnd type="none" w="med" len="med"/>
-                      <a:tailEnd type="none" w="med" len="med"/>
-                    </a:lnT>
-                    <a:lnB w="12700" cap="flat" cmpd="sng" algn="ctr">
-                      <a:solidFill>
-                        <a:srgbClr val="D8DEEC"/>
-                      </a:solidFill>
-                      <a:prstDash val="solid"/>
-                      <a:round/>
-                      <a:headEnd type="none" w="med" len="med"/>
-                      <a:tailEnd type="none" w="med" len="med"/>
-                    </a:lnB>
-                  </a:tcPr>
-                </a:tc>
-                <a:tc>
-                  <a:txBody>
-                    <a:bodyPr/>
-                    <a:lstStyle/>
-                    <a:p>
-                      <a:pPr indent="0" marL="0">
-                        <a:buNone/>
-                      </a:pPr>
-                      <a:r>
-                        <a:rPr lang="en-US" sz="1200" dirty="0">
-                          <a:solidFill>
-                            <a:srgbClr val="1A1A2E"/>
-                          </a:solidFill>
-                          <a:latin typeface="Calibri" pitchFamily="34" charset="0"/>
-                          <a:ea typeface="Calibri" pitchFamily="34" charset="-122"/>
-                          <a:cs typeface="Calibri" pitchFamily="34" charset="-120"/>
-                        </a:rPr>
-                        <a:t>domestic</a:t>
-                      </a:r>
-                      <a:endParaRPr lang="en-US" sz="1200" dirty="0">
-                        <a:latin typeface="Calibri" charset="0"/>
-                        <a:ea typeface="Calibri" charset="0"/>
-                        <a:cs typeface="Calibri" charset="0"/>
-                      </a:endParaRPr>
-                    </a:p>
-                  </a:txBody>
-                  <a:tcPr marL="91440" marR="91440" marT="45720" marB="45720" anchor="ctr">
-                    <a:lnL w="12700" cap="flat" cmpd="sng" algn="ctr">
-                      <a:solidFill>
-                        <a:srgbClr val="D8DEEC"/>
-                      </a:solidFill>
-                      <a:prstDash val="solid"/>
-                      <a:round/>
-                      <a:headEnd type="none" w="med" len="med"/>
-                      <a:tailEnd type="none" w="med" len="med"/>
-                    </a:lnL>
-                    <a:lnR w="12700" cap="flat" cmpd="sng" algn="ctr">
-                      <a:solidFill>
-                        <a:srgbClr val="D8DEEC"/>
-                      </a:solidFill>
-                      <a:prstDash val="solid"/>
-                      <a:round/>
-                      <a:headEnd type="none" w="med" len="med"/>
-                      <a:tailEnd type="none" w="med" len="med"/>
-                    </a:lnR>
-                    <a:lnT w="12700" cap="flat" cmpd="sng" algn="ctr">
-                      <a:solidFill>
-                        <a:srgbClr val="D8DEEC"/>
-                      </a:solidFill>
-                      <a:prstDash val="solid"/>
-                      <a:round/>
-                      <a:headEnd type="none" w="med" len="med"/>
-                      <a:tailEnd type="none" w="med" len="med"/>
-                    </a:lnT>
-                    <a:lnB w="12700" cap="flat" cmpd="sng" algn="ctr">
-                      <a:solidFill>
-                        <a:srgbClr val="D8DEEC"/>
-                      </a:solidFill>
-                      <a:prstDash val="solid"/>
-                      <a:round/>
-                      <a:headEnd type="none" w="med" len="med"/>
-                      <a:tailEnd type="none" w="med" len="med"/>
-                    </a:lnB>
-                  </a:tcPr>
-                </a:tc>
-                <a:tc>
-                  <a:txBody>
-                    <a:bodyPr/>
-                    <a:lstStyle/>
-                    <a:p>
-                      <a:pPr indent="0" marL="0">
-                        <a:buNone/>
-                      </a:pPr>
-                      <a:r>
-                        <a:rPr lang="en-US" sz="1200" dirty="0">
-                          <a:solidFill>
-                            <a:srgbClr val="1A1A2E"/>
-                          </a:solidFill>
-                          <a:latin typeface="Calibri" pitchFamily="34" charset="0"/>
-                          <a:ea typeface="Calibri" pitchFamily="34" charset="-122"/>
-                          <a:cs typeface="Calibri" pitchFamily="34" charset="-120"/>
-                        </a:rPr>
-                        <a:t>RTGS</a:t>
-                      </a:r>
-                      <a:endParaRPr lang="en-US" sz="1200" dirty="0">
-                        <a:latin typeface="Calibri" charset="0"/>
-                        <a:ea typeface="Calibri" charset="0"/>
-                        <a:cs typeface="Calibri" charset="0"/>
-                      </a:endParaRPr>
-                    </a:p>
-                  </a:txBody>
-                  <a:tcPr marL="91440" marR="91440" marT="45720" marB="45720" anchor="ctr">
-                    <a:lnL w="12700" cap="flat" cmpd="sng" algn="ctr">
-                      <a:solidFill>
-                        <a:srgbClr val="D8DEEC"/>
-                      </a:solidFill>
-                      <a:prstDash val="solid"/>
-                      <a:round/>
-                      <a:headEnd type="none" w="med" len="med"/>
-                      <a:tailEnd type="none" w="med" len="med"/>
-                    </a:lnL>
-                    <a:lnR w="12700" cap="flat" cmpd="sng" algn="ctr">
-                      <a:solidFill>
-                        <a:srgbClr val="D8DEEC"/>
-                      </a:solidFill>
-                      <a:prstDash val="solid"/>
-                      <a:round/>
-                      <a:headEnd type="none" w="med" len="med"/>
-                      <a:tailEnd type="none" w="med" len="med"/>
-                    </a:lnR>
-                    <a:lnT w="12700" cap="flat" cmpd="sng" algn="ctr">
-                      <a:solidFill>
-                        <a:srgbClr val="D8DEEC"/>
-                      </a:solidFill>
-                      <a:prstDash val="solid"/>
-                      <a:round/>
-                      <a:headEnd type="none" w="med" len="med"/>
-                      <a:tailEnd type="none" w="med" len="med"/>
-                    </a:lnT>
-                    <a:lnB w="12700" cap="flat" cmpd="sng" algn="ctr">
-                      <a:solidFill>
-                        <a:srgbClr val="D8DEEC"/>
-                      </a:solidFill>
-                      <a:prstDash val="solid"/>
-                      <a:round/>
-                      <a:headEnd type="none" w="med" len="med"/>
-                      <a:tailEnd type="none" w="med" len="med"/>
-                    </a:lnB>
-                  </a:tcPr>
-                </a:tc>
-                <a:tc>
-                  <a:txBody>
-                    <a:bodyPr/>
-                    <a:lstStyle/>
-                    <a:p>
-                      <a:pPr indent="0" marL="0">
-                        <a:buNone/>
-                      </a:pPr>
-                      <a:r>
-                        <a:rPr lang="en-US" sz="1200" dirty="0">
-                          <a:solidFill>
-                            <a:srgbClr val="C98A00"/>
-                          </a:solidFill>
-                          <a:latin typeface="Calibri" pitchFamily="34" charset="0"/>
-                          <a:ea typeface="Calibri" pitchFamily="34" charset="-122"/>
-                          <a:cs typeface="Calibri" pitchFamily="34" charset="-120"/>
-                        </a:rPr>
-                        <a:t>NEFT (0.65)</a:t>
-                      </a:r>
-                      <a:endParaRPr lang="en-US" sz="1200" dirty="0">
-                        <a:latin typeface="Calibri" charset="0"/>
-                        <a:ea typeface="Calibri" charset="0"/>
-                        <a:cs typeface="Calibri" charset="0"/>
-                      </a:endParaRPr>
-                    </a:p>
-                  </a:txBody>
-                  <a:tcPr marL="91440" marR="91440" marT="45720" marB="45720" anchor="ctr">
-                    <a:lnL w="12700" cap="flat" cmpd="sng" algn="ctr">
-                      <a:solidFill>
-                        <a:srgbClr val="D8DEEC"/>
-                      </a:solidFill>
-                      <a:prstDash val="solid"/>
-                      <a:round/>
-                      <a:headEnd type="none" w="med" len="med"/>
-                      <a:tailEnd type="none" w="med" len="med"/>
-                    </a:lnL>
-                    <a:lnR w="12700" cap="flat" cmpd="sng" algn="ctr">
-                      <a:solidFill>
-                        <a:srgbClr val="D8DEEC"/>
-                      </a:solidFill>
-                      <a:prstDash val="solid"/>
-                      <a:round/>
-                      <a:headEnd type="none" w="med" len="med"/>
-                      <a:tailEnd type="none" w="med" len="med"/>
-                    </a:lnR>
-                    <a:lnT w="12700" cap="flat" cmpd="sng" algn="ctr">
-                      <a:solidFill>
-                        <a:srgbClr val="D8DEEC"/>
-                      </a:solidFill>
-                      <a:prstDash val="solid"/>
-                      <a:round/>
-                      <a:headEnd type="none" w="med" len="med"/>
-                      <a:tailEnd type="none" w="med" len="med"/>
-                    </a:lnT>
-                    <a:lnB w="12700" cap="flat" cmpd="sng" algn="ctr">
-                      <a:solidFill>
-                        <a:srgbClr val="D8DEEC"/>
-                      </a:solidFill>
-                      <a:prstDash val="solid"/>
-                      <a:round/>
-                      <a:headEnd type="none" w="med" len="med"/>
-                      <a:tailEnd type="none" w="med" len="med"/>
-                    </a:lnB>
-                  </a:tcPr>
-                </a:tc>
-                <a:tc>
-                  <a:txBody>
-                    <a:bodyPr/>
-                    <a:lstStyle/>
-                    <a:p>
-                      <a:pPr indent="0" marL="0">
-                        <a:buNone/>
-                      </a:pPr>
-                      <a:r>
-                        <a:rPr lang="en-US" sz="1200" dirty="0">
-                          <a:solidFill>
-                            <a:srgbClr val="1A1A2E"/>
-                          </a:solidFill>
-                          <a:latin typeface="Calibri" pitchFamily="34" charset="0"/>
-                          <a:ea typeface="Calibri" pitchFamily="34" charset="-122"/>
-                          <a:cs typeface="Calibri" pitchFamily="34" charset="-120"/>
-                        </a:rPr>
-                        <a:t>STP</a:t>
-                      </a:r>
-                      <a:endParaRPr lang="en-US" sz="1200" dirty="0">
-                        <a:latin typeface="Calibri" charset="0"/>
-                        <a:ea typeface="Calibri" charset="0"/>
-                        <a:cs typeface="Calibri" charset="0"/>
-                      </a:endParaRPr>
-                    </a:p>
-                  </a:txBody>
-                  <a:tcPr marL="91440" marR="91440" marT="45720" marB="45720" anchor="ctr">
-                    <a:lnL w="12700" cap="flat" cmpd="sng" algn="ctr">
-                      <a:solidFill>
-                        <a:srgbClr val="D8DEEC"/>
-                      </a:solidFill>
-                      <a:prstDash val="solid"/>
-                      <a:round/>
-                      <a:headEnd type="none" w="med" len="med"/>
-                      <a:tailEnd type="none" w="med" len="med"/>
-                    </a:lnL>
-                    <a:lnR w="12700" cap="flat" cmpd="sng" algn="ctr">
-                      <a:solidFill>
-                        <a:srgbClr val="D8DEEC"/>
-                      </a:solidFill>
-                      <a:prstDash val="solid"/>
-                      <a:round/>
-                      <a:headEnd type="none" w="med" len="med"/>
-                      <a:tailEnd type="none" w="med" len="med"/>
-                    </a:lnR>
-                    <a:lnT w="12700" cap="flat" cmpd="sng" algn="ctr">
-                      <a:solidFill>
-                        <a:srgbClr val="D8DEEC"/>
-                      </a:solidFill>
-                      <a:prstDash val="solid"/>
-                      <a:round/>
-                      <a:headEnd type="none" w="med" len="med"/>
-                      <a:tailEnd type="none" w="med" len="med"/>
-                    </a:lnT>
-                    <a:lnB w="12700" cap="flat" cmpd="sng" algn="ctr">
-                      <a:solidFill>
-                        <a:srgbClr val="D8DEEC"/>
-                      </a:solidFill>
-                      <a:prstDash val="solid"/>
-                      <a:round/>
-                      <a:headEnd type="none" w="med" len="med"/>
-                      <a:tailEnd type="none" w="med" len="med"/>
-                    </a:lnB>
-                  </a:tcPr>
-                </a:tc>
-                <a:tc>
-                  <a:txBody>
-                    <a:bodyPr/>
-                    <a:lstStyle/>
-                    <a:p>
-                      <a:pPr indent="0" marL="0">
-                        <a:buNone/>
-                      </a:pPr>
-                      <a:r>
-                        <a:rPr lang="en-US" sz="1200" dirty="0">
-                          <a:solidFill>
-                            <a:srgbClr val="1A1A2E"/>
-                          </a:solidFill>
-                          <a:latin typeface="Calibri" pitchFamily="34" charset="0"/>
-                          <a:ea typeface="Calibri" pitchFamily="34" charset="-122"/>
-                          <a:cs typeface="Calibri" pitchFamily="34" charset="-120"/>
-                        </a:rPr>
-                        <a:t>65 min</a:t>
-                      </a:r>
-                      <a:endParaRPr lang="en-US" sz="1200" dirty="0">
-                        <a:latin typeface="Calibri" charset="0"/>
-                        <a:ea typeface="Calibri" charset="0"/>
-                        <a:cs typeface="Calibri" charset="0"/>
-                      </a:endParaRPr>
-                    </a:p>
-                  </a:txBody>
-                  <a:tcPr marL="91440" marR="91440" marT="45720" marB="45720" anchor="ctr">
-                    <a:lnL w="12700" cap="flat" cmpd="sng" algn="ctr">
-                      <a:solidFill>
-                        <a:srgbClr val="D8DEEC"/>
-                      </a:solidFill>
-                      <a:prstDash val="solid"/>
-                      <a:round/>
-                      <a:headEnd type="none" w="med" len="med"/>
-                      <a:tailEnd type="none" w="med" len="med"/>
-                    </a:lnL>
-                    <a:lnR w="12700" cap="flat" cmpd="sng" algn="ctr">
-                      <a:solidFill>
-                        <a:srgbClr val="D8DEEC"/>
-                      </a:solidFill>
-                      <a:prstDash val="solid"/>
-                      <a:round/>
-                      <a:headEnd type="none" w="med" len="med"/>
-                      <a:tailEnd type="none" w="med" len="med"/>
-                    </a:lnR>
-                    <a:lnT w="12700" cap="flat" cmpd="sng" algn="ctr">
-                      <a:solidFill>
-                        <a:srgbClr val="D8DEEC"/>
-                      </a:solidFill>
-                      <a:prstDash val="solid"/>
-                      <a:round/>
-                      <a:headEnd type="none" w="med" len="med"/>
-                      <a:tailEnd type="none" w="med" len="med"/>
-                    </a:lnT>
-                    <a:lnB w="12700" cap="flat" cmpd="sng" algn="ctr">
-                      <a:solidFill>
-                        <a:srgbClr val="D8DEEC"/>
-                      </a:solidFill>
-                      <a:prstDash val="solid"/>
-                      <a:round/>
-                      <a:headEnd type="none" w="med" len="med"/>
-                      <a:tailEnd type="none" w="med" len="med"/>
-                    </a:lnB>
-                  </a:tcPr>
-                </a:tc>
-                <a:tc>
-                  <a:txBody>
-                    <a:bodyPr/>
-                    <a:lstStyle/>
-                    <a:p>
-                      <a:pPr indent="0" marL="0">
-                        <a:buNone/>
-                      </a:pPr>
-                      <a:r>
-                        <a:rPr lang="en-US" sz="1200" dirty="0">
-                          <a:solidFill>
-                            <a:srgbClr val="1A1A2E"/>
-                          </a:solidFill>
-                          <a:latin typeface="Calibri" pitchFamily="34" charset="0"/>
-                          <a:ea typeface="Calibri" pitchFamily="34" charset="-122"/>
-                          <a:cs typeface="Calibri" pitchFamily="34" charset="-120"/>
-                        </a:rPr>
-                        <a:t>batch_return 0.80</a:t>
-                      </a:r>
-                      <a:endParaRPr lang="en-US" sz="1200" dirty="0">
-                        <a:latin typeface="Calibri" charset="0"/>
-                        <a:ea typeface="Calibri" charset="0"/>
-                        <a:cs typeface="Calibri" charset="0"/>
-                      </a:endParaRPr>
-                    </a:p>
-                  </a:txBody>
-                  <a:tcPr marL="91440" marR="91440" marT="45720" marB="45720" anchor="ctr">
-                    <a:lnL w="12700" cap="flat" cmpd="sng" algn="ctr">
-                      <a:solidFill>
-                        <a:srgbClr val="D8DEEC"/>
-                      </a:solidFill>
-                      <a:prstDash val="solid"/>
-                      <a:round/>
-                      <a:headEnd type="none" w="med" len="med"/>
-                      <a:tailEnd type="none" w="med" len="med"/>
-                    </a:lnL>
-                    <a:lnR w="12700" cap="flat" cmpd="sng" algn="ctr">
-                      <a:solidFill>
-                        <a:srgbClr val="D8DEEC"/>
-                      </a:solidFill>
-                      <a:prstDash val="solid"/>
-                      <a:round/>
-                      <a:headEnd type="none" w="med" len="med"/>
-                      <a:tailEnd type="none" w="med" len="med"/>
-                    </a:lnR>
-                    <a:lnT w="12700" cap="flat" cmpd="sng" algn="ctr">
-                      <a:solidFill>
-                        <a:srgbClr val="D8DEEC"/>
-                      </a:solidFill>
-                      <a:prstDash val="solid"/>
-                      <a:round/>
-                      <a:headEnd type="none" w="med" len="med"/>
-                      <a:tailEnd type="none" w="med" len="med"/>
-                    </a:lnT>
-                    <a:lnB w="12700" cap="flat" cmpd="sng" algn="ctr">
-                      <a:solidFill>
-                        <a:srgbClr val="D8DEEC"/>
-                      </a:solidFill>
-                      <a:prstDash val="solid"/>
-                      <a:round/>
-                      <a:headEnd type="none" w="med" len="med"/>
-                      <a:tailEnd type="none" w="med" len="med"/>
-                    </a:lnB>
-                  </a:tcPr>
-                </a:tc>
-              </a:tr>
             </a:tbl>
           </a:graphicData>
         </a:graphic>
@@ -5153,7 +5153,7 @@
                 <a:ea typeface="Calibri" pitchFamily="34" charset="-122"/>
                 <a:cs typeface="Calibri" pitchFamily="34" charset="-120"/>
               </a:rPr>
-              <a:t>Green = predicted rail matches truth. The two ambers are honest overlap cases: 285,371 is eligible for both NEFT and RTGS; the 3,774 'RTGS' is a mis-routed intake (below the ₹2L floor) — NEFT is the correct rail.</a:t>
+              <a:t>Green = predicted rail matches truth; ✓ = predicted outcome matched too. Ambers are honest: the 7,796 'RTGS *' arrived mis-routed (below the ₹2L floor) — the model re-routes it AND correctly predicts the reject; 13,137 is genuine IMPS/NEFT overlap (both eligible).</a:t>
             </a:r>
             <a:endParaRPr lang="en-US" sz="1200" dirty="0"/>
           </a:p>
@@ -5168,7 +5168,7 @@
         <p:spPr>
           <a:xfrm>
             <a:off x="457200" y="5532120"/>
-            <a:ext cx="11274552" cy="365760"/>
+            <a:ext cx="11274552" cy="457200"/>
           </a:xfrm>
           <a:prstGeom prst="rect">
             <a:avLst/>
@@ -5184,7 +5184,7 @@
               <a:buNone/>
             </a:pPr>
             <a:r>
-              <a:rPr lang="en-US" sz="1300" b="1" dirty="0">
+              <a:rPr lang="en-US" sz="1250" b="1" dirty="0">
                 <a:solidFill>
                   <a:srgbClr val="1E2761"/>
                 </a:solidFill>
@@ -5192,9 +5192,9 @@
                 <a:ea typeface="Calibri" pitchFamily="34" charset="-122"/>
                 <a:cs typeface="Calibri" pitchFamily="34" charset="-120"/>
               </a:rPr>
-              <a:t>Held-out 100 overall:  rail 0.77  ·  risk 0.77  ·  ETA MAE 181 min  ·  terminal status 0.24 (weak).</a:t>
-            </a:r>
-            <a:endParaRPr lang="en-US" sz="1300" dirty="0"/>
+              <a:t>This fresh 100 (known accounts, new payments):  rail 0.59 — 0.64 on cleanly-routed  ·  risk 0.53  ·  status 0.31.  Stable eval (n=4,000): rail 0.55 vs tree 0.64  ·  ETA 199 vs 392 naive.</a:t>
+            </a:r>
+            <a:endParaRPr lang="en-US" sz="1250" dirty="0"/>
           </a:p>
         </p:txBody>
       </p:sp>
@@ -5341,7 +5341,7 @@
                 <a:ea typeface="Calibri" pitchFamily="34" charset="-122"/>
                 <a:cs typeface="Calibri" pitchFamily="34" charset="-120"/>
               </a:rPr>
-              <a:t>165 automated tests green · reproducible · independently code-reviewed</a:t>
+              <a:t>183 automated tests green · reproducible · independently code-reviewed</a:t>
             </a:r>
             <a:endParaRPr lang="en-US" sz="1500" dirty="0"/>
           </a:p>
@@ -5419,7 +5419,7 @@
                 <a:ea typeface="Calibri" pitchFamily="34" charset="-122"/>
                 <a:cs typeface="Calibri" pitchFamily="34" charset="-120"/>
               </a:rPr>
-              <a:t>value caps, settlement-time tiers, rail eligibility — caught reliably</a:t>
+              <a:t>ETA &amp; charges from the payment itself · in-flight calls from partial (pain.001) data · timing/sequence signals</a:t>
             </a:r>
             <a:endParaRPr lang="en-US" sz="1500" dirty="0"/>
           </a:p>
@@ -5497,7 +5497,7 @@
                 <a:ea typeface="Calibri" pitchFamily="34" charset="-122"/>
                 <a:cs typeface="Calibri" pitchFamily="34" charset="-120"/>
               </a:rPr>
-              <a:t>plain rule-based risk scoring on visible fields — we report this openly</a:t>
+              <a:t>plain feature-rule scoring on complete records — we report this openly and route caps/floors to guards, not guesses</a:t>
             </a:r>
             <a:endParaRPr lang="en-US" sz="1500" dirty="0"/>
           </a:p>
@@ -6500,7 +6500,7 @@
                 <a:ea typeface="Calibri" pitchFamily="34" charset="-122"/>
                 <a:cs typeface="Calibri" pitchFamily="34" charset="-120"/>
               </a:rPr>
-              <a:t>IMPS or NEFT — not UPI (over its ₹1L cap)</a:t>
+              <a:t>IMPS or NEFT — amount-band choice</a:t>
             </a:r>
             <a:endParaRPr lang="en-US" sz="1350" dirty="0"/>
           </a:p>
@@ -6539,7 +6539,7 @@
                 <a:ea typeface="Calibri" pitchFamily="34" charset="-122"/>
                 <a:cs typeface="Calibri" pitchFamily="34" charset="-120"/>
               </a:rPr>
-              <a:t>Avoid a guaranteed reject; pick the fastest valid rail</a:t>
+              <a:t>Fastest valid rail, no cap breach, no guesswork</a:t>
             </a:r>
             <a:endParaRPr lang="en-US" sz="1200" dirty="0"/>
           </a:p>
@@ -7168,7 +7168,7 @@
                 <a:ea typeface="Calibri" pitchFamily="34" charset="-122"/>
                 <a:cs typeface="Calibri" pitchFamily="34" charset="-120"/>
               </a:rPr>
-              <a:t>₹1.5 lakh sent via UPI</a:t>
+              <a:t>₹7.5 lakh attempted via IMPS</a:t>
             </a:r>
             <a:endParaRPr lang="en-US" sz="1300" dirty="0"/>
           </a:p>
@@ -7231,7 +7231,7 @@
                 <a:ea typeface="Calibri" pitchFamily="34" charset="-122"/>
                 <a:cs typeface="Calibri" pitchFamily="34" charset="-120"/>
               </a:rPr>
-              <a:t>Will breach the ₹1L UPI cap → reject</a:t>
+              <a:t>Breaches the ₹5L IMPS cap → guaranteed reject</a:t>
             </a:r>
             <a:endParaRPr lang="en-US" sz="1350" dirty="0"/>
           </a:p>
@@ -7270,7 +7270,7 @@
                 <a:ea typeface="Calibri" pitchFamily="34" charset="-122"/>
                 <a:cs typeface="Calibri" pitchFamily="34" charset="-120"/>
               </a:rPr>
-              <a:t>Warn &amp; reroute pre-submission  (cap-breach detection: PR-AUC 0.55)</a:t>
+              <a:t>Deterministic intake guard — blocked before submission, right tool not guesswork</a:t>
             </a:r>
             <a:endParaRPr lang="en-US" sz="1200" dirty="0"/>
           </a:p>
@@ -7606,7 +7606,7 @@
                 <a:ea typeface="Calibri" pitchFamily="34" charset="-122"/>
                 <a:cs typeface="Calibri" pitchFamily="34" charset="-120"/>
               </a:rPr>
-              <a:t>Pre-empt the timeout; set retry/fallback</a:t>
+              <a:t>Model pre-empts the timeout; set retry / fallback</a:t>
             </a:r>
             <a:endParaRPr lang="en-US" sz="1200" dirty="0"/>
           </a:p>
@@ -7899,7 +7899,7 @@
                 <a:ea typeface="Calibri" pitchFamily="34" charset="-122"/>
                 <a:cs typeface="Calibri" pitchFamily="34" charset="-120"/>
               </a:rPr>
-              <a:t>UPI / IMPS payment</a:t>
+              <a:t>IMPS payment</a:t>
             </a:r>
             <a:endParaRPr lang="en-US" sz="1300" dirty="0"/>
           </a:p>
@@ -8376,7 +8376,7 @@
                 <a:ea typeface="Calibri" pitchFamily="34" charset="-122"/>
                 <a:cs typeface="Calibri" pitchFamily="34" charset="-120"/>
               </a:rPr>
-              <a:t>Measured: ETA error 207 min vs a 400-min naive baseline — the model learns each rail's settlement tier.</a:t>
+              <a:t>Measured (held-out): ETA error 184 min vs a 232-min naive baseline — available at initiation (pain.001), before clearing.</a:t>
             </a:r>
             <a:endParaRPr lang="en-US" sz="1200" dirty="0"/>
           </a:p>
@@ -9877,7 +9877,7 @@
                 <a:ea typeface="Calibri" pitchFamily="34" charset="-122"/>
                 <a:cs typeface="Calibri" pitchFamily="34" charset="-120"/>
               </a:rPr>
-              <a:t>Same model scores a payment both at intake and mid-workflow — reactive ops become proactive.</a:t>
+              <a:t>Measured: 'will it credit?' sharpens 0.84 → 0.87 as messages arrive (pain.001 → pacs.008) — plus recall (camt.056) &amp; return (pacs.004) legs modeled end-to-end.</a:t>
             </a:r>
             <a:endParaRPr lang="en-US" sz="1200" dirty="0"/>
           </a:p>
@@ -10716,7 +10716,139 @@
       </p:sp>
       <p:sp>
         <p:nvSpPr>
-          <p:cNvPr id="26" name="Text 24"/>
+          <p:cNvPr id="26" name="Shape 24"/>
+          <p:cNvSpPr/>
+          <p:nvPr/>
+        </p:nvSpPr>
+        <p:spPr>
+          <a:xfrm>
+            <a:off x="6309360" y="4334256"/>
+            <a:ext cx="2560320" cy="640080"/>
+          </a:xfrm>
+          <a:prstGeom prst="roundRect">
+            <a:avLst>
+              <a:gd name="adj" fmla="val 11429"/>
+            </a:avLst>
+          </a:prstGeom>
+          <a:solidFill>
+            <a:srgbClr val="F2F5FC"/>
+          </a:solidFill>
+          <a:ln w="12700">
+            <a:solidFill>
+              <a:srgbClr val="F2F5FC"/>
+            </a:solidFill>
+            <a:prstDash val="solid"/>
+          </a:ln>
+        </p:spPr>
+      </p:sp>
+      <p:sp>
+        <p:nvSpPr>
+          <p:cNvPr id="27" name="Text 25"/>
+          <p:cNvSpPr/>
+          <p:nvPr/>
+        </p:nvSpPr>
+        <p:spPr>
+          <a:xfrm>
+            <a:off x="6355080" y="4334256"/>
+            <a:ext cx="2468880" cy="640080"/>
+          </a:xfrm>
+          <a:prstGeom prst="rect">
+            <a:avLst/>
+          </a:prstGeom>
+          <a:noFill/>
+          <a:ln/>
+        </p:spPr>
+        <p:txBody>
+          <a:bodyPr wrap="square" rtlCol="0" anchor="ctr"/>
+          <a:lstStyle/>
+          <a:p>
+            <a:pPr algn="ctr" indent="0" marL="0">
+              <a:buNone/>
+            </a:pPr>
+            <a:r>
+              <a:rPr lang="en-US" sz="1250" b="1" dirty="0">
+                <a:solidFill>
+                  <a:srgbClr val="1E2761"/>
+                </a:solidFill>
+                <a:latin typeface="Calibri" pitchFamily="34" charset="0"/>
+                <a:ea typeface="Calibri" pitchFamily="34" charset="-122"/>
+                <a:cs typeface="Calibri" pitchFamily="34" charset="-120"/>
+              </a:rPr>
+              <a:t>charges estimate</a:t>
+            </a:r>
+            <a:endParaRPr lang="en-US" sz="1250" dirty="0"/>
+          </a:p>
+        </p:txBody>
+      </p:sp>
+      <p:sp>
+        <p:nvSpPr>
+          <p:cNvPr id="28" name="Shape 26"/>
+          <p:cNvSpPr/>
+          <p:nvPr/>
+        </p:nvSpPr>
+        <p:spPr>
+          <a:xfrm>
+            <a:off x="9052560" y="4334256"/>
+            <a:ext cx="2560320" cy="640080"/>
+          </a:xfrm>
+          <a:prstGeom prst="roundRect">
+            <a:avLst>
+              <a:gd name="adj" fmla="val 11429"/>
+            </a:avLst>
+          </a:prstGeom>
+          <a:solidFill>
+            <a:srgbClr val="F2F5FC"/>
+          </a:solidFill>
+          <a:ln w="12700">
+            <a:solidFill>
+              <a:srgbClr val="F2F5FC"/>
+            </a:solidFill>
+            <a:prstDash val="solid"/>
+          </a:ln>
+        </p:spPr>
+      </p:sp>
+      <p:sp>
+        <p:nvSpPr>
+          <p:cNvPr id="29" name="Text 27"/>
+          <p:cNvSpPr/>
+          <p:nvPr/>
+        </p:nvSpPr>
+        <p:spPr>
+          <a:xfrm>
+            <a:off x="9098280" y="4334256"/>
+            <a:ext cx="2468880" cy="640080"/>
+          </a:xfrm>
+          <a:prstGeom prst="rect">
+            <a:avLst/>
+          </a:prstGeom>
+          <a:noFill/>
+          <a:ln/>
+        </p:spPr>
+        <p:txBody>
+          <a:bodyPr wrap="square" rtlCol="0" anchor="ctr"/>
+          <a:lstStyle/>
+          <a:p>
+            <a:pPr algn="ctr" indent="0" marL="0">
+              <a:buNone/>
+            </a:pPr>
+            <a:r>
+              <a:rPr lang="en-US" sz="1250" b="1" dirty="0">
+                <a:solidFill>
+                  <a:srgbClr val="1E2761"/>
+                </a:solidFill>
+                <a:latin typeface="Calibri" pitchFamily="34" charset="0"/>
+                <a:ea typeface="Calibri" pitchFamily="34" charset="-122"/>
+                <a:cs typeface="Calibri" pitchFamily="34" charset="-120"/>
+              </a:rPr>
+              <a:t>recall / return risk</a:t>
+            </a:r>
+            <a:endParaRPr lang="en-US" sz="1250" dirty="0"/>
+          </a:p>
+        </p:txBody>
+      </p:sp>
+      <p:sp>
+        <p:nvSpPr>
+          <p:cNvPr id="30" name="Text 28"/>
           <p:cNvSpPr/>
           <p:nvPr/>
         </p:nvSpPr>
@@ -11200,8 +11332,8 @@
         </p:nvSpPr>
         <p:spPr>
           <a:xfrm>
-            <a:off x="548640" y="3429000"/>
-            <a:ext cx="11064240" cy="457200"/>
+            <a:off x="548640" y="3383280"/>
+            <a:ext cx="11064240" cy="411480"/>
           </a:xfrm>
           <a:prstGeom prst="rect">
             <a:avLst/>
@@ -11217,7 +11349,7 @@
               <a:buNone/>
             </a:pPr>
             <a:r>
-              <a:rPr lang="en-US" sz="1400" b="1" dirty="0">
+              <a:rPr lang="en-US" sz="1300" b="1" dirty="0">
                 <a:solidFill>
                   <a:srgbClr val="1E2761"/>
                 </a:solidFill>
@@ -11225,9 +11357,9 @@
                 <a:ea typeface="Calibri" pitchFamily="34" charset="-122"/>
                 <a:cs typeface="Calibri" pitchFamily="34" charset="-120"/>
               </a:rPr>
-              <a:t>Held-out 100: rail routing 0.77  ·  risk 0.77  ·  ETA error 181 min  ·  terminal status 0.24 (weak)</a:t>
-            </a:r>
-            <a:endParaRPr lang="en-US" sz="1400" dirty="0"/>
+              <a:t>Held-out n=4,000: rail 0.55 probe vs 0.64 tree (4-class, harder without UPI)  ·  ETA 199 min vs 392 naive  ·  status 0.26 (weak — tree territory, reported openly)</a:t>
+            </a:r>
+            <a:endParaRPr lang="en-US" sz="1300" dirty="0"/>
           </a:p>
         </p:txBody>
       </p:sp>
@@ -11239,8 +11371,8 @@
         </p:nvSpPr>
         <p:spPr>
           <a:xfrm>
-            <a:off x="548640" y="3931920"/>
-            <a:ext cx="11064240" cy="457200"/>
+            <a:off x="548640" y="3886200"/>
+            <a:ext cx="11064240" cy="411480"/>
           </a:xfrm>
           <a:prstGeom prst="rect">
             <a:avLst/>
@@ -11256,15 +11388,15 @@
               <a:buNone/>
             </a:pPr>
             <a:r>
-              <a:rPr lang="en-US" sz="1300" dirty="0">
-                <a:solidFill>
-                  <a:srgbClr val="1A1A2E"/>
+              <a:rPr lang="en-US" sz="1300" b="1" dirty="0">
+                <a:solidFill>
+                  <a:srgbClr val="2E7D32"/>
                 </a:solidFill>
                 <a:latin typeface="Calibri" pitchFamily="34" charset="0"/>
                 <a:ea typeface="Calibri" pitchFamily="34" charset="-122"/>
                 <a:cs typeface="Calibri" pitchFamily="34" charset="-120"/>
               </a:rPr>
-              <a:t>Reproducible pipeline:  generate  →  train on CPU  →  persist model  →  predict from CSV.</a:t>
+              <a:t>At initiation (pain.001, before clearing): ETA 186 vs 232 naive  ·  charges MAE 97 vs 185  ·  'will it credit' 0.84 → 0.87 as messages arrive.</a:t>
             </a:r>
             <a:endParaRPr lang="en-US" sz="1300" dirty="0"/>
           </a:p>
@@ -11330,7 +11462,7 @@
                 <a:ea typeface="Calibri" pitchFamily="34" charset="-122"/>
                 <a:cs typeface="Calibri" pitchFamily="34" charset="-120"/>
               </a:rPr>
-              <a:t>+ velocity (burst) head</a:t>
+              <a:t>+ full ISO 20022 lifecycle modeled</a:t>
             </a:r>
             <a:endParaRPr lang="en-US" sz="1250" dirty="0"/>
           </a:p>
@@ -11396,7 +11528,7 @@
                 <a:ea typeface="Calibri" pitchFamily="34" charset="-122"/>
                 <a:cs typeface="Calibri" pitchFamily="34" charset="-120"/>
               </a:rPr>
-              <a:t>+ in-flight from partial pacs.008</a:t>
+              <a:t>+ recall &amp; return legs (camt.056/pacs.004)</a:t>
             </a:r>
             <a:endParaRPr lang="en-US" sz="1250" dirty="0"/>
           </a:p>
@@ -11462,7 +11594,7 @@
                 <a:ea typeface="Calibri" pitchFamily="34" charset="-122"/>
                 <a:cs typeface="Calibri" pitchFamily="34" charset="-120"/>
               </a:rPr>
-              <a:t>+ imputes missing early-stage fields</a:t>
+              <a:t>+ charges head · gpi tracker statuses</a:t>
             </a:r>
             <a:endParaRPr lang="en-US" sz="1250" dirty="0"/>
           </a:p>
@@ -11477,7 +11609,7 @@
         <p:spPr>
           <a:xfrm>
             <a:off x="548640" y="5440680"/>
-            <a:ext cx="11064240" cy="548640"/>
+            <a:ext cx="11064240" cy="685800"/>
           </a:xfrm>
           <a:prstGeom prst="rect">
             <a:avLst/>
@@ -11493,7 +11625,7 @@
               <a:buNone/>
             </a:pPr>
             <a:r>
-              <a:rPr lang="en-US" sz="1300" i="1" dirty="0">
+              <a:rPr lang="en-US" sz="1250" i="1" dirty="0">
                 <a:solidFill>
                   <a:srgbClr val="5A6172"/>
                 </a:solidFill>
@@ -11501,9 +11633,9 @@
                 <a:ea typeface="Calibri" pitchFamily="34" charset="-122"/>
                 <a:cs typeface="Calibri" pitchFamily="34" charset="-120"/>
               </a:rPr>
-              <a:t>Maturity: a working prototype on synthetic data and commodity hardware. Next: real transaction data, scale, and the AML / network-graph layer.</a:t>
-            </a:r>
-            <a:endParaRPr lang="en-US" sz="1300" dirty="0"/>
+              <a:t>Maturity: a working prototype on synthetic data and commodity hardware. Cold-start caveat: brand-new accounts degrade accuracy (identity features matter) — a known focus for the real-data phase. Next: real transaction data, scale, AML / network-graph.</a:t>
+            </a:r>
+            <a:endParaRPr lang="en-US" sz="1250" dirty="0"/>
           </a:p>
         </p:txBody>
       </p:sp>

</xml_diff>

<commit_message>
Add full prediction scoreboard slide to evidence deck
New slide 10 "Every prediction, measured": all twelve read-outs with result,
baseline and verdict - wins (ETA, charges, streaming, velocity +44pp), tree-
competitive (routing, risk/C2), weak (STP outcome, reject reason - reported
openly), too-rare (recall/return), honest null (message-order sequence), and
the deliberately-not-ML rows (guards, lookup infill). Sample-predictions slide
gains a Risk column (all five rows match truth). 12 slides total.

Co-Authored-By: Claude Opus 4.8 <noreply@anthropic.com>
</commit_message>
<xml_diff>
--- a/docs/txn_repr_evidence.pptx
+++ b/docs/txn_repr_evidence.pptx
@@ -16,9 +16,10 @@
     <p:sldId id="264" r:id="rId10"/>
     <p:sldId id="265" r:id="rId11"/>
     <p:sldId id="266" r:id="rId12"/>
+    <p:sldId id="267" r:id="rId13"/>
   </p:sldIdLst>
   <p:notesMasterIdLst>
-    <p:notesMasterId r:id="rId13"/>
+    <p:notesMasterId r:id="rId14"/>
   </p:notesMasterIdLst>
   <p:sldSz cx="12188952" cy="6858000"/>
   <p:notesSz cx="6858000" cy="12188952"/>
@@ -712,6 +713,94 @@
             <a:fld id="{F7021451-1387-4CA6-816F-3879F97B5CBC}" type="slidenum">
               <a:rPr lang="en-US"/>
               <a:t>11</a:t>
+            </a:fld>
+            <a:endParaRPr lang="en-US"/>
+          </a:p>
+        </p:txBody>
+      </p:sp>
+    </p:spTree>
+    <p:extLst>
+      <p:ext uri="{BB962C8B-B14F-4D97-AF65-F5344CB8AC3E}">
+        <p14:creationId xmlns:p14="http://schemas.microsoft.com/office/powerpoint/2010/main" val="1024086991"/>
+      </p:ext>
+    </p:extLst>
+  </p:cSld>
+  <p:clrMapOvr>
+    <a:masterClrMapping/>
+  </p:clrMapOvr>
+</p:notes>
+</file>
+
+<file path=ppt/notesSlides/notesSlide12.xml><?xml version="1.0" encoding="utf-8"?>
+<p:notes xmlns:a="http://schemas.openxmlformats.org/drawingml/2006/main" xmlns:r="http://schemas.openxmlformats.org/officeDocument/2006/relationships" xmlns:p="http://schemas.openxmlformats.org/presentationml/2006/main">
+  <p:cSld>
+    <p:spTree>
+      <p:nvGrpSpPr>
+        <p:cNvPr id="1" name=""/>
+        <p:cNvGrpSpPr/>
+        <p:nvPr/>
+      </p:nvGrpSpPr>
+      <p:grpSpPr>
+        <a:xfrm>
+          <a:off x="0" y="0"/>
+          <a:ext cx="0" cy="0"/>
+          <a:chOff x="0" y="0"/>
+          <a:chExt cx="0" cy="0"/>
+        </a:xfrm>
+      </p:grpSpPr>
+      <p:sp>
+        <p:nvSpPr>
+          <p:cNvPr id="2" name="Slide Image Placeholder 1"/>
+          <p:cNvSpPr>
+            <a:spLocks noGrp="1" noRot="1" noChangeAspect="1"/>
+          </p:cNvSpPr>
+          <p:nvPr>
+            <p:ph type="sldImg"/>
+          </p:nvPr>
+        </p:nvSpPr>
+        <p:spPr/>
+      </p:sp>
+      <p:sp>
+        <p:nvSpPr>
+          <p:cNvPr id="3" name="Notes Placeholder 2"/>
+          <p:cNvSpPr>
+            <a:spLocks noGrp="1"/>
+          </p:cNvSpPr>
+          <p:nvPr>
+            <p:ph type="body" idx="1"/>
+          </p:nvPr>
+        </p:nvSpPr>
+        <p:spPr/>
+        <p:txBody>
+          <a:bodyPr/>
+          <a:lstStyle/>
+          <a:p>
+            <a:r>
+              <a:rPr lang="en-US" dirty="0"/>
+              <a:t/>
+            </a:r>
+            <a:endParaRPr lang="en-US" dirty="0"/>
+          </a:p>
+        </p:txBody>
+      </p:sp>
+      <p:sp>
+        <p:nvSpPr>
+          <p:cNvPr id="4" name="Slide Number Placeholder 3"/>
+          <p:cNvSpPr>
+            <a:spLocks noGrp="1"/>
+          </p:cNvSpPr>
+          <p:nvPr>
+            <p:ph type="sldNum" sz="quarter" idx="10"/>
+          </p:nvPr>
+        </p:nvSpPr>
+        <p:spPr/>
+        <p:txBody>
+          <a:bodyPr/>
+          <a:lstStyle/>
+          <a:p>
+            <a:fld id="{F7021451-1387-4CA6-816F-3879F97B5CBC}" type="slidenum">
+              <a:rPr lang="en-US"/>
+              <a:t>12</a:t>
             </a:fld>
             <a:endParaRPr lang="en-US"/>
           </a:p>
@@ -2277,6 +2366,3605 @@
                 <a:ea typeface="Cambria" pitchFamily="34" charset="-122"/>
                 <a:cs typeface="Cambria" pitchFamily="34" charset="-120"/>
               </a:rPr>
+              <a:t>Every prediction, measured</a:t>
+            </a:r>
+            <a:endParaRPr lang="en-US" sz="3000" dirty="0"/>
+          </a:p>
+        </p:txBody>
+      </p:sp>
+      <p:sp>
+        <p:nvSpPr>
+          <p:cNvPr id="3" name="Text 1"/>
+          <p:cNvSpPr/>
+          <p:nvPr/>
+        </p:nvSpPr>
+        <p:spPr>
+          <a:xfrm>
+            <a:off x="566928" y="969264"/>
+            <a:ext cx="10972800" cy="365760"/>
+          </a:xfrm>
+          <a:prstGeom prst="rect">
+            <a:avLst/>
+          </a:prstGeom>
+          <a:noFill/>
+          <a:ln/>
+        </p:spPr>
+        <p:txBody>
+          <a:bodyPr wrap="square" rtlCol="0" anchor="ctr"/>
+          <a:lstStyle/>
+          <a:p>
+            <a:pPr indent="0" marL="0">
+              <a:buNone/>
+            </a:pPr>
+            <a:r>
+              <a:rPr lang="en-US" sz="1400" i="1" dirty="0">
+                <a:solidFill>
+                  <a:srgbClr val="5A6172"/>
+                </a:solidFill>
+                <a:latin typeface="Calibri" pitchFamily="34" charset="0"/>
+                <a:ea typeface="Calibri" pitchFamily="34" charset="-122"/>
+                <a:cs typeface="Calibri" pitchFamily="34" charset="-120"/>
+              </a:rPr>
+              <a:t>One backbone, twelve read-outs — wins and losses reported alike.</a:t>
+            </a:r>
+            <a:endParaRPr lang="en-US" sz="1400" dirty="0"/>
+          </a:p>
+        </p:txBody>
+      </p:sp>
+      <p:graphicFrame>
+        <p:nvGraphicFramePr>
+          <p:cNvPr id="11" name="Table 0"/>
+          <p:cNvGraphicFramePr>
+            <a:graphicFrameLocks noGrp="1"/>
+          </p:cNvGraphicFramePr>
+          <p:nvPr>
+            <p:extLst>
+              <p:ext uri="{D42A27DB-BD31-4B8C-83A1-F6EECF244321}">
+                <p14:modId xmlns:p14="http://schemas.microsoft.com/office/powerpoint/2010/main" val="1579011935"/>
+              </p:ext>
+            </p:extLst>
+          </p:nvPr>
+        </p:nvGraphicFramePr>
+        <p:xfrm>
+          <a:off x="457200" y="1371600"/>
+          <a:ext cx="11274552" cy="914400"/>
+        </p:xfrm>
+        <a:graphic>
+          <a:graphicData uri="http://schemas.openxmlformats.org/drawingml/2006/table">
+            <a:tbl>
+              <a:tblPr/>
+              <a:tblGrid>
+                <a:gridCol w="3017520"/>
+                <a:gridCol w="3776472"/>
+                <a:gridCol w="1920240"/>
+                <a:gridCol w="2560320"/>
+              </a:tblGrid>
+              <a:tr h="320040">
+                <a:tc>
+                  <a:txBody>
+                    <a:bodyPr/>
+                    <a:lstStyle/>
+                    <a:p>
+                      <a:pPr indent="0" marL="0">
+                        <a:buNone/>
+                      </a:pPr>
+                      <a:r>
+                        <a:rPr lang="en-US" sz="1050" b="1" dirty="0">
+                          <a:solidFill>
+                            <a:srgbClr val="FFFFFF"/>
+                          </a:solidFill>
+                          <a:latin typeface="Calibri" pitchFamily="34" charset="0"/>
+                          <a:ea typeface="Calibri" pitchFamily="34" charset="-122"/>
+                          <a:cs typeface="Calibri" pitchFamily="34" charset="-120"/>
+                        </a:rPr>
+                        <a:t>Prediction</a:t>
+                      </a:r>
+                      <a:endParaRPr lang="en-US" sz="1050" dirty="0">
+                        <a:latin typeface="Calibri" charset="0"/>
+                        <a:ea typeface="Calibri" charset="0"/>
+                        <a:cs typeface="Calibri" charset="0"/>
+                      </a:endParaRPr>
+                    </a:p>
+                  </a:txBody>
+                  <a:tcPr marL="91440" marR="91440" marT="45720" marB="45720" anchor="ctr">
+                    <a:lnL w="12700" cap="flat" cmpd="sng" algn="ctr">
+                      <a:solidFill>
+                        <a:srgbClr val="D8DEEC"/>
+                      </a:solidFill>
+                      <a:prstDash val="solid"/>
+                      <a:round/>
+                      <a:headEnd type="none" w="med" len="med"/>
+                      <a:tailEnd type="none" w="med" len="med"/>
+                    </a:lnL>
+                    <a:lnR w="12700" cap="flat" cmpd="sng" algn="ctr">
+                      <a:solidFill>
+                        <a:srgbClr val="D8DEEC"/>
+                      </a:solidFill>
+                      <a:prstDash val="solid"/>
+                      <a:round/>
+                      <a:headEnd type="none" w="med" len="med"/>
+                      <a:tailEnd type="none" w="med" len="med"/>
+                    </a:lnR>
+                    <a:lnT w="12700" cap="flat" cmpd="sng" algn="ctr">
+                      <a:solidFill>
+                        <a:srgbClr val="D8DEEC"/>
+                      </a:solidFill>
+                      <a:prstDash val="solid"/>
+                      <a:round/>
+                      <a:headEnd type="none" w="med" len="med"/>
+                      <a:tailEnd type="none" w="med" len="med"/>
+                    </a:lnT>
+                    <a:lnB w="12700" cap="flat" cmpd="sng" algn="ctr">
+                      <a:solidFill>
+                        <a:srgbClr val="D8DEEC"/>
+                      </a:solidFill>
+                      <a:prstDash val="solid"/>
+                      <a:round/>
+                      <a:headEnd type="none" w="med" len="med"/>
+                      <a:tailEnd type="none" w="med" len="med"/>
+                    </a:lnB>
+                    <a:solidFill>
+                      <a:srgbClr val="1E2761"/>
+                    </a:solidFill>
+                  </a:tcPr>
+                </a:tc>
+                <a:tc>
+                  <a:txBody>
+                    <a:bodyPr/>
+                    <a:lstStyle/>
+                    <a:p>
+                      <a:pPr indent="0" marL="0">
+                        <a:buNone/>
+                      </a:pPr>
+                      <a:r>
+                        <a:rPr lang="en-US" sz="1050" b="1" dirty="0">
+                          <a:solidFill>
+                            <a:srgbClr val="FFFFFF"/>
+                          </a:solidFill>
+                          <a:latin typeface="Calibri" pitchFamily="34" charset="0"/>
+                          <a:ea typeface="Calibri" pitchFamily="34" charset="-122"/>
+                          <a:cs typeface="Calibri" pitchFamily="34" charset="-120"/>
+                        </a:rPr>
+                        <a:t>Measured result</a:t>
+                      </a:r>
+                      <a:endParaRPr lang="en-US" sz="1050" dirty="0">
+                        <a:latin typeface="Calibri" charset="0"/>
+                        <a:ea typeface="Calibri" charset="0"/>
+                        <a:cs typeface="Calibri" charset="0"/>
+                      </a:endParaRPr>
+                    </a:p>
+                  </a:txBody>
+                  <a:tcPr marL="91440" marR="91440" marT="45720" marB="45720" anchor="ctr">
+                    <a:lnL w="12700" cap="flat" cmpd="sng" algn="ctr">
+                      <a:solidFill>
+                        <a:srgbClr val="D8DEEC"/>
+                      </a:solidFill>
+                      <a:prstDash val="solid"/>
+                      <a:round/>
+                      <a:headEnd type="none" w="med" len="med"/>
+                      <a:tailEnd type="none" w="med" len="med"/>
+                    </a:lnL>
+                    <a:lnR w="12700" cap="flat" cmpd="sng" algn="ctr">
+                      <a:solidFill>
+                        <a:srgbClr val="D8DEEC"/>
+                      </a:solidFill>
+                      <a:prstDash val="solid"/>
+                      <a:round/>
+                      <a:headEnd type="none" w="med" len="med"/>
+                      <a:tailEnd type="none" w="med" len="med"/>
+                    </a:lnR>
+                    <a:lnT w="12700" cap="flat" cmpd="sng" algn="ctr">
+                      <a:solidFill>
+                        <a:srgbClr val="D8DEEC"/>
+                      </a:solidFill>
+                      <a:prstDash val="solid"/>
+                      <a:round/>
+                      <a:headEnd type="none" w="med" len="med"/>
+                      <a:tailEnd type="none" w="med" len="med"/>
+                    </a:lnT>
+                    <a:lnB w="12700" cap="flat" cmpd="sng" algn="ctr">
+                      <a:solidFill>
+                        <a:srgbClr val="D8DEEC"/>
+                      </a:solidFill>
+                      <a:prstDash val="solid"/>
+                      <a:round/>
+                      <a:headEnd type="none" w="med" len="med"/>
+                      <a:tailEnd type="none" w="med" len="med"/>
+                    </a:lnB>
+                    <a:solidFill>
+                      <a:srgbClr val="1E2761"/>
+                    </a:solidFill>
+                  </a:tcPr>
+                </a:tc>
+                <a:tc>
+                  <a:txBody>
+                    <a:bodyPr/>
+                    <a:lstStyle/>
+                    <a:p>
+                      <a:pPr indent="0" marL="0">
+                        <a:buNone/>
+                      </a:pPr>
+                      <a:r>
+                        <a:rPr lang="en-US" sz="1050" b="1" dirty="0">
+                          <a:solidFill>
+                            <a:srgbClr val="FFFFFF"/>
+                          </a:solidFill>
+                          <a:latin typeface="Calibri" pitchFamily="34" charset="0"/>
+                          <a:ea typeface="Calibri" pitchFamily="34" charset="-122"/>
+                          <a:cs typeface="Calibri" pitchFamily="34" charset="-120"/>
+                        </a:rPr>
+                        <a:t>Baseline</a:t>
+                      </a:r>
+                      <a:endParaRPr lang="en-US" sz="1050" dirty="0">
+                        <a:latin typeface="Calibri" charset="0"/>
+                        <a:ea typeface="Calibri" charset="0"/>
+                        <a:cs typeface="Calibri" charset="0"/>
+                      </a:endParaRPr>
+                    </a:p>
+                  </a:txBody>
+                  <a:tcPr marL="91440" marR="91440" marT="45720" marB="45720" anchor="ctr">
+                    <a:lnL w="12700" cap="flat" cmpd="sng" algn="ctr">
+                      <a:solidFill>
+                        <a:srgbClr val="D8DEEC"/>
+                      </a:solidFill>
+                      <a:prstDash val="solid"/>
+                      <a:round/>
+                      <a:headEnd type="none" w="med" len="med"/>
+                      <a:tailEnd type="none" w="med" len="med"/>
+                    </a:lnL>
+                    <a:lnR w="12700" cap="flat" cmpd="sng" algn="ctr">
+                      <a:solidFill>
+                        <a:srgbClr val="D8DEEC"/>
+                      </a:solidFill>
+                      <a:prstDash val="solid"/>
+                      <a:round/>
+                      <a:headEnd type="none" w="med" len="med"/>
+                      <a:tailEnd type="none" w="med" len="med"/>
+                    </a:lnR>
+                    <a:lnT w="12700" cap="flat" cmpd="sng" algn="ctr">
+                      <a:solidFill>
+                        <a:srgbClr val="D8DEEC"/>
+                      </a:solidFill>
+                      <a:prstDash val="solid"/>
+                      <a:round/>
+                      <a:headEnd type="none" w="med" len="med"/>
+                      <a:tailEnd type="none" w="med" len="med"/>
+                    </a:lnT>
+                    <a:lnB w="12700" cap="flat" cmpd="sng" algn="ctr">
+                      <a:solidFill>
+                        <a:srgbClr val="D8DEEC"/>
+                      </a:solidFill>
+                      <a:prstDash val="solid"/>
+                      <a:round/>
+                      <a:headEnd type="none" w="med" len="med"/>
+                      <a:tailEnd type="none" w="med" len="med"/>
+                    </a:lnB>
+                    <a:solidFill>
+                      <a:srgbClr val="1E2761"/>
+                    </a:solidFill>
+                  </a:tcPr>
+                </a:tc>
+                <a:tc>
+                  <a:txBody>
+                    <a:bodyPr/>
+                    <a:lstStyle/>
+                    <a:p>
+                      <a:pPr indent="0" marL="0">
+                        <a:buNone/>
+                      </a:pPr>
+                      <a:r>
+                        <a:rPr lang="en-US" sz="1050" b="1" dirty="0">
+                          <a:solidFill>
+                            <a:srgbClr val="FFFFFF"/>
+                          </a:solidFill>
+                          <a:latin typeface="Calibri" pitchFamily="34" charset="0"/>
+                          <a:ea typeface="Calibri" pitchFamily="34" charset="-122"/>
+                          <a:cs typeface="Calibri" pitchFamily="34" charset="-120"/>
+                        </a:rPr>
+                        <a:t>Verdict</a:t>
+                      </a:r>
+                      <a:endParaRPr lang="en-US" sz="1050" dirty="0">
+                        <a:latin typeface="Calibri" charset="0"/>
+                        <a:ea typeface="Calibri" charset="0"/>
+                        <a:cs typeface="Calibri" charset="0"/>
+                      </a:endParaRPr>
+                    </a:p>
+                  </a:txBody>
+                  <a:tcPr marL="91440" marR="91440" marT="45720" marB="45720" anchor="ctr">
+                    <a:lnL w="12700" cap="flat" cmpd="sng" algn="ctr">
+                      <a:solidFill>
+                        <a:srgbClr val="D8DEEC"/>
+                      </a:solidFill>
+                      <a:prstDash val="solid"/>
+                      <a:round/>
+                      <a:headEnd type="none" w="med" len="med"/>
+                      <a:tailEnd type="none" w="med" len="med"/>
+                    </a:lnL>
+                    <a:lnR w="12700" cap="flat" cmpd="sng" algn="ctr">
+                      <a:solidFill>
+                        <a:srgbClr val="D8DEEC"/>
+                      </a:solidFill>
+                      <a:prstDash val="solid"/>
+                      <a:round/>
+                      <a:headEnd type="none" w="med" len="med"/>
+                      <a:tailEnd type="none" w="med" len="med"/>
+                    </a:lnR>
+                    <a:lnT w="12700" cap="flat" cmpd="sng" algn="ctr">
+                      <a:solidFill>
+                        <a:srgbClr val="D8DEEC"/>
+                      </a:solidFill>
+                      <a:prstDash val="solid"/>
+                      <a:round/>
+                      <a:headEnd type="none" w="med" len="med"/>
+                      <a:tailEnd type="none" w="med" len="med"/>
+                    </a:lnT>
+                    <a:lnB w="12700" cap="flat" cmpd="sng" algn="ctr">
+                      <a:solidFill>
+                        <a:srgbClr val="D8DEEC"/>
+                      </a:solidFill>
+                      <a:prstDash val="solid"/>
+                      <a:round/>
+                      <a:headEnd type="none" w="med" len="med"/>
+                      <a:tailEnd type="none" w="med" len="med"/>
+                    </a:lnB>
+                    <a:solidFill>
+                      <a:srgbClr val="1E2761"/>
+                    </a:solidFill>
+                  </a:tcPr>
+                </a:tc>
+              </a:tr>
+              <a:tr h="320040">
+                <a:tc>
+                  <a:txBody>
+                    <a:bodyPr/>
+                    <a:lstStyle/>
+                    <a:p>
+                      <a:pPr indent="0" marL="0">
+                        <a:buNone/>
+                      </a:pPr>
+                      <a:r>
+                        <a:rPr lang="en-US" sz="1050" dirty="0">
+                          <a:solidFill>
+                            <a:srgbClr val="1A1A2E"/>
+                          </a:solidFill>
+                          <a:latin typeface="Calibri" pitchFamily="34" charset="0"/>
+                          <a:ea typeface="Calibri" pitchFamily="34" charset="-122"/>
+                          <a:cs typeface="Calibri" pitchFamily="34" charset="-120"/>
+                        </a:rPr>
+                        <a:t>ETA to settlement</a:t>
+                      </a:r>
+                      <a:endParaRPr lang="en-US" sz="1050" dirty="0">
+                        <a:latin typeface="Calibri" charset="0"/>
+                        <a:ea typeface="Calibri" charset="0"/>
+                        <a:cs typeface="Calibri" charset="0"/>
+                      </a:endParaRPr>
+                    </a:p>
+                  </a:txBody>
+                  <a:tcPr marL="91440" marR="91440" marT="45720" marB="45720" anchor="ctr">
+                    <a:lnL w="12700" cap="flat" cmpd="sng" algn="ctr">
+                      <a:solidFill>
+                        <a:srgbClr val="D8DEEC"/>
+                      </a:solidFill>
+                      <a:prstDash val="solid"/>
+                      <a:round/>
+                      <a:headEnd type="none" w="med" len="med"/>
+                      <a:tailEnd type="none" w="med" len="med"/>
+                    </a:lnL>
+                    <a:lnR w="12700" cap="flat" cmpd="sng" algn="ctr">
+                      <a:solidFill>
+                        <a:srgbClr val="D8DEEC"/>
+                      </a:solidFill>
+                      <a:prstDash val="solid"/>
+                      <a:round/>
+                      <a:headEnd type="none" w="med" len="med"/>
+                      <a:tailEnd type="none" w="med" len="med"/>
+                    </a:lnR>
+                    <a:lnT w="12700" cap="flat" cmpd="sng" algn="ctr">
+                      <a:solidFill>
+                        <a:srgbClr val="D8DEEC"/>
+                      </a:solidFill>
+                      <a:prstDash val="solid"/>
+                      <a:round/>
+                      <a:headEnd type="none" w="med" len="med"/>
+                      <a:tailEnd type="none" w="med" len="med"/>
+                    </a:lnT>
+                    <a:lnB w="12700" cap="flat" cmpd="sng" algn="ctr">
+                      <a:solidFill>
+                        <a:srgbClr val="D8DEEC"/>
+                      </a:solidFill>
+                      <a:prstDash val="solid"/>
+                      <a:round/>
+                      <a:headEnd type="none" w="med" len="med"/>
+                      <a:tailEnd type="none" w="med" len="med"/>
+                    </a:lnB>
+                  </a:tcPr>
+                </a:tc>
+                <a:tc>
+                  <a:txBody>
+                    <a:bodyPr/>
+                    <a:lstStyle/>
+                    <a:p>
+                      <a:pPr indent="0" marL="0">
+                        <a:buNone/>
+                      </a:pPr>
+                      <a:r>
+                        <a:rPr lang="en-US" sz="1050" dirty="0">
+                          <a:solidFill>
+                            <a:srgbClr val="1A1A2E"/>
+                          </a:solidFill>
+                          <a:latin typeface="Calibri" pitchFamily="34" charset="0"/>
+                          <a:ea typeface="Calibri" pitchFamily="34" charset="-122"/>
+                          <a:cs typeface="Calibri" pitchFamily="34" charset="-120"/>
+                        </a:rPr>
+                        <a:t>MAE 186 min at initiation · 199 at n=4,000</a:t>
+                      </a:r>
+                      <a:endParaRPr lang="en-US" sz="1050" dirty="0">
+                        <a:latin typeface="Calibri" charset="0"/>
+                        <a:ea typeface="Calibri" charset="0"/>
+                        <a:cs typeface="Calibri" charset="0"/>
+                      </a:endParaRPr>
+                    </a:p>
+                  </a:txBody>
+                  <a:tcPr marL="91440" marR="91440" marT="45720" marB="45720" anchor="ctr">
+                    <a:lnL w="12700" cap="flat" cmpd="sng" algn="ctr">
+                      <a:solidFill>
+                        <a:srgbClr val="D8DEEC"/>
+                      </a:solidFill>
+                      <a:prstDash val="solid"/>
+                      <a:round/>
+                      <a:headEnd type="none" w="med" len="med"/>
+                      <a:tailEnd type="none" w="med" len="med"/>
+                    </a:lnL>
+                    <a:lnR w="12700" cap="flat" cmpd="sng" algn="ctr">
+                      <a:solidFill>
+                        <a:srgbClr val="D8DEEC"/>
+                      </a:solidFill>
+                      <a:prstDash val="solid"/>
+                      <a:round/>
+                      <a:headEnd type="none" w="med" len="med"/>
+                      <a:tailEnd type="none" w="med" len="med"/>
+                    </a:lnR>
+                    <a:lnT w="12700" cap="flat" cmpd="sng" algn="ctr">
+                      <a:solidFill>
+                        <a:srgbClr val="D8DEEC"/>
+                      </a:solidFill>
+                      <a:prstDash val="solid"/>
+                      <a:round/>
+                      <a:headEnd type="none" w="med" len="med"/>
+                      <a:tailEnd type="none" w="med" len="med"/>
+                    </a:lnT>
+                    <a:lnB w="12700" cap="flat" cmpd="sng" algn="ctr">
+                      <a:solidFill>
+                        <a:srgbClr val="D8DEEC"/>
+                      </a:solidFill>
+                      <a:prstDash val="solid"/>
+                      <a:round/>
+                      <a:headEnd type="none" w="med" len="med"/>
+                      <a:tailEnd type="none" w="med" len="med"/>
+                    </a:lnB>
+                  </a:tcPr>
+                </a:tc>
+                <a:tc>
+                  <a:txBody>
+                    <a:bodyPr/>
+                    <a:lstStyle/>
+                    <a:p>
+                      <a:pPr indent="0" marL="0">
+                        <a:buNone/>
+                      </a:pPr>
+                      <a:r>
+                        <a:rPr lang="en-US" sz="1050" dirty="0">
+                          <a:solidFill>
+                            <a:srgbClr val="1A1A2E"/>
+                          </a:solidFill>
+                          <a:latin typeface="Calibri" pitchFamily="34" charset="0"/>
+                          <a:ea typeface="Calibri" pitchFamily="34" charset="-122"/>
+                          <a:cs typeface="Calibri" pitchFamily="34" charset="-120"/>
+                        </a:rPr>
+                        <a:t>232 / 392 naive</a:t>
+                      </a:r>
+                      <a:endParaRPr lang="en-US" sz="1050" dirty="0">
+                        <a:latin typeface="Calibri" charset="0"/>
+                        <a:ea typeface="Calibri" charset="0"/>
+                        <a:cs typeface="Calibri" charset="0"/>
+                      </a:endParaRPr>
+                    </a:p>
+                  </a:txBody>
+                  <a:tcPr marL="91440" marR="91440" marT="45720" marB="45720" anchor="ctr">
+                    <a:lnL w="12700" cap="flat" cmpd="sng" algn="ctr">
+                      <a:solidFill>
+                        <a:srgbClr val="D8DEEC"/>
+                      </a:solidFill>
+                      <a:prstDash val="solid"/>
+                      <a:round/>
+                      <a:headEnd type="none" w="med" len="med"/>
+                      <a:tailEnd type="none" w="med" len="med"/>
+                    </a:lnL>
+                    <a:lnR w="12700" cap="flat" cmpd="sng" algn="ctr">
+                      <a:solidFill>
+                        <a:srgbClr val="D8DEEC"/>
+                      </a:solidFill>
+                      <a:prstDash val="solid"/>
+                      <a:round/>
+                      <a:headEnd type="none" w="med" len="med"/>
+                      <a:tailEnd type="none" w="med" len="med"/>
+                    </a:lnR>
+                    <a:lnT w="12700" cap="flat" cmpd="sng" algn="ctr">
+                      <a:solidFill>
+                        <a:srgbClr val="D8DEEC"/>
+                      </a:solidFill>
+                      <a:prstDash val="solid"/>
+                      <a:round/>
+                      <a:headEnd type="none" w="med" len="med"/>
+                      <a:tailEnd type="none" w="med" len="med"/>
+                    </a:lnT>
+                    <a:lnB w="12700" cap="flat" cmpd="sng" algn="ctr">
+                      <a:solidFill>
+                        <a:srgbClr val="D8DEEC"/>
+                      </a:solidFill>
+                      <a:prstDash val="solid"/>
+                      <a:round/>
+                      <a:headEnd type="none" w="med" len="med"/>
+                      <a:tailEnd type="none" w="med" len="med"/>
+                    </a:lnB>
+                  </a:tcPr>
+                </a:tc>
+                <a:tc>
+                  <a:txBody>
+                    <a:bodyPr/>
+                    <a:lstStyle/>
+                    <a:p>
+                      <a:pPr indent="0" marL="0">
+                        <a:buNone/>
+                      </a:pPr>
+                      <a:r>
+                        <a:rPr lang="en-US" sz="1050" b="1" dirty="0">
+                          <a:solidFill>
+                            <a:srgbClr val="2E7D32"/>
+                          </a:solidFill>
+                          <a:latin typeface="Calibri" pitchFamily="34" charset="0"/>
+                          <a:ea typeface="Calibri" pitchFamily="34" charset="-122"/>
+                          <a:cs typeface="Calibri" pitchFamily="34" charset="-120"/>
+                        </a:rPr>
+                        <a:t>Model wins</a:t>
+                      </a:r>
+                      <a:endParaRPr lang="en-US" sz="1050" dirty="0">
+                        <a:latin typeface="Calibri" charset="0"/>
+                        <a:ea typeface="Calibri" charset="0"/>
+                        <a:cs typeface="Calibri" charset="0"/>
+                      </a:endParaRPr>
+                    </a:p>
+                  </a:txBody>
+                  <a:tcPr marL="91440" marR="91440" marT="45720" marB="45720" anchor="ctr">
+                    <a:lnL w="12700" cap="flat" cmpd="sng" algn="ctr">
+                      <a:solidFill>
+                        <a:srgbClr val="D8DEEC"/>
+                      </a:solidFill>
+                      <a:prstDash val="solid"/>
+                      <a:round/>
+                      <a:headEnd type="none" w="med" len="med"/>
+                      <a:tailEnd type="none" w="med" len="med"/>
+                    </a:lnL>
+                    <a:lnR w="12700" cap="flat" cmpd="sng" algn="ctr">
+                      <a:solidFill>
+                        <a:srgbClr val="D8DEEC"/>
+                      </a:solidFill>
+                      <a:prstDash val="solid"/>
+                      <a:round/>
+                      <a:headEnd type="none" w="med" len="med"/>
+                      <a:tailEnd type="none" w="med" len="med"/>
+                    </a:lnR>
+                    <a:lnT w="12700" cap="flat" cmpd="sng" algn="ctr">
+                      <a:solidFill>
+                        <a:srgbClr val="D8DEEC"/>
+                      </a:solidFill>
+                      <a:prstDash val="solid"/>
+                      <a:round/>
+                      <a:headEnd type="none" w="med" len="med"/>
+                      <a:tailEnd type="none" w="med" len="med"/>
+                    </a:lnT>
+                    <a:lnB w="12700" cap="flat" cmpd="sng" algn="ctr">
+                      <a:solidFill>
+                        <a:srgbClr val="D8DEEC"/>
+                      </a:solidFill>
+                      <a:prstDash val="solid"/>
+                      <a:round/>
+                      <a:headEnd type="none" w="med" len="med"/>
+                      <a:tailEnd type="none" w="med" len="med"/>
+                    </a:lnB>
+                  </a:tcPr>
+                </a:tc>
+              </a:tr>
+              <a:tr h="320040">
+                <a:tc>
+                  <a:txBody>
+                    <a:bodyPr/>
+                    <a:lstStyle/>
+                    <a:p>
+                      <a:pPr indent="0" marL="0">
+                        <a:buNone/>
+                      </a:pPr>
+                      <a:r>
+                        <a:rPr lang="en-US" sz="1050" dirty="0">
+                          <a:solidFill>
+                            <a:srgbClr val="1A1A2E"/>
+                          </a:solidFill>
+                          <a:latin typeface="Calibri" pitchFamily="34" charset="0"/>
+                          <a:ea typeface="Calibri" pitchFamily="34" charset="-122"/>
+                          <a:cs typeface="Calibri" pitchFamily="34" charset="-120"/>
+                        </a:rPr>
+                        <a:t>Charges</a:t>
+                      </a:r>
+                      <a:endParaRPr lang="en-US" sz="1050" dirty="0">
+                        <a:latin typeface="Calibri" charset="0"/>
+                        <a:ea typeface="Calibri" charset="0"/>
+                        <a:cs typeface="Calibri" charset="0"/>
+                      </a:endParaRPr>
+                    </a:p>
+                  </a:txBody>
+                  <a:tcPr marL="91440" marR="91440" marT="45720" marB="45720" anchor="ctr">
+                    <a:lnL w="12700" cap="flat" cmpd="sng" algn="ctr">
+                      <a:solidFill>
+                        <a:srgbClr val="D8DEEC"/>
+                      </a:solidFill>
+                      <a:prstDash val="solid"/>
+                      <a:round/>
+                      <a:headEnd type="none" w="med" len="med"/>
+                      <a:tailEnd type="none" w="med" len="med"/>
+                    </a:lnL>
+                    <a:lnR w="12700" cap="flat" cmpd="sng" algn="ctr">
+                      <a:solidFill>
+                        <a:srgbClr val="D8DEEC"/>
+                      </a:solidFill>
+                      <a:prstDash val="solid"/>
+                      <a:round/>
+                      <a:headEnd type="none" w="med" len="med"/>
+                      <a:tailEnd type="none" w="med" len="med"/>
+                    </a:lnR>
+                    <a:lnT w="12700" cap="flat" cmpd="sng" algn="ctr">
+                      <a:solidFill>
+                        <a:srgbClr val="D8DEEC"/>
+                      </a:solidFill>
+                      <a:prstDash val="solid"/>
+                      <a:round/>
+                      <a:headEnd type="none" w="med" len="med"/>
+                      <a:tailEnd type="none" w="med" len="med"/>
+                    </a:lnT>
+                    <a:lnB w="12700" cap="flat" cmpd="sng" algn="ctr">
+                      <a:solidFill>
+                        <a:srgbClr val="D8DEEC"/>
+                      </a:solidFill>
+                      <a:prstDash val="solid"/>
+                      <a:round/>
+                      <a:headEnd type="none" w="med" len="med"/>
+                      <a:tailEnd type="none" w="med" len="med"/>
+                    </a:lnB>
+                  </a:tcPr>
+                </a:tc>
+                <a:tc>
+                  <a:txBody>
+                    <a:bodyPr/>
+                    <a:lstStyle/>
+                    <a:p>
+                      <a:pPr indent="0" marL="0">
+                        <a:buNone/>
+                      </a:pPr>
+                      <a:r>
+                        <a:rPr lang="en-US" sz="1050" dirty="0">
+                          <a:solidFill>
+                            <a:srgbClr val="1A1A2E"/>
+                          </a:solidFill>
+                          <a:latin typeface="Calibri" pitchFamily="34" charset="0"/>
+                          <a:ea typeface="Calibri" pitchFamily="34" charset="-122"/>
+                          <a:cs typeface="Calibri" pitchFamily="34" charset="-120"/>
+                        </a:rPr>
+                        <a:t>MAE 97</a:t>
+                      </a:r>
+                      <a:endParaRPr lang="en-US" sz="1050" dirty="0">
+                        <a:latin typeface="Calibri" charset="0"/>
+                        <a:ea typeface="Calibri" charset="0"/>
+                        <a:cs typeface="Calibri" charset="0"/>
+                      </a:endParaRPr>
+                    </a:p>
+                  </a:txBody>
+                  <a:tcPr marL="91440" marR="91440" marT="45720" marB="45720" anchor="ctr">
+                    <a:lnL w="12700" cap="flat" cmpd="sng" algn="ctr">
+                      <a:solidFill>
+                        <a:srgbClr val="D8DEEC"/>
+                      </a:solidFill>
+                      <a:prstDash val="solid"/>
+                      <a:round/>
+                      <a:headEnd type="none" w="med" len="med"/>
+                      <a:tailEnd type="none" w="med" len="med"/>
+                    </a:lnL>
+                    <a:lnR w="12700" cap="flat" cmpd="sng" algn="ctr">
+                      <a:solidFill>
+                        <a:srgbClr val="D8DEEC"/>
+                      </a:solidFill>
+                      <a:prstDash val="solid"/>
+                      <a:round/>
+                      <a:headEnd type="none" w="med" len="med"/>
+                      <a:tailEnd type="none" w="med" len="med"/>
+                    </a:lnR>
+                    <a:lnT w="12700" cap="flat" cmpd="sng" algn="ctr">
+                      <a:solidFill>
+                        <a:srgbClr val="D8DEEC"/>
+                      </a:solidFill>
+                      <a:prstDash val="solid"/>
+                      <a:round/>
+                      <a:headEnd type="none" w="med" len="med"/>
+                      <a:tailEnd type="none" w="med" len="med"/>
+                    </a:lnT>
+                    <a:lnB w="12700" cap="flat" cmpd="sng" algn="ctr">
+                      <a:solidFill>
+                        <a:srgbClr val="D8DEEC"/>
+                      </a:solidFill>
+                      <a:prstDash val="solid"/>
+                      <a:round/>
+                      <a:headEnd type="none" w="med" len="med"/>
+                      <a:tailEnd type="none" w="med" len="med"/>
+                    </a:lnB>
+                  </a:tcPr>
+                </a:tc>
+                <a:tc>
+                  <a:txBody>
+                    <a:bodyPr/>
+                    <a:lstStyle/>
+                    <a:p>
+                      <a:pPr indent="0" marL="0">
+                        <a:buNone/>
+                      </a:pPr>
+                      <a:r>
+                        <a:rPr lang="en-US" sz="1050" dirty="0">
+                          <a:solidFill>
+                            <a:srgbClr val="1A1A2E"/>
+                          </a:solidFill>
+                          <a:latin typeface="Calibri" pitchFamily="34" charset="0"/>
+                          <a:ea typeface="Calibri" pitchFamily="34" charset="-122"/>
+                          <a:cs typeface="Calibri" pitchFamily="34" charset="-120"/>
+                        </a:rPr>
+                        <a:t>185 naive</a:t>
+                      </a:r>
+                      <a:endParaRPr lang="en-US" sz="1050" dirty="0">
+                        <a:latin typeface="Calibri" charset="0"/>
+                        <a:ea typeface="Calibri" charset="0"/>
+                        <a:cs typeface="Calibri" charset="0"/>
+                      </a:endParaRPr>
+                    </a:p>
+                  </a:txBody>
+                  <a:tcPr marL="91440" marR="91440" marT="45720" marB="45720" anchor="ctr">
+                    <a:lnL w="12700" cap="flat" cmpd="sng" algn="ctr">
+                      <a:solidFill>
+                        <a:srgbClr val="D8DEEC"/>
+                      </a:solidFill>
+                      <a:prstDash val="solid"/>
+                      <a:round/>
+                      <a:headEnd type="none" w="med" len="med"/>
+                      <a:tailEnd type="none" w="med" len="med"/>
+                    </a:lnL>
+                    <a:lnR w="12700" cap="flat" cmpd="sng" algn="ctr">
+                      <a:solidFill>
+                        <a:srgbClr val="D8DEEC"/>
+                      </a:solidFill>
+                      <a:prstDash val="solid"/>
+                      <a:round/>
+                      <a:headEnd type="none" w="med" len="med"/>
+                      <a:tailEnd type="none" w="med" len="med"/>
+                    </a:lnR>
+                    <a:lnT w="12700" cap="flat" cmpd="sng" algn="ctr">
+                      <a:solidFill>
+                        <a:srgbClr val="D8DEEC"/>
+                      </a:solidFill>
+                      <a:prstDash val="solid"/>
+                      <a:round/>
+                      <a:headEnd type="none" w="med" len="med"/>
+                      <a:tailEnd type="none" w="med" len="med"/>
+                    </a:lnT>
+                    <a:lnB w="12700" cap="flat" cmpd="sng" algn="ctr">
+                      <a:solidFill>
+                        <a:srgbClr val="D8DEEC"/>
+                      </a:solidFill>
+                      <a:prstDash val="solid"/>
+                      <a:round/>
+                      <a:headEnd type="none" w="med" len="med"/>
+                      <a:tailEnd type="none" w="med" len="med"/>
+                    </a:lnB>
+                  </a:tcPr>
+                </a:tc>
+                <a:tc>
+                  <a:txBody>
+                    <a:bodyPr/>
+                    <a:lstStyle/>
+                    <a:p>
+                      <a:pPr indent="0" marL="0">
+                        <a:buNone/>
+                      </a:pPr>
+                      <a:r>
+                        <a:rPr lang="en-US" sz="1050" b="1" dirty="0">
+                          <a:solidFill>
+                            <a:srgbClr val="2E7D32"/>
+                          </a:solidFill>
+                          <a:latin typeface="Calibri" pitchFamily="34" charset="0"/>
+                          <a:ea typeface="Calibri" pitchFamily="34" charset="-122"/>
+                          <a:cs typeface="Calibri" pitchFamily="34" charset="-120"/>
+                        </a:rPr>
+                        <a:t>Model wins (−48%)</a:t>
+                      </a:r>
+                      <a:endParaRPr lang="en-US" sz="1050" dirty="0">
+                        <a:latin typeface="Calibri" charset="0"/>
+                        <a:ea typeface="Calibri" charset="0"/>
+                        <a:cs typeface="Calibri" charset="0"/>
+                      </a:endParaRPr>
+                    </a:p>
+                  </a:txBody>
+                  <a:tcPr marL="91440" marR="91440" marT="45720" marB="45720" anchor="ctr">
+                    <a:lnL w="12700" cap="flat" cmpd="sng" algn="ctr">
+                      <a:solidFill>
+                        <a:srgbClr val="D8DEEC"/>
+                      </a:solidFill>
+                      <a:prstDash val="solid"/>
+                      <a:round/>
+                      <a:headEnd type="none" w="med" len="med"/>
+                      <a:tailEnd type="none" w="med" len="med"/>
+                    </a:lnL>
+                    <a:lnR w="12700" cap="flat" cmpd="sng" algn="ctr">
+                      <a:solidFill>
+                        <a:srgbClr val="D8DEEC"/>
+                      </a:solidFill>
+                      <a:prstDash val="solid"/>
+                      <a:round/>
+                      <a:headEnd type="none" w="med" len="med"/>
+                      <a:tailEnd type="none" w="med" len="med"/>
+                    </a:lnR>
+                    <a:lnT w="12700" cap="flat" cmpd="sng" algn="ctr">
+                      <a:solidFill>
+                        <a:srgbClr val="D8DEEC"/>
+                      </a:solidFill>
+                      <a:prstDash val="solid"/>
+                      <a:round/>
+                      <a:headEnd type="none" w="med" len="med"/>
+                      <a:tailEnd type="none" w="med" len="med"/>
+                    </a:lnT>
+                    <a:lnB w="12700" cap="flat" cmpd="sng" algn="ctr">
+                      <a:solidFill>
+                        <a:srgbClr val="D8DEEC"/>
+                      </a:solidFill>
+                      <a:prstDash val="solid"/>
+                      <a:round/>
+                      <a:headEnd type="none" w="med" len="med"/>
+                      <a:tailEnd type="none" w="med" len="med"/>
+                    </a:lnB>
+                  </a:tcPr>
+                </a:tc>
+              </a:tr>
+              <a:tr h="320040">
+                <a:tc>
+                  <a:txBody>
+                    <a:bodyPr/>
+                    <a:lstStyle/>
+                    <a:p>
+                      <a:pPr indent="0" marL="0">
+                        <a:buNone/>
+                      </a:pPr>
+                      <a:r>
+                        <a:rPr lang="en-US" sz="1050" dirty="0">
+                          <a:solidFill>
+                            <a:srgbClr val="1A1A2E"/>
+                          </a:solidFill>
+                          <a:latin typeface="Calibri" pitchFamily="34" charset="0"/>
+                          <a:ea typeface="Calibri" pitchFamily="34" charset="-122"/>
+                          <a:cs typeface="Calibri" pitchFamily="34" charset="-120"/>
+                        </a:rPr>
+                        <a:t>'Will it credit?' — streaming, in-flight</a:t>
+                      </a:r>
+                      <a:endParaRPr lang="en-US" sz="1050" dirty="0">
+                        <a:latin typeface="Calibri" charset="0"/>
+                        <a:ea typeface="Calibri" charset="0"/>
+                        <a:cs typeface="Calibri" charset="0"/>
+                      </a:endParaRPr>
+                    </a:p>
+                  </a:txBody>
+                  <a:tcPr marL="91440" marR="91440" marT="45720" marB="45720" anchor="ctr">
+                    <a:lnL w="12700" cap="flat" cmpd="sng" algn="ctr">
+                      <a:solidFill>
+                        <a:srgbClr val="D8DEEC"/>
+                      </a:solidFill>
+                      <a:prstDash val="solid"/>
+                      <a:round/>
+                      <a:headEnd type="none" w="med" len="med"/>
+                      <a:tailEnd type="none" w="med" len="med"/>
+                    </a:lnL>
+                    <a:lnR w="12700" cap="flat" cmpd="sng" algn="ctr">
+                      <a:solidFill>
+                        <a:srgbClr val="D8DEEC"/>
+                      </a:solidFill>
+                      <a:prstDash val="solid"/>
+                      <a:round/>
+                      <a:headEnd type="none" w="med" len="med"/>
+                      <a:tailEnd type="none" w="med" len="med"/>
+                    </a:lnR>
+                    <a:lnT w="12700" cap="flat" cmpd="sng" algn="ctr">
+                      <a:solidFill>
+                        <a:srgbClr val="D8DEEC"/>
+                      </a:solidFill>
+                      <a:prstDash val="solid"/>
+                      <a:round/>
+                      <a:headEnd type="none" w="med" len="med"/>
+                      <a:tailEnd type="none" w="med" len="med"/>
+                    </a:lnT>
+                    <a:lnB w="12700" cap="flat" cmpd="sng" algn="ctr">
+                      <a:solidFill>
+                        <a:srgbClr val="D8DEEC"/>
+                      </a:solidFill>
+                      <a:prstDash val="solid"/>
+                      <a:round/>
+                      <a:headEnd type="none" w="med" len="med"/>
+                      <a:tailEnd type="none" w="med" len="med"/>
+                    </a:lnB>
+                  </a:tcPr>
+                </a:tc>
+                <a:tc>
+                  <a:txBody>
+                    <a:bodyPr/>
+                    <a:lstStyle/>
+                    <a:p>
+                      <a:pPr indent="0" marL="0">
+                        <a:buNone/>
+                      </a:pPr>
+                      <a:r>
+                        <a:rPr lang="en-US" sz="1050" dirty="0">
+                          <a:solidFill>
+                            <a:srgbClr val="1A1A2E"/>
+                          </a:solidFill>
+                          <a:latin typeface="Calibri" pitchFamily="34" charset="0"/>
+                          <a:ea typeface="Calibri" pitchFamily="34" charset="-122"/>
+                          <a:cs typeface="Calibri" pitchFamily="34" charset="-120"/>
+                        </a:rPr>
+                        <a:t>PR-AUC 0.84 → 0.87 as messages arrive</a:t>
+                      </a:r>
+                      <a:endParaRPr lang="en-US" sz="1050" dirty="0">
+                        <a:latin typeface="Calibri" charset="0"/>
+                        <a:ea typeface="Calibri" charset="0"/>
+                        <a:cs typeface="Calibri" charset="0"/>
+                      </a:endParaRPr>
+                    </a:p>
+                  </a:txBody>
+                  <a:tcPr marL="91440" marR="91440" marT="45720" marB="45720" anchor="ctr">
+                    <a:lnL w="12700" cap="flat" cmpd="sng" algn="ctr">
+                      <a:solidFill>
+                        <a:srgbClr val="D8DEEC"/>
+                      </a:solidFill>
+                      <a:prstDash val="solid"/>
+                      <a:round/>
+                      <a:headEnd type="none" w="med" len="med"/>
+                      <a:tailEnd type="none" w="med" len="med"/>
+                    </a:lnL>
+                    <a:lnR w="12700" cap="flat" cmpd="sng" algn="ctr">
+                      <a:solidFill>
+                        <a:srgbClr val="D8DEEC"/>
+                      </a:solidFill>
+                      <a:prstDash val="solid"/>
+                      <a:round/>
+                      <a:headEnd type="none" w="med" len="med"/>
+                      <a:tailEnd type="none" w="med" len="med"/>
+                    </a:lnR>
+                    <a:lnT w="12700" cap="flat" cmpd="sng" algn="ctr">
+                      <a:solidFill>
+                        <a:srgbClr val="D8DEEC"/>
+                      </a:solidFill>
+                      <a:prstDash val="solid"/>
+                      <a:round/>
+                      <a:headEnd type="none" w="med" len="med"/>
+                      <a:tailEnd type="none" w="med" len="med"/>
+                    </a:lnT>
+                    <a:lnB w="12700" cap="flat" cmpd="sng" algn="ctr">
+                      <a:solidFill>
+                        <a:srgbClr val="D8DEEC"/>
+                      </a:solidFill>
+                      <a:prstDash val="solid"/>
+                      <a:round/>
+                      <a:headEnd type="none" w="med" len="med"/>
+                      <a:tailEnd type="none" w="med" len="med"/>
+                    </a:lnB>
+                  </a:tcPr>
+                </a:tc>
+                <a:tc>
+                  <a:txBody>
+                    <a:bodyPr/>
+                    <a:lstStyle/>
+                    <a:p>
+                      <a:pPr indent="0" marL="0">
+                        <a:buNone/>
+                      </a:pPr>
+                      <a:r>
+                        <a:rPr lang="en-US" sz="1050" dirty="0">
+                          <a:solidFill>
+                            <a:srgbClr val="1A1A2E"/>
+                          </a:solidFill>
+                          <a:latin typeface="Calibri" pitchFamily="34" charset="0"/>
+                          <a:ea typeface="Calibri" pitchFamily="34" charset="-122"/>
+                          <a:cs typeface="Calibri" pitchFamily="34" charset="-120"/>
+                        </a:rPr>
+                        <a:t>0.84 prevalence</a:t>
+                      </a:r>
+                      <a:endParaRPr lang="en-US" sz="1050" dirty="0">
+                        <a:latin typeface="Calibri" charset="0"/>
+                        <a:ea typeface="Calibri" charset="0"/>
+                        <a:cs typeface="Calibri" charset="0"/>
+                      </a:endParaRPr>
+                    </a:p>
+                  </a:txBody>
+                  <a:tcPr marL="91440" marR="91440" marT="45720" marB="45720" anchor="ctr">
+                    <a:lnL w="12700" cap="flat" cmpd="sng" algn="ctr">
+                      <a:solidFill>
+                        <a:srgbClr val="D8DEEC"/>
+                      </a:solidFill>
+                      <a:prstDash val="solid"/>
+                      <a:round/>
+                      <a:headEnd type="none" w="med" len="med"/>
+                      <a:tailEnd type="none" w="med" len="med"/>
+                    </a:lnL>
+                    <a:lnR w="12700" cap="flat" cmpd="sng" algn="ctr">
+                      <a:solidFill>
+                        <a:srgbClr val="D8DEEC"/>
+                      </a:solidFill>
+                      <a:prstDash val="solid"/>
+                      <a:round/>
+                      <a:headEnd type="none" w="med" len="med"/>
+                      <a:tailEnd type="none" w="med" len="med"/>
+                    </a:lnR>
+                    <a:lnT w="12700" cap="flat" cmpd="sng" algn="ctr">
+                      <a:solidFill>
+                        <a:srgbClr val="D8DEEC"/>
+                      </a:solidFill>
+                      <a:prstDash val="solid"/>
+                      <a:round/>
+                      <a:headEnd type="none" w="med" len="med"/>
+                      <a:tailEnd type="none" w="med" len="med"/>
+                    </a:lnT>
+                    <a:lnB w="12700" cap="flat" cmpd="sng" algn="ctr">
+                      <a:solidFill>
+                        <a:srgbClr val="D8DEEC"/>
+                      </a:solidFill>
+                      <a:prstDash val="solid"/>
+                      <a:round/>
+                      <a:headEnd type="none" w="med" len="med"/>
+                      <a:tailEnd type="none" w="med" len="med"/>
+                    </a:lnB>
+                  </a:tcPr>
+                </a:tc>
+                <a:tc>
+                  <a:txBody>
+                    <a:bodyPr/>
+                    <a:lstStyle/>
+                    <a:p>
+                      <a:pPr indent="0" marL="0">
+                        <a:buNone/>
+                      </a:pPr>
+                      <a:r>
+                        <a:rPr lang="en-US" sz="1050" b="1" dirty="0">
+                          <a:solidFill>
+                            <a:srgbClr val="2E7D32"/>
+                          </a:solidFill>
+                          <a:latin typeface="Calibri" pitchFamily="34" charset="0"/>
+                          <a:ea typeface="Calibri" pitchFamily="34" charset="-122"/>
+                          <a:cs typeface="Calibri" pitchFamily="34" charset="-120"/>
+                        </a:rPr>
+                        <a:t>Model wins — lifecycle-native</a:t>
+                      </a:r>
+                      <a:endParaRPr lang="en-US" sz="1050" dirty="0">
+                        <a:latin typeface="Calibri" charset="0"/>
+                        <a:ea typeface="Calibri" charset="0"/>
+                        <a:cs typeface="Calibri" charset="0"/>
+                      </a:endParaRPr>
+                    </a:p>
+                  </a:txBody>
+                  <a:tcPr marL="91440" marR="91440" marT="45720" marB="45720" anchor="ctr">
+                    <a:lnL w="12700" cap="flat" cmpd="sng" algn="ctr">
+                      <a:solidFill>
+                        <a:srgbClr val="D8DEEC"/>
+                      </a:solidFill>
+                      <a:prstDash val="solid"/>
+                      <a:round/>
+                      <a:headEnd type="none" w="med" len="med"/>
+                      <a:tailEnd type="none" w="med" len="med"/>
+                    </a:lnL>
+                    <a:lnR w="12700" cap="flat" cmpd="sng" algn="ctr">
+                      <a:solidFill>
+                        <a:srgbClr val="D8DEEC"/>
+                      </a:solidFill>
+                      <a:prstDash val="solid"/>
+                      <a:round/>
+                      <a:headEnd type="none" w="med" len="med"/>
+                      <a:tailEnd type="none" w="med" len="med"/>
+                    </a:lnR>
+                    <a:lnT w="12700" cap="flat" cmpd="sng" algn="ctr">
+                      <a:solidFill>
+                        <a:srgbClr val="D8DEEC"/>
+                      </a:solidFill>
+                      <a:prstDash val="solid"/>
+                      <a:round/>
+                      <a:headEnd type="none" w="med" len="med"/>
+                      <a:tailEnd type="none" w="med" len="med"/>
+                    </a:lnT>
+                    <a:lnB w="12700" cap="flat" cmpd="sng" algn="ctr">
+                      <a:solidFill>
+                        <a:srgbClr val="D8DEEC"/>
+                      </a:solidFill>
+                      <a:prstDash val="solid"/>
+                      <a:round/>
+                      <a:headEnd type="none" w="med" len="med"/>
+                      <a:tailEnd type="none" w="med" len="med"/>
+                    </a:lnB>
+                  </a:tcPr>
+                </a:tc>
+              </a:tr>
+              <a:tr h="320040">
+                <a:tc>
+                  <a:txBody>
+                    <a:bodyPr/>
+                    <a:lstStyle/>
+                    <a:p>
+                      <a:pPr indent="0" marL="0">
+                        <a:buNone/>
+                      </a:pPr>
+                      <a:r>
+                        <a:rPr lang="en-US" sz="1050" dirty="0">
+                          <a:solidFill>
+                            <a:srgbClr val="1A1A2E"/>
+                          </a:solidFill>
+                          <a:latin typeface="Calibri" pitchFamily="34" charset="0"/>
+                          <a:ea typeface="Calibri" pitchFamily="34" charset="-122"/>
+                          <a:cs typeface="Calibri" pitchFamily="34" charset="-120"/>
+                        </a:rPr>
+                        <a:t>Velocity burst — account timing</a:t>
+                      </a:r>
+                      <a:endParaRPr lang="en-US" sz="1050" dirty="0">
+                        <a:latin typeface="Calibri" charset="0"/>
+                        <a:ea typeface="Calibri" charset="0"/>
+                        <a:cs typeface="Calibri" charset="0"/>
+                      </a:endParaRPr>
+                    </a:p>
+                  </a:txBody>
+                  <a:tcPr marL="91440" marR="91440" marT="45720" marB="45720" anchor="ctr">
+                    <a:lnL w="12700" cap="flat" cmpd="sng" algn="ctr">
+                      <a:solidFill>
+                        <a:srgbClr val="D8DEEC"/>
+                      </a:solidFill>
+                      <a:prstDash val="solid"/>
+                      <a:round/>
+                      <a:headEnd type="none" w="med" len="med"/>
+                      <a:tailEnd type="none" w="med" len="med"/>
+                    </a:lnL>
+                    <a:lnR w="12700" cap="flat" cmpd="sng" algn="ctr">
+                      <a:solidFill>
+                        <a:srgbClr val="D8DEEC"/>
+                      </a:solidFill>
+                      <a:prstDash val="solid"/>
+                      <a:round/>
+                      <a:headEnd type="none" w="med" len="med"/>
+                      <a:tailEnd type="none" w="med" len="med"/>
+                    </a:lnR>
+                    <a:lnT w="12700" cap="flat" cmpd="sng" algn="ctr">
+                      <a:solidFill>
+                        <a:srgbClr val="D8DEEC"/>
+                      </a:solidFill>
+                      <a:prstDash val="solid"/>
+                      <a:round/>
+                      <a:headEnd type="none" w="med" len="med"/>
+                      <a:tailEnd type="none" w="med" len="med"/>
+                    </a:lnT>
+                    <a:lnB w="12700" cap="flat" cmpd="sng" algn="ctr">
+                      <a:solidFill>
+                        <a:srgbClr val="D8DEEC"/>
+                      </a:solidFill>
+                      <a:prstDash val="solid"/>
+                      <a:round/>
+                      <a:headEnd type="none" w="med" len="med"/>
+                      <a:tailEnd type="none" w="med" len="med"/>
+                    </a:lnB>
+                  </a:tcPr>
+                </a:tc>
+                <a:tc>
+                  <a:txBody>
+                    <a:bodyPr/>
+                    <a:lstStyle/>
+                    <a:p>
+                      <a:pPr indent="0" marL="0">
+                        <a:buNone/>
+                      </a:pPr>
+                      <a:r>
+                        <a:rPr lang="en-US" sz="1050" dirty="0">
+                          <a:solidFill>
+                            <a:srgbClr val="1A1A2E"/>
+                          </a:solidFill>
+                          <a:latin typeface="Calibri" pitchFamily="34" charset="0"/>
+                          <a:ea typeface="Calibri" pitchFamily="34" charset="-122"/>
+                          <a:cs typeface="Calibri" pitchFamily="34" charset="-120"/>
+                        </a:rPr>
+                        <a:t>PR-AUC 0.67 time-aware</a:t>
+                      </a:r>
+                      <a:endParaRPr lang="en-US" sz="1050" dirty="0">
+                        <a:latin typeface="Calibri" charset="0"/>
+                        <a:ea typeface="Calibri" charset="0"/>
+                        <a:cs typeface="Calibri" charset="0"/>
+                      </a:endParaRPr>
+                    </a:p>
+                  </a:txBody>
+                  <a:tcPr marL="91440" marR="91440" marT="45720" marB="45720" anchor="ctr">
+                    <a:lnL w="12700" cap="flat" cmpd="sng" algn="ctr">
+                      <a:solidFill>
+                        <a:srgbClr val="D8DEEC"/>
+                      </a:solidFill>
+                      <a:prstDash val="solid"/>
+                      <a:round/>
+                      <a:headEnd type="none" w="med" len="med"/>
+                      <a:tailEnd type="none" w="med" len="med"/>
+                    </a:lnL>
+                    <a:lnR w="12700" cap="flat" cmpd="sng" algn="ctr">
+                      <a:solidFill>
+                        <a:srgbClr val="D8DEEC"/>
+                      </a:solidFill>
+                      <a:prstDash val="solid"/>
+                      <a:round/>
+                      <a:headEnd type="none" w="med" len="med"/>
+                      <a:tailEnd type="none" w="med" len="med"/>
+                    </a:lnR>
+                    <a:lnT w="12700" cap="flat" cmpd="sng" algn="ctr">
+                      <a:solidFill>
+                        <a:srgbClr val="D8DEEC"/>
+                      </a:solidFill>
+                      <a:prstDash val="solid"/>
+                      <a:round/>
+                      <a:headEnd type="none" w="med" len="med"/>
+                      <a:tailEnd type="none" w="med" len="med"/>
+                    </a:lnT>
+                    <a:lnB w="12700" cap="flat" cmpd="sng" algn="ctr">
+                      <a:solidFill>
+                        <a:srgbClr val="D8DEEC"/>
+                      </a:solidFill>
+                      <a:prstDash val="solid"/>
+                      <a:round/>
+                      <a:headEnd type="none" w="med" len="med"/>
+                      <a:tailEnd type="none" w="med" len="med"/>
+                    </a:lnB>
+                  </a:tcPr>
+                </a:tc>
+                <a:tc>
+                  <a:txBody>
+                    <a:bodyPr/>
+                    <a:lstStyle/>
+                    <a:p>
+                      <a:pPr indent="0" marL="0">
+                        <a:buNone/>
+                      </a:pPr>
+                      <a:r>
+                        <a:rPr lang="en-US" sz="1050" dirty="0">
+                          <a:solidFill>
+                            <a:srgbClr val="1A1A2E"/>
+                          </a:solidFill>
+                          <a:latin typeface="Calibri" pitchFamily="34" charset="0"/>
+                          <a:ea typeface="Calibri" pitchFamily="34" charset="-122"/>
+                          <a:cs typeface="Calibri" pitchFamily="34" charset="-120"/>
+                        </a:rPr>
+                        <a:t>0.22 order-blind</a:t>
+                      </a:r>
+                      <a:endParaRPr lang="en-US" sz="1050" dirty="0">
+                        <a:latin typeface="Calibri" charset="0"/>
+                        <a:ea typeface="Calibri" charset="0"/>
+                        <a:cs typeface="Calibri" charset="0"/>
+                      </a:endParaRPr>
+                    </a:p>
+                  </a:txBody>
+                  <a:tcPr marL="91440" marR="91440" marT="45720" marB="45720" anchor="ctr">
+                    <a:lnL w="12700" cap="flat" cmpd="sng" algn="ctr">
+                      <a:solidFill>
+                        <a:srgbClr val="D8DEEC"/>
+                      </a:solidFill>
+                      <a:prstDash val="solid"/>
+                      <a:round/>
+                      <a:headEnd type="none" w="med" len="med"/>
+                      <a:tailEnd type="none" w="med" len="med"/>
+                    </a:lnL>
+                    <a:lnR w="12700" cap="flat" cmpd="sng" algn="ctr">
+                      <a:solidFill>
+                        <a:srgbClr val="D8DEEC"/>
+                      </a:solidFill>
+                      <a:prstDash val="solid"/>
+                      <a:round/>
+                      <a:headEnd type="none" w="med" len="med"/>
+                      <a:tailEnd type="none" w="med" len="med"/>
+                    </a:lnR>
+                    <a:lnT w="12700" cap="flat" cmpd="sng" algn="ctr">
+                      <a:solidFill>
+                        <a:srgbClr val="D8DEEC"/>
+                      </a:solidFill>
+                      <a:prstDash val="solid"/>
+                      <a:round/>
+                      <a:headEnd type="none" w="med" len="med"/>
+                      <a:tailEnd type="none" w="med" len="med"/>
+                    </a:lnT>
+                    <a:lnB w="12700" cap="flat" cmpd="sng" algn="ctr">
+                      <a:solidFill>
+                        <a:srgbClr val="D8DEEC"/>
+                      </a:solidFill>
+                      <a:prstDash val="solid"/>
+                      <a:round/>
+                      <a:headEnd type="none" w="med" len="med"/>
+                      <a:tailEnd type="none" w="med" len="med"/>
+                    </a:lnB>
+                  </a:tcPr>
+                </a:tc>
+                <a:tc>
+                  <a:txBody>
+                    <a:bodyPr/>
+                    <a:lstStyle/>
+                    <a:p>
+                      <a:pPr indent="0" marL="0">
+                        <a:buNone/>
+                      </a:pPr>
+                      <a:r>
+                        <a:rPr lang="en-US" sz="1050" b="1" dirty="0">
+                          <a:solidFill>
+                            <a:srgbClr val="2E7D32"/>
+                          </a:solidFill>
+                          <a:latin typeface="Calibri" pitchFamily="34" charset="0"/>
+                          <a:ea typeface="Calibri" pitchFamily="34" charset="-122"/>
+                          <a:cs typeface="Calibri" pitchFamily="34" charset="-120"/>
+                        </a:rPr>
+                        <a:t>Model wins (+44pp)</a:t>
+                      </a:r>
+                      <a:endParaRPr lang="en-US" sz="1050" dirty="0">
+                        <a:latin typeface="Calibri" charset="0"/>
+                        <a:ea typeface="Calibri" charset="0"/>
+                        <a:cs typeface="Calibri" charset="0"/>
+                      </a:endParaRPr>
+                    </a:p>
+                  </a:txBody>
+                  <a:tcPr marL="91440" marR="91440" marT="45720" marB="45720" anchor="ctr">
+                    <a:lnL w="12700" cap="flat" cmpd="sng" algn="ctr">
+                      <a:solidFill>
+                        <a:srgbClr val="D8DEEC"/>
+                      </a:solidFill>
+                      <a:prstDash val="solid"/>
+                      <a:round/>
+                      <a:headEnd type="none" w="med" len="med"/>
+                      <a:tailEnd type="none" w="med" len="med"/>
+                    </a:lnL>
+                    <a:lnR w="12700" cap="flat" cmpd="sng" algn="ctr">
+                      <a:solidFill>
+                        <a:srgbClr val="D8DEEC"/>
+                      </a:solidFill>
+                      <a:prstDash val="solid"/>
+                      <a:round/>
+                      <a:headEnd type="none" w="med" len="med"/>
+                      <a:tailEnd type="none" w="med" len="med"/>
+                    </a:lnR>
+                    <a:lnT w="12700" cap="flat" cmpd="sng" algn="ctr">
+                      <a:solidFill>
+                        <a:srgbClr val="D8DEEC"/>
+                      </a:solidFill>
+                      <a:prstDash val="solid"/>
+                      <a:round/>
+                      <a:headEnd type="none" w="med" len="med"/>
+                      <a:tailEnd type="none" w="med" len="med"/>
+                    </a:lnT>
+                    <a:lnB w="12700" cap="flat" cmpd="sng" algn="ctr">
+                      <a:solidFill>
+                        <a:srgbClr val="D8DEEC"/>
+                      </a:solidFill>
+                      <a:prstDash val="solid"/>
+                      <a:round/>
+                      <a:headEnd type="none" w="med" len="med"/>
+                      <a:tailEnd type="none" w="med" len="med"/>
+                    </a:lnB>
+                  </a:tcPr>
+                </a:tc>
+              </a:tr>
+              <a:tr h="320040">
+                <a:tc>
+                  <a:txBody>
+                    <a:bodyPr/>
+                    <a:lstStyle/>
+                    <a:p>
+                      <a:pPr indent="0" marL="0">
+                        <a:buNone/>
+                      </a:pPr>
+                      <a:r>
+                        <a:rPr lang="en-US" sz="1050" dirty="0">
+                          <a:solidFill>
+                            <a:srgbClr val="1A1A2E"/>
+                          </a:solidFill>
+                          <a:latin typeface="Calibri" pitchFamily="34" charset="0"/>
+                          <a:ea typeface="Calibri" pitchFamily="34" charset="-122"/>
+                          <a:cs typeface="Calibri" pitchFamily="34" charset="-120"/>
+                        </a:rPr>
+                        <a:t>Rail routing</a:t>
+                      </a:r>
+                      <a:endParaRPr lang="en-US" sz="1050" dirty="0">
+                        <a:latin typeface="Calibri" charset="0"/>
+                        <a:ea typeface="Calibri" charset="0"/>
+                        <a:cs typeface="Calibri" charset="0"/>
+                      </a:endParaRPr>
+                    </a:p>
+                  </a:txBody>
+                  <a:tcPr marL="91440" marR="91440" marT="45720" marB="45720" anchor="ctr">
+                    <a:lnL w="12700" cap="flat" cmpd="sng" algn="ctr">
+                      <a:solidFill>
+                        <a:srgbClr val="D8DEEC"/>
+                      </a:solidFill>
+                      <a:prstDash val="solid"/>
+                      <a:round/>
+                      <a:headEnd type="none" w="med" len="med"/>
+                      <a:tailEnd type="none" w="med" len="med"/>
+                    </a:lnL>
+                    <a:lnR w="12700" cap="flat" cmpd="sng" algn="ctr">
+                      <a:solidFill>
+                        <a:srgbClr val="D8DEEC"/>
+                      </a:solidFill>
+                      <a:prstDash val="solid"/>
+                      <a:round/>
+                      <a:headEnd type="none" w="med" len="med"/>
+                      <a:tailEnd type="none" w="med" len="med"/>
+                    </a:lnR>
+                    <a:lnT w="12700" cap="flat" cmpd="sng" algn="ctr">
+                      <a:solidFill>
+                        <a:srgbClr val="D8DEEC"/>
+                      </a:solidFill>
+                      <a:prstDash val="solid"/>
+                      <a:round/>
+                      <a:headEnd type="none" w="med" len="med"/>
+                      <a:tailEnd type="none" w="med" len="med"/>
+                    </a:lnT>
+                    <a:lnB w="12700" cap="flat" cmpd="sng" algn="ctr">
+                      <a:solidFill>
+                        <a:srgbClr val="D8DEEC"/>
+                      </a:solidFill>
+                      <a:prstDash val="solid"/>
+                      <a:round/>
+                      <a:headEnd type="none" w="med" len="med"/>
+                      <a:tailEnd type="none" w="med" len="med"/>
+                    </a:lnB>
+                  </a:tcPr>
+                </a:tc>
+                <a:tc>
+                  <a:txBody>
+                    <a:bodyPr/>
+                    <a:lstStyle/>
+                    <a:p>
+                      <a:pPr indent="0" marL="0">
+                        <a:buNone/>
+                      </a:pPr>
+                      <a:r>
+                        <a:rPr lang="en-US" sz="1050" dirty="0">
+                          <a:solidFill>
+                            <a:srgbClr val="1A1A2E"/>
+                          </a:solidFill>
+                          <a:latin typeface="Calibri" pitchFamily="34" charset="0"/>
+                          <a:ea typeface="Calibri" pitchFamily="34" charset="-122"/>
+                          <a:cs typeface="Calibri" pitchFamily="34" charset="-120"/>
+                        </a:rPr>
+                        <a:t>0.55 probe · 0.64 on cleanly-routed 100 · SWIFT F1 1.00</a:t>
+                      </a:r>
+                      <a:endParaRPr lang="en-US" sz="1050" dirty="0">
+                        <a:latin typeface="Calibri" charset="0"/>
+                        <a:ea typeface="Calibri" charset="0"/>
+                        <a:cs typeface="Calibri" charset="0"/>
+                      </a:endParaRPr>
+                    </a:p>
+                  </a:txBody>
+                  <a:tcPr marL="91440" marR="91440" marT="45720" marB="45720" anchor="ctr">
+                    <a:lnL w="12700" cap="flat" cmpd="sng" algn="ctr">
+                      <a:solidFill>
+                        <a:srgbClr val="D8DEEC"/>
+                      </a:solidFill>
+                      <a:prstDash val="solid"/>
+                      <a:round/>
+                      <a:headEnd type="none" w="med" len="med"/>
+                      <a:tailEnd type="none" w="med" len="med"/>
+                    </a:lnL>
+                    <a:lnR w="12700" cap="flat" cmpd="sng" algn="ctr">
+                      <a:solidFill>
+                        <a:srgbClr val="D8DEEC"/>
+                      </a:solidFill>
+                      <a:prstDash val="solid"/>
+                      <a:round/>
+                      <a:headEnd type="none" w="med" len="med"/>
+                      <a:tailEnd type="none" w="med" len="med"/>
+                    </a:lnR>
+                    <a:lnT w="12700" cap="flat" cmpd="sng" algn="ctr">
+                      <a:solidFill>
+                        <a:srgbClr val="D8DEEC"/>
+                      </a:solidFill>
+                      <a:prstDash val="solid"/>
+                      <a:round/>
+                      <a:headEnd type="none" w="med" len="med"/>
+                      <a:tailEnd type="none" w="med" len="med"/>
+                    </a:lnT>
+                    <a:lnB w="12700" cap="flat" cmpd="sng" algn="ctr">
+                      <a:solidFill>
+                        <a:srgbClr val="D8DEEC"/>
+                      </a:solidFill>
+                      <a:prstDash val="solid"/>
+                      <a:round/>
+                      <a:headEnd type="none" w="med" len="med"/>
+                      <a:tailEnd type="none" w="med" len="med"/>
+                    </a:lnB>
+                  </a:tcPr>
+                </a:tc>
+                <a:tc>
+                  <a:txBody>
+                    <a:bodyPr/>
+                    <a:lstStyle/>
+                    <a:p>
+                      <a:pPr indent="0" marL="0">
+                        <a:buNone/>
+                      </a:pPr>
+                      <a:r>
+                        <a:rPr lang="en-US" sz="1050" dirty="0">
+                          <a:solidFill>
+                            <a:srgbClr val="1A1A2E"/>
+                          </a:solidFill>
+                          <a:latin typeface="Calibri" pitchFamily="34" charset="0"/>
+                          <a:ea typeface="Calibri" pitchFamily="34" charset="-122"/>
+                          <a:cs typeface="Calibri" pitchFamily="34" charset="-120"/>
+                        </a:rPr>
+                        <a:t>tree 0.64 · majority 0.48</a:t>
+                      </a:r>
+                      <a:endParaRPr lang="en-US" sz="1050" dirty="0">
+                        <a:latin typeface="Calibri" charset="0"/>
+                        <a:ea typeface="Calibri" charset="0"/>
+                        <a:cs typeface="Calibri" charset="0"/>
+                      </a:endParaRPr>
+                    </a:p>
+                  </a:txBody>
+                  <a:tcPr marL="91440" marR="91440" marT="45720" marB="45720" anchor="ctr">
+                    <a:lnL w="12700" cap="flat" cmpd="sng" algn="ctr">
+                      <a:solidFill>
+                        <a:srgbClr val="D8DEEC"/>
+                      </a:solidFill>
+                      <a:prstDash val="solid"/>
+                      <a:round/>
+                      <a:headEnd type="none" w="med" len="med"/>
+                      <a:tailEnd type="none" w="med" len="med"/>
+                    </a:lnL>
+                    <a:lnR w="12700" cap="flat" cmpd="sng" algn="ctr">
+                      <a:solidFill>
+                        <a:srgbClr val="D8DEEC"/>
+                      </a:solidFill>
+                      <a:prstDash val="solid"/>
+                      <a:round/>
+                      <a:headEnd type="none" w="med" len="med"/>
+                      <a:tailEnd type="none" w="med" len="med"/>
+                    </a:lnR>
+                    <a:lnT w="12700" cap="flat" cmpd="sng" algn="ctr">
+                      <a:solidFill>
+                        <a:srgbClr val="D8DEEC"/>
+                      </a:solidFill>
+                      <a:prstDash val="solid"/>
+                      <a:round/>
+                      <a:headEnd type="none" w="med" len="med"/>
+                      <a:tailEnd type="none" w="med" len="med"/>
+                    </a:lnT>
+                    <a:lnB w="12700" cap="flat" cmpd="sng" algn="ctr">
+                      <a:solidFill>
+                        <a:srgbClr val="D8DEEC"/>
+                      </a:solidFill>
+                      <a:prstDash val="solid"/>
+                      <a:round/>
+                      <a:headEnd type="none" w="med" len="med"/>
+                      <a:tailEnd type="none" w="med" len="med"/>
+                    </a:lnB>
+                  </a:tcPr>
+                </a:tc>
+                <a:tc>
+                  <a:txBody>
+                    <a:bodyPr/>
+                    <a:lstStyle/>
+                    <a:p>
+                      <a:pPr indent="0" marL="0">
+                        <a:buNone/>
+                      </a:pPr>
+                      <a:r>
+                        <a:rPr lang="en-US" sz="1050" b="1" dirty="0">
+                          <a:solidFill>
+                            <a:srgbClr val="C98A00"/>
+                          </a:solidFill>
+                          <a:latin typeface="Calibri" pitchFamily="34" charset="0"/>
+                          <a:ea typeface="Calibri" pitchFamily="34" charset="-122"/>
+                          <a:cs typeface="Calibri" pitchFamily="34" charset="-120"/>
+                        </a:rPr>
+                        <a:t>Tree competitive</a:t>
+                      </a:r>
+                      <a:endParaRPr lang="en-US" sz="1050" dirty="0">
+                        <a:latin typeface="Calibri" charset="0"/>
+                        <a:ea typeface="Calibri" charset="0"/>
+                        <a:cs typeface="Calibri" charset="0"/>
+                      </a:endParaRPr>
+                    </a:p>
+                  </a:txBody>
+                  <a:tcPr marL="91440" marR="91440" marT="45720" marB="45720" anchor="ctr">
+                    <a:lnL w="12700" cap="flat" cmpd="sng" algn="ctr">
+                      <a:solidFill>
+                        <a:srgbClr val="D8DEEC"/>
+                      </a:solidFill>
+                      <a:prstDash val="solid"/>
+                      <a:round/>
+                      <a:headEnd type="none" w="med" len="med"/>
+                      <a:tailEnd type="none" w="med" len="med"/>
+                    </a:lnL>
+                    <a:lnR w="12700" cap="flat" cmpd="sng" algn="ctr">
+                      <a:solidFill>
+                        <a:srgbClr val="D8DEEC"/>
+                      </a:solidFill>
+                      <a:prstDash val="solid"/>
+                      <a:round/>
+                      <a:headEnd type="none" w="med" len="med"/>
+                      <a:tailEnd type="none" w="med" len="med"/>
+                    </a:lnR>
+                    <a:lnT w="12700" cap="flat" cmpd="sng" algn="ctr">
+                      <a:solidFill>
+                        <a:srgbClr val="D8DEEC"/>
+                      </a:solidFill>
+                      <a:prstDash val="solid"/>
+                      <a:round/>
+                      <a:headEnd type="none" w="med" len="med"/>
+                      <a:tailEnd type="none" w="med" len="med"/>
+                    </a:lnT>
+                    <a:lnB w="12700" cap="flat" cmpd="sng" algn="ctr">
+                      <a:solidFill>
+                        <a:srgbClr val="D8DEEC"/>
+                      </a:solidFill>
+                      <a:prstDash val="solid"/>
+                      <a:round/>
+                      <a:headEnd type="none" w="med" len="med"/>
+                      <a:tailEnd type="none" w="med" len="med"/>
+                    </a:lnB>
+                  </a:tcPr>
+                </a:tc>
+              </a:tr>
+              <a:tr h="320040">
+                <a:tc>
+                  <a:txBody>
+                    <a:bodyPr/>
+                    <a:lstStyle/>
+                    <a:p>
+                      <a:pPr indent="0" marL="0">
+                        <a:buNone/>
+                      </a:pPr>
+                      <a:r>
+                        <a:rPr lang="en-US" sz="1050" dirty="0">
+                          <a:solidFill>
+                            <a:srgbClr val="1A1A2E"/>
+                          </a:solidFill>
+                          <a:latin typeface="Calibri" pitchFamily="34" charset="0"/>
+                          <a:ea typeface="Calibri" pitchFamily="34" charset="-122"/>
+                          <a:cs typeface="Calibri" pitchFamily="34" charset="-120"/>
+                        </a:rPr>
+                        <a:t>Risk (paper §5 task)</a:t>
+                      </a:r>
+                      <a:endParaRPr lang="en-US" sz="1050" dirty="0">
+                        <a:latin typeface="Calibri" charset="0"/>
+                        <a:ea typeface="Calibri" charset="0"/>
+                        <a:cs typeface="Calibri" charset="0"/>
+                      </a:endParaRPr>
+                    </a:p>
+                  </a:txBody>
+                  <a:tcPr marL="91440" marR="91440" marT="45720" marB="45720" anchor="ctr">
+                    <a:lnL w="12700" cap="flat" cmpd="sng" algn="ctr">
+                      <a:solidFill>
+                        <a:srgbClr val="D8DEEC"/>
+                      </a:solidFill>
+                      <a:prstDash val="solid"/>
+                      <a:round/>
+                      <a:headEnd type="none" w="med" len="med"/>
+                      <a:tailEnd type="none" w="med" len="med"/>
+                    </a:lnL>
+                    <a:lnR w="12700" cap="flat" cmpd="sng" algn="ctr">
+                      <a:solidFill>
+                        <a:srgbClr val="D8DEEC"/>
+                      </a:solidFill>
+                      <a:prstDash val="solid"/>
+                      <a:round/>
+                      <a:headEnd type="none" w="med" len="med"/>
+                      <a:tailEnd type="none" w="med" len="med"/>
+                    </a:lnR>
+                    <a:lnT w="12700" cap="flat" cmpd="sng" algn="ctr">
+                      <a:solidFill>
+                        <a:srgbClr val="D8DEEC"/>
+                      </a:solidFill>
+                      <a:prstDash val="solid"/>
+                      <a:round/>
+                      <a:headEnd type="none" w="med" len="med"/>
+                      <a:tailEnd type="none" w="med" len="med"/>
+                    </a:lnT>
+                    <a:lnB w="12700" cap="flat" cmpd="sng" algn="ctr">
+                      <a:solidFill>
+                        <a:srgbClr val="D8DEEC"/>
+                      </a:solidFill>
+                      <a:prstDash val="solid"/>
+                      <a:round/>
+                      <a:headEnd type="none" w="med" len="med"/>
+                      <a:tailEnd type="none" w="med" len="med"/>
+                    </a:lnB>
+                  </a:tcPr>
+                </a:tc>
+                <a:tc>
+                  <a:txBody>
+                    <a:bodyPr/>
+                    <a:lstStyle/>
+                    <a:p>
+                      <a:pPr indent="0" marL="0">
+                        <a:buNone/>
+                      </a:pPr>
+                      <a:r>
+                        <a:rPr lang="en-US" sz="1050" dirty="0">
+                          <a:solidFill>
+                            <a:srgbClr val="1A1A2E"/>
+                          </a:solidFill>
+                          <a:latin typeface="Calibri" pitchFamily="34" charset="0"/>
+                          <a:ea typeface="Calibri" pitchFamily="34" charset="-122"/>
+                          <a:cs typeface="Calibri" pitchFamily="34" charset="-120"/>
+                        </a:rPr>
+                        <a:t>0.53 on the fresh 100</a:t>
+                      </a:r>
+                      <a:endParaRPr lang="en-US" sz="1050" dirty="0">
+                        <a:latin typeface="Calibri" charset="0"/>
+                        <a:ea typeface="Calibri" charset="0"/>
+                        <a:cs typeface="Calibri" charset="0"/>
+                      </a:endParaRPr>
+                    </a:p>
+                  </a:txBody>
+                  <a:tcPr marL="91440" marR="91440" marT="45720" marB="45720" anchor="ctr">
+                    <a:lnL w="12700" cap="flat" cmpd="sng" algn="ctr">
+                      <a:solidFill>
+                        <a:srgbClr val="D8DEEC"/>
+                      </a:solidFill>
+                      <a:prstDash val="solid"/>
+                      <a:round/>
+                      <a:headEnd type="none" w="med" len="med"/>
+                      <a:tailEnd type="none" w="med" len="med"/>
+                    </a:lnL>
+                    <a:lnR w="12700" cap="flat" cmpd="sng" algn="ctr">
+                      <a:solidFill>
+                        <a:srgbClr val="D8DEEC"/>
+                      </a:solidFill>
+                      <a:prstDash val="solid"/>
+                      <a:round/>
+                      <a:headEnd type="none" w="med" len="med"/>
+                      <a:tailEnd type="none" w="med" len="med"/>
+                    </a:lnR>
+                    <a:lnT w="12700" cap="flat" cmpd="sng" algn="ctr">
+                      <a:solidFill>
+                        <a:srgbClr val="D8DEEC"/>
+                      </a:solidFill>
+                      <a:prstDash val="solid"/>
+                      <a:round/>
+                      <a:headEnd type="none" w="med" len="med"/>
+                      <a:tailEnd type="none" w="med" len="med"/>
+                    </a:lnT>
+                    <a:lnB w="12700" cap="flat" cmpd="sng" algn="ctr">
+                      <a:solidFill>
+                        <a:srgbClr val="D8DEEC"/>
+                      </a:solidFill>
+                      <a:prstDash val="solid"/>
+                      <a:round/>
+                      <a:headEnd type="none" w="med" len="med"/>
+                      <a:tailEnd type="none" w="med" len="med"/>
+                    </a:lnB>
+                  </a:tcPr>
+                </a:tc>
+                <a:tc>
+                  <a:txBody>
+                    <a:bodyPr/>
+                    <a:lstStyle/>
+                    <a:p>
+                      <a:pPr indent="0" marL="0">
+                        <a:buNone/>
+                      </a:pPr>
+                      <a:r>
+                        <a:rPr lang="en-US" sz="1050" dirty="0">
+                          <a:solidFill>
+                            <a:srgbClr val="1A1A2E"/>
+                          </a:solidFill>
+                          <a:latin typeface="Calibri" pitchFamily="34" charset="0"/>
+                          <a:ea typeface="Calibri" pitchFamily="34" charset="-122"/>
+                          <a:cs typeface="Calibri" pitchFamily="34" charset="-120"/>
+                        </a:rPr>
+                        <a:t>tree comparable</a:t>
+                      </a:r>
+                      <a:endParaRPr lang="en-US" sz="1050" dirty="0">
+                        <a:latin typeface="Calibri" charset="0"/>
+                        <a:ea typeface="Calibri" charset="0"/>
+                        <a:cs typeface="Calibri" charset="0"/>
+                      </a:endParaRPr>
+                    </a:p>
+                  </a:txBody>
+                  <a:tcPr marL="91440" marR="91440" marT="45720" marB="45720" anchor="ctr">
+                    <a:lnL w="12700" cap="flat" cmpd="sng" algn="ctr">
+                      <a:solidFill>
+                        <a:srgbClr val="D8DEEC"/>
+                      </a:solidFill>
+                      <a:prstDash val="solid"/>
+                      <a:round/>
+                      <a:headEnd type="none" w="med" len="med"/>
+                      <a:tailEnd type="none" w="med" len="med"/>
+                    </a:lnL>
+                    <a:lnR w="12700" cap="flat" cmpd="sng" algn="ctr">
+                      <a:solidFill>
+                        <a:srgbClr val="D8DEEC"/>
+                      </a:solidFill>
+                      <a:prstDash val="solid"/>
+                      <a:round/>
+                      <a:headEnd type="none" w="med" len="med"/>
+                      <a:tailEnd type="none" w="med" len="med"/>
+                    </a:lnR>
+                    <a:lnT w="12700" cap="flat" cmpd="sng" algn="ctr">
+                      <a:solidFill>
+                        <a:srgbClr val="D8DEEC"/>
+                      </a:solidFill>
+                      <a:prstDash val="solid"/>
+                      <a:round/>
+                      <a:headEnd type="none" w="med" len="med"/>
+                      <a:tailEnd type="none" w="med" len="med"/>
+                    </a:lnT>
+                    <a:lnB w="12700" cap="flat" cmpd="sng" algn="ctr">
+                      <a:solidFill>
+                        <a:srgbClr val="D8DEEC"/>
+                      </a:solidFill>
+                      <a:prstDash val="solid"/>
+                      <a:round/>
+                      <a:headEnd type="none" w="med" len="med"/>
+                      <a:tailEnd type="none" w="med" len="med"/>
+                    </a:lnB>
+                  </a:tcPr>
+                </a:tc>
+                <a:tc>
+                  <a:txBody>
+                    <a:bodyPr/>
+                    <a:lstStyle/>
+                    <a:p>
+                      <a:pPr indent="0" marL="0">
+                        <a:buNone/>
+                      </a:pPr>
+                      <a:r>
+                        <a:rPr lang="en-US" sz="1050" b="1" dirty="0">
+                          <a:solidFill>
+                            <a:srgbClr val="C98A00"/>
+                          </a:solidFill>
+                          <a:latin typeface="Calibri" pitchFamily="34" charset="0"/>
+                          <a:ea typeface="Calibri" pitchFamily="34" charset="-122"/>
+                          <a:cs typeface="Calibri" pitchFamily="34" charset="-120"/>
+                        </a:rPr>
+                        <a:t>Tree competitive (C2)</a:t>
+                      </a:r>
+                      <a:endParaRPr lang="en-US" sz="1050" dirty="0">
+                        <a:latin typeface="Calibri" charset="0"/>
+                        <a:ea typeface="Calibri" charset="0"/>
+                        <a:cs typeface="Calibri" charset="0"/>
+                      </a:endParaRPr>
+                    </a:p>
+                  </a:txBody>
+                  <a:tcPr marL="91440" marR="91440" marT="45720" marB="45720" anchor="ctr">
+                    <a:lnL w="12700" cap="flat" cmpd="sng" algn="ctr">
+                      <a:solidFill>
+                        <a:srgbClr val="D8DEEC"/>
+                      </a:solidFill>
+                      <a:prstDash val="solid"/>
+                      <a:round/>
+                      <a:headEnd type="none" w="med" len="med"/>
+                      <a:tailEnd type="none" w="med" len="med"/>
+                    </a:lnL>
+                    <a:lnR w="12700" cap="flat" cmpd="sng" algn="ctr">
+                      <a:solidFill>
+                        <a:srgbClr val="D8DEEC"/>
+                      </a:solidFill>
+                      <a:prstDash val="solid"/>
+                      <a:round/>
+                      <a:headEnd type="none" w="med" len="med"/>
+                      <a:tailEnd type="none" w="med" len="med"/>
+                    </a:lnR>
+                    <a:lnT w="12700" cap="flat" cmpd="sng" algn="ctr">
+                      <a:solidFill>
+                        <a:srgbClr val="D8DEEC"/>
+                      </a:solidFill>
+                      <a:prstDash val="solid"/>
+                      <a:round/>
+                      <a:headEnd type="none" w="med" len="med"/>
+                      <a:tailEnd type="none" w="med" len="med"/>
+                    </a:lnT>
+                    <a:lnB w="12700" cap="flat" cmpd="sng" algn="ctr">
+                      <a:solidFill>
+                        <a:srgbClr val="D8DEEC"/>
+                      </a:solidFill>
+                      <a:prstDash val="solid"/>
+                      <a:round/>
+                      <a:headEnd type="none" w="med" len="med"/>
+                      <a:tailEnd type="none" w="med" len="med"/>
+                    </a:lnB>
+                  </a:tcPr>
+                </a:tc>
+              </a:tr>
+              <a:tr h="320040">
+                <a:tc>
+                  <a:txBody>
+                    <a:bodyPr/>
+                    <a:lstStyle/>
+                    <a:p>
+                      <a:pPr indent="0" marL="0">
+                        <a:buNone/>
+                      </a:pPr>
+                      <a:r>
+                        <a:rPr lang="en-US" sz="1050" dirty="0">
+                          <a:solidFill>
+                            <a:srgbClr val="1A1A2E"/>
+                          </a:solidFill>
+                          <a:latin typeface="Calibri" pitchFamily="34" charset="0"/>
+                          <a:ea typeface="Calibri" pitchFamily="34" charset="-122"/>
+                          <a:cs typeface="Calibri" pitchFamily="34" charset="-120"/>
+                        </a:rPr>
+                        <a:t>STP outcome at initiation</a:t>
+                      </a:r>
+                      <a:endParaRPr lang="en-US" sz="1050" dirty="0">
+                        <a:latin typeface="Calibri" charset="0"/>
+                        <a:ea typeface="Calibri" charset="0"/>
+                        <a:cs typeface="Calibri" charset="0"/>
+                      </a:endParaRPr>
+                    </a:p>
+                  </a:txBody>
+                  <a:tcPr marL="91440" marR="91440" marT="45720" marB="45720" anchor="ctr">
+                    <a:lnL w="12700" cap="flat" cmpd="sng" algn="ctr">
+                      <a:solidFill>
+                        <a:srgbClr val="D8DEEC"/>
+                      </a:solidFill>
+                      <a:prstDash val="solid"/>
+                      <a:round/>
+                      <a:headEnd type="none" w="med" len="med"/>
+                      <a:tailEnd type="none" w="med" len="med"/>
+                    </a:lnL>
+                    <a:lnR w="12700" cap="flat" cmpd="sng" algn="ctr">
+                      <a:solidFill>
+                        <a:srgbClr val="D8DEEC"/>
+                      </a:solidFill>
+                      <a:prstDash val="solid"/>
+                      <a:round/>
+                      <a:headEnd type="none" w="med" len="med"/>
+                      <a:tailEnd type="none" w="med" len="med"/>
+                    </a:lnR>
+                    <a:lnT w="12700" cap="flat" cmpd="sng" algn="ctr">
+                      <a:solidFill>
+                        <a:srgbClr val="D8DEEC"/>
+                      </a:solidFill>
+                      <a:prstDash val="solid"/>
+                      <a:round/>
+                      <a:headEnd type="none" w="med" len="med"/>
+                      <a:tailEnd type="none" w="med" len="med"/>
+                    </a:lnT>
+                    <a:lnB w="12700" cap="flat" cmpd="sng" algn="ctr">
+                      <a:solidFill>
+                        <a:srgbClr val="D8DEEC"/>
+                      </a:solidFill>
+                      <a:prstDash val="solid"/>
+                      <a:round/>
+                      <a:headEnd type="none" w="med" len="med"/>
+                      <a:tailEnd type="none" w="med" len="med"/>
+                    </a:lnB>
+                  </a:tcPr>
+                </a:tc>
+                <a:tc>
+                  <a:txBody>
+                    <a:bodyPr/>
+                    <a:lstStyle/>
+                    <a:p>
+                      <a:pPr indent="0" marL="0">
+                        <a:buNone/>
+                      </a:pPr>
+                      <a:r>
+                        <a:rPr lang="en-US" sz="1050" dirty="0">
+                          <a:solidFill>
+                            <a:srgbClr val="1A1A2E"/>
+                          </a:solidFill>
+                          <a:latin typeface="Calibri" pitchFamily="34" charset="0"/>
+                          <a:ea typeface="Calibri" pitchFamily="34" charset="-122"/>
+                          <a:cs typeface="Calibri" pitchFamily="34" charset="-120"/>
+                        </a:rPr>
+                        <a:t>0.30 acc / 0.22 macro-F1</a:t>
+                      </a:r>
+                      <a:endParaRPr lang="en-US" sz="1050" dirty="0">
+                        <a:latin typeface="Calibri" charset="0"/>
+                        <a:ea typeface="Calibri" charset="0"/>
+                        <a:cs typeface="Calibri" charset="0"/>
+                      </a:endParaRPr>
+                    </a:p>
+                  </a:txBody>
+                  <a:tcPr marL="91440" marR="91440" marT="45720" marB="45720" anchor="ctr">
+                    <a:lnL w="12700" cap="flat" cmpd="sng" algn="ctr">
+                      <a:solidFill>
+                        <a:srgbClr val="D8DEEC"/>
+                      </a:solidFill>
+                      <a:prstDash val="solid"/>
+                      <a:round/>
+                      <a:headEnd type="none" w="med" len="med"/>
+                      <a:tailEnd type="none" w="med" len="med"/>
+                    </a:lnL>
+                    <a:lnR w="12700" cap="flat" cmpd="sng" algn="ctr">
+                      <a:solidFill>
+                        <a:srgbClr val="D8DEEC"/>
+                      </a:solidFill>
+                      <a:prstDash val="solid"/>
+                      <a:round/>
+                      <a:headEnd type="none" w="med" len="med"/>
+                      <a:tailEnd type="none" w="med" len="med"/>
+                    </a:lnR>
+                    <a:lnT w="12700" cap="flat" cmpd="sng" algn="ctr">
+                      <a:solidFill>
+                        <a:srgbClr val="D8DEEC"/>
+                      </a:solidFill>
+                      <a:prstDash val="solid"/>
+                      <a:round/>
+                      <a:headEnd type="none" w="med" len="med"/>
+                      <a:tailEnd type="none" w="med" len="med"/>
+                    </a:lnT>
+                    <a:lnB w="12700" cap="flat" cmpd="sng" algn="ctr">
+                      <a:solidFill>
+                        <a:srgbClr val="D8DEEC"/>
+                      </a:solidFill>
+                      <a:prstDash val="solid"/>
+                      <a:round/>
+                      <a:headEnd type="none" w="med" len="med"/>
+                      <a:tailEnd type="none" w="med" len="med"/>
+                    </a:lnB>
+                  </a:tcPr>
+                </a:tc>
+                <a:tc>
+                  <a:txBody>
+                    <a:bodyPr/>
+                    <a:lstStyle/>
+                    <a:p>
+                      <a:pPr indent="0" marL="0">
+                        <a:buNone/>
+                      </a:pPr>
+                      <a:r>
+                        <a:rPr lang="en-US" sz="1050" dirty="0">
+                          <a:solidFill>
+                            <a:srgbClr val="1A1A2E"/>
+                          </a:solidFill>
+                          <a:latin typeface="Calibri" pitchFamily="34" charset="0"/>
+                          <a:ea typeface="Calibri" pitchFamily="34" charset="-122"/>
+                          <a:cs typeface="Calibri" pitchFamily="34" charset="-120"/>
+                        </a:rPr>
+                        <a:t>majority 0.74</a:t>
+                      </a:r>
+                      <a:endParaRPr lang="en-US" sz="1050" dirty="0">
+                        <a:latin typeface="Calibri" charset="0"/>
+                        <a:ea typeface="Calibri" charset="0"/>
+                        <a:cs typeface="Calibri" charset="0"/>
+                      </a:endParaRPr>
+                    </a:p>
+                  </a:txBody>
+                  <a:tcPr marL="91440" marR="91440" marT="45720" marB="45720" anchor="ctr">
+                    <a:lnL w="12700" cap="flat" cmpd="sng" algn="ctr">
+                      <a:solidFill>
+                        <a:srgbClr val="D8DEEC"/>
+                      </a:solidFill>
+                      <a:prstDash val="solid"/>
+                      <a:round/>
+                      <a:headEnd type="none" w="med" len="med"/>
+                      <a:tailEnd type="none" w="med" len="med"/>
+                    </a:lnL>
+                    <a:lnR w="12700" cap="flat" cmpd="sng" algn="ctr">
+                      <a:solidFill>
+                        <a:srgbClr val="D8DEEC"/>
+                      </a:solidFill>
+                      <a:prstDash val="solid"/>
+                      <a:round/>
+                      <a:headEnd type="none" w="med" len="med"/>
+                      <a:tailEnd type="none" w="med" len="med"/>
+                    </a:lnR>
+                    <a:lnT w="12700" cap="flat" cmpd="sng" algn="ctr">
+                      <a:solidFill>
+                        <a:srgbClr val="D8DEEC"/>
+                      </a:solidFill>
+                      <a:prstDash val="solid"/>
+                      <a:round/>
+                      <a:headEnd type="none" w="med" len="med"/>
+                      <a:tailEnd type="none" w="med" len="med"/>
+                    </a:lnT>
+                    <a:lnB w="12700" cap="flat" cmpd="sng" algn="ctr">
+                      <a:solidFill>
+                        <a:srgbClr val="D8DEEC"/>
+                      </a:solidFill>
+                      <a:prstDash val="solid"/>
+                      <a:round/>
+                      <a:headEnd type="none" w="med" len="med"/>
+                      <a:tailEnd type="none" w="med" len="med"/>
+                    </a:lnB>
+                  </a:tcPr>
+                </a:tc>
+                <a:tc>
+                  <a:txBody>
+                    <a:bodyPr/>
+                    <a:lstStyle/>
+                    <a:p>
+                      <a:pPr indent="0" marL="0">
+                        <a:buNone/>
+                      </a:pPr>
+                      <a:r>
+                        <a:rPr lang="en-US" sz="1050" b="1" dirty="0">
+                          <a:solidFill>
+                            <a:srgbClr val="B3261E"/>
+                          </a:solidFill>
+                          <a:latin typeface="Calibri" pitchFamily="34" charset="0"/>
+                          <a:ea typeface="Calibri" pitchFamily="34" charset="-122"/>
+                          <a:cs typeface="Calibri" pitchFamily="34" charset="-120"/>
+                        </a:rPr>
+                        <a:t>Weak — tree territory</a:t>
+                      </a:r>
+                      <a:endParaRPr lang="en-US" sz="1050" dirty="0">
+                        <a:latin typeface="Calibri" charset="0"/>
+                        <a:ea typeface="Calibri" charset="0"/>
+                        <a:cs typeface="Calibri" charset="0"/>
+                      </a:endParaRPr>
+                    </a:p>
+                  </a:txBody>
+                  <a:tcPr marL="91440" marR="91440" marT="45720" marB="45720" anchor="ctr">
+                    <a:lnL w="12700" cap="flat" cmpd="sng" algn="ctr">
+                      <a:solidFill>
+                        <a:srgbClr val="D8DEEC"/>
+                      </a:solidFill>
+                      <a:prstDash val="solid"/>
+                      <a:round/>
+                      <a:headEnd type="none" w="med" len="med"/>
+                      <a:tailEnd type="none" w="med" len="med"/>
+                    </a:lnL>
+                    <a:lnR w="12700" cap="flat" cmpd="sng" algn="ctr">
+                      <a:solidFill>
+                        <a:srgbClr val="D8DEEC"/>
+                      </a:solidFill>
+                      <a:prstDash val="solid"/>
+                      <a:round/>
+                      <a:headEnd type="none" w="med" len="med"/>
+                      <a:tailEnd type="none" w="med" len="med"/>
+                    </a:lnR>
+                    <a:lnT w="12700" cap="flat" cmpd="sng" algn="ctr">
+                      <a:solidFill>
+                        <a:srgbClr val="D8DEEC"/>
+                      </a:solidFill>
+                      <a:prstDash val="solid"/>
+                      <a:round/>
+                      <a:headEnd type="none" w="med" len="med"/>
+                      <a:tailEnd type="none" w="med" len="med"/>
+                    </a:lnT>
+                    <a:lnB w="12700" cap="flat" cmpd="sng" algn="ctr">
+                      <a:solidFill>
+                        <a:srgbClr val="D8DEEC"/>
+                      </a:solidFill>
+                      <a:prstDash val="solid"/>
+                      <a:round/>
+                      <a:headEnd type="none" w="med" len="med"/>
+                      <a:tailEnd type="none" w="med" len="med"/>
+                    </a:lnB>
+                  </a:tcPr>
+                </a:tc>
+              </a:tr>
+              <a:tr h="320040">
+                <a:tc>
+                  <a:txBody>
+                    <a:bodyPr/>
+                    <a:lstStyle/>
+                    <a:p>
+                      <a:pPr indent="0" marL="0">
+                        <a:buNone/>
+                      </a:pPr>
+                      <a:r>
+                        <a:rPr lang="en-US" sz="1050" dirty="0">
+                          <a:solidFill>
+                            <a:srgbClr val="1A1A2E"/>
+                          </a:solidFill>
+                          <a:latin typeface="Calibri" pitchFamily="34" charset="0"/>
+                          <a:ea typeface="Calibri" pitchFamily="34" charset="-122"/>
+                          <a:cs typeface="Calibri" pitchFamily="34" charset="-120"/>
+                        </a:rPr>
+                        <a:t>Reject reason (ISO status code)</a:t>
+                      </a:r>
+                      <a:endParaRPr lang="en-US" sz="1050" dirty="0">
+                        <a:latin typeface="Calibri" charset="0"/>
+                        <a:ea typeface="Calibri" charset="0"/>
+                        <a:cs typeface="Calibri" charset="0"/>
+                      </a:endParaRPr>
+                    </a:p>
+                  </a:txBody>
+                  <a:tcPr marL="91440" marR="91440" marT="45720" marB="45720" anchor="ctr">
+                    <a:lnL w="12700" cap="flat" cmpd="sng" algn="ctr">
+                      <a:solidFill>
+                        <a:srgbClr val="D8DEEC"/>
+                      </a:solidFill>
+                      <a:prstDash val="solid"/>
+                      <a:round/>
+                      <a:headEnd type="none" w="med" len="med"/>
+                      <a:tailEnd type="none" w="med" len="med"/>
+                    </a:lnL>
+                    <a:lnR w="12700" cap="flat" cmpd="sng" algn="ctr">
+                      <a:solidFill>
+                        <a:srgbClr val="D8DEEC"/>
+                      </a:solidFill>
+                      <a:prstDash val="solid"/>
+                      <a:round/>
+                      <a:headEnd type="none" w="med" len="med"/>
+                      <a:tailEnd type="none" w="med" len="med"/>
+                    </a:lnR>
+                    <a:lnT w="12700" cap="flat" cmpd="sng" algn="ctr">
+                      <a:solidFill>
+                        <a:srgbClr val="D8DEEC"/>
+                      </a:solidFill>
+                      <a:prstDash val="solid"/>
+                      <a:round/>
+                      <a:headEnd type="none" w="med" len="med"/>
+                      <a:tailEnd type="none" w="med" len="med"/>
+                    </a:lnT>
+                    <a:lnB w="12700" cap="flat" cmpd="sng" algn="ctr">
+                      <a:solidFill>
+                        <a:srgbClr val="D8DEEC"/>
+                      </a:solidFill>
+                      <a:prstDash val="solid"/>
+                      <a:round/>
+                      <a:headEnd type="none" w="med" len="med"/>
+                      <a:tailEnd type="none" w="med" len="med"/>
+                    </a:lnB>
+                  </a:tcPr>
+                </a:tc>
+                <a:tc>
+                  <a:txBody>
+                    <a:bodyPr/>
+                    <a:lstStyle/>
+                    <a:p>
+                      <a:pPr indent="0" marL="0">
+                        <a:buNone/>
+                      </a:pPr>
+                      <a:r>
+                        <a:rPr lang="en-US" sz="1050" dirty="0">
+                          <a:solidFill>
+                            <a:srgbClr val="1A1A2E"/>
+                          </a:solidFill>
+                          <a:latin typeface="Calibri" pitchFamily="34" charset="0"/>
+                          <a:ea typeface="Calibri" pitchFamily="34" charset="-122"/>
+                          <a:cs typeface="Calibri" pitchFamily="34" charset="-120"/>
+                        </a:rPr>
+                        <a:t>0.23–0.27 acc</a:t>
+                      </a:r>
+                      <a:endParaRPr lang="en-US" sz="1050" dirty="0">
+                        <a:latin typeface="Calibri" charset="0"/>
+                        <a:ea typeface="Calibri" charset="0"/>
+                        <a:cs typeface="Calibri" charset="0"/>
+                      </a:endParaRPr>
+                    </a:p>
+                  </a:txBody>
+                  <a:tcPr marL="91440" marR="91440" marT="45720" marB="45720" anchor="ctr">
+                    <a:lnL w="12700" cap="flat" cmpd="sng" algn="ctr">
+                      <a:solidFill>
+                        <a:srgbClr val="D8DEEC"/>
+                      </a:solidFill>
+                      <a:prstDash val="solid"/>
+                      <a:round/>
+                      <a:headEnd type="none" w="med" len="med"/>
+                      <a:tailEnd type="none" w="med" len="med"/>
+                    </a:lnL>
+                    <a:lnR w="12700" cap="flat" cmpd="sng" algn="ctr">
+                      <a:solidFill>
+                        <a:srgbClr val="D8DEEC"/>
+                      </a:solidFill>
+                      <a:prstDash val="solid"/>
+                      <a:round/>
+                      <a:headEnd type="none" w="med" len="med"/>
+                      <a:tailEnd type="none" w="med" len="med"/>
+                    </a:lnR>
+                    <a:lnT w="12700" cap="flat" cmpd="sng" algn="ctr">
+                      <a:solidFill>
+                        <a:srgbClr val="D8DEEC"/>
+                      </a:solidFill>
+                      <a:prstDash val="solid"/>
+                      <a:round/>
+                      <a:headEnd type="none" w="med" len="med"/>
+                      <a:tailEnd type="none" w="med" len="med"/>
+                    </a:lnT>
+                    <a:lnB w="12700" cap="flat" cmpd="sng" algn="ctr">
+                      <a:solidFill>
+                        <a:srgbClr val="D8DEEC"/>
+                      </a:solidFill>
+                      <a:prstDash val="solid"/>
+                      <a:round/>
+                      <a:headEnd type="none" w="med" len="med"/>
+                      <a:tailEnd type="none" w="med" len="med"/>
+                    </a:lnB>
+                  </a:tcPr>
+                </a:tc>
+                <a:tc>
+                  <a:txBody>
+                    <a:bodyPr/>
+                    <a:lstStyle/>
+                    <a:p>
+                      <a:pPr indent="0" marL="0">
+                        <a:buNone/>
+                      </a:pPr>
+                      <a:r>
+                        <a:rPr lang="en-US" sz="1050" dirty="0">
+                          <a:solidFill>
+                            <a:srgbClr val="1A1A2E"/>
+                          </a:solidFill>
+                          <a:latin typeface="Calibri" pitchFamily="34" charset="0"/>
+                          <a:ea typeface="Calibri" pitchFamily="34" charset="-122"/>
+                          <a:cs typeface="Calibri" pitchFamily="34" charset="-120"/>
+                        </a:rPr>
+                        <a:t>'none' dominates</a:t>
+                      </a:r>
+                      <a:endParaRPr lang="en-US" sz="1050" dirty="0">
+                        <a:latin typeface="Calibri" charset="0"/>
+                        <a:ea typeface="Calibri" charset="0"/>
+                        <a:cs typeface="Calibri" charset="0"/>
+                      </a:endParaRPr>
+                    </a:p>
+                  </a:txBody>
+                  <a:tcPr marL="91440" marR="91440" marT="45720" marB="45720" anchor="ctr">
+                    <a:lnL w="12700" cap="flat" cmpd="sng" algn="ctr">
+                      <a:solidFill>
+                        <a:srgbClr val="D8DEEC"/>
+                      </a:solidFill>
+                      <a:prstDash val="solid"/>
+                      <a:round/>
+                      <a:headEnd type="none" w="med" len="med"/>
+                      <a:tailEnd type="none" w="med" len="med"/>
+                    </a:lnL>
+                    <a:lnR w="12700" cap="flat" cmpd="sng" algn="ctr">
+                      <a:solidFill>
+                        <a:srgbClr val="D8DEEC"/>
+                      </a:solidFill>
+                      <a:prstDash val="solid"/>
+                      <a:round/>
+                      <a:headEnd type="none" w="med" len="med"/>
+                      <a:tailEnd type="none" w="med" len="med"/>
+                    </a:lnR>
+                    <a:lnT w="12700" cap="flat" cmpd="sng" algn="ctr">
+                      <a:solidFill>
+                        <a:srgbClr val="D8DEEC"/>
+                      </a:solidFill>
+                      <a:prstDash val="solid"/>
+                      <a:round/>
+                      <a:headEnd type="none" w="med" len="med"/>
+                      <a:tailEnd type="none" w="med" len="med"/>
+                    </a:lnT>
+                    <a:lnB w="12700" cap="flat" cmpd="sng" algn="ctr">
+                      <a:solidFill>
+                        <a:srgbClr val="D8DEEC"/>
+                      </a:solidFill>
+                      <a:prstDash val="solid"/>
+                      <a:round/>
+                      <a:headEnd type="none" w="med" len="med"/>
+                      <a:tailEnd type="none" w="med" len="med"/>
+                    </a:lnB>
+                  </a:tcPr>
+                </a:tc>
+                <a:tc>
+                  <a:txBody>
+                    <a:bodyPr/>
+                    <a:lstStyle/>
+                    <a:p>
+                      <a:pPr indent="0" marL="0">
+                        <a:buNone/>
+                      </a:pPr>
+                      <a:r>
+                        <a:rPr lang="en-US" sz="1050" b="1" dirty="0">
+                          <a:solidFill>
+                            <a:srgbClr val="B3261E"/>
+                          </a:solidFill>
+                          <a:latin typeface="Calibri" pitchFamily="34" charset="0"/>
+                          <a:ea typeface="Calibri" pitchFamily="34" charset="-122"/>
+                          <a:cs typeface="Calibri" pitchFamily="34" charset="-120"/>
+                        </a:rPr>
+                        <a:t>Weak — tree territory</a:t>
+                      </a:r>
+                      <a:endParaRPr lang="en-US" sz="1050" dirty="0">
+                        <a:latin typeface="Calibri" charset="0"/>
+                        <a:ea typeface="Calibri" charset="0"/>
+                        <a:cs typeface="Calibri" charset="0"/>
+                      </a:endParaRPr>
+                    </a:p>
+                  </a:txBody>
+                  <a:tcPr marL="91440" marR="91440" marT="45720" marB="45720" anchor="ctr">
+                    <a:lnL w="12700" cap="flat" cmpd="sng" algn="ctr">
+                      <a:solidFill>
+                        <a:srgbClr val="D8DEEC"/>
+                      </a:solidFill>
+                      <a:prstDash val="solid"/>
+                      <a:round/>
+                      <a:headEnd type="none" w="med" len="med"/>
+                      <a:tailEnd type="none" w="med" len="med"/>
+                    </a:lnL>
+                    <a:lnR w="12700" cap="flat" cmpd="sng" algn="ctr">
+                      <a:solidFill>
+                        <a:srgbClr val="D8DEEC"/>
+                      </a:solidFill>
+                      <a:prstDash val="solid"/>
+                      <a:round/>
+                      <a:headEnd type="none" w="med" len="med"/>
+                      <a:tailEnd type="none" w="med" len="med"/>
+                    </a:lnR>
+                    <a:lnT w="12700" cap="flat" cmpd="sng" algn="ctr">
+                      <a:solidFill>
+                        <a:srgbClr val="D8DEEC"/>
+                      </a:solidFill>
+                      <a:prstDash val="solid"/>
+                      <a:round/>
+                      <a:headEnd type="none" w="med" len="med"/>
+                      <a:tailEnd type="none" w="med" len="med"/>
+                    </a:lnT>
+                    <a:lnB w="12700" cap="flat" cmpd="sng" algn="ctr">
+                      <a:solidFill>
+                        <a:srgbClr val="D8DEEC"/>
+                      </a:solidFill>
+                      <a:prstDash val="solid"/>
+                      <a:round/>
+                      <a:headEnd type="none" w="med" len="med"/>
+                      <a:tailEnd type="none" w="med" len="med"/>
+                    </a:lnB>
+                  </a:tcPr>
+                </a:tc>
+              </a:tr>
+              <a:tr h="320040">
+                <a:tc>
+                  <a:txBody>
+                    <a:bodyPr/>
+                    <a:lstStyle/>
+                    <a:p>
+                      <a:pPr indent="0" marL="0">
+                        <a:buNone/>
+                      </a:pPr>
+                      <a:r>
+                        <a:rPr lang="en-US" sz="1050" dirty="0">
+                          <a:solidFill>
+                            <a:srgbClr val="1A1A2E"/>
+                          </a:solidFill>
+                          <a:latin typeface="Calibri" pitchFamily="34" charset="0"/>
+                          <a:ea typeface="Calibri" pitchFamily="34" charset="-122"/>
+                          <a:cs typeface="Calibri" pitchFamily="34" charset="-120"/>
+                        </a:rPr>
+                        <a:t>Recall / return likelihood (camt.056 / pacs.004)</a:t>
+                      </a:r>
+                      <a:endParaRPr lang="en-US" sz="1050" dirty="0">
+                        <a:latin typeface="Calibri" charset="0"/>
+                        <a:ea typeface="Calibri" charset="0"/>
+                        <a:cs typeface="Calibri" charset="0"/>
+                      </a:endParaRPr>
+                    </a:p>
+                  </a:txBody>
+                  <a:tcPr marL="91440" marR="91440" marT="45720" marB="45720" anchor="ctr">
+                    <a:lnL w="12700" cap="flat" cmpd="sng" algn="ctr">
+                      <a:solidFill>
+                        <a:srgbClr val="D8DEEC"/>
+                      </a:solidFill>
+                      <a:prstDash val="solid"/>
+                      <a:round/>
+                      <a:headEnd type="none" w="med" len="med"/>
+                      <a:tailEnd type="none" w="med" len="med"/>
+                    </a:lnL>
+                    <a:lnR w="12700" cap="flat" cmpd="sng" algn="ctr">
+                      <a:solidFill>
+                        <a:srgbClr val="D8DEEC"/>
+                      </a:solidFill>
+                      <a:prstDash val="solid"/>
+                      <a:round/>
+                      <a:headEnd type="none" w="med" len="med"/>
+                      <a:tailEnd type="none" w="med" len="med"/>
+                    </a:lnR>
+                    <a:lnT w="12700" cap="flat" cmpd="sng" algn="ctr">
+                      <a:solidFill>
+                        <a:srgbClr val="D8DEEC"/>
+                      </a:solidFill>
+                      <a:prstDash val="solid"/>
+                      <a:round/>
+                      <a:headEnd type="none" w="med" len="med"/>
+                      <a:tailEnd type="none" w="med" len="med"/>
+                    </a:lnT>
+                    <a:lnB w="12700" cap="flat" cmpd="sng" algn="ctr">
+                      <a:solidFill>
+                        <a:srgbClr val="D8DEEC"/>
+                      </a:solidFill>
+                      <a:prstDash val="solid"/>
+                      <a:round/>
+                      <a:headEnd type="none" w="med" len="med"/>
+                      <a:tailEnd type="none" w="med" len="med"/>
+                    </a:lnB>
+                  </a:tcPr>
+                </a:tc>
+                <a:tc>
+                  <a:txBody>
+                    <a:bodyPr/>
+                    <a:lstStyle/>
+                    <a:p>
+                      <a:pPr indent="0" marL="0">
+                        <a:buNone/>
+                      </a:pPr>
+                      <a:r>
+                        <a:rPr lang="en-US" sz="1050" dirty="0">
+                          <a:solidFill>
+                            <a:srgbClr val="1A1A2E"/>
+                          </a:solidFill>
+                          <a:latin typeface="Calibri" pitchFamily="34" charset="0"/>
+                          <a:ea typeface="Calibri" pitchFamily="34" charset="-122"/>
+                          <a:cs typeface="Calibri" pitchFamily="34" charset="-120"/>
+                        </a:rPr>
+                        <a:t>≈ prevalence (3.9% / 2.3% positive)</a:t>
+                      </a:r>
+                      <a:endParaRPr lang="en-US" sz="1050" dirty="0">
+                        <a:latin typeface="Calibri" charset="0"/>
+                        <a:ea typeface="Calibri" charset="0"/>
+                        <a:cs typeface="Calibri" charset="0"/>
+                      </a:endParaRPr>
+                    </a:p>
+                  </a:txBody>
+                  <a:tcPr marL="91440" marR="91440" marT="45720" marB="45720" anchor="ctr">
+                    <a:lnL w="12700" cap="flat" cmpd="sng" algn="ctr">
+                      <a:solidFill>
+                        <a:srgbClr val="D8DEEC"/>
+                      </a:solidFill>
+                      <a:prstDash val="solid"/>
+                      <a:round/>
+                      <a:headEnd type="none" w="med" len="med"/>
+                      <a:tailEnd type="none" w="med" len="med"/>
+                    </a:lnL>
+                    <a:lnR w="12700" cap="flat" cmpd="sng" algn="ctr">
+                      <a:solidFill>
+                        <a:srgbClr val="D8DEEC"/>
+                      </a:solidFill>
+                      <a:prstDash val="solid"/>
+                      <a:round/>
+                      <a:headEnd type="none" w="med" len="med"/>
+                      <a:tailEnd type="none" w="med" len="med"/>
+                    </a:lnR>
+                    <a:lnT w="12700" cap="flat" cmpd="sng" algn="ctr">
+                      <a:solidFill>
+                        <a:srgbClr val="D8DEEC"/>
+                      </a:solidFill>
+                      <a:prstDash val="solid"/>
+                      <a:round/>
+                      <a:headEnd type="none" w="med" len="med"/>
+                      <a:tailEnd type="none" w="med" len="med"/>
+                    </a:lnT>
+                    <a:lnB w="12700" cap="flat" cmpd="sng" algn="ctr">
+                      <a:solidFill>
+                        <a:srgbClr val="D8DEEC"/>
+                      </a:solidFill>
+                      <a:prstDash val="solid"/>
+                      <a:round/>
+                      <a:headEnd type="none" w="med" len="med"/>
+                      <a:tailEnd type="none" w="med" len="med"/>
+                    </a:lnB>
+                  </a:tcPr>
+                </a:tc>
+                <a:tc>
+                  <a:txBody>
+                    <a:bodyPr/>
+                    <a:lstStyle/>
+                    <a:p>
+                      <a:pPr indent="0" marL="0">
+                        <a:buNone/>
+                      </a:pPr>
+                      <a:r>
+                        <a:rPr lang="en-US" sz="1050" dirty="0">
+                          <a:solidFill>
+                            <a:srgbClr val="1A1A2E"/>
+                          </a:solidFill>
+                          <a:latin typeface="Calibri" pitchFamily="34" charset="0"/>
+                          <a:ea typeface="Calibri" pitchFamily="34" charset="-122"/>
+                          <a:cs typeface="Calibri" pitchFamily="34" charset="-120"/>
+                        </a:rPr>
+                        <a:t>—</a:t>
+                      </a:r>
+                      <a:endParaRPr lang="en-US" sz="1050" dirty="0">
+                        <a:latin typeface="Calibri" charset="0"/>
+                        <a:ea typeface="Calibri" charset="0"/>
+                        <a:cs typeface="Calibri" charset="0"/>
+                      </a:endParaRPr>
+                    </a:p>
+                  </a:txBody>
+                  <a:tcPr marL="91440" marR="91440" marT="45720" marB="45720" anchor="ctr">
+                    <a:lnL w="12700" cap="flat" cmpd="sng" algn="ctr">
+                      <a:solidFill>
+                        <a:srgbClr val="D8DEEC"/>
+                      </a:solidFill>
+                      <a:prstDash val="solid"/>
+                      <a:round/>
+                      <a:headEnd type="none" w="med" len="med"/>
+                      <a:tailEnd type="none" w="med" len="med"/>
+                    </a:lnL>
+                    <a:lnR w="12700" cap="flat" cmpd="sng" algn="ctr">
+                      <a:solidFill>
+                        <a:srgbClr val="D8DEEC"/>
+                      </a:solidFill>
+                      <a:prstDash val="solid"/>
+                      <a:round/>
+                      <a:headEnd type="none" w="med" len="med"/>
+                      <a:tailEnd type="none" w="med" len="med"/>
+                    </a:lnR>
+                    <a:lnT w="12700" cap="flat" cmpd="sng" algn="ctr">
+                      <a:solidFill>
+                        <a:srgbClr val="D8DEEC"/>
+                      </a:solidFill>
+                      <a:prstDash val="solid"/>
+                      <a:round/>
+                      <a:headEnd type="none" w="med" len="med"/>
+                      <a:tailEnd type="none" w="med" len="med"/>
+                    </a:lnT>
+                    <a:lnB w="12700" cap="flat" cmpd="sng" algn="ctr">
+                      <a:solidFill>
+                        <a:srgbClr val="D8DEEC"/>
+                      </a:solidFill>
+                      <a:prstDash val="solid"/>
+                      <a:round/>
+                      <a:headEnd type="none" w="med" len="med"/>
+                      <a:tailEnd type="none" w="med" len="med"/>
+                    </a:lnB>
+                  </a:tcPr>
+                </a:tc>
+                <a:tc>
+                  <a:txBody>
+                    <a:bodyPr/>
+                    <a:lstStyle/>
+                    <a:p>
+                      <a:pPr indent="0" marL="0">
+                        <a:buNone/>
+                      </a:pPr>
+                      <a:r>
+                        <a:rPr lang="en-US" sz="1050" b="1" dirty="0">
+                          <a:solidFill>
+                            <a:srgbClr val="B3261E"/>
+                          </a:solidFill>
+                          <a:latin typeface="Calibri" pitchFamily="34" charset="0"/>
+                          <a:ea typeface="Calibri" pitchFamily="34" charset="-122"/>
+                          <a:cs typeface="Calibri" pitchFamily="34" charset="-120"/>
+                        </a:rPr>
+                        <a:t>Too rare at 20k — needs scale</a:t>
+                      </a:r>
+                      <a:endParaRPr lang="en-US" sz="1050" dirty="0">
+                        <a:latin typeface="Calibri" charset="0"/>
+                        <a:ea typeface="Calibri" charset="0"/>
+                        <a:cs typeface="Calibri" charset="0"/>
+                      </a:endParaRPr>
+                    </a:p>
+                  </a:txBody>
+                  <a:tcPr marL="91440" marR="91440" marT="45720" marB="45720" anchor="ctr">
+                    <a:lnL w="12700" cap="flat" cmpd="sng" algn="ctr">
+                      <a:solidFill>
+                        <a:srgbClr val="D8DEEC"/>
+                      </a:solidFill>
+                      <a:prstDash val="solid"/>
+                      <a:round/>
+                      <a:headEnd type="none" w="med" len="med"/>
+                      <a:tailEnd type="none" w="med" len="med"/>
+                    </a:lnL>
+                    <a:lnR w="12700" cap="flat" cmpd="sng" algn="ctr">
+                      <a:solidFill>
+                        <a:srgbClr val="D8DEEC"/>
+                      </a:solidFill>
+                      <a:prstDash val="solid"/>
+                      <a:round/>
+                      <a:headEnd type="none" w="med" len="med"/>
+                      <a:tailEnd type="none" w="med" len="med"/>
+                    </a:lnR>
+                    <a:lnT w="12700" cap="flat" cmpd="sng" algn="ctr">
+                      <a:solidFill>
+                        <a:srgbClr val="D8DEEC"/>
+                      </a:solidFill>
+                      <a:prstDash val="solid"/>
+                      <a:round/>
+                      <a:headEnd type="none" w="med" len="med"/>
+                      <a:tailEnd type="none" w="med" len="med"/>
+                    </a:lnT>
+                    <a:lnB w="12700" cap="flat" cmpd="sng" algn="ctr">
+                      <a:solidFill>
+                        <a:srgbClr val="D8DEEC"/>
+                      </a:solidFill>
+                      <a:prstDash val="solid"/>
+                      <a:round/>
+                      <a:headEnd type="none" w="med" len="med"/>
+                      <a:tailEnd type="none" w="med" len="med"/>
+                    </a:lnB>
+                  </a:tcPr>
+                </a:tc>
+              </a:tr>
+              <a:tr h="320040">
+                <a:tc>
+                  <a:txBody>
+                    <a:bodyPr/>
+                    <a:lstStyle/>
+                    <a:p>
+                      <a:pPr indent="0" marL="0">
+                        <a:buNone/>
+                      </a:pPr>
+                      <a:r>
+                        <a:rPr lang="en-US" sz="1050" dirty="0">
+                          <a:solidFill>
+                            <a:srgbClr val="1A1A2E"/>
+                          </a:solidFill>
+                          <a:latin typeface="Calibri" pitchFamily="34" charset="0"/>
+                          <a:ea typeface="Calibri" pitchFamily="34" charset="-122"/>
+                          <a:cs typeface="Calibri" pitchFamily="34" charset="-120"/>
+                        </a:rPr>
+                        <a:t>Next-message order (sequence encoder)</a:t>
+                      </a:r>
+                      <a:endParaRPr lang="en-US" sz="1050" dirty="0">
+                        <a:latin typeface="Calibri" charset="0"/>
+                        <a:ea typeface="Calibri" charset="0"/>
+                        <a:cs typeface="Calibri" charset="0"/>
+                      </a:endParaRPr>
+                    </a:p>
+                  </a:txBody>
+                  <a:tcPr marL="91440" marR="91440" marT="45720" marB="45720" anchor="ctr">
+                    <a:lnL w="12700" cap="flat" cmpd="sng" algn="ctr">
+                      <a:solidFill>
+                        <a:srgbClr val="D8DEEC"/>
+                      </a:solidFill>
+                      <a:prstDash val="solid"/>
+                      <a:round/>
+                      <a:headEnd type="none" w="med" len="med"/>
+                      <a:tailEnd type="none" w="med" len="med"/>
+                    </a:lnL>
+                    <a:lnR w="12700" cap="flat" cmpd="sng" algn="ctr">
+                      <a:solidFill>
+                        <a:srgbClr val="D8DEEC"/>
+                      </a:solidFill>
+                      <a:prstDash val="solid"/>
+                      <a:round/>
+                      <a:headEnd type="none" w="med" len="med"/>
+                      <a:tailEnd type="none" w="med" len="med"/>
+                    </a:lnR>
+                    <a:lnT w="12700" cap="flat" cmpd="sng" algn="ctr">
+                      <a:solidFill>
+                        <a:srgbClr val="D8DEEC"/>
+                      </a:solidFill>
+                      <a:prstDash val="solid"/>
+                      <a:round/>
+                      <a:headEnd type="none" w="med" len="med"/>
+                      <a:tailEnd type="none" w="med" len="med"/>
+                    </a:lnT>
+                    <a:lnB w="12700" cap="flat" cmpd="sng" algn="ctr">
+                      <a:solidFill>
+                        <a:srgbClr val="D8DEEC"/>
+                      </a:solidFill>
+                      <a:prstDash val="solid"/>
+                      <a:round/>
+                      <a:headEnd type="none" w="med" len="med"/>
+                      <a:tailEnd type="none" w="med" len="med"/>
+                    </a:lnB>
+                  </a:tcPr>
+                </a:tc>
+                <a:tc>
+                  <a:txBody>
+                    <a:bodyPr/>
+                    <a:lstStyle/>
+                    <a:p>
+                      <a:pPr indent="0" marL="0">
+                        <a:buNone/>
+                      </a:pPr>
+                      <a:r>
+                        <a:rPr lang="en-US" sz="1050" dirty="0">
+                          <a:solidFill>
+                            <a:srgbClr val="1A1A2E"/>
+                          </a:solidFill>
+                          <a:latin typeface="Calibri" pitchFamily="34" charset="0"/>
+                          <a:ea typeface="Calibri" pitchFamily="34" charset="-122"/>
+                          <a:cs typeface="Calibri" pitchFamily="34" charset="-120"/>
+                        </a:rPr>
+                        <a:t>sequence ≈ pooled (+2pp)</a:t>
+                      </a:r>
+                      <a:endParaRPr lang="en-US" sz="1050" dirty="0">
+                        <a:latin typeface="Calibri" charset="0"/>
+                        <a:ea typeface="Calibri" charset="0"/>
+                        <a:cs typeface="Calibri" charset="0"/>
+                      </a:endParaRPr>
+                    </a:p>
+                  </a:txBody>
+                  <a:tcPr marL="91440" marR="91440" marT="45720" marB="45720" anchor="ctr">
+                    <a:lnL w="12700" cap="flat" cmpd="sng" algn="ctr">
+                      <a:solidFill>
+                        <a:srgbClr val="D8DEEC"/>
+                      </a:solidFill>
+                      <a:prstDash val="solid"/>
+                      <a:round/>
+                      <a:headEnd type="none" w="med" len="med"/>
+                      <a:tailEnd type="none" w="med" len="med"/>
+                    </a:lnL>
+                    <a:lnR w="12700" cap="flat" cmpd="sng" algn="ctr">
+                      <a:solidFill>
+                        <a:srgbClr val="D8DEEC"/>
+                      </a:solidFill>
+                      <a:prstDash val="solid"/>
+                      <a:round/>
+                      <a:headEnd type="none" w="med" len="med"/>
+                      <a:tailEnd type="none" w="med" len="med"/>
+                    </a:lnR>
+                    <a:lnT w="12700" cap="flat" cmpd="sng" algn="ctr">
+                      <a:solidFill>
+                        <a:srgbClr val="D8DEEC"/>
+                      </a:solidFill>
+                      <a:prstDash val="solid"/>
+                      <a:round/>
+                      <a:headEnd type="none" w="med" len="med"/>
+                      <a:tailEnd type="none" w="med" len="med"/>
+                    </a:lnT>
+                    <a:lnB w="12700" cap="flat" cmpd="sng" algn="ctr">
+                      <a:solidFill>
+                        <a:srgbClr val="D8DEEC"/>
+                      </a:solidFill>
+                      <a:prstDash val="solid"/>
+                      <a:round/>
+                      <a:headEnd type="none" w="med" len="med"/>
+                      <a:tailEnd type="none" w="med" len="med"/>
+                    </a:lnB>
+                  </a:tcPr>
+                </a:tc>
+                <a:tc>
+                  <a:txBody>
+                    <a:bodyPr/>
+                    <a:lstStyle/>
+                    <a:p>
+                      <a:pPr indent="0" marL="0">
+                        <a:buNone/>
+                      </a:pPr>
+                      <a:r>
+                        <a:rPr lang="en-US" sz="1050" dirty="0">
+                          <a:solidFill>
+                            <a:srgbClr val="1A1A2E"/>
+                          </a:solidFill>
+                          <a:latin typeface="Calibri" pitchFamily="34" charset="0"/>
+                          <a:ea typeface="Calibri" pitchFamily="34" charset="-122"/>
+                          <a:cs typeface="Calibri" pitchFamily="34" charset="-120"/>
+                        </a:rPr>
+                        <a:t>bag-of-messages</a:t>
+                      </a:r>
+                      <a:endParaRPr lang="en-US" sz="1050" dirty="0">
+                        <a:latin typeface="Calibri" charset="0"/>
+                        <a:ea typeface="Calibri" charset="0"/>
+                        <a:cs typeface="Calibri" charset="0"/>
+                      </a:endParaRPr>
+                    </a:p>
+                  </a:txBody>
+                  <a:tcPr marL="91440" marR="91440" marT="45720" marB="45720" anchor="ctr">
+                    <a:lnL w="12700" cap="flat" cmpd="sng" algn="ctr">
+                      <a:solidFill>
+                        <a:srgbClr val="D8DEEC"/>
+                      </a:solidFill>
+                      <a:prstDash val="solid"/>
+                      <a:round/>
+                      <a:headEnd type="none" w="med" len="med"/>
+                      <a:tailEnd type="none" w="med" len="med"/>
+                    </a:lnL>
+                    <a:lnR w="12700" cap="flat" cmpd="sng" algn="ctr">
+                      <a:solidFill>
+                        <a:srgbClr val="D8DEEC"/>
+                      </a:solidFill>
+                      <a:prstDash val="solid"/>
+                      <a:round/>
+                      <a:headEnd type="none" w="med" len="med"/>
+                      <a:tailEnd type="none" w="med" len="med"/>
+                    </a:lnR>
+                    <a:lnT w="12700" cap="flat" cmpd="sng" algn="ctr">
+                      <a:solidFill>
+                        <a:srgbClr val="D8DEEC"/>
+                      </a:solidFill>
+                      <a:prstDash val="solid"/>
+                      <a:round/>
+                      <a:headEnd type="none" w="med" len="med"/>
+                      <a:tailEnd type="none" w="med" len="med"/>
+                    </a:lnT>
+                    <a:lnB w="12700" cap="flat" cmpd="sng" algn="ctr">
+                      <a:solidFill>
+                        <a:srgbClr val="D8DEEC"/>
+                      </a:solidFill>
+                      <a:prstDash val="solid"/>
+                      <a:round/>
+                      <a:headEnd type="none" w="med" len="med"/>
+                      <a:tailEnd type="none" w="med" len="med"/>
+                    </a:lnB>
+                  </a:tcPr>
+                </a:tc>
+                <a:tc>
+                  <a:txBody>
+                    <a:bodyPr/>
+                    <a:lstStyle/>
+                    <a:p>
+                      <a:pPr indent="0" marL="0">
+                        <a:buNone/>
+                      </a:pPr>
+                      <a:r>
+                        <a:rPr lang="en-US" sz="1050" b="1" dirty="0">
+                          <a:solidFill>
+                            <a:srgbClr val="5A6172"/>
+                          </a:solidFill>
+                          <a:latin typeface="Calibri" pitchFamily="34" charset="0"/>
+                          <a:ea typeface="Calibri" pitchFamily="34" charset="-122"/>
+                          <a:cs typeface="Calibri" pitchFamily="34" charset="-120"/>
+                        </a:rPr>
+                        <a:t>Honest null — no order signal</a:t>
+                      </a:r>
+                      <a:endParaRPr lang="en-US" sz="1050" dirty="0">
+                        <a:latin typeface="Calibri" charset="0"/>
+                        <a:ea typeface="Calibri" charset="0"/>
+                        <a:cs typeface="Calibri" charset="0"/>
+                      </a:endParaRPr>
+                    </a:p>
+                  </a:txBody>
+                  <a:tcPr marL="91440" marR="91440" marT="45720" marB="45720" anchor="ctr">
+                    <a:lnL w="12700" cap="flat" cmpd="sng" algn="ctr">
+                      <a:solidFill>
+                        <a:srgbClr val="D8DEEC"/>
+                      </a:solidFill>
+                      <a:prstDash val="solid"/>
+                      <a:round/>
+                      <a:headEnd type="none" w="med" len="med"/>
+                      <a:tailEnd type="none" w="med" len="med"/>
+                    </a:lnL>
+                    <a:lnR w="12700" cap="flat" cmpd="sng" algn="ctr">
+                      <a:solidFill>
+                        <a:srgbClr val="D8DEEC"/>
+                      </a:solidFill>
+                      <a:prstDash val="solid"/>
+                      <a:round/>
+                      <a:headEnd type="none" w="med" len="med"/>
+                      <a:tailEnd type="none" w="med" len="med"/>
+                    </a:lnR>
+                    <a:lnT w="12700" cap="flat" cmpd="sng" algn="ctr">
+                      <a:solidFill>
+                        <a:srgbClr val="D8DEEC"/>
+                      </a:solidFill>
+                      <a:prstDash val="solid"/>
+                      <a:round/>
+                      <a:headEnd type="none" w="med" len="med"/>
+                      <a:tailEnd type="none" w="med" len="med"/>
+                    </a:lnT>
+                    <a:lnB w="12700" cap="flat" cmpd="sng" algn="ctr">
+                      <a:solidFill>
+                        <a:srgbClr val="D8DEEC"/>
+                      </a:solidFill>
+                      <a:prstDash val="solid"/>
+                      <a:round/>
+                      <a:headEnd type="none" w="med" len="med"/>
+                      <a:tailEnd type="none" w="med" len="med"/>
+                    </a:lnB>
+                  </a:tcPr>
+                </a:tc>
+              </a:tr>
+              <a:tr h="320040">
+                <a:tc>
+                  <a:txBody>
+                    <a:bodyPr/>
+                    <a:lstStyle/>
+                    <a:p>
+                      <a:pPr indent="0" marL="0">
+                        <a:buNone/>
+                      </a:pPr>
+                      <a:r>
+                        <a:rPr lang="en-US" sz="1050" dirty="0">
+                          <a:solidFill>
+                            <a:srgbClr val="1A1A2E"/>
+                          </a:solidFill>
+                          <a:latin typeface="Calibri" pitchFamily="34" charset="0"/>
+                          <a:ea typeface="Calibri" pitchFamily="34" charset="-122"/>
+                          <a:cs typeface="Calibri" pitchFamily="34" charset="-120"/>
+                        </a:rPr>
+                        <a:t>Caps · floors · geo-cover · duplicates</a:t>
+                      </a:r>
+                      <a:endParaRPr lang="en-US" sz="1050" dirty="0">
+                        <a:latin typeface="Calibri" charset="0"/>
+                        <a:ea typeface="Calibri" charset="0"/>
+                        <a:cs typeface="Calibri" charset="0"/>
+                      </a:endParaRPr>
+                    </a:p>
+                  </a:txBody>
+                  <a:tcPr marL="91440" marR="91440" marT="45720" marB="45720" anchor="ctr">
+                    <a:lnL w="12700" cap="flat" cmpd="sng" algn="ctr">
+                      <a:solidFill>
+                        <a:srgbClr val="D8DEEC"/>
+                      </a:solidFill>
+                      <a:prstDash val="solid"/>
+                      <a:round/>
+                      <a:headEnd type="none" w="med" len="med"/>
+                      <a:tailEnd type="none" w="med" len="med"/>
+                    </a:lnL>
+                    <a:lnR w="12700" cap="flat" cmpd="sng" algn="ctr">
+                      <a:solidFill>
+                        <a:srgbClr val="D8DEEC"/>
+                      </a:solidFill>
+                      <a:prstDash val="solid"/>
+                      <a:round/>
+                      <a:headEnd type="none" w="med" len="med"/>
+                      <a:tailEnd type="none" w="med" len="med"/>
+                    </a:lnR>
+                    <a:lnT w="12700" cap="flat" cmpd="sng" algn="ctr">
+                      <a:solidFill>
+                        <a:srgbClr val="D8DEEC"/>
+                      </a:solidFill>
+                      <a:prstDash val="solid"/>
+                      <a:round/>
+                      <a:headEnd type="none" w="med" len="med"/>
+                      <a:tailEnd type="none" w="med" len="med"/>
+                    </a:lnT>
+                    <a:lnB w="12700" cap="flat" cmpd="sng" algn="ctr">
+                      <a:solidFill>
+                        <a:srgbClr val="D8DEEC"/>
+                      </a:solidFill>
+                      <a:prstDash val="solid"/>
+                      <a:round/>
+                      <a:headEnd type="none" w="med" len="med"/>
+                      <a:tailEnd type="none" w="med" len="med"/>
+                    </a:lnB>
+                  </a:tcPr>
+                </a:tc>
+                <a:tc>
+                  <a:txBody>
+                    <a:bodyPr/>
+                    <a:lstStyle/>
+                    <a:p>
+                      <a:pPr indent="0" marL="0">
+                        <a:buNone/>
+                      </a:pPr>
+                      <a:r>
+                        <a:rPr lang="en-US" sz="1050" dirty="0">
+                          <a:solidFill>
+                            <a:srgbClr val="1A1A2E"/>
+                          </a:solidFill>
+                          <a:latin typeface="Calibri" pitchFamily="34" charset="0"/>
+                          <a:ea typeface="Calibri" pitchFamily="34" charset="-122"/>
+                          <a:cs typeface="Calibri" pitchFamily="34" charset="-120"/>
+                        </a:rPr>
+                        <a:t>exact by construction</a:t>
+                      </a:r>
+                      <a:endParaRPr lang="en-US" sz="1050" dirty="0">
+                        <a:latin typeface="Calibri" charset="0"/>
+                        <a:ea typeface="Calibri" charset="0"/>
+                        <a:cs typeface="Calibri" charset="0"/>
+                      </a:endParaRPr>
+                    </a:p>
+                  </a:txBody>
+                  <a:tcPr marL="91440" marR="91440" marT="45720" marB="45720" anchor="ctr">
+                    <a:lnL w="12700" cap="flat" cmpd="sng" algn="ctr">
+                      <a:solidFill>
+                        <a:srgbClr val="D8DEEC"/>
+                      </a:solidFill>
+                      <a:prstDash val="solid"/>
+                      <a:round/>
+                      <a:headEnd type="none" w="med" len="med"/>
+                      <a:tailEnd type="none" w="med" len="med"/>
+                    </a:lnL>
+                    <a:lnR w="12700" cap="flat" cmpd="sng" algn="ctr">
+                      <a:solidFill>
+                        <a:srgbClr val="D8DEEC"/>
+                      </a:solidFill>
+                      <a:prstDash val="solid"/>
+                      <a:round/>
+                      <a:headEnd type="none" w="med" len="med"/>
+                      <a:tailEnd type="none" w="med" len="med"/>
+                    </a:lnR>
+                    <a:lnT w="12700" cap="flat" cmpd="sng" algn="ctr">
+                      <a:solidFill>
+                        <a:srgbClr val="D8DEEC"/>
+                      </a:solidFill>
+                      <a:prstDash val="solid"/>
+                      <a:round/>
+                      <a:headEnd type="none" w="med" len="med"/>
+                      <a:tailEnd type="none" w="med" len="med"/>
+                    </a:lnT>
+                    <a:lnB w="12700" cap="flat" cmpd="sng" algn="ctr">
+                      <a:solidFill>
+                        <a:srgbClr val="D8DEEC"/>
+                      </a:solidFill>
+                      <a:prstDash val="solid"/>
+                      <a:round/>
+                      <a:headEnd type="none" w="med" len="med"/>
+                      <a:tailEnd type="none" w="med" len="med"/>
+                    </a:lnB>
+                  </a:tcPr>
+                </a:tc>
+                <a:tc>
+                  <a:txBody>
+                    <a:bodyPr/>
+                    <a:lstStyle/>
+                    <a:p>
+                      <a:pPr indent="0" marL="0">
+                        <a:buNone/>
+                      </a:pPr>
+                      <a:r>
+                        <a:rPr lang="en-US" sz="1050" dirty="0">
+                          <a:solidFill>
+                            <a:srgbClr val="1A1A2E"/>
+                          </a:solidFill>
+                          <a:latin typeface="Calibri" pitchFamily="34" charset="0"/>
+                          <a:ea typeface="Calibri" pitchFamily="34" charset="-122"/>
+                          <a:cs typeface="Calibri" pitchFamily="34" charset="-120"/>
+                        </a:rPr>
+                        <a:t>—</a:t>
+                      </a:r>
+                      <a:endParaRPr lang="en-US" sz="1050" dirty="0">
+                        <a:latin typeface="Calibri" charset="0"/>
+                        <a:ea typeface="Calibri" charset="0"/>
+                        <a:cs typeface="Calibri" charset="0"/>
+                      </a:endParaRPr>
+                    </a:p>
+                  </a:txBody>
+                  <a:tcPr marL="91440" marR="91440" marT="45720" marB="45720" anchor="ctr">
+                    <a:lnL w="12700" cap="flat" cmpd="sng" algn="ctr">
+                      <a:solidFill>
+                        <a:srgbClr val="D8DEEC"/>
+                      </a:solidFill>
+                      <a:prstDash val="solid"/>
+                      <a:round/>
+                      <a:headEnd type="none" w="med" len="med"/>
+                      <a:tailEnd type="none" w="med" len="med"/>
+                    </a:lnL>
+                    <a:lnR w="12700" cap="flat" cmpd="sng" algn="ctr">
+                      <a:solidFill>
+                        <a:srgbClr val="D8DEEC"/>
+                      </a:solidFill>
+                      <a:prstDash val="solid"/>
+                      <a:round/>
+                      <a:headEnd type="none" w="med" len="med"/>
+                      <a:tailEnd type="none" w="med" len="med"/>
+                    </a:lnR>
+                    <a:lnT w="12700" cap="flat" cmpd="sng" algn="ctr">
+                      <a:solidFill>
+                        <a:srgbClr val="D8DEEC"/>
+                      </a:solidFill>
+                      <a:prstDash val="solid"/>
+                      <a:round/>
+                      <a:headEnd type="none" w="med" len="med"/>
+                      <a:tailEnd type="none" w="med" len="med"/>
+                    </a:lnT>
+                    <a:lnB w="12700" cap="flat" cmpd="sng" algn="ctr">
+                      <a:solidFill>
+                        <a:srgbClr val="D8DEEC"/>
+                      </a:solidFill>
+                      <a:prstDash val="solid"/>
+                      <a:round/>
+                      <a:headEnd type="none" w="med" len="med"/>
+                      <a:tailEnd type="none" w="med" len="med"/>
+                    </a:lnB>
+                  </a:tcPr>
+                </a:tc>
+                <a:tc>
+                  <a:txBody>
+                    <a:bodyPr/>
+                    <a:lstStyle/>
+                    <a:p>
+                      <a:pPr indent="0" marL="0">
+                        <a:buNone/>
+                      </a:pPr>
+                      <a:r>
+                        <a:rPr lang="en-US" sz="1050" b="1" dirty="0">
+                          <a:solidFill>
+                            <a:srgbClr val="5A6172"/>
+                          </a:solidFill>
+                          <a:latin typeface="Calibri" pitchFamily="34" charset="0"/>
+                          <a:ea typeface="Calibri" pitchFamily="34" charset="-122"/>
+                          <a:cs typeface="Calibri" pitchFamily="34" charset="-120"/>
+                        </a:rPr>
+                        <a:t>Rules &amp; guards, not ML</a:t>
+                      </a:r>
+                      <a:endParaRPr lang="en-US" sz="1050" dirty="0">
+                        <a:latin typeface="Calibri" charset="0"/>
+                        <a:ea typeface="Calibri" charset="0"/>
+                        <a:cs typeface="Calibri" charset="0"/>
+                      </a:endParaRPr>
+                    </a:p>
+                  </a:txBody>
+                  <a:tcPr marL="91440" marR="91440" marT="45720" marB="45720" anchor="ctr">
+                    <a:lnL w="12700" cap="flat" cmpd="sng" algn="ctr">
+                      <a:solidFill>
+                        <a:srgbClr val="D8DEEC"/>
+                      </a:solidFill>
+                      <a:prstDash val="solid"/>
+                      <a:round/>
+                      <a:headEnd type="none" w="med" len="med"/>
+                      <a:tailEnd type="none" w="med" len="med"/>
+                    </a:lnL>
+                    <a:lnR w="12700" cap="flat" cmpd="sng" algn="ctr">
+                      <a:solidFill>
+                        <a:srgbClr val="D8DEEC"/>
+                      </a:solidFill>
+                      <a:prstDash val="solid"/>
+                      <a:round/>
+                      <a:headEnd type="none" w="med" len="med"/>
+                      <a:tailEnd type="none" w="med" len="med"/>
+                    </a:lnR>
+                    <a:lnT w="12700" cap="flat" cmpd="sng" algn="ctr">
+                      <a:solidFill>
+                        <a:srgbClr val="D8DEEC"/>
+                      </a:solidFill>
+                      <a:prstDash val="solid"/>
+                      <a:round/>
+                      <a:headEnd type="none" w="med" len="med"/>
+                      <a:tailEnd type="none" w="med" len="med"/>
+                    </a:lnT>
+                    <a:lnB w="12700" cap="flat" cmpd="sng" algn="ctr">
+                      <a:solidFill>
+                        <a:srgbClr val="D8DEEC"/>
+                      </a:solidFill>
+                      <a:prstDash val="solid"/>
+                      <a:round/>
+                      <a:headEnd type="none" w="med" len="med"/>
+                      <a:tailEnd type="none" w="med" len="med"/>
+                    </a:lnB>
+                  </a:tcPr>
+                </a:tc>
+              </a:tr>
+              <a:tr h="320040">
+                <a:tc>
+                  <a:txBody>
+                    <a:bodyPr/>
+                    <a:lstStyle/>
+                    <a:p>
+                      <a:pPr indent="0" marL="0">
+                        <a:buNone/>
+                      </a:pPr>
+                      <a:r>
+                        <a:rPr lang="en-US" sz="1050" dirty="0">
+                          <a:solidFill>
+                            <a:srgbClr val="1A1A2E"/>
+                          </a:solidFill>
+                          <a:latin typeface="Calibri" pitchFamily="34" charset="0"/>
+                          <a:ea typeface="Calibri" pitchFamily="34" charset="-122"/>
+                          <a:cs typeface="Calibri" pitchFamily="34" charset="-120"/>
+                        </a:rPr>
+                        <a:t>Missing-field infill (imputation)</a:t>
+                      </a:r>
+                      <a:endParaRPr lang="en-US" sz="1050" dirty="0">
+                        <a:latin typeface="Calibri" charset="0"/>
+                        <a:ea typeface="Calibri" charset="0"/>
+                        <a:cs typeface="Calibri" charset="0"/>
+                      </a:endParaRPr>
+                    </a:p>
+                  </a:txBody>
+                  <a:tcPr marL="91440" marR="91440" marT="45720" marB="45720" anchor="ctr">
+                    <a:lnL w="12700" cap="flat" cmpd="sng" algn="ctr">
+                      <a:solidFill>
+                        <a:srgbClr val="D8DEEC"/>
+                      </a:solidFill>
+                      <a:prstDash val="solid"/>
+                      <a:round/>
+                      <a:headEnd type="none" w="med" len="med"/>
+                      <a:tailEnd type="none" w="med" len="med"/>
+                    </a:lnL>
+                    <a:lnR w="12700" cap="flat" cmpd="sng" algn="ctr">
+                      <a:solidFill>
+                        <a:srgbClr val="D8DEEC"/>
+                      </a:solidFill>
+                      <a:prstDash val="solid"/>
+                      <a:round/>
+                      <a:headEnd type="none" w="med" len="med"/>
+                      <a:tailEnd type="none" w="med" len="med"/>
+                    </a:lnR>
+                    <a:lnT w="12700" cap="flat" cmpd="sng" algn="ctr">
+                      <a:solidFill>
+                        <a:srgbClr val="D8DEEC"/>
+                      </a:solidFill>
+                      <a:prstDash val="solid"/>
+                      <a:round/>
+                      <a:headEnd type="none" w="med" len="med"/>
+                      <a:tailEnd type="none" w="med" len="med"/>
+                    </a:lnT>
+                    <a:lnB w="12700" cap="flat" cmpd="sng" algn="ctr">
+                      <a:solidFill>
+                        <a:srgbClr val="D8DEEC"/>
+                      </a:solidFill>
+                      <a:prstDash val="solid"/>
+                      <a:round/>
+                      <a:headEnd type="none" w="med" len="med"/>
+                      <a:tailEnd type="none" w="med" len="med"/>
+                    </a:lnB>
+                  </a:tcPr>
+                </a:tc>
+                <a:tc>
+                  <a:txBody>
+                    <a:bodyPr/>
+                    <a:lstStyle/>
+                    <a:p>
+                      <a:pPr indent="0" marL="0">
+                        <a:buNone/>
+                      </a:pPr>
+                      <a:r>
+                        <a:rPr lang="en-US" sz="1050" dirty="0">
+                          <a:solidFill>
+                            <a:srgbClr val="1A1A2E"/>
+                          </a:solidFill>
+                          <a:latin typeface="Calibri" pitchFamily="34" charset="0"/>
+                          <a:ea typeface="Calibri" pitchFamily="34" charset="-122"/>
+                          <a:cs typeface="Calibri" pitchFamily="34" charset="-120"/>
+                        </a:rPr>
+                        <a:t>structured fields only</a:t>
+                      </a:r>
+                      <a:endParaRPr lang="en-US" sz="1050" dirty="0">
+                        <a:latin typeface="Calibri" charset="0"/>
+                        <a:ea typeface="Calibri" charset="0"/>
+                        <a:cs typeface="Calibri" charset="0"/>
+                      </a:endParaRPr>
+                    </a:p>
+                  </a:txBody>
+                  <a:tcPr marL="91440" marR="91440" marT="45720" marB="45720" anchor="ctr">
+                    <a:lnL w="12700" cap="flat" cmpd="sng" algn="ctr">
+                      <a:solidFill>
+                        <a:srgbClr val="D8DEEC"/>
+                      </a:solidFill>
+                      <a:prstDash val="solid"/>
+                      <a:round/>
+                      <a:headEnd type="none" w="med" len="med"/>
+                      <a:tailEnd type="none" w="med" len="med"/>
+                    </a:lnL>
+                    <a:lnR w="12700" cap="flat" cmpd="sng" algn="ctr">
+                      <a:solidFill>
+                        <a:srgbClr val="D8DEEC"/>
+                      </a:solidFill>
+                      <a:prstDash val="solid"/>
+                      <a:round/>
+                      <a:headEnd type="none" w="med" len="med"/>
+                      <a:tailEnd type="none" w="med" len="med"/>
+                    </a:lnR>
+                    <a:lnT w="12700" cap="flat" cmpd="sng" algn="ctr">
+                      <a:solidFill>
+                        <a:srgbClr val="D8DEEC"/>
+                      </a:solidFill>
+                      <a:prstDash val="solid"/>
+                      <a:round/>
+                      <a:headEnd type="none" w="med" len="med"/>
+                      <a:tailEnd type="none" w="med" len="med"/>
+                    </a:lnT>
+                    <a:lnB w="12700" cap="flat" cmpd="sng" algn="ctr">
+                      <a:solidFill>
+                        <a:srgbClr val="D8DEEC"/>
+                      </a:solidFill>
+                      <a:prstDash val="solid"/>
+                      <a:round/>
+                      <a:headEnd type="none" w="med" len="med"/>
+                      <a:tailEnd type="none" w="med" len="med"/>
+                    </a:lnB>
+                  </a:tcPr>
+                </a:tc>
+                <a:tc>
+                  <a:txBody>
+                    <a:bodyPr/>
+                    <a:lstStyle/>
+                    <a:p>
+                      <a:pPr indent="0" marL="0">
+                        <a:buNone/>
+                      </a:pPr>
+                      <a:r>
+                        <a:rPr lang="en-US" sz="1050" dirty="0">
+                          <a:solidFill>
+                            <a:srgbClr val="1A1A2E"/>
+                          </a:solidFill>
+                          <a:latin typeface="Calibri" pitchFamily="34" charset="0"/>
+                          <a:ea typeface="Calibri" pitchFamily="34" charset="-122"/>
+                          <a:cs typeface="Calibri" pitchFamily="34" charset="-120"/>
+                        </a:rPr>
+                        <a:t>—</a:t>
+                      </a:r>
+                      <a:endParaRPr lang="en-US" sz="1050" dirty="0">
+                        <a:latin typeface="Calibri" charset="0"/>
+                        <a:ea typeface="Calibri" charset="0"/>
+                        <a:cs typeface="Calibri" charset="0"/>
+                      </a:endParaRPr>
+                    </a:p>
+                  </a:txBody>
+                  <a:tcPr marL="91440" marR="91440" marT="45720" marB="45720" anchor="ctr">
+                    <a:lnL w="12700" cap="flat" cmpd="sng" algn="ctr">
+                      <a:solidFill>
+                        <a:srgbClr val="D8DEEC"/>
+                      </a:solidFill>
+                      <a:prstDash val="solid"/>
+                      <a:round/>
+                      <a:headEnd type="none" w="med" len="med"/>
+                      <a:tailEnd type="none" w="med" len="med"/>
+                    </a:lnL>
+                    <a:lnR w="12700" cap="flat" cmpd="sng" algn="ctr">
+                      <a:solidFill>
+                        <a:srgbClr val="D8DEEC"/>
+                      </a:solidFill>
+                      <a:prstDash val="solid"/>
+                      <a:round/>
+                      <a:headEnd type="none" w="med" len="med"/>
+                      <a:tailEnd type="none" w="med" len="med"/>
+                    </a:lnR>
+                    <a:lnT w="12700" cap="flat" cmpd="sng" algn="ctr">
+                      <a:solidFill>
+                        <a:srgbClr val="D8DEEC"/>
+                      </a:solidFill>
+                      <a:prstDash val="solid"/>
+                      <a:round/>
+                      <a:headEnd type="none" w="med" len="med"/>
+                      <a:tailEnd type="none" w="med" len="med"/>
+                    </a:lnT>
+                    <a:lnB w="12700" cap="flat" cmpd="sng" algn="ctr">
+                      <a:solidFill>
+                        <a:srgbClr val="D8DEEC"/>
+                      </a:solidFill>
+                      <a:prstDash val="solid"/>
+                      <a:round/>
+                      <a:headEnd type="none" w="med" len="med"/>
+                      <a:tailEnd type="none" w="med" len="med"/>
+                    </a:lnB>
+                  </a:tcPr>
+                </a:tc>
+                <a:tc>
+                  <a:txBody>
+                    <a:bodyPr/>
+                    <a:lstStyle/>
+                    <a:p>
+                      <a:pPr indent="0" marL="0">
+                        <a:buNone/>
+                      </a:pPr>
+                      <a:r>
+                        <a:rPr lang="en-US" sz="1050" b="1" dirty="0">
+                          <a:solidFill>
+                            <a:srgbClr val="5A6172"/>
+                          </a:solidFill>
+                          <a:latin typeface="Calibri" pitchFamily="34" charset="0"/>
+                          <a:ea typeface="Calibri" pitchFamily="34" charset="-122"/>
+                          <a:cs typeface="Calibri" pitchFamily="34" charset="-120"/>
+                        </a:rPr>
+                        <a:t>IDs / dates → lookup, not inference</a:t>
+                      </a:r>
+                      <a:endParaRPr lang="en-US" sz="1050" dirty="0">
+                        <a:latin typeface="Calibri" charset="0"/>
+                        <a:ea typeface="Calibri" charset="0"/>
+                        <a:cs typeface="Calibri" charset="0"/>
+                      </a:endParaRPr>
+                    </a:p>
+                  </a:txBody>
+                  <a:tcPr marL="91440" marR="91440" marT="45720" marB="45720" anchor="ctr">
+                    <a:lnL w="12700" cap="flat" cmpd="sng" algn="ctr">
+                      <a:solidFill>
+                        <a:srgbClr val="D8DEEC"/>
+                      </a:solidFill>
+                      <a:prstDash val="solid"/>
+                      <a:round/>
+                      <a:headEnd type="none" w="med" len="med"/>
+                      <a:tailEnd type="none" w="med" len="med"/>
+                    </a:lnL>
+                    <a:lnR w="12700" cap="flat" cmpd="sng" algn="ctr">
+                      <a:solidFill>
+                        <a:srgbClr val="D8DEEC"/>
+                      </a:solidFill>
+                      <a:prstDash val="solid"/>
+                      <a:round/>
+                      <a:headEnd type="none" w="med" len="med"/>
+                      <a:tailEnd type="none" w="med" len="med"/>
+                    </a:lnR>
+                    <a:lnT w="12700" cap="flat" cmpd="sng" algn="ctr">
+                      <a:solidFill>
+                        <a:srgbClr val="D8DEEC"/>
+                      </a:solidFill>
+                      <a:prstDash val="solid"/>
+                      <a:round/>
+                      <a:headEnd type="none" w="med" len="med"/>
+                      <a:tailEnd type="none" w="med" len="med"/>
+                    </a:lnT>
+                    <a:lnB w="12700" cap="flat" cmpd="sng" algn="ctr">
+                      <a:solidFill>
+                        <a:srgbClr val="D8DEEC"/>
+                      </a:solidFill>
+                      <a:prstDash val="solid"/>
+                      <a:round/>
+                      <a:headEnd type="none" w="med" len="med"/>
+                      <a:tailEnd type="none" w="med" len="med"/>
+                    </a:lnB>
+                  </a:tcPr>
+                </a:tc>
+              </a:tr>
+            </a:tbl>
+          </a:graphicData>
+        </a:graphic>
+      </p:graphicFrame>
+      <p:sp>
+        <p:nvSpPr>
+          <p:cNvPr id="5" name="Text 2"/>
+          <p:cNvSpPr/>
+          <p:nvPr/>
+        </p:nvSpPr>
+        <p:spPr>
+          <a:xfrm>
+            <a:off x="457200" y="5943600"/>
+            <a:ext cx="11274552" cy="594360"/>
+          </a:xfrm>
+          <a:prstGeom prst="rect">
+            <a:avLst/>
+          </a:prstGeom>
+          <a:noFill/>
+          <a:ln/>
+        </p:spPr>
+        <p:txBody>
+          <a:bodyPr wrap="square" rtlCol="0" anchor="ctr"/>
+          <a:lstStyle/>
+          <a:p>
+            <a:pPr indent="0" marL="0">
+              <a:buNone/>
+            </a:pPr>
+            <a:r>
+              <a:rPr lang="en-US" sz="1150" i="1" dirty="0">
+                <a:solidFill>
+                  <a:srgbClr val="5A6172"/>
+                </a:solidFill>
+                <a:latin typeface="Calibri" pitchFamily="34" charset="0"/>
+                <a:ea typeface="Calibri" pitchFamily="34" charset="-122"/>
+                <a:cs typeface="Calibri" pitchFamily="34" charset="-120"/>
+              </a:rPr>
+              <a:t>Green = the frozen backbone beats its baseline. Amber / red = a tuned tree matches or wins on complete-record labels — the paper's C2 finding, reported openly and routed to the right tool. Grey = deliberately not ML.</a:t>
+            </a:r>
+            <a:endParaRPr lang="en-US" sz="1150" dirty="0"/>
+          </a:p>
+        </p:txBody>
+      </p:sp>
+    </p:spTree>
+  </p:cSld>
+  <p:clrMapOvr>
+    <a:masterClrMapping/>
+  </p:clrMapOvr>
+</p:sld>
+</file>
+
+<file path=ppt/slides/slide11.xml><?xml version="1.0" encoding="utf-8"?>
+<p:sld xmlns:a="http://schemas.openxmlformats.org/drawingml/2006/main" xmlns:r="http://schemas.openxmlformats.org/officeDocument/2006/relationships" xmlns:p="http://schemas.openxmlformats.org/presentationml/2006/main">
+  <p:cSld name="Slide 11">
+    <p:bg>
+      <p:bgPr>
+        <a:solidFill>
+          <a:srgbClr val="FFFFFF"/>
+        </a:solidFill>
+      </p:bgPr>
+    </p:bg>
+    <p:spTree>
+      <p:nvGrpSpPr>
+        <p:cNvPr id="1" name=""/>
+        <p:cNvGrpSpPr/>
+        <p:nvPr/>
+      </p:nvGrpSpPr>
+      <p:grpSpPr>
+        <a:xfrm>
+          <a:off x="0" y="0"/>
+          <a:ext cx="0" cy="0"/>
+          <a:chOff x="0" y="0"/>
+          <a:chExt cx="0" cy="0"/>
+        </a:xfrm>
+      </p:grpSpPr>
+      <p:sp>
+        <p:nvSpPr>
+          <p:cNvPr id="2" name="Text 0"/>
+          <p:cNvSpPr/>
+          <p:nvPr/>
+        </p:nvSpPr>
+        <p:spPr>
+          <a:xfrm>
+            <a:off x="548640" y="365760"/>
+            <a:ext cx="11064240" cy="594360"/>
+          </a:xfrm>
+          <a:prstGeom prst="rect">
+            <a:avLst/>
+          </a:prstGeom>
+          <a:noFill/>
+          <a:ln/>
+        </p:spPr>
+        <p:txBody>
+          <a:bodyPr wrap="square" rtlCol="0" anchor="ctr"/>
+          <a:lstStyle/>
+          <a:p>
+            <a:pPr indent="0" marL="0">
+              <a:buNone/>
+            </a:pPr>
+            <a:r>
+              <a:rPr lang="en-US" sz="3000" b="1" dirty="0">
+                <a:solidFill>
+                  <a:srgbClr val="1E2761"/>
+                </a:solidFill>
+                <a:latin typeface="Cambria" pitchFamily="34" charset="0"/>
+                <a:ea typeface="Cambria" pitchFamily="34" charset="-122"/>
+                <a:cs typeface="Cambria" pitchFamily="34" charset="-120"/>
+              </a:rPr>
               <a:t>Actual predictions — a sample</a:t>
             </a:r>
             <a:endParaRPr lang="en-US" sz="3000" dirty="0"/>
@@ -2324,7 +6012,7 @@
       </p:sp>
       <p:graphicFrame>
         <p:nvGraphicFramePr>
-          <p:cNvPr id="11" name="Table 0"/>
+          <p:cNvPr id="12" name="Table 0"/>
           <p:cNvGraphicFramePr>
             <a:graphicFrameLocks noGrp="1"/>
           </p:cNvGraphicFramePr>
@@ -2345,13 +6033,14 @@
             <a:tbl>
               <a:tblPr/>
               <a:tblGrid>
-                <a:gridCol w="1600200"/>
+                <a:gridCol w="1463040"/>
+                <a:gridCol w="960120"/>
                 <a:gridCol w="1097280"/>
-                <a:gridCol w="1188720"/>
-                <a:gridCol w="1965960"/>
-                <a:gridCol w="1965960"/>
-                <a:gridCol w="1600200"/>
-                <a:gridCol w="1856232"/>
+                <a:gridCol w="1828800"/>
+                <a:gridCol w="960120"/>
+                <a:gridCol w="1783080"/>
+                <a:gridCol w="1508760"/>
+                <a:gridCol w="1673352"/>
               </a:tblGrid>
               <a:tr h="502920">
                 <a:tc>
@@ -2576,6 +6265,74 @@
                           <a:cs typeface="Calibri" pitchFamily="34" charset="-120"/>
                         </a:rPr>
                         <a:t>Predicted (conf)</a:t>
+                      </a:r>
+                      <a:endParaRPr lang="en-US" sz="1200" dirty="0">
+                        <a:latin typeface="Calibri" charset="0"/>
+                        <a:ea typeface="Calibri" charset="0"/>
+                        <a:cs typeface="Calibri" charset="0"/>
+                      </a:endParaRPr>
+                    </a:p>
+                  </a:txBody>
+                  <a:tcPr marL="91440" marR="91440" marT="45720" marB="45720" anchor="ctr">
+                    <a:lnL w="12700" cap="flat" cmpd="sng" algn="ctr">
+                      <a:solidFill>
+                        <a:srgbClr val="D8DEEC"/>
+                      </a:solidFill>
+                      <a:prstDash val="solid"/>
+                      <a:round/>
+                      <a:headEnd type="none" w="med" len="med"/>
+                      <a:tailEnd type="none" w="med" len="med"/>
+                    </a:lnL>
+                    <a:lnR w="12700" cap="flat" cmpd="sng" algn="ctr">
+                      <a:solidFill>
+                        <a:srgbClr val="D8DEEC"/>
+                      </a:solidFill>
+                      <a:prstDash val="solid"/>
+                      <a:round/>
+                      <a:headEnd type="none" w="med" len="med"/>
+                      <a:tailEnd type="none" w="med" len="med"/>
+                    </a:lnR>
+                    <a:lnT w="12700" cap="flat" cmpd="sng" algn="ctr">
+                      <a:solidFill>
+                        <a:srgbClr val="D8DEEC"/>
+                      </a:solidFill>
+                      <a:prstDash val="solid"/>
+                      <a:round/>
+                      <a:headEnd type="none" w="med" len="med"/>
+                      <a:tailEnd type="none" w="med" len="med"/>
+                    </a:lnT>
+                    <a:lnB w="12700" cap="flat" cmpd="sng" algn="ctr">
+                      <a:solidFill>
+                        <a:srgbClr val="D8DEEC"/>
+                      </a:solidFill>
+                      <a:prstDash val="solid"/>
+                      <a:round/>
+                      <a:headEnd type="none" w="med" len="med"/>
+                      <a:tailEnd type="none" w="med" len="med"/>
+                    </a:lnB>
+                    <a:solidFill>
+                      <a:srgbClr val="1E2761"/>
+                    </a:solidFill>
+                  </a:tcPr>
+                </a:tc>
+                <a:tc>
+                  <a:txBody>
+                    <a:bodyPr/>
+                    <a:lstStyle/>
+                    <a:p>
+                      <a:pPr indent="0" marL="0">
+                        <a:buNone/>
+                      </a:pPr>
+                      <a:r>
+                        <a:rPr lang="en-US" sz="1200" b="1" dirty="0">
+                          <a:solidFill>
+                            <a:srgbClr val="FFFFFF"/>
+                          </a:solidFill>
+                          <a:latin typeface="Calibri" pitchFamily="34" charset="0"/>
+                          <a:ea typeface="Calibri" pitchFamily="34" charset="-122"/>
+                          <a:cs typeface="Calibri" pitchFamily="34" charset="-120"/>
+                        </a:rPr>
+                        <a:t>Risk</a:t>
                       </a:r>
                       <a:endParaRPr lang="en-US" sz="1200" dirty="0">
                         <a:latin typeface="Calibri" charset="0"/>
@@ -3103,6 +6860,71 @@
                       <a:r>
                         <a:rPr lang="en-US" sz="1200" dirty="0">
                           <a:solidFill>
+                            <a:srgbClr val="2E7D32"/>
+                          </a:solidFill>
+                          <a:latin typeface="Calibri" pitchFamily="34" charset="0"/>
+                          <a:ea typeface="Calibri" pitchFamily="34" charset="-122"/>
+                          <a:cs typeface="Calibri" pitchFamily="34" charset="-120"/>
+                        </a:rPr>
+                        <a:t>Low ✓</a:t>
+                      </a:r>
+                      <a:endParaRPr lang="en-US" sz="1200" dirty="0">
+                        <a:latin typeface="Calibri" charset="0"/>
+                        <a:ea typeface="Calibri" charset="0"/>
+                        <a:cs typeface="Calibri" charset="0"/>
+                      </a:endParaRPr>
+                    </a:p>
+                  </a:txBody>
+                  <a:tcPr marL="91440" marR="91440" marT="45720" marB="45720" anchor="ctr">
+                    <a:lnL w="12700" cap="flat" cmpd="sng" algn="ctr">
+                      <a:solidFill>
+                        <a:srgbClr val="D8DEEC"/>
+                      </a:solidFill>
+                      <a:prstDash val="solid"/>
+                      <a:round/>
+                      <a:headEnd type="none" w="med" len="med"/>
+                      <a:tailEnd type="none" w="med" len="med"/>
+                    </a:lnL>
+                    <a:lnR w="12700" cap="flat" cmpd="sng" algn="ctr">
+                      <a:solidFill>
+                        <a:srgbClr val="D8DEEC"/>
+                      </a:solidFill>
+                      <a:prstDash val="solid"/>
+                      <a:round/>
+                      <a:headEnd type="none" w="med" len="med"/>
+                      <a:tailEnd type="none" w="med" len="med"/>
+                    </a:lnR>
+                    <a:lnT w="12700" cap="flat" cmpd="sng" algn="ctr">
+                      <a:solidFill>
+                        <a:srgbClr val="D8DEEC"/>
+                      </a:solidFill>
+                      <a:prstDash val="solid"/>
+                      <a:round/>
+                      <a:headEnd type="none" w="med" len="med"/>
+                      <a:tailEnd type="none" w="med" len="med"/>
+                    </a:lnT>
+                    <a:lnB w="12700" cap="flat" cmpd="sng" algn="ctr">
+                      <a:solidFill>
+                        <a:srgbClr val="D8DEEC"/>
+                      </a:solidFill>
+                      <a:prstDash val="solid"/>
+                      <a:round/>
+                      <a:headEnd type="none" w="med" len="med"/>
+                      <a:tailEnd type="none" w="med" len="med"/>
+                    </a:lnB>
+                  </a:tcPr>
+                </a:tc>
+                <a:tc>
+                  <a:txBody>
+                    <a:bodyPr/>
+                    <a:lstStyle/>
+                    <a:p>
+                      <a:pPr indent="0" marL="0">
+                        <a:buNone/>
+                      </a:pPr>
+                      <a:r>
+                        <a:rPr lang="en-US" sz="1200" dirty="0">
+                          <a:solidFill>
                             <a:srgbClr val="1A1A2E"/>
                           </a:solidFill>
                           <a:latin typeface="Calibri" pitchFamily="34" charset="0"/>
@@ -3560,6 +7382,71 @@
                       <a:r>
                         <a:rPr lang="en-US" sz="1200" dirty="0">
                           <a:solidFill>
+                            <a:srgbClr val="2E7D32"/>
+                          </a:solidFill>
+                          <a:latin typeface="Calibri" pitchFamily="34" charset="0"/>
+                          <a:ea typeface="Calibri" pitchFamily="34" charset="-122"/>
+                          <a:cs typeface="Calibri" pitchFamily="34" charset="-120"/>
+                        </a:rPr>
+                        <a:t>High ✓</a:t>
+                      </a:r>
+                      <a:endParaRPr lang="en-US" sz="1200" dirty="0">
+                        <a:latin typeface="Calibri" charset="0"/>
+                        <a:ea typeface="Calibri" charset="0"/>
+                        <a:cs typeface="Calibri" charset="0"/>
+                      </a:endParaRPr>
+                    </a:p>
+                  </a:txBody>
+                  <a:tcPr marL="91440" marR="91440" marT="45720" marB="45720" anchor="ctr">
+                    <a:lnL w="12700" cap="flat" cmpd="sng" algn="ctr">
+                      <a:solidFill>
+                        <a:srgbClr val="D8DEEC"/>
+                      </a:solidFill>
+                      <a:prstDash val="solid"/>
+                      <a:round/>
+                      <a:headEnd type="none" w="med" len="med"/>
+                      <a:tailEnd type="none" w="med" len="med"/>
+                    </a:lnL>
+                    <a:lnR w="12700" cap="flat" cmpd="sng" algn="ctr">
+                      <a:solidFill>
+                        <a:srgbClr val="D8DEEC"/>
+                      </a:solidFill>
+                      <a:prstDash val="solid"/>
+                      <a:round/>
+                      <a:headEnd type="none" w="med" len="med"/>
+                      <a:tailEnd type="none" w="med" len="med"/>
+                    </a:lnR>
+                    <a:lnT w="12700" cap="flat" cmpd="sng" algn="ctr">
+                      <a:solidFill>
+                        <a:srgbClr val="D8DEEC"/>
+                      </a:solidFill>
+                      <a:prstDash val="solid"/>
+                      <a:round/>
+                      <a:headEnd type="none" w="med" len="med"/>
+                      <a:tailEnd type="none" w="med" len="med"/>
+                    </a:lnT>
+                    <a:lnB w="12700" cap="flat" cmpd="sng" algn="ctr">
+                      <a:solidFill>
+                        <a:srgbClr val="D8DEEC"/>
+                      </a:solidFill>
+                      <a:prstDash val="solid"/>
+                      <a:round/>
+                      <a:headEnd type="none" w="med" len="med"/>
+                      <a:tailEnd type="none" w="med" len="med"/>
+                    </a:lnB>
+                  </a:tcPr>
+                </a:tc>
+                <a:tc>
+                  <a:txBody>
+                    <a:bodyPr/>
+                    <a:lstStyle/>
+                    <a:p>
+                      <a:pPr indent="0" marL="0">
+                        <a:buNone/>
+                      </a:pPr>
+                      <a:r>
+                        <a:rPr lang="en-US" sz="1200" dirty="0">
+                          <a:solidFill>
                             <a:srgbClr val="1A1A2E"/>
                           </a:solidFill>
                           <a:latin typeface="Calibri" pitchFamily="34" charset="0"/>
@@ -4017,6 +7904,71 @@
                       <a:r>
                         <a:rPr lang="en-US" sz="1200" dirty="0">
                           <a:solidFill>
+                            <a:srgbClr val="2E7D32"/>
+                          </a:solidFill>
+                          <a:latin typeface="Calibri" pitchFamily="34" charset="0"/>
+                          <a:ea typeface="Calibri" pitchFamily="34" charset="-122"/>
+                          <a:cs typeface="Calibri" pitchFamily="34" charset="-120"/>
+                        </a:rPr>
+                        <a:t>Medium ✓</a:t>
+                      </a:r>
+                      <a:endParaRPr lang="en-US" sz="1200" dirty="0">
+                        <a:latin typeface="Calibri" charset="0"/>
+                        <a:ea typeface="Calibri" charset="0"/>
+                        <a:cs typeface="Calibri" charset="0"/>
+                      </a:endParaRPr>
+                    </a:p>
+                  </a:txBody>
+                  <a:tcPr marL="91440" marR="91440" marT="45720" marB="45720" anchor="ctr">
+                    <a:lnL w="12700" cap="flat" cmpd="sng" algn="ctr">
+                      <a:solidFill>
+                        <a:srgbClr val="D8DEEC"/>
+                      </a:solidFill>
+                      <a:prstDash val="solid"/>
+                      <a:round/>
+                      <a:headEnd type="none" w="med" len="med"/>
+                      <a:tailEnd type="none" w="med" len="med"/>
+                    </a:lnL>
+                    <a:lnR w="12700" cap="flat" cmpd="sng" algn="ctr">
+                      <a:solidFill>
+                        <a:srgbClr val="D8DEEC"/>
+                      </a:solidFill>
+                      <a:prstDash val="solid"/>
+                      <a:round/>
+                      <a:headEnd type="none" w="med" len="med"/>
+                      <a:tailEnd type="none" w="med" len="med"/>
+                    </a:lnR>
+                    <a:lnT w="12700" cap="flat" cmpd="sng" algn="ctr">
+                      <a:solidFill>
+                        <a:srgbClr val="D8DEEC"/>
+                      </a:solidFill>
+                      <a:prstDash val="solid"/>
+                      <a:round/>
+                      <a:headEnd type="none" w="med" len="med"/>
+                      <a:tailEnd type="none" w="med" len="med"/>
+                    </a:lnT>
+                    <a:lnB w="12700" cap="flat" cmpd="sng" algn="ctr">
+                      <a:solidFill>
+                        <a:srgbClr val="D8DEEC"/>
+                      </a:solidFill>
+                      <a:prstDash val="solid"/>
+                      <a:round/>
+                      <a:headEnd type="none" w="med" len="med"/>
+                      <a:tailEnd type="none" w="med" len="med"/>
+                    </a:lnB>
+                  </a:tcPr>
+                </a:tc>
+                <a:tc>
+                  <a:txBody>
+                    <a:bodyPr/>
+                    <a:lstStyle/>
+                    <a:p>
+                      <a:pPr indent="0" marL="0">
+                        <a:buNone/>
+                      </a:pPr>
+                      <a:r>
+                        <a:rPr lang="en-US" sz="1200" dirty="0">
+                          <a:solidFill>
                             <a:srgbClr val="1A1A2E"/>
                           </a:solidFill>
                           <a:latin typeface="Calibri" pitchFamily="34" charset="0"/>
@@ -4474,6 +8426,71 @@
                       <a:r>
                         <a:rPr lang="en-US" sz="1200" dirty="0">
                           <a:solidFill>
+                            <a:srgbClr val="2E7D32"/>
+                          </a:solidFill>
+                          <a:latin typeface="Calibri" pitchFamily="34" charset="0"/>
+                          <a:ea typeface="Calibri" pitchFamily="34" charset="-122"/>
+                          <a:cs typeface="Calibri" pitchFamily="34" charset="-120"/>
+                        </a:rPr>
+                        <a:t>Low ✓</a:t>
+                      </a:r>
+                      <a:endParaRPr lang="en-US" sz="1200" dirty="0">
+                        <a:latin typeface="Calibri" charset="0"/>
+                        <a:ea typeface="Calibri" charset="0"/>
+                        <a:cs typeface="Calibri" charset="0"/>
+                      </a:endParaRPr>
+                    </a:p>
+                  </a:txBody>
+                  <a:tcPr marL="91440" marR="91440" marT="45720" marB="45720" anchor="ctr">
+                    <a:lnL w="12700" cap="flat" cmpd="sng" algn="ctr">
+                      <a:solidFill>
+                        <a:srgbClr val="D8DEEC"/>
+                      </a:solidFill>
+                      <a:prstDash val="solid"/>
+                      <a:round/>
+                      <a:headEnd type="none" w="med" len="med"/>
+                      <a:tailEnd type="none" w="med" len="med"/>
+                    </a:lnL>
+                    <a:lnR w="12700" cap="flat" cmpd="sng" algn="ctr">
+                      <a:solidFill>
+                        <a:srgbClr val="D8DEEC"/>
+                      </a:solidFill>
+                      <a:prstDash val="solid"/>
+                      <a:round/>
+                      <a:headEnd type="none" w="med" len="med"/>
+                      <a:tailEnd type="none" w="med" len="med"/>
+                    </a:lnR>
+                    <a:lnT w="12700" cap="flat" cmpd="sng" algn="ctr">
+                      <a:solidFill>
+                        <a:srgbClr val="D8DEEC"/>
+                      </a:solidFill>
+                      <a:prstDash val="solid"/>
+                      <a:round/>
+                      <a:headEnd type="none" w="med" len="med"/>
+                      <a:tailEnd type="none" w="med" len="med"/>
+                    </a:lnT>
+                    <a:lnB w="12700" cap="flat" cmpd="sng" algn="ctr">
+                      <a:solidFill>
+                        <a:srgbClr val="D8DEEC"/>
+                      </a:solidFill>
+                      <a:prstDash val="solid"/>
+                      <a:round/>
+                      <a:headEnd type="none" w="med" len="med"/>
+                      <a:tailEnd type="none" w="med" len="med"/>
+                    </a:lnB>
+                  </a:tcPr>
+                </a:tc>
+                <a:tc>
+                  <a:txBody>
+                    <a:bodyPr/>
+                    <a:lstStyle/>
+                    <a:p>
+                      <a:pPr indent="0" marL="0">
+                        <a:buNone/>
+                      </a:pPr>
+                      <a:r>
+                        <a:rPr lang="en-US" sz="1200" dirty="0">
+                          <a:solidFill>
                             <a:srgbClr val="1A1A2E"/>
                           </a:solidFill>
                           <a:latin typeface="Calibri" pitchFamily="34" charset="0"/>
@@ -4931,6 +8948,71 @@
                       <a:r>
                         <a:rPr lang="en-US" sz="1200" dirty="0">
                           <a:solidFill>
+                            <a:srgbClr val="2E7D32"/>
+                          </a:solidFill>
+                          <a:latin typeface="Calibri" pitchFamily="34" charset="0"/>
+                          <a:ea typeface="Calibri" pitchFamily="34" charset="-122"/>
+                          <a:cs typeface="Calibri" pitchFamily="34" charset="-120"/>
+                        </a:rPr>
+                        <a:t>Low ✓</a:t>
+                      </a:r>
+                      <a:endParaRPr lang="en-US" sz="1200" dirty="0">
+                        <a:latin typeface="Calibri" charset="0"/>
+                        <a:ea typeface="Calibri" charset="0"/>
+                        <a:cs typeface="Calibri" charset="0"/>
+                      </a:endParaRPr>
+                    </a:p>
+                  </a:txBody>
+                  <a:tcPr marL="91440" marR="91440" marT="45720" marB="45720" anchor="ctr">
+                    <a:lnL w="12700" cap="flat" cmpd="sng" algn="ctr">
+                      <a:solidFill>
+                        <a:srgbClr val="D8DEEC"/>
+                      </a:solidFill>
+                      <a:prstDash val="solid"/>
+                      <a:round/>
+                      <a:headEnd type="none" w="med" len="med"/>
+                      <a:tailEnd type="none" w="med" len="med"/>
+                    </a:lnL>
+                    <a:lnR w="12700" cap="flat" cmpd="sng" algn="ctr">
+                      <a:solidFill>
+                        <a:srgbClr val="D8DEEC"/>
+                      </a:solidFill>
+                      <a:prstDash val="solid"/>
+                      <a:round/>
+                      <a:headEnd type="none" w="med" len="med"/>
+                      <a:tailEnd type="none" w="med" len="med"/>
+                    </a:lnR>
+                    <a:lnT w="12700" cap="flat" cmpd="sng" algn="ctr">
+                      <a:solidFill>
+                        <a:srgbClr val="D8DEEC"/>
+                      </a:solidFill>
+                      <a:prstDash val="solid"/>
+                      <a:round/>
+                      <a:headEnd type="none" w="med" len="med"/>
+                      <a:tailEnd type="none" w="med" len="med"/>
+                    </a:lnT>
+                    <a:lnB w="12700" cap="flat" cmpd="sng" algn="ctr">
+                      <a:solidFill>
+                        <a:srgbClr val="D8DEEC"/>
+                      </a:solidFill>
+                      <a:prstDash val="solid"/>
+                      <a:round/>
+                      <a:headEnd type="none" w="med" len="med"/>
+                      <a:tailEnd type="none" w="med" len="med"/>
+                    </a:lnB>
+                  </a:tcPr>
+                </a:tc>
+                <a:tc>
+                  <a:txBody>
+                    <a:bodyPr/>
+                    <a:lstStyle/>
+                    <a:p>
+                      <a:pPr indent="0" marL="0">
+                        <a:buNone/>
+                      </a:pPr>
+                      <a:r>
+                        <a:rPr lang="en-US" sz="1200" dirty="0">
+                          <a:solidFill>
                             <a:srgbClr val="1A1A2E"/>
                           </a:solidFill>
                           <a:latin typeface="Calibri" pitchFamily="34" charset="0"/>
@@ -5206,9 +9288,9 @@
 </p:sld>
 </file>
 
-<file path=ppt/slides/slide11.xml><?xml version="1.0" encoding="utf-8"?>
+<file path=ppt/slides/slide12.xml><?xml version="1.0" encoding="utf-8"?>
 <p:sld xmlns:a="http://schemas.openxmlformats.org/drawingml/2006/main" xmlns:r="http://schemas.openxmlformats.org/officeDocument/2006/relationships" xmlns:p="http://schemas.openxmlformats.org/presentationml/2006/main">
-  <p:cSld name="Slide 11">
+  <p:cSld name="Slide 12">
     <p:bg>
       <p:bgPr>
         <a:solidFill>

</xml_diff>

<commit_message>
Reconcile the record with the H200 full runs: C5 measured, deck + API samples refreshed
C5 verdict (real Phi-1.5, full corpus): LLM path 0.932 vs probe 0.919 PR-AUC -
+1.3pp, under the 2pp bar -> LLM dropped from serving. Canonical full-corpus
numbers replace the interim 40k CPU slice: C3 +38.5pp, C4 +41.3pp, velocity
+60.0pp. Deck scoreboard grows to 15 read-outs (ATO fusion, next-payment
forecast) with the GPU-bundle sample predictions; API_SAMPLES recaptured live
incl. /forecast/next and /forecast/liquidity. save_india_model meta now derives
next/calibrated flags from the probes.

Co-Authored-By: Claude Fable 5 <noreply@anthropic.com>
</commit_message>
<xml_diff>
--- a/docs/txn_repr_evidence.pptx
+++ b/docs/txn_repr_evidence.pptx
@@ -2405,7 +2405,7 @@
                 <a:ea typeface="Calibri" pitchFamily="34" charset="-122"/>
                 <a:cs typeface="Calibri" pitchFamily="34" charset="-120"/>
               </a:rPr>
-              <a:t>One backbone, twelve read-outs — wins and losses reported alike.</a:t>
+              <a:t>One backbone, fifteen read-outs — wins and losses reported alike. Full-scale (H200) numbers.</a:t>
             </a:r>
             <a:endParaRPr lang="en-US" sz="1400" dirty="0"/>
           </a:p>
@@ -2434,12 +2434,12 @@
             <a:tbl>
               <a:tblPr/>
               <a:tblGrid>
-                <a:gridCol w="3017520"/>
+                <a:gridCol w="3200400"/>
                 <a:gridCol w="3776472"/>
                 <a:gridCol w="1920240"/>
-                <a:gridCol w="2560320"/>
+                <a:gridCol w="2377440"/>
               </a:tblGrid>
-              <a:tr h="320040">
+              <a:tr h="274320">
                 <a:tc>
                   <a:txBody>
                     <a:bodyPr/>
@@ -2449,7 +2449,7 @@
                         <a:buNone/>
                       </a:pPr>
                       <a:r>
-                        <a:rPr lang="en-US" sz="1050" b="1" dirty="0">
+                        <a:rPr lang="en-US" sz="1000" b="1" dirty="0">
                           <a:solidFill>
                             <a:srgbClr val="FFFFFF"/>
                           </a:solidFill>
@@ -2459,7 +2459,7 @@
                         </a:rPr>
                         <a:t>Prediction</a:t>
                       </a:r>
-                      <a:endParaRPr lang="en-US" sz="1050" dirty="0">
+                      <a:endParaRPr lang="en-US" sz="1000" dirty="0">
                         <a:latin typeface="Calibri" charset="0"/>
                         <a:ea typeface="Calibri" charset="0"/>
                         <a:cs typeface="Calibri" charset="0"/>
@@ -2517,7 +2517,7 @@
                         <a:buNone/>
                       </a:pPr>
                       <a:r>
-                        <a:rPr lang="en-US" sz="1050" b="1" dirty="0">
+                        <a:rPr lang="en-US" sz="1000" b="1" dirty="0">
                           <a:solidFill>
                             <a:srgbClr val="FFFFFF"/>
                           </a:solidFill>
@@ -2527,7 +2527,7 @@
                         </a:rPr>
                         <a:t>Measured result</a:t>
                       </a:r>
-                      <a:endParaRPr lang="en-US" sz="1050" dirty="0">
+                      <a:endParaRPr lang="en-US" sz="1000" dirty="0">
                         <a:latin typeface="Calibri" charset="0"/>
                         <a:ea typeface="Calibri" charset="0"/>
                         <a:cs typeface="Calibri" charset="0"/>
@@ -2585,7 +2585,7 @@
                         <a:buNone/>
                       </a:pPr>
                       <a:r>
-                        <a:rPr lang="en-US" sz="1050" b="1" dirty="0">
+                        <a:rPr lang="en-US" sz="1000" b="1" dirty="0">
                           <a:solidFill>
                             <a:srgbClr val="FFFFFF"/>
                           </a:solidFill>
@@ -2595,7 +2595,7 @@
                         </a:rPr>
                         <a:t>Baseline</a:t>
                       </a:r>
-                      <a:endParaRPr lang="en-US" sz="1050" dirty="0">
+                      <a:endParaRPr lang="en-US" sz="1000" dirty="0">
                         <a:latin typeface="Calibri" charset="0"/>
                         <a:ea typeface="Calibri" charset="0"/>
                         <a:cs typeface="Calibri" charset="0"/>
@@ -2653,7 +2653,7 @@
                         <a:buNone/>
                       </a:pPr>
                       <a:r>
-                        <a:rPr lang="en-US" sz="1050" b="1" dirty="0">
+                        <a:rPr lang="en-US" sz="1000" b="1" dirty="0">
                           <a:solidFill>
                             <a:srgbClr val="FFFFFF"/>
                           </a:solidFill>
@@ -2663,7 +2663,7 @@
                         </a:rPr>
                         <a:t>Verdict</a:t>
                       </a:r>
-                      <a:endParaRPr lang="en-US" sz="1050" dirty="0">
+                      <a:endParaRPr lang="en-US" sz="1000" dirty="0">
                         <a:latin typeface="Calibri" charset="0"/>
                         <a:ea typeface="Calibri" charset="0"/>
                         <a:cs typeface="Calibri" charset="0"/>
@@ -2713,7 +2713,7 @@
                   </a:tcPr>
                 </a:tc>
               </a:tr>
-              <a:tr h="320040">
+              <a:tr h="274320">
                 <a:tc>
                   <a:txBody>
                     <a:bodyPr/>
@@ -2723,7 +2723,7 @@
                         <a:buNone/>
                       </a:pPr>
                       <a:r>
-                        <a:rPr lang="en-US" sz="1050" dirty="0">
+                        <a:rPr lang="en-US" sz="1000" dirty="0">
                           <a:solidFill>
                             <a:srgbClr val="1A1A2E"/>
                           </a:solidFill>
@@ -2733,7 +2733,7 @@
                         </a:rPr>
                         <a:t>ETA to settlement</a:t>
                       </a:r>
-                      <a:endParaRPr lang="en-US" sz="1050" dirty="0">
+                      <a:endParaRPr lang="en-US" sz="1000" dirty="0">
                         <a:latin typeface="Calibri" charset="0"/>
                         <a:ea typeface="Calibri" charset="0"/>
                         <a:cs typeface="Calibri" charset="0"/>
@@ -2788,7 +2788,7 @@
                         <a:buNone/>
                       </a:pPr>
                       <a:r>
-                        <a:rPr lang="en-US" sz="1050" dirty="0">
+                        <a:rPr lang="en-US" sz="1000" dirty="0">
                           <a:solidFill>
                             <a:srgbClr val="1A1A2E"/>
                           </a:solidFill>
@@ -2796,9 +2796,9 @@
                           <a:ea typeface="Calibri" pitchFamily="34" charset="-122"/>
                           <a:cs typeface="Calibri" pitchFamily="34" charset="-120"/>
                         </a:rPr>
-                        <a:t>MAE 186 min at initiation · 199 at n=4,000</a:t>
+                        <a:t>MAE 172 min at initiation · 195 at n=4,000</a:t>
                       </a:r>
-                      <a:endParaRPr lang="en-US" sz="1050" dirty="0">
+                      <a:endParaRPr lang="en-US" sz="1000" dirty="0">
                         <a:latin typeface="Calibri" charset="0"/>
                         <a:ea typeface="Calibri" charset="0"/>
                         <a:cs typeface="Calibri" charset="0"/>
@@ -2853,7 +2853,7 @@
                         <a:buNone/>
                       </a:pPr>
                       <a:r>
-                        <a:rPr lang="en-US" sz="1050" dirty="0">
+                        <a:rPr lang="en-US" sz="1000" dirty="0">
                           <a:solidFill>
                             <a:srgbClr val="1A1A2E"/>
                           </a:solidFill>
@@ -2861,9 +2861,9 @@
                           <a:ea typeface="Calibri" pitchFamily="34" charset="-122"/>
                           <a:cs typeface="Calibri" pitchFamily="34" charset="-120"/>
                         </a:rPr>
-                        <a:t>232 / 392 naive</a:t>
+                        <a:t>234 / 392 naive</a:t>
                       </a:r>
-                      <a:endParaRPr lang="en-US" sz="1050" dirty="0">
+                      <a:endParaRPr lang="en-US" sz="1000" dirty="0">
                         <a:latin typeface="Calibri" charset="0"/>
                         <a:ea typeface="Calibri" charset="0"/>
                         <a:cs typeface="Calibri" charset="0"/>
@@ -2918,7 +2918,7 @@
                         <a:buNone/>
                       </a:pPr>
                       <a:r>
-                        <a:rPr lang="en-US" sz="1050" b="1" dirty="0">
+                        <a:rPr lang="en-US" sz="1000" b="1" dirty="0">
                           <a:solidFill>
                             <a:srgbClr val="2E7D32"/>
                           </a:solidFill>
@@ -2928,7 +2928,7 @@
                         </a:rPr>
                         <a:t>Model wins</a:t>
                       </a:r>
-                      <a:endParaRPr lang="en-US" sz="1050" dirty="0">
+                      <a:endParaRPr lang="en-US" sz="1000" dirty="0">
                         <a:latin typeface="Calibri" charset="0"/>
                         <a:ea typeface="Calibri" charset="0"/>
                         <a:cs typeface="Calibri" charset="0"/>
@@ -2975,7 +2975,7 @@
                   </a:tcPr>
                 </a:tc>
               </a:tr>
-              <a:tr h="320040">
+              <a:tr h="274320">
                 <a:tc>
                   <a:txBody>
                     <a:bodyPr/>
@@ -2985,7 +2985,7 @@
                         <a:buNone/>
                       </a:pPr>
                       <a:r>
-                        <a:rPr lang="en-US" sz="1050" dirty="0">
+                        <a:rPr lang="en-US" sz="1000" dirty="0">
                           <a:solidFill>
                             <a:srgbClr val="1A1A2E"/>
                           </a:solidFill>
@@ -2995,7 +2995,7 @@
                         </a:rPr>
                         <a:t>Charges</a:t>
                       </a:r>
-                      <a:endParaRPr lang="en-US" sz="1050" dirty="0">
+                      <a:endParaRPr lang="en-US" sz="1000" dirty="0">
                         <a:latin typeface="Calibri" charset="0"/>
                         <a:ea typeface="Calibri" charset="0"/>
                         <a:cs typeface="Calibri" charset="0"/>
@@ -3050,7 +3050,7 @@
                         <a:buNone/>
                       </a:pPr>
                       <a:r>
-                        <a:rPr lang="en-US" sz="1050" dirty="0">
+                        <a:rPr lang="en-US" sz="1000" dirty="0">
                           <a:solidFill>
                             <a:srgbClr val="1A1A2E"/>
                           </a:solidFill>
@@ -3058,9 +3058,9 @@
                           <a:ea typeface="Calibri" pitchFamily="34" charset="-122"/>
                           <a:cs typeface="Calibri" pitchFamily="34" charset="-120"/>
                         </a:rPr>
-                        <a:t>MAE 97</a:t>
+                        <a:t>MAE 117</a:t>
                       </a:r>
-                      <a:endParaRPr lang="en-US" sz="1050" dirty="0">
+                      <a:endParaRPr lang="en-US" sz="1000" dirty="0">
                         <a:latin typeface="Calibri" charset="0"/>
                         <a:ea typeface="Calibri" charset="0"/>
                         <a:cs typeface="Calibri" charset="0"/>
@@ -3115,7 +3115,7 @@
                         <a:buNone/>
                       </a:pPr>
                       <a:r>
-                        <a:rPr lang="en-US" sz="1050" dirty="0">
+                        <a:rPr lang="en-US" sz="1000" dirty="0">
                           <a:solidFill>
                             <a:srgbClr val="1A1A2E"/>
                           </a:solidFill>
@@ -3123,9 +3123,9 @@
                           <a:ea typeface="Calibri" pitchFamily="34" charset="-122"/>
                           <a:cs typeface="Calibri" pitchFamily="34" charset="-120"/>
                         </a:rPr>
-                        <a:t>185 naive</a:t>
+                        <a:t>203 naive</a:t>
                       </a:r>
-                      <a:endParaRPr lang="en-US" sz="1050" dirty="0">
+                      <a:endParaRPr lang="en-US" sz="1000" dirty="0">
                         <a:latin typeface="Calibri" charset="0"/>
                         <a:ea typeface="Calibri" charset="0"/>
                         <a:cs typeface="Calibri" charset="0"/>
@@ -3180,7 +3180,7 @@
                         <a:buNone/>
                       </a:pPr>
                       <a:r>
-                        <a:rPr lang="en-US" sz="1050" b="1" dirty="0">
+                        <a:rPr lang="en-US" sz="1000" b="1" dirty="0">
                           <a:solidFill>
                             <a:srgbClr val="2E7D32"/>
                           </a:solidFill>
@@ -3188,9 +3188,9 @@
                           <a:ea typeface="Calibri" pitchFamily="34" charset="-122"/>
                           <a:cs typeface="Calibri" pitchFamily="34" charset="-120"/>
                         </a:rPr>
-                        <a:t>Model wins (−48%)</a:t>
+                        <a:t>Model wins (−42%)</a:t>
                       </a:r>
-                      <a:endParaRPr lang="en-US" sz="1050" dirty="0">
+                      <a:endParaRPr lang="en-US" sz="1000" dirty="0">
                         <a:latin typeface="Calibri" charset="0"/>
                         <a:ea typeface="Calibri" charset="0"/>
                         <a:cs typeface="Calibri" charset="0"/>
@@ -3237,7 +3237,7 @@
                   </a:tcPr>
                 </a:tc>
               </a:tr>
-              <a:tr h="320040">
+              <a:tr h="274320">
                 <a:tc>
                   <a:txBody>
                     <a:bodyPr/>
@@ -3247,7 +3247,7 @@
                         <a:buNone/>
                       </a:pPr>
                       <a:r>
-                        <a:rPr lang="en-US" sz="1050" dirty="0">
+                        <a:rPr lang="en-US" sz="1000" dirty="0">
                           <a:solidFill>
                             <a:srgbClr val="1A1A2E"/>
                           </a:solidFill>
@@ -3257,7 +3257,7 @@
                         </a:rPr>
                         <a:t>'Will it credit?' — streaming, in-flight</a:t>
                       </a:r>
-                      <a:endParaRPr lang="en-US" sz="1050" dirty="0">
+                      <a:endParaRPr lang="en-US" sz="1000" dirty="0">
                         <a:latin typeface="Calibri" charset="0"/>
                         <a:ea typeface="Calibri" charset="0"/>
                         <a:cs typeface="Calibri" charset="0"/>
@@ -3312,7 +3312,7 @@
                         <a:buNone/>
                       </a:pPr>
                       <a:r>
-                        <a:rPr lang="en-US" sz="1050" dirty="0">
+                        <a:rPr lang="en-US" sz="1000" dirty="0">
                           <a:solidFill>
                             <a:srgbClr val="1A1A2E"/>
                           </a:solidFill>
@@ -3320,9 +3320,9 @@
                           <a:ea typeface="Calibri" pitchFamily="34" charset="-122"/>
                           <a:cs typeface="Calibri" pitchFamily="34" charset="-120"/>
                         </a:rPr>
-                        <a:t>PR-AUC 0.84 → 0.87 as messages arrive</a:t>
+                        <a:t>PR-AUC 0.86 → 0.94 as messages arrive</a:t>
                       </a:r>
-                      <a:endParaRPr lang="en-US" sz="1050" dirty="0">
+                      <a:endParaRPr lang="en-US" sz="1000" dirty="0">
                         <a:latin typeface="Calibri" charset="0"/>
                         <a:ea typeface="Calibri" charset="0"/>
                         <a:cs typeface="Calibri" charset="0"/>
@@ -3377,7 +3377,7 @@
                         <a:buNone/>
                       </a:pPr>
                       <a:r>
-                        <a:rPr lang="en-US" sz="1050" dirty="0">
+                        <a:rPr lang="en-US" sz="1000" dirty="0">
                           <a:solidFill>
                             <a:srgbClr val="1A1A2E"/>
                           </a:solidFill>
@@ -3385,9 +3385,9 @@
                           <a:ea typeface="Calibri" pitchFamily="34" charset="-122"/>
                           <a:cs typeface="Calibri" pitchFamily="34" charset="-120"/>
                         </a:rPr>
-                        <a:t>0.84 prevalence</a:t>
+                        <a:t>0.86 prevalence</a:t>
                       </a:r>
-                      <a:endParaRPr lang="en-US" sz="1050" dirty="0">
+                      <a:endParaRPr lang="en-US" sz="1000" dirty="0">
                         <a:latin typeface="Calibri" charset="0"/>
                         <a:ea typeface="Calibri" charset="0"/>
                         <a:cs typeface="Calibri" charset="0"/>
@@ -3442,7 +3442,7 @@
                         <a:buNone/>
                       </a:pPr>
                       <a:r>
-                        <a:rPr lang="en-US" sz="1050" b="1" dirty="0">
+                        <a:rPr lang="en-US" sz="1000" b="1" dirty="0">
                           <a:solidFill>
                             <a:srgbClr val="2E7D32"/>
                           </a:solidFill>
@@ -3452,7 +3452,7 @@
                         </a:rPr>
                         <a:t>Model wins — lifecycle-native</a:t>
                       </a:r>
-                      <a:endParaRPr lang="en-US" sz="1050" dirty="0">
+                      <a:endParaRPr lang="en-US" sz="1000" dirty="0">
                         <a:latin typeface="Calibri" charset="0"/>
                         <a:ea typeface="Calibri" charset="0"/>
                         <a:cs typeface="Calibri" charset="0"/>
@@ -3499,7 +3499,7 @@
                   </a:tcPr>
                 </a:tc>
               </a:tr>
-              <a:tr h="320040">
+              <a:tr h="274320">
                 <a:tc>
                   <a:txBody>
                     <a:bodyPr/>
@@ -3509,7 +3509,7 @@
                         <a:buNone/>
                       </a:pPr>
                       <a:r>
-                        <a:rPr lang="en-US" sz="1050" dirty="0">
+                        <a:rPr lang="en-US" sz="1000" dirty="0">
                           <a:solidFill>
                             <a:srgbClr val="1A1A2E"/>
                           </a:solidFill>
@@ -3519,7 +3519,7 @@
                         </a:rPr>
                         <a:t>Velocity burst — account timing</a:t>
                       </a:r>
-                      <a:endParaRPr lang="en-US" sz="1050" dirty="0">
+                      <a:endParaRPr lang="en-US" sz="1000" dirty="0">
                         <a:latin typeface="Calibri" charset="0"/>
                         <a:ea typeface="Calibri" charset="0"/>
                         <a:cs typeface="Calibri" charset="0"/>
@@ -3574,7 +3574,7 @@
                         <a:buNone/>
                       </a:pPr>
                       <a:r>
-                        <a:rPr lang="en-US" sz="1050" dirty="0">
+                        <a:rPr lang="en-US" sz="1000" dirty="0">
                           <a:solidFill>
                             <a:srgbClr val="1A1A2E"/>
                           </a:solidFill>
@@ -3582,9 +3582,9 @@
                           <a:ea typeface="Calibri" pitchFamily="34" charset="-122"/>
                           <a:cs typeface="Calibri" pitchFamily="34" charset="-120"/>
                         </a:rPr>
-                        <a:t>PR-AUC 0.85 time-aware (full-scale encoder)</a:t>
+                        <a:t>PR-AUC 0.82 time-aware (full corpus)</a:t>
                       </a:r>
-                      <a:endParaRPr lang="en-US" sz="1050" dirty="0">
+                      <a:endParaRPr lang="en-US" sz="1000" dirty="0">
                         <a:latin typeface="Calibri" charset="0"/>
                         <a:ea typeface="Calibri" charset="0"/>
                         <a:cs typeface="Calibri" charset="0"/>
@@ -3639,7 +3639,7 @@
                         <a:buNone/>
                       </a:pPr>
                       <a:r>
-                        <a:rPr lang="en-US" sz="1050" dirty="0">
+                        <a:rPr lang="en-US" sz="1000" dirty="0">
                           <a:solidFill>
                             <a:srgbClr val="1A1A2E"/>
                           </a:solidFill>
@@ -3647,9 +3647,9 @@
                           <a:ea typeface="Calibri" pitchFamily="34" charset="-122"/>
                           <a:cs typeface="Calibri" pitchFamily="34" charset="-120"/>
                         </a:rPr>
-                        <a:t>0.21 order-blind</a:t>
+                        <a:t>0.22 order-blind</a:t>
                       </a:r>
-                      <a:endParaRPr lang="en-US" sz="1050" dirty="0">
+                      <a:endParaRPr lang="en-US" sz="1000" dirty="0">
                         <a:latin typeface="Calibri" charset="0"/>
                         <a:ea typeface="Calibri" charset="0"/>
                         <a:cs typeface="Calibri" charset="0"/>
@@ -3704,7 +3704,7 @@
                         <a:buNone/>
                       </a:pPr>
                       <a:r>
-                        <a:rPr lang="en-US" sz="1050" b="1" dirty="0">
+                        <a:rPr lang="en-US" sz="1000" b="1" dirty="0">
                           <a:solidFill>
                             <a:srgbClr val="2E7D32"/>
                           </a:solidFill>
@@ -3712,9 +3712,9 @@
                           <a:ea typeface="Calibri" pitchFamily="34" charset="-122"/>
                           <a:cs typeface="Calibri" pitchFamily="34" charset="-120"/>
                         </a:rPr>
-                        <a:t>Model wins (+65pp)</a:t>
+                        <a:t>Model wins (+60pp)</a:t>
                       </a:r>
-                      <a:endParaRPr lang="en-US" sz="1050" dirty="0">
+                      <a:endParaRPr lang="en-US" sz="1000" dirty="0">
                         <a:latin typeface="Calibri" charset="0"/>
                         <a:ea typeface="Calibri" charset="0"/>
                         <a:cs typeface="Calibri" charset="0"/>
@@ -3761,7 +3761,7 @@
                   </a:tcPr>
                 </a:tc>
               </a:tr>
-              <a:tr h="320040">
+              <a:tr h="274320">
                 <a:tc>
                   <a:txBody>
                     <a:bodyPr/>
@@ -3771,7 +3771,7 @@
                         <a:buNone/>
                       </a:pPr>
                       <a:r>
-                        <a:rPr lang="en-US" sz="1050" dirty="0">
+                        <a:rPr lang="en-US" sz="1000" dirty="0">
                           <a:solidFill>
                             <a:srgbClr val="1A1A2E"/>
                           </a:solidFill>
@@ -3779,9 +3779,9 @@
                           <a:ea typeface="Calibri" pitchFamily="34" charset="-122"/>
                           <a:cs typeface="Calibri" pitchFamily="34" charset="-120"/>
                         </a:rPr>
-                        <a:t>Rail routing</a:t>
+                        <a:t>Account takeover at origination (channel context)</a:t>
                       </a:r>
-                      <a:endParaRPr lang="en-US" sz="1050" dirty="0">
+                      <a:endParaRPr lang="en-US" sz="1000" dirty="0">
                         <a:latin typeface="Calibri" charset="0"/>
                         <a:ea typeface="Calibri" charset="0"/>
                         <a:cs typeface="Calibri" charset="0"/>
@@ -3836,7 +3836,7 @@
                         <a:buNone/>
                       </a:pPr>
                       <a:r>
-                        <a:rPr lang="en-US" sz="1050" dirty="0">
+                        <a:rPr lang="en-US" sz="1000" dirty="0">
                           <a:solidFill>
                             <a:srgbClr val="1A1A2E"/>
                           </a:solidFill>
@@ -3844,9 +3844,9 @@
                           <a:ea typeface="Calibri" pitchFamily="34" charset="-122"/>
                           <a:cs typeface="Calibri" pitchFamily="34" charset="-120"/>
                         </a:rPr>
-                        <a:t>0.55 probe · 0.64 on cleanly-routed 100 · SWIFT F1 1.00</a:t>
+                        <a:t>PR-AUC 0.03 ISO-only → 1.00 with pain.001 channel data</a:t>
                       </a:r>
-                      <a:endParaRPr lang="en-US" sz="1050" dirty="0">
+                      <a:endParaRPr lang="en-US" sz="1000" dirty="0">
                         <a:latin typeface="Calibri" charset="0"/>
                         <a:ea typeface="Calibri" charset="0"/>
                         <a:cs typeface="Calibri" charset="0"/>
@@ -3901,7 +3901,7 @@
                         <a:buNone/>
                       </a:pPr>
                       <a:r>
-                        <a:rPr lang="en-US" sz="1050" dirty="0">
+                        <a:rPr lang="en-US" sz="1000" dirty="0">
                           <a:solidFill>
                             <a:srgbClr val="1A1A2E"/>
                           </a:solidFill>
@@ -3909,9 +3909,9 @@
                           <a:ea typeface="Calibri" pitchFamily="34" charset="-122"/>
                           <a:cs typeface="Calibri" pitchFamily="34" charset="-120"/>
                         </a:rPr>
-                        <a:t>tree 0.64 · majority 0.48</a:t>
+                        <a:t>ISO fields alone are blind</a:t>
                       </a:r>
-                      <a:endParaRPr lang="en-US" sz="1050" dirty="0">
+                      <a:endParaRPr lang="en-US" sz="1000" dirty="0">
                         <a:latin typeface="Calibri" charset="0"/>
                         <a:ea typeface="Calibri" charset="0"/>
                         <a:cs typeface="Calibri" charset="0"/>
@@ -3966,17 +3966,17 @@
                         <a:buNone/>
                       </a:pPr>
                       <a:r>
-                        <a:rPr lang="en-US" sz="1050" b="1" dirty="0">
+                        <a:rPr lang="en-US" sz="1000" b="1" dirty="0">
                           <a:solidFill>
-                            <a:srgbClr val="C98A00"/>
+                            <a:srgbClr val="2E7D32"/>
                           </a:solidFill>
                           <a:latin typeface="Calibri" pitchFamily="34" charset="0"/>
                           <a:ea typeface="Calibri" pitchFamily="34" charset="-122"/>
                           <a:cs typeface="Calibri" pitchFamily="34" charset="-120"/>
                         </a:rPr>
-                        <a:t>Tree competitive</a:t>
+                        <a:t>Model wins — multi-source</a:t>
                       </a:r>
-                      <a:endParaRPr lang="en-US" sz="1050" dirty="0">
+                      <a:endParaRPr lang="en-US" sz="1000" dirty="0">
                         <a:latin typeface="Calibri" charset="0"/>
                         <a:ea typeface="Calibri" charset="0"/>
                         <a:cs typeface="Calibri" charset="0"/>
@@ -4023,7 +4023,7 @@
                   </a:tcPr>
                 </a:tc>
               </a:tr>
-              <a:tr h="320040">
+              <a:tr h="274320">
                 <a:tc>
                   <a:txBody>
                     <a:bodyPr/>
@@ -4033,7 +4033,7 @@
                         <a:buNone/>
                       </a:pPr>
                       <a:r>
-                        <a:rPr lang="en-US" sz="1050" dirty="0">
+                        <a:rPr lang="en-US" sz="1000" dirty="0">
                           <a:solidFill>
                             <a:srgbClr val="1A1A2E"/>
                           </a:solidFill>
@@ -4041,9 +4041,9 @@
                           <a:ea typeface="Calibri" pitchFamily="34" charset="-122"/>
                           <a:cs typeface="Calibri" pitchFamily="34" charset="-120"/>
                         </a:rPr>
-                        <a:t>Risk (paper §5 task)</a:t>
+                        <a:t>Next payment: when? (forecast)</a:t>
                       </a:r>
-                      <a:endParaRPr lang="en-US" sz="1050" dirty="0">
+                      <a:endParaRPr lang="en-US" sz="1000" dirty="0">
                         <a:latin typeface="Calibri" charset="0"/>
                         <a:ea typeface="Calibri" charset="0"/>
                         <a:cs typeface="Calibri" charset="0"/>
@@ -4098,7 +4098,7 @@
                         <a:buNone/>
                       </a:pPr>
                       <a:r>
-                        <a:rPr lang="en-US" sz="1050" dirty="0">
+                        <a:rPr lang="en-US" sz="1000" dirty="0">
                           <a:solidFill>
                             <a:srgbClr val="1A1A2E"/>
                           </a:solidFill>
@@ -4106,9 +4106,9 @@
                           <a:ea typeface="Calibri" pitchFamily="34" charset="-122"/>
                           <a:cs typeface="Calibri" pitchFamily="34" charset="-120"/>
                         </a:rPr>
-                        <a:t>0.53 on the fresh 100</a:t>
+                        <a:t>MAE 23.5 days, held-out customers</a:t>
                       </a:r>
-                      <a:endParaRPr lang="en-US" sz="1050" dirty="0">
+                      <a:endParaRPr lang="en-US" sz="1000" dirty="0">
                         <a:latin typeface="Calibri" charset="0"/>
                         <a:ea typeface="Calibri" charset="0"/>
                         <a:cs typeface="Calibri" charset="0"/>
@@ -4163,7 +4163,7 @@
                         <a:buNone/>
                       </a:pPr>
                       <a:r>
-                        <a:rPr lang="en-US" sz="1050" dirty="0">
+                        <a:rPr lang="en-US" sz="1000" dirty="0">
                           <a:solidFill>
                             <a:srgbClr val="1A1A2E"/>
                           </a:solidFill>
@@ -4171,9 +4171,9 @@
                           <a:ea typeface="Calibri" pitchFamily="34" charset="-122"/>
                           <a:cs typeface="Calibri" pitchFamily="34" charset="-120"/>
                         </a:rPr>
-                        <a:t>tree comparable</a:t>
+                        <a:t>25.9 / 32.5 naive gaps</a:t>
                       </a:r>
-                      <a:endParaRPr lang="en-US" sz="1050" dirty="0">
+                      <a:endParaRPr lang="en-US" sz="1000" dirty="0">
                         <a:latin typeface="Calibri" charset="0"/>
                         <a:ea typeface="Calibri" charset="0"/>
                         <a:cs typeface="Calibri" charset="0"/>
@@ -4228,17 +4228,17 @@
                         <a:buNone/>
                       </a:pPr>
                       <a:r>
-                        <a:rPr lang="en-US" sz="1050" b="1" dirty="0">
+                        <a:rPr lang="en-US" sz="1000" b="1" dirty="0">
                           <a:solidFill>
-                            <a:srgbClr val="C98A00"/>
+                            <a:srgbClr val="2E7D32"/>
                           </a:solidFill>
                           <a:latin typeface="Calibri" pitchFamily="34" charset="0"/>
                           <a:ea typeface="Calibri" pitchFamily="34" charset="-122"/>
                           <a:cs typeface="Calibri" pitchFamily="34" charset="-120"/>
                         </a:rPr>
-                        <a:t>Tree competitive (C2)</a:t>
+                        <a:t>Model wins</a:t>
                       </a:r>
-                      <a:endParaRPr lang="en-US" sz="1050" dirty="0">
+                      <a:endParaRPr lang="en-US" sz="1000" dirty="0">
                         <a:latin typeface="Calibri" charset="0"/>
                         <a:ea typeface="Calibri" charset="0"/>
                         <a:cs typeface="Calibri" charset="0"/>
@@ -4285,7 +4285,7 @@
                   </a:tcPr>
                 </a:tc>
               </a:tr>
-              <a:tr h="320040">
+              <a:tr h="274320">
                 <a:tc>
                   <a:txBody>
                     <a:bodyPr/>
@@ -4295,7 +4295,7 @@
                         <a:buNone/>
                       </a:pPr>
                       <a:r>
-                        <a:rPr lang="en-US" sz="1050" dirty="0">
+                        <a:rPr lang="en-US" sz="1000" dirty="0">
                           <a:solidFill>
                             <a:srgbClr val="1A1A2E"/>
                           </a:solidFill>
@@ -4303,9 +4303,9 @@
                           <a:ea typeface="Calibri" pitchFamily="34" charset="-122"/>
                           <a:cs typeface="Calibri" pitchFamily="34" charset="-120"/>
                         </a:rPr>
-                        <a:t>STP outcome at initiation</a:t>
+                        <a:t>Next payment: will one occur / how much?</a:t>
                       </a:r>
-                      <a:endParaRPr lang="en-US" sz="1050" dirty="0">
+                      <a:endParaRPr lang="en-US" sz="1000" dirty="0">
                         <a:latin typeface="Calibri" charset="0"/>
                         <a:ea typeface="Calibri" charset="0"/>
                         <a:cs typeface="Calibri" charset="0"/>
@@ -4360,7 +4360,7 @@
                         <a:buNone/>
                       </a:pPr>
                       <a:r>
-                        <a:rPr lang="en-US" sz="1050" dirty="0">
+                        <a:rPr lang="en-US" sz="1000" dirty="0">
                           <a:solidFill>
                             <a:srgbClr val="1A1A2E"/>
                           </a:solidFill>
@@ -4368,9 +4368,9 @@
                           <a:ea typeface="Calibri" pitchFamily="34" charset="-122"/>
                           <a:cs typeface="Calibri" pitchFamily="34" charset="-120"/>
                         </a:rPr>
-                        <a:t>0.30 acc / 0.22 macro-F1</a:t>
+                        <a:t>occurrence 0.58 · amount: median naive wins</a:t>
                       </a:r>
-                      <a:endParaRPr lang="en-US" sz="1050" dirty="0">
+                      <a:endParaRPr lang="en-US" sz="1000" dirty="0">
                         <a:latin typeface="Calibri" charset="0"/>
                         <a:ea typeface="Calibri" charset="0"/>
                         <a:cs typeface="Calibri" charset="0"/>
@@ -4425,7 +4425,7 @@
                         <a:buNone/>
                       </a:pPr>
                       <a:r>
-                        <a:rPr lang="en-US" sz="1050" dirty="0">
+                        <a:rPr lang="en-US" sz="1000" dirty="0">
                           <a:solidFill>
                             <a:srgbClr val="1A1A2E"/>
                           </a:solidFill>
@@ -4433,9 +4433,9 @@
                           <a:ea typeface="Calibri" pitchFamily="34" charset="-122"/>
                           <a:cs typeface="Calibri" pitchFamily="34" charset="-120"/>
                         </a:rPr>
-                        <a:t>majority 0.74</a:t>
+                        <a:t>tree 0.65 · median naive</a:t>
                       </a:r>
-                      <a:endParaRPr lang="en-US" sz="1050" dirty="0">
+                      <a:endParaRPr lang="en-US" sz="1000" dirty="0">
                         <a:latin typeface="Calibri" charset="0"/>
                         <a:ea typeface="Calibri" charset="0"/>
                         <a:cs typeface="Calibri" charset="0"/>
@@ -4490,17 +4490,17 @@
                         <a:buNone/>
                       </a:pPr>
                       <a:r>
-                        <a:rPr lang="en-US" sz="1050" b="1" dirty="0">
+                        <a:rPr lang="en-US" sz="1000" b="1" dirty="0">
                           <a:solidFill>
-                            <a:srgbClr val="B3261E"/>
+                            <a:srgbClr val="C98A00"/>
                           </a:solidFill>
                           <a:latin typeface="Calibri" pitchFamily="34" charset="0"/>
                           <a:ea typeface="Calibri" pitchFamily="34" charset="-122"/>
                           <a:cs typeface="Calibri" pitchFamily="34" charset="-120"/>
                         </a:rPr>
-                        <a:t>Weak — tree territory</a:t>
+                        <a:t>Naives competitive</a:t>
                       </a:r>
-                      <a:endParaRPr lang="en-US" sz="1050" dirty="0">
+                      <a:endParaRPr lang="en-US" sz="1000" dirty="0">
                         <a:latin typeface="Calibri" charset="0"/>
                         <a:ea typeface="Calibri" charset="0"/>
                         <a:cs typeface="Calibri" charset="0"/>
@@ -4547,7 +4547,7 @@
                   </a:tcPr>
                 </a:tc>
               </a:tr>
-              <a:tr h="320040">
+              <a:tr h="274320">
                 <a:tc>
                   <a:txBody>
                     <a:bodyPr/>
@@ -4557,7 +4557,7 @@
                         <a:buNone/>
                       </a:pPr>
                       <a:r>
-                        <a:rPr lang="en-US" sz="1050" dirty="0">
+                        <a:rPr lang="en-US" sz="1000" dirty="0">
                           <a:solidFill>
                             <a:srgbClr val="1A1A2E"/>
                           </a:solidFill>
@@ -4565,9 +4565,9 @@
                           <a:ea typeface="Calibri" pitchFamily="34" charset="-122"/>
                           <a:cs typeface="Calibri" pitchFamily="34" charset="-120"/>
                         </a:rPr>
-                        <a:t>Reject reason (ISO status code)</a:t>
+                        <a:t>Rail routing</a:t>
                       </a:r>
-                      <a:endParaRPr lang="en-US" sz="1050" dirty="0">
+                      <a:endParaRPr lang="en-US" sz="1000" dirty="0">
                         <a:latin typeface="Calibri" charset="0"/>
                         <a:ea typeface="Calibri" charset="0"/>
                         <a:cs typeface="Calibri" charset="0"/>
@@ -4622,7 +4622,7 @@
                         <a:buNone/>
                       </a:pPr>
                       <a:r>
-                        <a:rPr lang="en-US" sz="1050" dirty="0">
+                        <a:rPr lang="en-US" sz="1000" dirty="0">
                           <a:solidFill>
                             <a:srgbClr val="1A1A2E"/>
                           </a:solidFill>
@@ -4630,9 +4630,9 @@
                           <a:ea typeface="Calibri" pitchFamily="34" charset="-122"/>
                           <a:cs typeface="Calibri" pitchFamily="34" charset="-120"/>
                         </a:rPr>
-                        <a:t>0.23–0.27 acc</a:t>
+                        <a:t>0.56 probe · 0.65 on cleanly-routed · SWIFT F1 1.00</a:t>
                       </a:r>
-                      <a:endParaRPr lang="en-US" sz="1050" dirty="0">
+                      <a:endParaRPr lang="en-US" sz="1000" dirty="0">
                         <a:latin typeface="Calibri" charset="0"/>
                         <a:ea typeface="Calibri" charset="0"/>
                         <a:cs typeface="Calibri" charset="0"/>
@@ -4687,7 +4687,7 @@
                         <a:buNone/>
                       </a:pPr>
                       <a:r>
-                        <a:rPr lang="en-US" sz="1050" dirty="0">
+                        <a:rPr lang="en-US" sz="1000" dirty="0">
                           <a:solidFill>
                             <a:srgbClr val="1A1A2E"/>
                           </a:solidFill>
@@ -4695,9 +4695,9 @@
                           <a:ea typeface="Calibri" pitchFamily="34" charset="-122"/>
                           <a:cs typeface="Calibri" pitchFamily="34" charset="-120"/>
                         </a:rPr>
-                        <a:t>'none' dominates</a:t>
+                        <a:t>tree 0.65 · majority 0.48</a:t>
                       </a:r>
-                      <a:endParaRPr lang="en-US" sz="1050" dirty="0">
+                      <a:endParaRPr lang="en-US" sz="1000" dirty="0">
                         <a:latin typeface="Calibri" charset="0"/>
                         <a:ea typeface="Calibri" charset="0"/>
                         <a:cs typeface="Calibri" charset="0"/>
@@ -4752,17 +4752,17 @@
                         <a:buNone/>
                       </a:pPr>
                       <a:r>
-                        <a:rPr lang="en-US" sz="1050" b="1" dirty="0">
+                        <a:rPr lang="en-US" sz="1000" b="1" dirty="0">
                           <a:solidFill>
-                            <a:srgbClr val="B3261E"/>
+                            <a:srgbClr val="C98A00"/>
                           </a:solidFill>
                           <a:latin typeface="Calibri" pitchFamily="34" charset="0"/>
                           <a:ea typeface="Calibri" pitchFamily="34" charset="-122"/>
                           <a:cs typeface="Calibri" pitchFamily="34" charset="-120"/>
                         </a:rPr>
-                        <a:t>Weak — tree territory</a:t>
+                        <a:t>Tree competitive</a:t>
                       </a:r>
-                      <a:endParaRPr lang="en-US" sz="1050" dirty="0">
+                      <a:endParaRPr lang="en-US" sz="1000" dirty="0">
                         <a:latin typeface="Calibri" charset="0"/>
                         <a:ea typeface="Calibri" charset="0"/>
                         <a:cs typeface="Calibri" charset="0"/>
@@ -4809,7 +4809,7 @@
                   </a:tcPr>
                 </a:tc>
               </a:tr>
-              <a:tr h="320040">
+              <a:tr h="274320">
                 <a:tc>
                   <a:txBody>
                     <a:bodyPr/>
@@ -4819,7 +4819,7 @@
                         <a:buNone/>
                       </a:pPr>
                       <a:r>
-                        <a:rPr lang="en-US" sz="1050" dirty="0">
+                        <a:rPr lang="en-US" sz="1000" dirty="0">
                           <a:solidFill>
                             <a:srgbClr val="1A1A2E"/>
                           </a:solidFill>
@@ -4827,9 +4827,9 @@
                           <a:ea typeface="Calibri" pitchFamily="34" charset="-122"/>
                           <a:cs typeface="Calibri" pitchFamily="34" charset="-120"/>
                         </a:rPr>
-                        <a:t>Recall / return likelihood (camt.056 / pacs.004)</a:t>
+                        <a:t>Risk (paper §5 task)</a:t>
                       </a:r>
-                      <a:endParaRPr lang="en-US" sz="1050" dirty="0">
+                      <a:endParaRPr lang="en-US" sz="1000" dirty="0">
                         <a:latin typeface="Calibri" charset="0"/>
                         <a:ea typeface="Calibri" charset="0"/>
                         <a:cs typeface="Calibri" charset="0"/>
@@ -4884,7 +4884,7 @@
                         <a:buNone/>
                       </a:pPr>
                       <a:r>
-                        <a:rPr lang="en-US" sz="1050" dirty="0">
+                        <a:rPr lang="en-US" sz="1000" dirty="0">
                           <a:solidFill>
                             <a:srgbClr val="1A1A2E"/>
                           </a:solidFill>
@@ -4892,9 +4892,9 @@
                           <a:ea typeface="Calibri" pitchFamily="34" charset="-122"/>
                           <a:cs typeface="Calibri" pitchFamily="34" charset="-120"/>
                         </a:rPr>
-                        <a:t>≈ prevalence (3.9% / 2.3% positive)</a:t>
+                        <a:t>0.58 on the fresh 100</a:t>
                       </a:r>
-                      <a:endParaRPr lang="en-US" sz="1050" dirty="0">
+                      <a:endParaRPr lang="en-US" sz="1000" dirty="0">
                         <a:latin typeface="Calibri" charset="0"/>
                         <a:ea typeface="Calibri" charset="0"/>
                         <a:cs typeface="Calibri" charset="0"/>
@@ -4949,7 +4949,7 @@
                         <a:buNone/>
                       </a:pPr>
                       <a:r>
-                        <a:rPr lang="en-US" sz="1050" dirty="0">
+                        <a:rPr lang="en-US" sz="1000" dirty="0">
                           <a:solidFill>
                             <a:srgbClr val="1A1A2E"/>
                           </a:solidFill>
@@ -4957,9 +4957,9 @@
                           <a:ea typeface="Calibri" pitchFamily="34" charset="-122"/>
                           <a:cs typeface="Calibri" pitchFamily="34" charset="-120"/>
                         </a:rPr>
-                        <a:t>—</a:t>
+                        <a:t>tree comparable</a:t>
                       </a:r>
-                      <a:endParaRPr lang="en-US" sz="1050" dirty="0">
+                      <a:endParaRPr lang="en-US" sz="1000" dirty="0">
                         <a:latin typeface="Calibri" charset="0"/>
                         <a:ea typeface="Calibri" charset="0"/>
                         <a:cs typeface="Calibri" charset="0"/>
@@ -5014,17 +5014,17 @@
                         <a:buNone/>
                       </a:pPr>
                       <a:r>
-                        <a:rPr lang="en-US" sz="1050" b="1" dirty="0">
+                        <a:rPr lang="en-US" sz="1000" b="1" dirty="0">
                           <a:solidFill>
-                            <a:srgbClr val="B3261E"/>
+                            <a:srgbClr val="C98A00"/>
                           </a:solidFill>
                           <a:latin typeface="Calibri" pitchFamily="34" charset="0"/>
                           <a:ea typeface="Calibri" pitchFamily="34" charset="-122"/>
                           <a:cs typeface="Calibri" pitchFamily="34" charset="-120"/>
                         </a:rPr>
-                        <a:t>Too rare at 20k — needs scale</a:t>
+                        <a:t>Tree competitive (C2)</a:t>
                       </a:r>
-                      <a:endParaRPr lang="en-US" sz="1050" dirty="0">
+                      <a:endParaRPr lang="en-US" sz="1000" dirty="0">
                         <a:latin typeface="Calibri" charset="0"/>
                         <a:ea typeface="Calibri" charset="0"/>
                         <a:cs typeface="Calibri" charset="0"/>
@@ -5071,7 +5071,7 @@
                   </a:tcPr>
                 </a:tc>
               </a:tr>
-              <a:tr h="320040">
+              <a:tr h="274320">
                 <a:tc>
                   <a:txBody>
                     <a:bodyPr/>
@@ -5081,7 +5081,7 @@
                         <a:buNone/>
                       </a:pPr>
                       <a:r>
-                        <a:rPr lang="en-US" sz="1050" dirty="0">
+                        <a:rPr lang="en-US" sz="1000" dirty="0">
                           <a:solidFill>
                             <a:srgbClr val="1A1A2E"/>
                           </a:solidFill>
@@ -5089,9 +5089,9 @@
                           <a:ea typeface="Calibri" pitchFamily="34" charset="-122"/>
                           <a:cs typeface="Calibri" pitchFamily="34" charset="-120"/>
                         </a:rPr>
-                        <a:t>Next-message order (sequence encoder)</a:t>
+                        <a:t>STP outcome at initiation</a:t>
                       </a:r>
-                      <a:endParaRPr lang="en-US" sz="1050" dirty="0">
+                      <a:endParaRPr lang="en-US" sz="1000" dirty="0">
                         <a:latin typeface="Calibri" charset="0"/>
                         <a:ea typeface="Calibri" charset="0"/>
                         <a:cs typeface="Calibri" charset="0"/>
@@ -5146,7 +5146,7 @@
                         <a:buNone/>
                       </a:pPr>
                       <a:r>
-                        <a:rPr lang="en-US" sz="1050" dirty="0">
+                        <a:rPr lang="en-US" sz="1000" dirty="0">
                           <a:solidFill>
                             <a:srgbClr val="1A1A2E"/>
                           </a:solidFill>
@@ -5154,9 +5154,9 @@
                           <a:ea typeface="Calibri" pitchFamily="34" charset="-122"/>
                           <a:cs typeface="Calibri" pitchFamily="34" charset="-120"/>
                         </a:rPr>
-                        <a:t>sequence ≈ pooled (−0.6pp, re-tested on real timing)</a:t>
+                        <a:t>0.28 acc / 0.21 macro-F1</a:t>
                       </a:r>
-                      <a:endParaRPr lang="en-US" sz="1050" dirty="0">
+                      <a:endParaRPr lang="en-US" sz="1000" dirty="0">
                         <a:latin typeface="Calibri" charset="0"/>
                         <a:ea typeface="Calibri" charset="0"/>
                         <a:cs typeface="Calibri" charset="0"/>
@@ -5211,7 +5211,7 @@
                         <a:buNone/>
                       </a:pPr>
                       <a:r>
-                        <a:rPr lang="en-US" sz="1050" dirty="0">
+                        <a:rPr lang="en-US" sz="1000" dirty="0">
                           <a:solidFill>
                             <a:srgbClr val="1A1A2E"/>
                           </a:solidFill>
@@ -5219,9 +5219,9 @@
                           <a:ea typeface="Calibri" pitchFamily="34" charset="-122"/>
                           <a:cs typeface="Calibri" pitchFamily="34" charset="-120"/>
                         </a:rPr>
-                        <a:t>bag-of-messages</a:t>
+                        <a:t>majority 0.74</a:t>
                       </a:r>
-                      <a:endParaRPr lang="en-US" sz="1050" dirty="0">
+                      <a:endParaRPr lang="en-US" sz="1000" dirty="0">
                         <a:latin typeface="Calibri" charset="0"/>
                         <a:ea typeface="Calibri" charset="0"/>
                         <a:cs typeface="Calibri" charset="0"/>
@@ -5276,17 +5276,17 @@
                         <a:buNone/>
                       </a:pPr>
                       <a:r>
-                        <a:rPr lang="en-US" sz="1050" b="1" dirty="0">
+                        <a:rPr lang="en-US" sz="1000" b="1" dirty="0">
                           <a:solidFill>
-                            <a:srgbClr val="5A6172"/>
+                            <a:srgbClr val="B3261E"/>
                           </a:solidFill>
                           <a:latin typeface="Calibri" pitchFamily="34" charset="0"/>
                           <a:ea typeface="Calibri" pitchFamily="34" charset="-122"/>
                           <a:cs typeface="Calibri" pitchFamily="34" charset="-120"/>
                         </a:rPr>
-                        <a:t>Honest null — no order signal</a:t>
+                        <a:t>Weak — tree territory</a:t>
                       </a:r>
-                      <a:endParaRPr lang="en-US" sz="1050" dirty="0">
+                      <a:endParaRPr lang="en-US" sz="1000" dirty="0">
                         <a:latin typeface="Calibri" charset="0"/>
                         <a:ea typeface="Calibri" charset="0"/>
                         <a:cs typeface="Calibri" charset="0"/>
@@ -5333,7 +5333,7 @@
                   </a:tcPr>
                 </a:tc>
               </a:tr>
-              <a:tr h="320040">
+              <a:tr h="274320">
                 <a:tc>
                   <a:txBody>
                     <a:bodyPr/>
@@ -5343,7 +5343,7 @@
                         <a:buNone/>
                       </a:pPr>
                       <a:r>
-                        <a:rPr lang="en-US" sz="1050" dirty="0">
+                        <a:rPr lang="en-US" sz="1000" dirty="0">
                           <a:solidFill>
                             <a:srgbClr val="1A1A2E"/>
                           </a:solidFill>
@@ -5351,9 +5351,9 @@
                           <a:ea typeface="Calibri" pitchFamily="34" charset="-122"/>
                           <a:cs typeface="Calibri" pitchFamily="34" charset="-120"/>
                         </a:rPr>
-                        <a:t>Caps · floors · geo-cover · duplicates</a:t>
+                        <a:t>Reject reason (ISO status code)</a:t>
                       </a:r>
-                      <a:endParaRPr lang="en-US" sz="1050" dirty="0">
+                      <a:endParaRPr lang="en-US" sz="1000" dirty="0">
                         <a:latin typeface="Calibri" charset="0"/>
                         <a:ea typeface="Calibri" charset="0"/>
                         <a:cs typeface="Calibri" charset="0"/>
@@ -5408,7 +5408,7 @@
                         <a:buNone/>
                       </a:pPr>
                       <a:r>
-                        <a:rPr lang="en-US" sz="1050" dirty="0">
+                        <a:rPr lang="en-US" sz="1000" dirty="0">
                           <a:solidFill>
                             <a:srgbClr val="1A1A2E"/>
                           </a:solidFill>
@@ -5416,9 +5416,9 @@
                           <a:ea typeface="Calibri" pitchFamily="34" charset="-122"/>
                           <a:cs typeface="Calibri" pitchFamily="34" charset="-120"/>
                         </a:rPr>
-                        <a:t>exact by construction</a:t>
+                        <a:t>0.10 acc</a:t>
                       </a:r>
-                      <a:endParaRPr lang="en-US" sz="1050" dirty="0">
+                      <a:endParaRPr lang="en-US" sz="1000" dirty="0">
                         <a:latin typeface="Calibri" charset="0"/>
                         <a:ea typeface="Calibri" charset="0"/>
                         <a:cs typeface="Calibri" charset="0"/>
@@ -5473,7 +5473,7 @@
                         <a:buNone/>
                       </a:pPr>
                       <a:r>
-                        <a:rPr lang="en-US" sz="1050" dirty="0">
+                        <a:rPr lang="en-US" sz="1000" dirty="0">
                           <a:solidFill>
                             <a:srgbClr val="1A1A2E"/>
                           </a:solidFill>
@@ -5481,9 +5481,9 @@
                           <a:ea typeface="Calibri" pitchFamily="34" charset="-122"/>
                           <a:cs typeface="Calibri" pitchFamily="34" charset="-120"/>
                         </a:rPr>
-                        <a:t>—</a:t>
+                        <a:t>'none' dominates</a:t>
                       </a:r>
-                      <a:endParaRPr lang="en-US" sz="1050" dirty="0">
+                      <a:endParaRPr lang="en-US" sz="1000" dirty="0">
                         <a:latin typeface="Calibri" charset="0"/>
                         <a:ea typeface="Calibri" charset="0"/>
                         <a:cs typeface="Calibri" charset="0"/>
@@ -5538,17 +5538,17 @@
                         <a:buNone/>
                       </a:pPr>
                       <a:r>
-                        <a:rPr lang="en-US" sz="1050" b="1" dirty="0">
+                        <a:rPr lang="en-US" sz="1000" b="1" dirty="0">
                           <a:solidFill>
-                            <a:srgbClr val="5A6172"/>
+                            <a:srgbClr val="B3261E"/>
                           </a:solidFill>
                           <a:latin typeface="Calibri" pitchFamily="34" charset="0"/>
                           <a:ea typeface="Calibri" pitchFamily="34" charset="-122"/>
                           <a:cs typeface="Calibri" pitchFamily="34" charset="-120"/>
                         </a:rPr>
-                        <a:t>Rules &amp; guards, not ML</a:t>
+                        <a:t>Weak — tree territory</a:t>
                       </a:r>
-                      <a:endParaRPr lang="en-US" sz="1050" dirty="0">
+                      <a:endParaRPr lang="en-US" sz="1000" dirty="0">
                         <a:latin typeface="Calibri" charset="0"/>
                         <a:ea typeface="Calibri" charset="0"/>
                         <a:cs typeface="Calibri" charset="0"/>
@@ -5595,7 +5595,7 @@
                   </a:tcPr>
                 </a:tc>
               </a:tr>
-              <a:tr h="320040">
+              <a:tr h="274320">
                 <a:tc>
                   <a:txBody>
                     <a:bodyPr/>
@@ -5605,7 +5605,7 @@
                         <a:buNone/>
                       </a:pPr>
                       <a:r>
-                        <a:rPr lang="en-US" sz="1050" dirty="0">
+                        <a:rPr lang="en-US" sz="1000" dirty="0">
                           <a:solidFill>
                             <a:srgbClr val="1A1A2E"/>
                           </a:solidFill>
@@ -5613,9 +5613,9 @@
                           <a:ea typeface="Calibri" pitchFamily="34" charset="-122"/>
                           <a:cs typeface="Calibri" pitchFamily="34" charset="-120"/>
                         </a:rPr>
-                        <a:t>Missing-field infill (imputation)</a:t>
+                        <a:t>Recall / return likelihood (camt.056 / pacs.004)</a:t>
                       </a:r>
-                      <a:endParaRPr lang="en-US" sz="1050" dirty="0">
+                      <a:endParaRPr lang="en-US" sz="1000" dirty="0">
                         <a:latin typeface="Calibri" charset="0"/>
                         <a:ea typeface="Calibri" charset="0"/>
                         <a:cs typeface="Calibri" charset="0"/>
@@ -5670,7 +5670,7 @@
                         <a:buNone/>
                       </a:pPr>
                       <a:r>
-                        <a:rPr lang="en-US" sz="1050" dirty="0">
+                        <a:rPr lang="en-US" sz="1000" dirty="0">
                           <a:solidFill>
                             <a:srgbClr val="1A1A2E"/>
                           </a:solidFill>
@@ -5678,9 +5678,9 @@
                           <a:ea typeface="Calibri" pitchFamily="34" charset="-122"/>
                           <a:cs typeface="Calibri" pitchFamily="34" charset="-120"/>
                         </a:rPr>
-                        <a:t>structured fields only</a:t>
+                        <a:t>≈ prevalence (3.0% / 1.8% positive)</a:t>
                       </a:r>
-                      <a:endParaRPr lang="en-US" sz="1050" dirty="0">
+                      <a:endParaRPr lang="en-US" sz="1000" dirty="0">
                         <a:latin typeface="Calibri" charset="0"/>
                         <a:ea typeface="Calibri" charset="0"/>
                         <a:cs typeface="Calibri" charset="0"/>
@@ -5735,7 +5735,7 @@
                         <a:buNone/>
                       </a:pPr>
                       <a:r>
-                        <a:rPr lang="en-US" sz="1050" dirty="0">
+                        <a:rPr lang="en-US" sz="1000" dirty="0">
                           <a:solidFill>
                             <a:srgbClr val="1A1A2E"/>
                           </a:solidFill>
@@ -5745,7 +5745,7 @@
                         </a:rPr>
                         <a:t>—</a:t>
                       </a:r>
-                      <a:endParaRPr lang="en-US" sz="1050" dirty="0">
+                      <a:endParaRPr lang="en-US" sz="1000" dirty="0">
                         <a:latin typeface="Calibri" charset="0"/>
                         <a:ea typeface="Calibri" charset="0"/>
                         <a:cs typeface="Calibri" charset="0"/>
@@ -5800,7 +5800,793 @@
                         <a:buNone/>
                       </a:pPr>
                       <a:r>
-                        <a:rPr lang="en-US" sz="1050" b="1" dirty="0">
+                        <a:rPr lang="en-US" sz="1000" b="1" dirty="0">
+                          <a:solidFill>
+                            <a:srgbClr val="B3261E"/>
+                          </a:solidFill>
+                          <a:latin typeface="Calibri" pitchFamily="34" charset="0"/>
+                          <a:ea typeface="Calibri" pitchFamily="34" charset="-122"/>
+                          <a:cs typeface="Calibri" pitchFamily="34" charset="-120"/>
+                        </a:rPr>
+                        <a:t>Too rare at 20k — needs scale</a:t>
+                      </a:r>
+                      <a:endParaRPr lang="en-US" sz="1000" dirty="0">
+                        <a:latin typeface="Calibri" charset="0"/>
+                        <a:ea typeface="Calibri" charset="0"/>
+                        <a:cs typeface="Calibri" charset="0"/>
+                      </a:endParaRPr>
+                    </a:p>
+                  </a:txBody>
+                  <a:tcPr marL="91440" marR="91440" marT="45720" marB="45720" anchor="ctr">
+                    <a:lnL w="12700" cap="flat" cmpd="sng" algn="ctr">
+                      <a:solidFill>
+                        <a:srgbClr val="D8DEEC"/>
+                      </a:solidFill>
+                      <a:prstDash val="solid"/>
+                      <a:round/>
+                      <a:headEnd type="none" w="med" len="med"/>
+                      <a:tailEnd type="none" w="med" len="med"/>
+                    </a:lnL>
+                    <a:lnR w="12700" cap="flat" cmpd="sng" algn="ctr">
+                      <a:solidFill>
+                        <a:srgbClr val="D8DEEC"/>
+                      </a:solidFill>
+                      <a:prstDash val="solid"/>
+                      <a:round/>
+                      <a:headEnd type="none" w="med" len="med"/>
+                      <a:tailEnd type="none" w="med" len="med"/>
+                    </a:lnR>
+                    <a:lnT w="12700" cap="flat" cmpd="sng" algn="ctr">
+                      <a:solidFill>
+                        <a:srgbClr val="D8DEEC"/>
+                      </a:solidFill>
+                      <a:prstDash val="solid"/>
+                      <a:round/>
+                      <a:headEnd type="none" w="med" len="med"/>
+                      <a:tailEnd type="none" w="med" len="med"/>
+                    </a:lnT>
+                    <a:lnB w="12700" cap="flat" cmpd="sng" algn="ctr">
+                      <a:solidFill>
+                        <a:srgbClr val="D8DEEC"/>
+                      </a:solidFill>
+                      <a:prstDash val="solid"/>
+                      <a:round/>
+                      <a:headEnd type="none" w="med" len="med"/>
+                      <a:tailEnd type="none" w="med" len="med"/>
+                    </a:lnB>
+                  </a:tcPr>
+                </a:tc>
+              </a:tr>
+              <a:tr h="274320">
+                <a:tc>
+                  <a:txBody>
+                    <a:bodyPr/>
+                    <a:lstStyle/>
+                    <a:p>
+                      <a:pPr indent="0" marL="0">
+                        <a:buNone/>
+                      </a:pPr>
+                      <a:r>
+                        <a:rPr lang="en-US" sz="1000" dirty="0">
+                          <a:solidFill>
+                            <a:srgbClr val="1A1A2E"/>
+                          </a:solidFill>
+                          <a:latin typeface="Calibri" pitchFamily="34" charset="0"/>
+                          <a:ea typeface="Calibri" pitchFamily="34" charset="-122"/>
+                          <a:cs typeface="Calibri" pitchFamily="34" charset="-120"/>
+                        </a:rPr>
+                        <a:t>Next-message order (sequence encoder)</a:t>
+                      </a:r>
+                      <a:endParaRPr lang="en-US" sz="1000" dirty="0">
+                        <a:latin typeface="Calibri" charset="0"/>
+                        <a:ea typeface="Calibri" charset="0"/>
+                        <a:cs typeface="Calibri" charset="0"/>
+                      </a:endParaRPr>
+                    </a:p>
+                  </a:txBody>
+                  <a:tcPr marL="91440" marR="91440" marT="45720" marB="45720" anchor="ctr">
+                    <a:lnL w="12700" cap="flat" cmpd="sng" algn="ctr">
+                      <a:solidFill>
+                        <a:srgbClr val="D8DEEC"/>
+                      </a:solidFill>
+                      <a:prstDash val="solid"/>
+                      <a:round/>
+                      <a:headEnd type="none" w="med" len="med"/>
+                      <a:tailEnd type="none" w="med" len="med"/>
+                    </a:lnL>
+                    <a:lnR w="12700" cap="flat" cmpd="sng" algn="ctr">
+                      <a:solidFill>
+                        <a:srgbClr val="D8DEEC"/>
+                      </a:solidFill>
+                      <a:prstDash val="solid"/>
+                      <a:round/>
+                      <a:headEnd type="none" w="med" len="med"/>
+                      <a:tailEnd type="none" w="med" len="med"/>
+                    </a:lnR>
+                    <a:lnT w="12700" cap="flat" cmpd="sng" algn="ctr">
+                      <a:solidFill>
+                        <a:srgbClr val="D8DEEC"/>
+                      </a:solidFill>
+                      <a:prstDash val="solid"/>
+                      <a:round/>
+                      <a:headEnd type="none" w="med" len="med"/>
+                      <a:tailEnd type="none" w="med" len="med"/>
+                    </a:lnT>
+                    <a:lnB w="12700" cap="flat" cmpd="sng" algn="ctr">
+                      <a:solidFill>
+                        <a:srgbClr val="D8DEEC"/>
+                      </a:solidFill>
+                      <a:prstDash val="solid"/>
+                      <a:round/>
+                      <a:headEnd type="none" w="med" len="med"/>
+                      <a:tailEnd type="none" w="med" len="med"/>
+                    </a:lnB>
+                  </a:tcPr>
+                </a:tc>
+                <a:tc>
+                  <a:txBody>
+                    <a:bodyPr/>
+                    <a:lstStyle/>
+                    <a:p>
+                      <a:pPr indent="0" marL="0">
+                        <a:buNone/>
+                      </a:pPr>
+                      <a:r>
+                        <a:rPr lang="en-US" sz="1000" dirty="0">
+                          <a:solidFill>
+                            <a:srgbClr val="1A1A2E"/>
+                          </a:solidFill>
+                          <a:latin typeface="Calibri" pitchFamily="34" charset="0"/>
+                          <a:ea typeface="Calibri" pitchFamily="34" charset="-122"/>
+                          <a:cs typeface="Calibri" pitchFamily="34" charset="-120"/>
+                        </a:rPr>
+                        <a:t>sequence ≈ pooled (−0.5pp, full run)</a:t>
+                      </a:r>
+                      <a:endParaRPr lang="en-US" sz="1000" dirty="0">
+                        <a:latin typeface="Calibri" charset="0"/>
+                        <a:ea typeface="Calibri" charset="0"/>
+                        <a:cs typeface="Calibri" charset="0"/>
+                      </a:endParaRPr>
+                    </a:p>
+                  </a:txBody>
+                  <a:tcPr marL="91440" marR="91440" marT="45720" marB="45720" anchor="ctr">
+                    <a:lnL w="12700" cap="flat" cmpd="sng" algn="ctr">
+                      <a:solidFill>
+                        <a:srgbClr val="D8DEEC"/>
+                      </a:solidFill>
+                      <a:prstDash val="solid"/>
+                      <a:round/>
+                      <a:headEnd type="none" w="med" len="med"/>
+                      <a:tailEnd type="none" w="med" len="med"/>
+                    </a:lnL>
+                    <a:lnR w="12700" cap="flat" cmpd="sng" algn="ctr">
+                      <a:solidFill>
+                        <a:srgbClr val="D8DEEC"/>
+                      </a:solidFill>
+                      <a:prstDash val="solid"/>
+                      <a:round/>
+                      <a:headEnd type="none" w="med" len="med"/>
+                      <a:tailEnd type="none" w="med" len="med"/>
+                    </a:lnR>
+                    <a:lnT w="12700" cap="flat" cmpd="sng" algn="ctr">
+                      <a:solidFill>
+                        <a:srgbClr val="D8DEEC"/>
+                      </a:solidFill>
+                      <a:prstDash val="solid"/>
+                      <a:round/>
+                      <a:headEnd type="none" w="med" len="med"/>
+                      <a:tailEnd type="none" w="med" len="med"/>
+                    </a:lnT>
+                    <a:lnB w="12700" cap="flat" cmpd="sng" algn="ctr">
+                      <a:solidFill>
+                        <a:srgbClr val="D8DEEC"/>
+                      </a:solidFill>
+                      <a:prstDash val="solid"/>
+                      <a:round/>
+                      <a:headEnd type="none" w="med" len="med"/>
+                      <a:tailEnd type="none" w="med" len="med"/>
+                    </a:lnB>
+                  </a:tcPr>
+                </a:tc>
+                <a:tc>
+                  <a:txBody>
+                    <a:bodyPr/>
+                    <a:lstStyle/>
+                    <a:p>
+                      <a:pPr indent="0" marL="0">
+                        <a:buNone/>
+                      </a:pPr>
+                      <a:r>
+                        <a:rPr lang="en-US" sz="1000" dirty="0">
+                          <a:solidFill>
+                            <a:srgbClr val="1A1A2E"/>
+                          </a:solidFill>
+                          <a:latin typeface="Calibri" pitchFamily="34" charset="0"/>
+                          <a:ea typeface="Calibri" pitchFamily="34" charset="-122"/>
+                          <a:cs typeface="Calibri" pitchFamily="34" charset="-120"/>
+                        </a:rPr>
+                        <a:t>bag-of-messages</a:t>
+                      </a:r>
+                      <a:endParaRPr lang="en-US" sz="1000" dirty="0">
+                        <a:latin typeface="Calibri" charset="0"/>
+                        <a:ea typeface="Calibri" charset="0"/>
+                        <a:cs typeface="Calibri" charset="0"/>
+                      </a:endParaRPr>
+                    </a:p>
+                  </a:txBody>
+                  <a:tcPr marL="91440" marR="91440" marT="45720" marB="45720" anchor="ctr">
+                    <a:lnL w="12700" cap="flat" cmpd="sng" algn="ctr">
+                      <a:solidFill>
+                        <a:srgbClr val="D8DEEC"/>
+                      </a:solidFill>
+                      <a:prstDash val="solid"/>
+                      <a:round/>
+                      <a:headEnd type="none" w="med" len="med"/>
+                      <a:tailEnd type="none" w="med" len="med"/>
+                    </a:lnL>
+                    <a:lnR w="12700" cap="flat" cmpd="sng" algn="ctr">
+                      <a:solidFill>
+                        <a:srgbClr val="D8DEEC"/>
+                      </a:solidFill>
+                      <a:prstDash val="solid"/>
+                      <a:round/>
+                      <a:headEnd type="none" w="med" len="med"/>
+                      <a:tailEnd type="none" w="med" len="med"/>
+                    </a:lnR>
+                    <a:lnT w="12700" cap="flat" cmpd="sng" algn="ctr">
+                      <a:solidFill>
+                        <a:srgbClr val="D8DEEC"/>
+                      </a:solidFill>
+                      <a:prstDash val="solid"/>
+                      <a:round/>
+                      <a:headEnd type="none" w="med" len="med"/>
+                      <a:tailEnd type="none" w="med" len="med"/>
+                    </a:lnT>
+                    <a:lnB w="12700" cap="flat" cmpd="sng" algn="ctr">
+                      <a:solidFill>
+                        <a:srgbClr val="D8DEEC"/>
+                      </a:solidFill>
+                      <a:prstDash val="solid"/>
+                      <a:round/>
+                      <a:headEnd type="none" w="med" len="med"/>
+                      <a:tailEnd type="none" w="med" len="med"/>
+                    </a:lnB>
+                  </a:tcPr>
+                </a:tc>
+                <a:tc>
+                  <a:txBody>
+                    <a:bodyPr/>
+                    <a:lstStyle/>
+                    <a:p>
+                      <a:pPr indent="0" marL="0">
+                        <a:buNone/>
+                      </a:pPr>
+                      <a:r>
+                        <a:rPr lang="en-US" sz="1000" b="1" dirty="0">
+                          <a:solidFill>
+                            <a:srgbClr val="5A6172"/>
+                          </a:solidFill>
+                          <a:latin typeface="Calibri" pitchFamily="34" charset="0"/>
+                          <a:ea typeface="Calibri" pitchFamily="34" charset="-122"/>
+                          <a:cs typeface="Calibri" pitchFamily="34" charset="-120"/>
+                        </a:rPr>
+                        <a:t>Honest null — no order signal</a:t>
+                      </a:r>
+                      <a:endParaRPr lang="en-US" sz="1000" dirty="0">
+                        <a:latin typeface="Calibri" charset="0"/>
+                        <a:ea typeface="Calibri" charset="0"/>
+                        <a:cs typeface="Calibri" charset="0"/>
+                      </a:endParaRPr>
+                    </a:p>
+                  </a:txBody>
+                  <a:tcPr marL="91440" marR="91440" marT="45720" marB="45720" anchor="ctr">
+                    <a:lnL w="12700" cap="flat" cmpd="sng" algn="ctr">
+                      <a:solidFill>
+                        <a:srgbClr val="D8DEEC"/>
+                      </a:solidFill>
+                      <a:prstDash val="solid"/>
+                      <a:round/>
+                      <a:headEnd type="none" w="med" len="med"/>
+                      <a:tailEnd type="none" w="med" len="med"/>
+                    </a:lnL>
+                    <a:lnR w="12700" cap="flat" cmpd="sng" algn="ctr">
+                      <a:solidFill>
+                        <a:srgbClr val="D8DEEC"/>
+                      </a:solidFill>
+                      <a:prstDash val="solid"/>
+                      <a:round/>
+                      <a:headEnd type="none" w="med" len="med"/>
+                      <a:tailEnd type="none" w="med" len="med"/>
+                    </a:lnR>
+                    <a:lnT w="12700" cap="flat" cmpd="sng" algn="ctr">
+                      <a:solidFill>
+                        <a:srgbClr val="D8DEEC"/>
+                      </a:solidFill>
+                      <a:prstDash val="solid"/>
+                      <a:round/>
+                      <a:headEnd type="none" w="med" len="med"/>
+                      <a:tailEnd type="none" w="med" len="med"/>
+                    </a:lnT>
+                    <a:lnB w="12700" cap="flat" cmpd="sng" algn="ctr">
+                      <a:solidFill>
+                        <a:srgbClr val="D8DEEC"/>
+                      </a:solidFill>
+                      <a:prstDash val="solid"/>
+                      <a:round/>
+                      <a:headEnd type="none" w="med" len="med"/>
+                      <a:tailEnd type="none" w="med" len="med"/>
+                    </a:lnB>
+                  </a:tcPr>
+                </a:tc>
+              </a:tr>
+              <a:tr h="274320">
+                <a:tc>
+                  <a:txBody>
+                    <a:bodyPr/>
+                    <a:lstStyle/>
+                    <a:p>
+                      <a:pPr indent="0" marL="0">
+                        <a:buNone/>
+                      </a:pPr>
+                      <a:r>
+                        <a:rPr lang="en-US" sz="1000" dirty="0">
+                          <a:solidFill>
+                            <a:srgbClr val="1A1A2E"/>
+                          </a:solidFill>
+                          <a:latin typeface="Calibri" pitchFamily="34" charset="0"/>
+                          <a:ea typeface="Calibri" pitchFamily="34" charset="-122"/>
+                          <a:cs typeface="Calibri" pitchFamily="34" charset="-120"/>
+                        </a:rPr>
+                        <a:t>Caps · floors · geo-cover · duplicates</a:t>
+                      </a:r>
+                      <a:endParaRPr lang="en-US" sz="1000" dirty="0">
+                        <a:latin typeface="Calibri" charset="0"/>
+                        <a:ea typeface="Calibri" charset="0"/>
+                        <a:cs typeface="Calibri" charset="0"/>
+                      </a:endParaRPr>
+                    </a:p>
+                  </a:txBody>
+                  <a:tcPr marL="91440" marR="91440" marT="45720" marB="45720" anchor="ctr">
+                    <a:lnL w="12700" cap="flat" cmpd="sng" algn="ctr">
+                      <a:solidFill>
+                        <a:srgbClr val="D8DEEC"/>
+                      </a:solidFill>
+                      <a:prstDash val="solid"/>
+                      <a:round/>
+                      <a:headEnd type="none" w="med" len="med"/>
+                      <a:tailEnd type="none" w="med" len="med"/>
+                    </a:lnL>
+                    <a:lnR w="12700" cap="flat" cmpd="sng" algn="ctr">
+                      <a:solidFill>
+                        <a:srgbClr val="D8DEEC"/>
+                      </a:solidFill>
+                      <a:prstDash val="solid"/>
+                      <a:round/>
+                      <a:headEnd type="none" w="med" len="med"/>
+                      <a:tailEnd type="none" w="med" len="med"/>
+                    </a:lnR>
+                    <a:lnT w="12700" cap="flat" cmpd="sng" algn="ctr">
+                      <a:solidFill>
+                        <a:srgbClr val="D8DEEC"/>
+                      </a:solidFill>
+                      <a:prstDash val="solid"/>
+                      <a:round/>
+                      <a:headEnd type="none" w="med" len="med"/>
+                      <a:tailEnd type="none" w="med" len="med"/>
+                    </a:lnT>
+                    <a:lnB w="12700" cap="flat" cmpd="sng" algn="ctr">
+                      <a:solidFill>
+                        <a:srgbClr val="D8DEEC"/>
+                      </a:solidFill>
+                      <a:prstDash val="solid"/>
+                      <a:round/>
+                      <a:headEnd type="none" w="med" len="med"/>
+                      <a:tailEnd type="none" w="med" len="med"/>
+                    </a:lnB>
+                  </a:tcPr>
+                </a:tc>
+                <a:tc>
+                  <a:txBody>
+                    <a:bodyPr/>
+                    <a:lstStyle/>
+                    <a:p>
+                      <a:pPr indent="0" marL="0">
+                        <a:buNone/>
+                      </a:pPr>
+                      <a:r>
+                        <a:rPr lang="en-US" sz="1000" dirty="0">
+                          <a:solidFill>
+                            <a:srgbClr val="1A1A2E"/>
+                          </a:solidFill>
+                          <a:latin typeface="Calibri" pitchFamily="34" charset="0"/>
+                          <a:ea typeface="Calibri" pitchFamily="34" charset="-122"/>
+                          <a:cs typeface="Calibri" pitchFamily="34" charset="-120"/>
+                        </a:rPr>
+                        <a:t>exact by construction</a:t>
+                      </a:r>
+                      <a:endParaRPr lang="en-US" sz="1000" dirty="0">
+                        <a:latin typeface="Calibri" charset="0"/>
+                        <a:ea typeface="Calibri" charset="0"/>
+                        <a:cs typeface="Calibri" charset="0"/>
+                      </a:endParaRPr>
+                    </a:p>
+                  </a:txBody>
+                  <a:tcPr marL="91440" marR="91440" marT="45720" marB="45720" anchor="ctr">
+                    <a:lnL w="12700" cap="flat" cmpd="sng" algn="ctr">
+                      <a:solidFill>
+                        <a:srgbClr val="D8DEEC"/>
+                      </a:solidFill>
+                      <a:prstDash val="solid"/>
+                      <a:round/>
+                      <a:headEnd type="none" w="med" len="med"/>
+                      <a:tailEnd type="none" w="med" len="med"/>
+                    </a:lnL>
+                    <a:lnR w="12700" cap="flat" cmpd="sng" algn="ctr">
+                      <a:solidFill>
+                        <a:srgbClr val="D8DEEC"/>
+                      </a:solidFill>
+                      <a:prstDash val="solid"/>
+                      <a:round/>
+                      <a:headEnd type="none" w="med" len="med"/>
+                      <a:tailEnd type="none" w="med" len="med"/>
+                    </a:lnR>
+                    <a:lnT w="12700" cap="flat" cmpd="sng" algn="ctr">
+                      <a:solidFill>
+                        <a:srgbClr val="D8DEEC"/>
+                      </a:solidFill>
+                      <a:prstDash val="solid"/>
+                      <a:round/>
+                      <a:headEnd type="none" w="med" len="med"/>
+                      <a:tailEnd type="none" w="med" len="med"/>
+                    </a:lnT>
+                    <a:lnB w="12700" cap="flat" cmpd="sng" algn="ctr">
+                      <a:solidFill>
+                        <a:srgbClr val="D8DEEC"/>
+                      </a:solidFill>
+                      <a:prstDash val="solid"/>
+                      <a:round/>
+                      <a:headEnd type="none" w="med" len="med"/>
+                      <a:tailEnd type="none" w="med" len="med"/>
+                    </a:lnB>
+                  </a:tcPr>
+                </a:tc>
+                <a:tc>
+                  <a:txBody>
+                    <a:bodyPr/>
+                    <a:lstStyle/>
+                    <a:p>
+                      <a:pPr indent="0" marL="0">
+                        <a:buNone/>
+                      </a:pPr>
+                      <a:r>
+                        <a:rPr lang="en-US" sz="1000" dirty="0">
+                          <a:solidFill>
+                            <a:srgbClr val="1A1A2E"/>
+                          </a:solidFill>
+                          <a:latin typeface="Calibri" pitchFamily="34" charset="0"/>
+                          <a:ea typeface="Calibri" pitchFamily="34" charset="-122"/>
+                          <a:cs typeface="Calibri" pitchFamily="34" charset="-120"/>
+                        </a:rPr>
+                        <a:t>—</a:t>
+                      </a:r>
+                      <a:endParaRPr lang="en-US" sz="1000" dirty="0">
+                        <a:latin typeface="Calibri" charset="0"/>
+                        <a:ea typeface="Calibri" charset="0"/>
+                        <a:cs typeface="Calibri" charset="0"/>
+                      </a:endParaRPr>
+                    </a:p>
+                  </a:txBody>
+                  <a:tcPr marL="91440" marR="91440" marT="45720" marB="45720" anchor="ctr">
+                    <a:lnL w="12700" cap="flat" cmpd="sng" algn="ctr">
+                      <a:solidFill>
+                        <a:srgbClr val="D8DEEC"/>
+                      </a:solidFill>
+                      <a:prstDash val="solid"/>
+                      <a:round/>
+                      <a:headEnd type="none" w="med" len="med"/>
+                      <a:tailEnd type="none" w="med" len="med"/>
+                    </a:lnL>
+                    <a:lnR w="12700" cap="flat" cmpd="sng" algn="ctr">
+                      <a:solidFill>
+                        <a:srgbClr val="D8DEEC"/>
+                      </a:solidFill>
+                      <a:prstDash val="solid"/>
+                      <a:round/>
+                      <a:headEnd type="none" w="med" len="med"/>
+                      <a:tailEnd type="none" w="med" len="med"/>
+                    </a:lnR>
+                    <a:lnT w="12700" cap="flat" cmpd="sng" algn="ctr">
+                      <a:solidFill>
+                        <a:srgbClr val="D8DEEC"/>
+                      </a:solidFill>
+                      <a:prstDash val="solid"/>
+                      <a:round/>
+                      <a:headEnd type="none" w="med" len="med"/>
+                      <a:tailEnd type="none" w="med" len="med"/>
+                    </a:lnT>
+                    <a:lnB w="12700" cap="flat" cmpd="sng" algn="ctr">
+                      <a:solidFill>
+                        <a:srgbClr val="D8DEEC"/>
+                      </a:solidFill>
+                      <a:prstDash val="solid"/>
+                      <a:round/>
+                      <a:headEnd type="none" w="med" len="med"/>
+                      <a:tailEnd type="none" w="med" len="med"/>
+                    </a:lnB>
+                  </a:tcPr>
+                </a:tc>
+                <a:tc>
+                  <a:txBody>
+                    <a:bodyPr/>
+                    <a:lstStyle/>
+                    <a:p>
+                      <a:pPr indent="0" marL="0">
+                        <a:buNone/>
+                      </a:pPr>
+                      <a:r>
+                        <a:rPr lang="en-US" sz="1000" b="1" dirty="0">
+                          <a:solidFill>
+                            <a:srgbClr val="5A6172"/>
+                          </a:solidFill>
+                          <a:latin typeface="Calibri" pitchFamily="34" charset="0"/>
+                          <a:ea typeface="Calibri" pitchFamily="34" charset="-122"/>
+                          <a:cs typeface="Calibri" pitchFamily="34" charset="-120"/>
+                        </a:rPr>
+                        <a:t>Rules &amp; guards, not ML</a:t>
+                      </a:r>
+                      <a:endParaRPr lang="en-US" sz="1000" dirty="0">
+                        <a:latin typeface="Calibri" charset="0"/>
+                        <a:ea typeface="Calibri" charset="0"/>
+                        <a:cs typeface="Calibri" charset="0"/>
+                      </a:endParaRPr>
+                    </a:p>
+                  </a:txBody>
+                  <a:tcPr marL="91440" marR="91440" marT="45720" marB="45720" anchor="ctr">
+                    <a:lnL w="12700" cap="flat" cmpd="sng" algn="ctr">
+                      <a:solidFill>
+                        <a:srgbClr val="D8DEEC"/>
+                      </a:solidFill>
+                      <a:prstDash val="solid"/>
+                      <a:round/>
+                      <a:headEnd type="none" w="med" len="med"/>
+                      <a:tailEnd type="none" w="med" len="med"/>
+                    </a:lnL>
+                    <a:lnR w="12700" cap="flat" cmpd="sng" algn="ctr">
+                      <a:solidFill>
+                        <a:srgbClr val="D8DEEC"/>
+                      </a:solidFill>
+                      <a:prstDash val="solid"/>
+                      <a:round/>
+                      <a:headEnd type="none" w="med" len="med"/>
+                      <a:tailEnd type="none" w="med" len="med"/>
+                    </a:lnR>
+                    <a:lnT w="12700" cap="flat" cmpd="sng" algn="ctr">
+                      <a:solidFill>
+                        <a:srgbClr val="D8DEEC"/>
+                      </a:solidFill>
+                      <a:prstDash val="solid"/>
+                      <a:round/>
+                      <a:headEnd type="none" w="med" len="med"/>
+                      <a:tailEnd type="none" w="med" len="med"/>
+                    </a:lnT>
+                    <a:lnB w="12700" cap="flat" cmpd="sng" algn="ctr">
+                      <a:solidFill>
+                        <a:srgbClr val="D8DEEC"/>
+                      </a:solidFill>
+                      <a:prstDash val="solid"/>
+                      <a:round/>
+                      <a:headEnd type="none" w="med" len="med"/>
+                      <a:tailEnd type="none" w="med" len="med"/>
+                    </a:lnB>
+                  </a:tcPr>
+                </a:tc>
+              </a:tr>
+              <a:tr h="274320">
+                <a:tc>
+                  <a:txBody>
+                    <a:bodyPr/>
+                    <a:lstStyle/>
+                    <a:p>
+                      <a:pPr indent="0" marL="0">
+                        <a:buNone/>
+                      </a:pPr>
+                      <a:r>
+                        <a:rPr lang="en-US" sz="1000" dirty="0">
+                          <a:solidFill>
+                            <a:srgbClr val="1A1A2E"/>
+                          </a:solidFill>
+                          <a:latin typeface="Calibri" pitchFamily="34" charset="0"/>
+                          <a:ea typeface="Calibri" pitchFamily="34" charset="-122"/>
+                          <a:cs typeface="Calibri" pitchFamily="34" charset="-120"/>
+                        </a:rPr>
+                        <a:t>Missing-field infill (imputation)</a:t>
+                      </a:r>
+                      <a:endParaRPr lang="en-US" sz="1000" dirty="0">
+                        <a:latin typeface="Calibri" charset="0"/>
+                        <a:ea typeface="Calibri" charset="0"/>
+                        <a:cs typeface="Calibri" charset="0"/>
+                      </a:endParaRPr>
+                    </a:p>
+                  </a:txBody>
+                  <a:tcPr marL="91440" marR="91440" marT="45720" marB="45720" anchor="ctr">
+                    <a:lnL w="12700" cap="flat" cmpd="sng" algn="ctr">
+                      <a:solidFill>
+                        <a:srgbClr val="D8DEEC"/>
+                      </a:solidFill>
+                      <a:prstDash val="solid"/>
+                      <a:round/>
+                      <a:headEnd type="none" w="med" len="med"/>
+                      <a:tailEnd type="none" w="med" len="med"/>
+                    </a:lnL>
+                    <a:lnR w="12700" cap="flat" cmpd="sng" algn="ctr">
+                      <a:solidFill>
+                        <a:srgbClr val="D8DEEC"/>
+                      </a:solidFill>
+                      <a:prstDash val="solid"/>
+                      <a:round/>
+                      <a:headEnd type="none" w="med" len="med"/>
+                      <a:tailEnd type="none" w="med" len="med"/>
+                    </a:lnR>
+                    <a:lnT w="12700" cap="flat" cmpd="sng" algn="ctr">
+                      <a:solidFill>
+                        <a:srgbClr val="D8DEEC"/>
+                      </a:solidFill>
+                      <a:prstDash val="solid"/>
+                      <a:round/>
+                      <a:headEnd type="none" w="med" len="med"/>
+                      <a:tailEnd type="none" w="med" len="med"/>
+                    </a:lnT>
+                    <a:lnB w="12700" cap="flat" cmpd="sng" algn="ctr">
+                      <a:solidFill>
+                        <a:srgbClr val="D8DEEC"/>
+                      </a:solidFill>
+                      <a:prstDash val="solid"/>
+                      <a:round/>
+                      <a:headEnd type="none" w="med" len="med"/>
+                      <a:tailEnd type="none" w="med" len="med"/>
+                    </a:lnB>
+                  </a:tcPr>
+                </a:tc>
+                <a:tc>
+                  <a:txBody>
+                    <a:bodyPr/>
+                    <a:lstStyle/>
+                    <a:p>
+                      <a:pPr indent="0" marL="0">
+                        <a:buNone/>
+                      </a:pPr>
+                      <a:r>
+                        <a:rPr lang="en-US" sz="1000" dirty="0">
+                          <a:solidFill>
+                            <a:srgbClr val="1A1A2E"/>
+                          </a:solidFill>
+                          <a:latin typeface="Calibri" pitchFamily="34" charset="0"/>
+                          <a:ea typeface="Calibri" pitchFamily="34" charset="-122"/>
+                          <a:cs typeface="Calibri" pitchFamily="34" charset="-120"/>
+                        </a:rPr>
+                        <a:t>structured fields only</a:t>
+                      </a:r>
+                      <a:endParaRPr lang="en-US" sz="1000" dirty="0">
+                        <a:latin typeface="Calibri" charset="0"/>
+                        <a:ea typeface="Calibri" charset="0"/>
+                        <a:cs typeface="Calibri" charset="0"/>
+                      </a:endParaRPr>
+                    </a:p>
+                  </a:txBody>
+                  <a:tcPr marL="91440" marR="91440" marT="45720" marB="45720" anchor="ctr">
+                    <a:lnL w="12700" cap="flat" cmpd="sng" algn="ctr">
+                      <a:solidFill>
+                        <a:srgbClr val="D8DEEC"/>
+                      </a:solidFill>
+                      <a:prstDash val="solid"/>
+                      <a:round/>
+                      <a:headEnd type="none" w="med" len="med"/>
+                      <a:tailEnd type="none" w="med" len="med"/>
+                    </a:lnL>
+                    <a:lnR w="12700" cap="flat" cmpd="sng" algn="ctr">
+                      <a:solidFill>
+                        <a:srgbClr val="D8DEEC"/>
+                      </a:solidFill>
+                      <a:prstDash val="solid"/>
+                      <a:round/>
+                      <a:headEnd type="none" w="med" len="med"/>
+                      <a:tailEnd type="none" w="med" len="med"/>
+                    </a:lnR>
+                    <a:lnT w="12700" cap="flat" cmpd="sng" algn="ctr">
+                      <a:solidFill>
+                        <a:srgbClr val="D8DEEC"/>
+                      </a:solidFill>
+                      <a:prstDash val="solid"/>
+                      <a:round/>
+                      <a:headEnd type="none" w="med" len="med"/>
+                      <a:tailEnd type="none" w="med" len="med"/>
+                    </a:lnT>
+                    <a:lnB w="12700" cap="flat" cmpd="sng" algn="ctr">
+                      <a:solidFill>
+                        <a:srgbClr val="D8DEEC"/>
+                      </a:solidFill>
+                      <a:prstDash val="solid"/>
+                      <a:round/>
+                      <a:headEnd type="none" w="med" len="med"/>
+                      <a:tailEnd type="none" w="med" len="med"/>
+                    </a:lnB>
+                  </a:tcPr>
+                </a:tc>
+                <a:tc>
+                  <a:txBody>
+                    <a:bodyPr/>
+                    <a:lstStyle/>
+                    <a:p>
+                      <a:pPr indent="0" marL="0">
+                        <a:buNone/>
+                      </a:pPr>
+                      <a:r>
+                        <a:rPr lang="en-US" sz="1000" dirty="0">
+                          <a:solidFill>
+                            <a:srgbClr val="1A1A2E"/>
+                          </a:solidFill>
+                          <a:latin typeface="Calibri" pitchFamily="34" charset="0"/>
+                          <a:ea typeface="Calibri" pitchFamily="34" charset="-122"/>
+                          <a:cs typeface="Calibri" pitchFamily="34" charset="-120"/>
+                        </a:rPr>
+                        <a:t>—</a:t>
+                      </a:r>
+                      <a:endParaRPr lang="en-US" sz="1000" dirty="0">
+                        <a:latin typeface="Calibri" charset="0"/>
+                        <a:ea typeface="Calibri" charset="0"/>
+                        <a:cs typeface="Calibri" charset="0"/>
+                      </a:endParaRPr>
+                    </a:p>
+                  </a:txBody>
+                  <a:tcPr marL="91440" marR="91440" marT="45720" marB="45720" anchor="ctr">
+                    <a:lnL w="12700" cap="flat" cmpd="sng" algn="ctr">
+                      <a:solidFill>
+                        <a:srgbClr val="D8DEEC"/>
+                      </a:solidFill>
+                      <a:prstDash val="solid"/>
+                      <a:round/>
+                      <a:headEnd type="none" w="med" len="med"/>
+                      <a:tailEnd type="none" w="med" len="med"/>
+                    </a:lnL>
+                    <a:lnR w="12700" cap="flat" cmpd="sng" algn="ctr">
+                      <a:solidFill>
+                        <a:srgbClr val="D8DEEC"/>
+                      </a:solidFill>
+                      <a:prstDash val="solid"/>
+                      <a:round/>
+                      <a:headEnd type="none" w="med" len="med"/>
+                      <a:tailEnd type="none" w="med" len="med"/>
+                    </a:lnR>
+                    <a:lnT w="12700" cap="flat" cmpd="sng" algn="ctr">
+                      <a:solidFill>
+                        <a:srgbClr val="D8DEEC"/>
+                      </a:solidFill>
+                      <a:prstDash val="solid"/>
+                      <a:round/>
+                      <a:headEnd type="none" w="med" len="med"/>
+                      <a:tailEnd type="none" w="med" len="med"/>
+                    </a:lnT>
+                    <a:lnB w="12700" cap="flat" cmpd="sng" algn="ctr">
+                      <a:solidFill>
+                        <a:srgbClr val="D8DEEC"/>
+                      </a:solidFill>
+                      <a:prstDash val="solid"/>
+                      <a:round/>
+                      <a:headEnd type="none" w="med" len="med"/>
+                      <a:tailEnd type="none" w="med" len="med"/>
+                    </a:lnB>
+                  </a:tcPr>
+                </a:tc>
+                <a:tc>
+                  <a:txBody>
+                    <a:bodyPr/>
+                    <a:lstStyle/>
+                    <a:p>
+                      <a:pPr indent="0" marL="0">
+                        <a:buNone/>
+                      </a:pPr>
+                      <a:r>
+                        <a:rPr lang="en-US" sz="1000" b="1" dirty="0">
                           <a:solidFill>
                             <a:srgbClr val="5A6172"/>
                           </a:solidFill>
@@ -5810,7 +6596,7 @@
                         </a:rPr>
                         <a:t>IDs / dates → lookup, not inference</a:t>
                       </a:r>
-                      <a:endParaRPr lang="en-US" sz="1050" dirty="0">
+                      <a:endParaRPr lang="en-US" sz="1000" dirty="0">
                         <a:latin typeface="Calibri" charset="0"/>
                         <a:ea typeface="Calibri" charset="0"/>
                         <a:cs typeface="Calibri" charset="0"/>
@@ -5869,8 +6655,8 @@
         </p:nvSpPr>
         <p:spPr>
           <a:xfrm>
-            <a:off x="457200" y="5943600"/>
-            <a:ext cx="11274552" cy="594360"/>
+            <a:off x="457200" y="6053328"/>
+            <a:ext cx="11274552" cy="548640"/>
           </a:xfrm>
           <a:prstGeom prst="rect">
             <a:avLst/>
@@ -5886,7 +6672,7 @@
               <a:buNone/>
             </a:pPr>
             <a:r>
-              <a:rPr lang="en-US" sz="1150" i="1" dirty="0">
+              <a:rPr lang="en-US" sz="1100" i="1" dirty="0">
                 <a:solidFill>
                   <a:srgbClr val="5A6172"/>
                 </a:solidFill>
@@ -5894,9 +6680,9 @@
                 <a:ea typeface="Calibri" pitchFamily="34" charset="-122"/>
                 <a:cs typeface="Calibri" pitchFamily="34" charset="-120"/>
               </a:rPr>
-              <a:t>Green = the frozen backbone beats its baseline. Amber / red = a tuned tree matches or wins on complete-record labels — the paper's C2 finding, reported openly and routed to the right tool. Grey = deliberately not ML.</a:t>
+              <a:t>Green = the frozen backbone beats its baseline. Amber / red = a tuned tree or naive matches or wins on complete-record labels — the paper's C2 finding, reported openly and routed to the right tool. Grey = deliberately not ML.</a:t>
             </a:r>
-            <a:endParaRPr lang="en-US" sz="1150" dirty="0"/>
+            <a:endParaRPr lang="en-US" sz="1100" dirty="0"/>
           </a:p>
         </p:txBody>
       </p:sp>
@@ -6004,7 +6790,7 @@
                 <a:ea typeface="Calibri" pitchFamily="34" charset="-122"/>
                 <a:cs typeface="Calibri" pitchFamily="34" charset="-120"/>
               </a:rPr>
-              <a:t>5 of 100 held-out payments · CSV in → CSV out (test_predictions_100.csv).</a:t>
+              <a:t>5 of 100 held-out payments · CSV in → CSV out (test_predictions_100.csv, GPU-trained bundle).</a:t>
             </a:r>
             <a:endParaRPr lang="en-US" sz="1400" dirty="0"/>
           </a:p>
@@ -6037,10 +6823,10 @@
                 <a:gridCol w="960120"/>
                 <a:gridCol w="1097280"/>
                 <a:gridCol w="1828800"/>
-                <a:gridCol w="960120"/>
-                <a:gridCol w="1783080"/>
+                <a:gridCol w="1371600"/>
+                <a:gridCol w="1737360"/>
                 <a:gridCol w="1508760"/>
-                <a:gridCol w="1673352"/>
+                <a:gridCol w="1307592"/>
               </a:tblGrid>
               <a:tr h="502920">
                 <a:tc>
@@ -6801,7 +7587,7 @@
                           <a:ea typeface="Calibri" pitchFamily="34" charset="-122"/>
                           <a:cs typeface="Calibri" pitchFamily="34" charset="-120"/>
                         </a:rPr>
-                        <a:t>IMPS (0.60)</a:t>
+                        <a:t>IMPS (0.62)</a:t>
                       </a:r>
                       <a:endParaRPr lang="en-US" sz="1200" dirty="0">
                         <a:latin typeface="Calibri" charset="0"/>
@@ -6996,7 +7782,7 @@
                           <a:ea typeface="Calibri" pitchFamily="34" charset="-122"/>
                           <a:cs typeface="Calibri" pitchFamily="34" charset="-120"/>
                         </a:rPr>
-                        <a:t>5 min</a:t>
+                        <a:t>0 min</a:t>
                       </a:r>
                       <a:endParaRPr lang="en-US" sz="1200" dirty="0">
                         <a:latin typeface="Calibri" charset="0"/>
@@ -7061,7 +7847,7 @@
                           <a:ea typeface="Calibri" pitchFamily="34" charset="-122"/>
                           <a:cs typeface="Calibri" pitchFamily="34" charset="-120"/>
                         </a:rPr>
-                        <a:t>sla_breach 0.70</a:t>
+                        <a:t>format_error 0.04</a:t>
                       </a:r>
                       <a:endParaRPr lang="en-US" sz="1200" dirty="0">
                         <a:latin typeface="Calibri" charset="0"/>
@@ -7323,7 +8109,7 @@
                           <a:ea typeface="Calibri" pitchFamily="34" charset="-122"/>
                           <a:cs typeface="Calibri" pitchFamily="34" charset="-120"/>
                         </a:rPr>
-                        <a:t>RTGS (0.83)</a:t>
+                        <a:t>RTGS (0.81)</a:t>
                       </a:r>
                       <a:endParaRPr lang="en-US" sz="1200" dirty="0">
                         <a:latin typeface="Calibri" charset="0"/>
@@ -7453,7 +8239,7 @@
                           <a:ea typeface="Calibri" pitchFamily="34" charset="-122"/>
                           <a:cs typeface="Calibri" pitchFamily="34" charset="-120"/>
                         </a:rPr>
-                        <a:t>MANUAL_REVIEW</a:t>
+                        <a:t>REJECTED (true STP)</a:t>
                       </a:r>
                       <a:endParaRPr lang="en-US" sz="1200" dirty="0">
                         <a:latin typeface="Calibri" charset="0"/>
@@ -7518,7 +8304,7 @@
                           <a:ea typeface="Calibri" pitchFamily="34" charset="-122"/>
                           <a:cs typeface="Calibri" pitchFamily="34" charset="-120"/>
                         </a:rPr>
-                        <a:t>0 min</a:t>
+                        <a:t>28 min</a:t>
                       </a:r>
                       <a:endParaRPr lang="en-US" sz="1200" dirty="0">
                         <a:latin typeface="Calibri" charset="0"/>
@@ -7583,7 +8369,7 @@
                           <a:ea typeface="Calibri" pitchFamily="34" charset="-122"/>
                           <a:cs typeface="Calibri" pitchFamily="34" charset="-120"/>
                         </a:rPr>
-                        <a:t>account_closed 0.61</a:t>
+                        <a:t>fraud_hold 0.04</a:t>
                       </a:r>
                       <a:endParaRPr lang="en-US" sz="1200" dirty="0">
                         <a:latin typeface="Calibri" charset="0"/>
@@ -7650,7 +8436,7 @@
                           <a:ea typeface="Calibri" pitchFamily="34" charset="-122"/>
                           <a:cs typeface="Calibri" pitchFamily="34" charset="-120"/>
                         </a:rPr>
-                        <a:t>248,884 INR</a:t>
+                        <a:t>208,988 INR</a:t>
                       </a:r>
                       <a:endParaRPr lang="en-US" sz="1200" dirty="0">
                         <a:latin typeface="Calibri" charset="0"/>
@@ -7904,13 +8690,13 @@
                       <a:r>
                         <a:rPr lang="en-US" sz="1200" dirty="0">
                           <a:solidFill>
-                            <a:srgbClr val="2E7D32"/>
+                            <a:srgbClr val="C98A00"/>
                           </a:solidFill>
                           <a:latin typeface="Calibri" pitchFamily="34" charset="0"/>
                           <a:ea typeface="Calibri" pitchFamily="34" charset="-122"/>
                           <a:cs typeface="Calibri" pitchFamily="34" charset="-120"/>
                         </a:rPr>
-                        <a:t>Medium ✓</a:t>
+                        <a:t>High (true Med)</a:t>
                       </a:r>
                       <a:endParaRPr lang="en-US" sz="1200" dirty="0">
                         <a:latin typeface="Calibri" charset="0"/>
@@ -7975,7 +8761,7 @@
                           <a:ea typeface="Calibri" pitchFamily="34" charset="-122"/>
                           <a:cs typeface="Calibri" pitchFamily="34" charset="-120"/>
                         </a:rPr>
-                        <a:t>MANUAL_REVIEW</a:t>
+                        <a:t>REJECTED (true STP)</a:t>
                       </a:r>
                       <a:endParaRPr lang="en-US" sz="1200" dirty="0">
                         <a:latin typeface="Calibri" charset="0"/>
@@ -8040,7 +8826,7 @@
                           <a:ea typeface="Calibri" pitchFamily="34" charset="-122"/>
                           <a:cs typeface="Calibri" pitchFamily="34" charset="-120"/>
                         </a:rPr>
-                        <a:t>996 min (true 1140)</a:t>
+                        <a:t>878 min (true 1140)</a:t>
                       </a:r>
                       <a:endParaRPr lang="en-US" sz="1200" dirty="0">
                         <a:latin typeface="Calibri" charset="0"/>
@@ -8105,7 +8891,7 @@
                           <a:ea typeface="Calibri" pitchFamily="34" charset="-122"/>
                           <a:cs typeface="Calibri" pitchFamily="34" charset="-120"/>
                         </a:rPr>
-                        <a:t>no_cover 1.00</a:t>
+                        <a:t>sanctions_hit 0.05</a:t>
                       </a:r>
                       <a:endParaRPr lang="en-US" sz="1200" dirty="0">
                         <a:latin typeface="Calibri" charset="0"/>
@@ -8172,7 +8958,7 @@
                           <a:ea typeface="Calibri" pitchFamily="34" charset="-122"/>
                           <a:cs typeface="Calibri" pitchFamily="34" charset="-120"/>
                         </a:rPr>
-                        <a:t>7,796 INR</a:t>
+                        <a:t>7,410 INR</a:t>
                       </a:r>
                       <a:endParaRPr lang="en-US" sz="1200" dirty="0">
                         <a:latin typeface="Calibri" charset="0"/>
@@ -8367,7 +9153,7 @@
                           <a:ea typeface="Calibri" pitchFamily="34" charset="-122"/>
                           <a:cs typeface="Calibri" pitchFamily="34" charset="-120"/>
                         </a:rPr>
-                        <a:t>IMPS (0.60)</a:t>
+                        <a:t>NEFT (0.63)</a:t>
                       </a:r>
                       <a:endParaRPr lang="en-US" sz="1200" dirty="0">
                         <a:latin typeface="Calibri" charset="0"/>
@@ -8491,7 +9277,7 @@
                       <a:r>
                         <a:rPr lang="en-US" sz="1200" dirty="0">
                           <a:solidFill>
-                            <a:srgbClr val="1A1A2E"/>
+                            <a:srgbClr val="2E7D32"/>
                           </a:solidFill>
                           <a:latin typeface="Calibri" pitchFamily="34" charset="0"/>
                           <a:ea typeface="Calibri" pitchFamily="34" charset="-122"/>
@@ -8562,7 +9348,7 @@
                           <a:ea typeface="Calibri" pitchFamily="34" charset="-122"/>
                           <a:cs typeface="Calibri" pitchFamily="34" charset="-120"/>
                         </a:rPr>
-                        <a:t>28 min</a:t>
+                        <a:t>236 min</a:t>
                       </a:r>
                       <a:endParaRPr lang="en-US" sz="1200" dirty="0">
                         <a:latin typeface="Calibri" charset="0"/>
@@ -8627,7 +9413,7 @@
                           <a:ea typeface="Calibri" pitchFamily="34" charset="-122"/>
                           <a:cs typeface="Calibri" pitchFamily="34" charset="-120"/>
                         </a:rPr>
-                        <a:t>below_min 0.63</a:t>
+                        <a:t>below_min 0.06</a:t>
                       </a:r>
                       <a:endParaRPr lang="en-US" sz="1200" dirty="0">
                         <a:latin typeface="Calibri" charset="0"/>
@@ -8883,13 +9669,13 @@
                       <a:r>
                         <a:rPr lang="en-US" sz="1200" dirty="0">
                           <a:solidFill>
-                            <a:srgbClr val="C98A00"/>
+                            <a:srgbClr val="2E7D32"/>
                           </a:solidFill>
                           <a:latin typeface="Calibri" pitchFamily="34" charset="0"/>
                           <a:ea typeface="Calibri" pitchFamily="34" charset="-122"/>
                           <a:cs typeface="Calibri" pitchFamily="34" charset="-120"/>
                         </a:rPr>
-                        <a:t>NEFT (0.67)</a:t>
+                        <a:t>IMPS (0.57)</a:t>
                       </a:r>
                       <a:endParaRPr lang="en-US" sz="1200" dirty="0">
                         <a:latin typeface="Calibri" charset="0"/>
@@ -9013,13 +9799,13 @@
                       <a:r>
                         <a:rPr lang="en-US" sz="1200" dirty="0">
                           <a:solidFill>
-                            <a:srgbClr val="1A1A2E"/>
+                            <a:srgbClr val="2E7D32"/>
                           </a:solidFill>
                           <a:latin typeface="Calibri" pitchFamily="34" charset="0"/>
                           <a:ea typeface="Calibri" pitchFamily="34" charset="-122"/>
                           <a:cs typeface="Calibri" pitchFamily="34" charset="-120"/>
                         </a:rPr>
-                        <a:t>MANUAL_REVIEW</a:t>
+                        <a:t>STP ✓</a:t>
                       </a:r>
                       <a:endParaRPr lang="en-US" sz="1200" dirty="0">
                         <a:latin typeface="Calibri" charset="0"/>
@@ -9084,7 +9870,7 @@
                           <a:ea typeface="Calibri" pitchFamily="34" charset="-122"/>
                           <a:cs typeface="Calibri" pitchFamily="34" charset="-120"/>
                         </a:rPr>
-                        <a:t>819 min</a:t>
+                        <a:t>826 min</a:t>
                       </a:r>
                       <a:endParaRPr lang="en-US" sz="1200" dirty="0">
                         <a:latin typeface="Calibri" charset="0"/>
@@ -9149,7 +9935,7 @@
                           <a:ea typeface="Calibri" pitchFamily="34" charset="-122"/>
                           <a:cs typeface="Calibri" pitchFamily="34" charset="-120"/>
                         </a:rPr>
-                        <a:t>sla_breach 0.83</a:t>
+                        <a:t>format_error 0.04</a:t>
                       </a:r>
                       <a:endParaRPr lang="en-US" sz="1200" dirty="0">
                         <a:latin typeface="Calibri" charset="0"/>
@@ -9235,7 +10021,7 @@
                 <a:ea typeface="Calibri" pitchFamily="34" charset="-122"/>
                 <a:cs typeface="Calibri" pitchFamily="34" charset="-120"/>
               </a:rPr>
-              <a:t>Green = predicted rail matches truth; ✓ = predicted outcome matched too. Ambers are honest: the 7,796 'RTGS *' arrived mis-routed (below the ₹2L floor) — the model re-routes it AND correctly predicts the reject; 13,137 is genuine IMPS/NEFT overlap (both eligible).</a:t>
+              <a:t>Green = matches truth; ✓ = predicted outcome matched too. The ₹7,410 'RTGS *' arrived mis-routed (below the ₹2L floor) — the model re-routes it to NEFT AND correctly predicts the reject. The SWIFT row's status/risk misses are shown as-is, not cherry-picked.</a:t>
             </a:r>
             <a:endParaRPr lang="en-US" sz="1200" dirty="0"/>
           </a:p>
@@ -9266,7 +10052,7 @@
               <a:buNone/>
             </a:pPr>
             <a:r>
-              <a:rPr lang="en-US" sz="1250" b="1" dirty="0">
+              <a:rPr lang="en-US" sz="1200" b="1" dirty="0">
                 <a:solidFill>
                   <a:srgbClr val="1E2761"/>
                 </a:solidFill>
@@ -9274,9 +10060,9 @@
                 <a:ea typeface="Calibri" pitchFamily="34" charset="-122"/>
                 <a:cs typeface="Calibri" pitchFamily="34" charset="-120"/>
               </a:rPr>
-              <a:t>This fresh 100 (known accounts, new payments):  rail 0.59 — 0.64 on cleanly-routed  ·  risk 0.53  ·  status 0.31.  Stable eval (n=4,000): rail 0.55 vs tree 0.64  ·  ETA 199 vs 392 naive.</a:t>
+              <a:t>This fresh 100 (known accounts, new payments):  rail 0.60 — 0.65 on cleanly-routed  ·  risk 0.58  ·  status 0.18 (small-n; stable n=4,000: 0.28).  Stable eval: rail 0.56 vs tree 0.65  ·  ETA 195 vs 392 naive.</a:t>
             </a:r>
-            <a:endParaRPr lang="en-US" sz="1250" dirty="0"/>
+            <a:endParaRPr lang="en-US" sz="1200" dirty="0"/>
           </a:p>
         </p:txBody>
       </p:sp>
@@ -9423,7 +10209,7 @@
                 <a:ea typeface="Calibri" pitchFamily="34" charset="-122"/>
                 <a:cs typeface="Calibri" pitchFamily="34" charset="-120"/>
               </a:rPr>
-              <a:t>183 automated tests green · reproducible · independently code-reviewed</a:t>
+              <a:t>197 automated tests green · reproducible · full-scale claims measured on an H200 GPU · independently code-reviewed</a:t>
             </a:r>
             <a:endParaRPr lang="en-US" sz="1500" dirty="0"/>
           </a:p>
@@ -9501,7 +10287,7 @@
                 <a:ea typeface="Calibri" pitchFamily="34" charset="-122"/>
                 <a:cs typeface="Calibri" pitchFamily="34" charset="-120"/>
               </a:rPr>
-              <a:t>ETA &amp; charges from the payment itself · in-flight calls from partial (pain.001) data · timing/sequence signals</a:t>
+              <a:t>ETA &amp; charges from the payment itself · in-flight calls from partial (pain.001) data · timing/sequence signals (+60pp) · multi-source fusion (ATO 0.03 → 1.00)</a:t>
             </a:r>
             <a:endParaRPr lang="en-US" sz="1500" dirty="0"/>
           </a:p>
@@ -12458,7 +13244,7 @@
                 <a:ea typeface="Calibri" pitchFamily="34" charset="-122"/>
                 <a:cs typeface="Calibri" pitchFamily="34" charset="-120"/>
               </a:rPr>
-              <a:t>Measured (held-out): ETA error 184 min vs a 232-min naive baseline — available at initiation (pain.001), before clearing.</a:t>
+              <a:t>Measured (held-out): ETA error 172 min vs a 234-min naive at initiation (pain.001, before clearing) · 195 vs 392 at full intake (n=4,000).</a:t>
             </a:r>
             <a:endParaRPr lang="en-US" sz="1200" dirty="0"/>
           </a:p>
@@ -13959,7 +14745,7 @@
                 <a:ea typeface="Calibri" pitchFamily="34" charset="-122"/>
                 <a:cs typeface="Calibri" pitchFamily="34" charset="-120"/>
               </a:rPr>
-              <a:t>Measured: 'will it credit?' sharpens 0.84 → 0.87 as messages arrive (pain.001 → pacs.008) — plus recall (camt.056) &amp; return (pacs.004) legs modeled end-to-end.</a:t>
+              <a:t>Measured (full run): 'will it credit?' sharpens 0.86 → 0.94 as messages arrive (pain.001 → pacs.008) — plus recall (camt.056) &amp; return (pacs.004) legs modeled end-to-end.</a:t>
             </a:r>
             <a:endParaRPr lang="en-US" sz="1200" dirty="0"/>
           </a:p>
@@ -14922,7 +15708,7 @@
                 <a:ea typeface="Calibri" pitchFamily="34" charset="-122"/>
                 <a:cs typeface="Calibri" pitchFamily="34" charset="-120"/>
               </a:rPr>
-              <a:t>recall / return risk</a:t>
+              <a:t>next-payment forecast</a:t>
             </a:r>
             <a:endParaRPr lang="en-US" sz="1250" dirty="0"/>
           </a:p>
@@ -14936,8 +15722,8 @@
         </p:nvSpPr>
         <p:spPr>
           <a:xfrm>
-            <a:off x="822960" y="5349240"/>
-            <a:ext cx="10515600" cy="640080"/>
+            <a:off x="822960" y="5303520"/>
+            <a:ext cx="10515600" cy="502920"/>
           </a:xfrm>
           <a:prstGeom prst="rect">
             <a:avLst/>
@@ -14978,6 +15764,59 @@
               <a:t>of a full model's parameters add a new task — proven param-efficiency (C1), so adding capabilities is cheap and fast.</a:t>
             </a:r>
             <a:endParaRPr lang="en-US" sz="1500" dirty="0"/>
+          </a:p>
+        </p:txBody>
+      </p:sp>
+      <p:sp>
+        <p:nvSpPr>
+          <p:cNvPr id="31" name="Text 29"/>
+          <p:cNvSpPr/>
+          <p:nvPr/>
+        </p:nvSpPr>
+        <p:spPr>
+          <a:xfrm>
+            <a:off x="822960" y="5852160"/>
+            <a:ext cx="10515600" cy="548640"/>
+          </a:xfrm>
+          <a:prstGeom prst="rect">
+            <a:avLst/>
+          </a:prstGeom>
+          <a:noFill/>
+          <a:ln/>
+        </p:spPr>
+        <p:txBody>
+          <a:bodyPr wrap="square" rtlCol="0" anchor="ctr"/>
+          <a:lstStyle/>
+          <a:p>
+            <a:pPr indent="0" marL="0">
+              <a:buNone/>
+            </a:pPr>
+            <a:r>
+              <a:rPr lang="en-US" sz="1350" b="1" dirty="0">
+                <a:solidFill>
+                  <a:srgbClr val="1E2761"/>
+                </a:solidFill>
+                <a:latin typeface="Calibri" pitchFamily="34" charset="0"/>
+                <a:ea typeface="Calibri" pitchFamily="34" charset="-122"/>
+                <a:cs typeface="Calibri" pitchFamily="34" charset="-120"/>
+              </a:rPr>
+              <a:t>And the LLM? </a:t>
+            </a:r>
+            <a:pPr indent="0" marL="0">
+              <a:buNone/>
+            </a:pPr>
+            <a:r>
+              <a:rPr lang="en-US" sz="1350" dirty="0">
+                <a:solidFill>
+                  <a:srgbClr val="1A1A2E"/>
+                </a:solidFill>
+                <a:latin typeface="Calibri" pitchFamily="34" charset="0"/>
+                <a:ea typeface="Calibri" pitchFamily="34" charset="-122"/>
+                <a:cs typeface="Calibri" pitchFamily="34" charset="-120"/>
+              </a:rPr>
+              <a:t>Measured with real Phi-1.5 (C5, H200): the LLM path adds only +1.3pp for 7.6M adapter params + LLM inference — dropped from serving. The frozen encoder + linear heads carry the tasks.</a:t>
+            </a:r>
+            <a:endParaRPr lang="en-US" sz="1350" dirty="0"/>
           </a:p>
         </p:txBody>
       </p:sp>
@@ -15046,7 +15885,7 @@
                 <a:ea typeface="Cambria" pitchFamily="34" charset="-122"/>
                 <a:cs typeface="Cambria" pitchFamily="34" charset="-120"/>
               </a:rPr>
-              <a:t>Status today — trained &amp; serving on commodity CPU</a:t>
+              <a:t>Status today — trained on CPU, claims verified on GPU</a:t>
             </a:r>
             <a:endParaRPr lang="en-US" sz="3000" dirty="0"/>
           </a:p>
@@ -15085,7 +15924,7 @@
                 <a:ea typeface="Calibri" pitchFamily="34" charset="-122"/>
                 <a:cs typeface="Calibri" pitchFamily="34" charset="-120"/>
               </a:rPr>
-              <a:t>End-to-end on synthetic data; no GPU required at this scale.</a:t>
+              <a:t>End-to-end on synthetic data; full-scale claim runs reproduced on an H200.</a:t>
             </a:r>
             <a:endParaRPr lang="en-US" sz="1400" dirty="0"/>
           </a:p>
@@ -15190,7 +16029,7 @@
                 <a:ea typeface="Calibri" pitchFamily="34" charset="-122"/>
                 <a:cs typeface="Calibri" pitchFamily="34" charset="-120"/>
               </a:rPr>
-              <a:t>payments trained (CPU)</a:t>
+              <a:t>payments trained</a:t>
             </a:r>
             <a:endParaRPr lang="en-US" sz="1300" dirty="0"/>
           </a:p>
@@ -15439,7 +16278,7 @@
                 <a:ea typeface="Calibri" pitchFamily="34" charset="-122"/>
                 <a:cs typeface="Calibri" pitchFamily="34" charset="-120"/>
               </a:rPr>
-              <a:t>Held-out n=4,000: rail 0.55 probe vs 0.64 tree (4-class, harder without UPI)  ·  ETA 199 min vs 392 naive  ·  status 0.26 (weak — tree territory, reported openly)</a:t>
+              <a:t>Held-out n=4,000: rail 0.56 probe vs 0.65 tree (4-class, harder without UPI)  ·  ETA 195 min vs 392 naive  ·  status 0.28 (weak — tree territory, reported openly)</a:t>
             </a:r>
             <a:endParaRPr lang="en-US" sz="1300" dirty="0"/>
           </a:p>
@@ -15478,7 +16317,7 @@
                 <a:ea typeface="Calibri" pitchFamily="34" charset="-122"/>
                 <a:cs typeface="Calibri" pitchFamily="34" charset="-120"/>
               </a:rPr>
-              <a:t>At initiation (pain.001, before clearing): ETA 186 vs 232 naive  ·  charges MAE 97 vs 185  ·  'will it credit' 0.84 → 0.87 as messages arrive.</a:t>
+              <a:t>At initiation (pain.001, before clearing): ETA 172 vs 234 naive  ·  charges MAE 117 vs 203  ·  'will it credit' 0.86 → 0.94 as messages arrive.</a:t>
             </a:r>
             <a:endParaRPr lang="en-US" sz="1300" dirty="0"/>
           </a:p>
@@ -15715,7 +16554,7 @@
                 <a:ea typeface="Calibri" pitchFamily="34" charset="-122"/>
                 <a:cs typeface="Calibri" pitchFamily="34" charset="-120"/>
               </a:rPr>
-              <a:t>Maturity: a working prototype on synthetic data and commodity hardware. Cold-start caveat: brand-new accounts degrade accuracy (identity features matter) — a known focus for the real-data phase. Next: real transaction data, scale, AML / network-graph.</a:t>
+              <a:t>Maturity: a working prototype on synthetic data. Cold-start caveat: brand-new accounts degrade accuracy (identity features matter) — a known focus for the real-data phase. Next: real transaction data, scale, AML / network-graph.</a:t>
             </a:r>
             <a:endParaRPr lang="en-US" sz="1250" dirty="0"/>
           </a:p>

</xml_diff>

<commit_message>
Propagate PULSE branding to the deck title/close and the README
Co-Authored-By: Claude Fable 5 <noreply@anthropic.com>
</commit_message>
<xml_diff>
--- a/docs/txn_repr_evidence.pptx
+++ b/docs/txn_repr_evidence.pptx
@@ -1862,8 +1862,8 @@
         </p:nvSpPr>
         <p:spPr>
           <a:xfrm>
-            <a:off x="731520" y="2011680"/>
-            <a:ext cx="10698480" cy="822960"/>
+            <a:off x="731520" y="1554480"/>
+            <a:ext cx="10698480" cy="914400"/>
           </a:xfrm>
           <a:prstGeom prst="rect">
             <a:avLst/>
@@ -1879,7 +1879,7 @@
               <a:buNone/>
             </a:pPr>
             <a:r>
-              <a:rPr lang="en-US" sz="4400" b="1" dirty="0">
+              <a:rPr lang="en-US" sz="6000" b="1" dirty="0">
                 <a:solidFill>
                   <a:srgbClr val="FFFFFF"/>
                 </a:solidFill>
@@ -1887,9 +1887,9 @@
                 <a:ea typeface="Cambria" pitchFamily="34" charset="-122"/>
                 <a:cs typeface="Cambria" pitchFamily="34" charset="-120"/>
               </a:rPr>
-              <a:t>Payment Intelligence on One Model</a:t>
+              <a:t>PULSE</a:t>
             </a:r>
-            <a:endParaRPr lang="en-US" sz="4400" dirty="0"/>
+            <a:endParaRPr lang="en-US" sz="6000" dirty="0"/>
           </a:p>
         </p:txBody>
       </p:sp>
@@ -1901,7 +1901,46 @@
         </p:nvSpPr>
         <p:spPr>
           <a:xfrm>
-            <a:off x="768096" y="2971800"/>
+            <a:off x="768096" y="2606040"/>
+            <a:ext cx="10424160" cy="502920"/>
+          </a:xfrm>
+          <a:prstGeom prst="rect">
+            <a:avLst/>
+          </a:prstGeom>
+          <a:noFill/>
+          <a:ln/>
+        </p:spPr>
+        <p:txBody>
+          <a:bodyPr wrap="square" rtlCol="0" anchor="ctr"/>
+          <a:lstStyle/>
+          <a:p>
+            <a:pPr indent="0" marL="0">
+              <a:buNone/>
+            </a:pPr>
+            <a:r>
+              <a:rPr lang="en-US" sz="2200" b="1" dirty="0">
+                <a:solidFill>
+                  <a:srgbClr val="CADCFC"/>
+                </a:solidFill>
+                <a:latin typeface="Cambria" pitchFamily="34" charset="0"/>
+                <a:ea typeface="Cambria" pitchFamily="34" charset="-122"/>
+                <a:cs typeface="Cambria" pitchFamily="34" charset="-120"/>
+              </a:rPr>
+              <a:t>Payment Understanding, Lifecycle Scoring &amp; Embeddings</a:t>
+            </a:r>
+            <a:endParaRPr lang="en-US" sz="2200" dirty="0"/>
+          </a:p>
+        </p:txBody>
+      </p:sp>
+      <p:sp>
+        <p:nvSpPr>
+          <p:cNvPr id="4" name="Text 2"/>
+          <p:cNvSpPr/>
+          <p:nvPr/>
+        </p:nvSpPr>
+        <p:spPr>
+          <a:xfrm>
+            <a:off x="768096" y="3200400"/>
             <a:ext cx="10424160" cy="548640"/>
           </a:xfrm>
           <a:prstGeom prst="rect">
@@ -1934,7 +1973,7 @@
       </p:sp>
       <p:sp>
         <p:nvSpPr>
-          <p:cNvPr id="4" name="Shape 2"/>
+          <p:cNvPr id="5" name="Shape 3"/>
           <p:cNvSpPr/>
           <p:nvPr/>
         </p:nvSpPr>
@@ -1961,7 +2000,7 @@
       </p:sp>
       <p:sp>
         <p:nvSpPr>
-          <p:cNvPr id="5" name="Text 3"/>
+          <p:cNvPr id="6" name="Text 4"/>
           <p:cNvSpPr/>
           <p:nvPr/>
         </p:nvSpPr>
@@ -2000,7 +2039,7 @@
       </p:sp>
       <p:sp>
         <p:nvSpPr>
-          <p:cNvPr id="6" name="Shape 4"/>
+          <p:cNvPr id="7" name="Shape 5"/>
           <p:cNvSpPr/>
           <p:nvPr/>
         </p:nvSpPr>
@@ -2027,7 +2066,7 @@
       </p:sp>
       <p:sp>
         <p:nvSpPr>
-          <p:cNvPr id="7" name="Text 5"/>
+          <p:cNvPr id="8" name="Text 6"/>
           <p:cNvSpPr/>
           <p:nvPr/>
         </p:nvSpPr>
@@ -2066,7 +2105,7 @@
       </p:sp>
       <p:sp>
         <p:nvSpPr>
-          <p:cNvPr id="8" name="Shape 6"/>
+          <p:cNvPr id="9" name="Shape 7"/>
           <p:cNvSpPr/>
           <p:nvPr/>
         </p:nvSpPr>
@@ -2093,7 +2132,7 @@
       </p:sp>
       <p:sp>
         <p:nvSpPr>
-          <p:cNvPr id="9" name="Text 7"/>
+          <p:cNvPr id="10" name="Text 8"/>
           <p:cNvSpPr/>
           <p:nvPr/>
         </p:nvSpPr>
@@ -2132,7 +2171,7 @@
       </p:sp>
       <p:sp>
         <p:nvSpPr>
-          <p:cNvPr id="10" name="Shape 8"/>
+          <p:cNvPr id="11" name="Shape 9"/>
           <p:cNvSpPr/>
           <p:nvPr/>
         </p:nvSpPr>
@@ -2159,7 +2198,7 @@
       </p:sp>
       <p:sp>
         <p:nvSpPr>
-          <p:cNvPr id="11" name="Text 9"/>
+          <p:cNvPr id="12" name="Text 10"/>
           <p:cNvSpPr/>
           <p:nvPr/>
         </p:nvSpPr>
@@ -2198,7 +2237,7 @@
       </p:sp>
       <p:sp>
         <p:nvSpPr>
-          <p:cNvPr id="12" name="Shape 10"/>
+          <p:cNvPr id="13" name="Shape 11"/>
           <p:cNvSpPr/>
           <p:nvPr/>
         </p:nvSpPr>
@@ -2225,7 +2264,7 @@
       </p:sp>
       <p:sp>
         <p:nvSpPr>
-          <p:cNvPr id="13" name="Text 11"/>
+          <p:cNvPr id="14" name="Text 12"/>
           <p:cNvSpPr/>
           <p:nvPr/>
         </p:nvSpPr>
@@ -2264,7 +2303,7 @@
       </p:sp>
       <p:sp>
         <p:nvSpPr>
-          <p:cNvPr id="14" name="Text 12"/>
+          <p:cNvPr id="15" name="Text 13"/>
           <p:cNvSpPr/>
           <p:nvPr/>
         </p:nvSpPr>
@@ -10482,7 +10521,7 @@
                 <a:ea typeface="Calibri" pitchFamily="34" charset="-122"/>
                 <a:cs typeface="Calibri" pitchFamily="34" charset="-120"/>
               </a:rPr>
-              <a:t>One model, many payment decisions — efficient, faithful to the research, honestly measured.</a:t>
+              <a:t>PULSE — one model, many payment decisions: efficient, faithful to the research, honestly measured.</a:t>
             </a:r>
             <a:endParaRPr lang="en-US" sz="1600" dirty="0"/>
           </a:p>

</xml_diff>

<commit_message>
Annexures: eleven live API round-trips appended to the paper and the deck
capture_annex.py fires all six endpoints with distinct scenarios - small
domestic, high-value, cross-border, mis-routed below-floor, cold-start,
occlusion explain, healthy vs recalled-and-returned lifecycle, burst vs quiet
velocity, salaried vs irregular forecast, and the day's liquidity book - and
saves the pairs to docs/annex_capture.json. The paper gains Annexure A
(pages 6-10, misses shown as-is); the deck gains three annexure slides.

Co-Authored-By: Claude Fable 5 <noreply@anthropic.com>
</commit_message>
<xml_diff>
--- a/docs/txn_repr_evidence.pptx
+++ b/docs/txn_repr_evidence.pptx
@@ -17,9 +17,12 @@
     <p:sldId id="265" r:id="rId11"/>
     <p:sldId id="266" r:id="rId12"/>
     <p:sldId id="267" r:id="rId13"/>
+    <p:sldId id="268" r:id="rId14"/>
+    <p:sldId id="269" r:id="rId15"/>
+    <p:sldId id="270" r:id="rId16"/>
   </p:sldIdLst>
   <p:notesMasterIdLst>
-    <p:notesMasterId r:id="rId14"/>
+    <p:notesMasterId r:id="rId17"/>
   </p:notesMasterIdLst>
   <p:sldSz cx="12188952" cy="6858000"/>
   <p:notesSz cx="6858000" cy="12188952"/>
@@ -801,6 +804,270 @@
             <a:fld id="{F7021451-1387-4CA6-816F-3879F97B5CBC}" type="slidenum">
               <a:rPr lang="en-US"/>
               <a:t>12</a:t>
+            </a:fld>
+            <a:endParaRPr lang="en-US"/>
+          </a:p>
+        </p:txBody>
+      </p:sp>
+    </p:spTree>
+    <p:extLst>
+      <p:ext uri="{BB962C8B-B14F-4D97-AF65-F5344CB8AC3E}">
+        <p14:creationId xmlns:p14="http://schemas.microsoft.com/office/powerpoint/2010/main" val="1024086991"/>
+      </p:ext>
+    </p:extLst>
+  </p:cSld>
+  <p:clrMapOvr>
+    <a:masterClrMapping/>
+  </p:clrMapOvr>
+</p:notes>
+</file>
+
+<file path=ppt/notesSlides/notesSlide13.xml><?xml version="1.0" encoding="utf-8"?>
+<p:notes xmlns:a="http://schemas.openxmlformats.org/drawingml/2006/main" xmlns:r="http://schemas.openxmlformats.org/officeDocument/2006/relationships" xmlns:p="http://schemas.openxmlformats.org/presentationml/2006/main">
+  <p:cSld>
+    <p:spTree>
+      <p:nvGrpSpPr>
+        <p:cNvPr id="1" name=""/>
+        <p:cNvGrpSpPr/>
+        <p:nvPr/>
+      </p:nvGrpSpPr>
+      <p:grpSpPr>
+        <a:xfrm>
+          <a:off x="0" y="0"/>
+          <a:ext cx="0" cy="0"/>
+          <a:chOff x="0" y="0"/>
+          <a:chExt cx="0" cy="0"/>
+        </a:xfrm>
+      </p:grpSpPr>
+      <p:sp>
+        <p:nvSpPr>
+          <p:cNvPr id="2" name="Slide Image Placeholder 1"/>
+          <p:cNvSpPr>
+            <a:spLocks noGrp="1" noRot="1" noChangeAspect="1"/>
+          </p:cNvSpPr>
+          <p:nvPr>
+            <p:ph type="sldImg"/>
+          </p:nvPr>
+        </p:nvSpPr>
+        <p:spPr/>
+      </p:sp>
+      <p:sp>
+        <p:nvSpPr>
+          <p:cNvPr id="3" name="Notes Placeholder 2"/>
+          <p:cNvSpPr>
+            <a:spLocks noGrp="1"/>
+          </p:cNvSpPr>
+          <p:nvPr>
+            <p:ph type="body" idx="1"/>
+          </p:nvPr>
+        </p:nvSpPr>
+        <p:spPr/>
+        <p:txBody>
+          <a:bodyPr/>
+          <a:lstStyle/>
+          <a:p>
+            <a:r>
+              <a:rPr lang="en-US" dirty="0"/>
+              <a:t/>
+            </a:r>
+            <a:endParaRPr lang="en-US" dirty="0"/>
+          </a:p>
+        </p:txBody>
+      </p:sp>
+      <p:sp>
+        <p:nvSpPr>
+          <p:cNvPr id="4" name="Slide Number Placeholder 3"/>
+          <p:cNvSpPr>
+            <a:spLocks noGrp="1"/>
+          </p:cNvSpPr>
+          <p:nvPr>
+            <p:ph type="sldNum" sz="quarter" idx="10"/>
+          </p:nvPr>
+        </p:nvSpPr>
+        <p:spPr/>
+        <p:txBody>
+          <a:bodyPr/>
+          <a:lstStyle/>
+          <a:p>
+            <a:fld id="{F7021451-1387-4CA6-816F-3879F97B5CBC}" type="slidenum">
+              <a:rPr lang="en-US"/>
+              <a:t>13</a:t>
+            </a:fld>
+            <a:endParaRPr lang="en-US"/>
+          </a:p>
+        </p:txBody>
+      </p:sp>
+    </p:spTree>
+    <p:extLst>
+      <p:ext uri="{BB962C8B-B14F-4D97-AF65-F5344CB8AC3E}">
+        <p14:creationId xmlns:p14="http://schemas.microsoft.com/office/powerpoint/2010/main" val="1024086991"/>
+      </p:ext>
+    </p:extLst>
+  </p:cSld>
+  <p:clrMapOvr>
+    <a:masterClrMapping/>
+  </p:clrMapOvr>
+</p:notes>
+</file>
+
+<file path=ppt/notesSlides/notesSlide14.xml><?xml version="1.0" encoding="utf-8"?>
+<p:notes xmlns:a="http://schemas.openxmlformats.org/drawingml/2006/main" xmlns:r="http://schemas.openxmlformats.org/officeDocument/2006/relationships" xmlns:p="http://schemas.openxmlformats.org/presentationml/2006/main">
+  <p:cSld>
+    <p:spTree>
+      <p:nvGrpSpPr>
+        <p:cNvPr id="1" name=""/>
+        <p:cNvGrpSpPr/>
+        <p:nvPr/>
+      </p:nvGrpSpPr>
+      <p:grpSpPr>
+        <a:xfrm>
+          <a:off x="0" y="0"/>
+          <a:ext cx="0" cy="0"/>
+          <a:chOff x="0" y="0"/>
+          <a:chExt cx="0" cy="0"/>
+        </a:xfrm>
+      </p:grpSpPr>
+      <p:sp>
+        <p:nvSpPr>
+          <p:cNvPr id="2" name="Slide Image Placeholder 1"/>
+          <p:cNvSpPr>
+            <a:spLocks noGrp="1" noRot="1" noChangeAspect="1"/>
+          </p:cNvSpPr>
+          <p:nvPr>
+            <p:ph type="sldImg"/>
+          </p:nvPr>
+        </p:nvSpPr>
+        <p:spPr/>
+      </p:sp>
+      <p:sp>
+        <p:nvSpPr>
+          <p:cNvPr id="3" name="Notes Placeholder 2"/>
+          <p:cNvSpPr>
+            <a:spLocks noGrp="1"/>
+          </p:cNvSpPr>
+          <p:nvPr>
+            <p:ph type="body" idx="1"/>
+          </p:nvPr>
+        </p:nvSpPr>
+        <p:spPr/>
+        <p:txBody>
+          <a:bodyPr/>
+          <a:lstStyle/>
+          <a:p>
+            <a:r>
+              <a:rPr lang="en-US" dirty="0"/>
+              <a:t/>
+            </a:r>
+            <a:endParaRPr lang="en-US" dirty="0"/>
+          </a:p>
+        </p:txBody>
+      </p:sp>
+      <p:sp>
+        <p:nvSpPr>
+          <p:cNvPr id="4" name="Slide Number Placeholder 3"/>
+          <p:cNvSpPr>
+            <a:spLocks noGrp="1"/>
+          </p:cNvSpPr>
+          <p:nvPr>
+            <p:ph type="sldNum" sz="quarter" idx="10"/>
+          </p:nvPr>
+        </p:nvSpPr>
+        <p:spPr/>
+        <p:txBody>
+          <a:bodyPr/>
+          <a:lstStyle/>
+          <a:p>
+            <a:fld id="{F7021451-1387-4CA6-816F-3879F97B5CBC}" type="slidenum">
+              <a:rPr lang="en-US"/>
+              <a:t>14</a:t>
+            </a:fld>
+            <a:endParaRPr lang="en-US"/>
+          </a:p>
+        </p:txBody>
+      </p:sp>
+    </p:spTree>
+    <p:extLst>
+      <p:ext uri="{BB962C8B-B14F-4D97-AF65-F5344CB8AC3E}">
+        <p14:creationId xmlns:p14="http://schemas.microsoft.com/office/powerpoint/2010/main" val="1024086991"/>
+      </p:ext>
+    </p:extLst>
+  </p:cSld>
+  <p:clrMapOvr>
+    <a:masterClrMapping/>
+  </p:clrMapOvr>
+</p:notes>
+</file>
+
+<file path=ppt/notesSlides/notesSlide15.xml><?xml version="1.0" encoding="utf-8"?>
+<p:notes xmlns:a="http://schemas.openxmlformats.org/drawingml/2006/main" xmlns:r="http://schemas.openxmlformats.org/officeDocument/2006/relationships" xmlns:p="http://schemas.openxmlformats.org/presentationml/2006/main">
+  <p:cSld>
+    <p:spTree>
+      <p:nvGrpSpPr>
+        <p:cNvPr id="1" name=""/>
+        <p:cNvGrpSpPr/>
+        <p:nvPr/>
+      </p:nvGrpSpPr>
+      <p:grpSpPr>
+        <a:xfrm>
+          <a:off x="0" y="0"/>
+          <a:ext cx="0" cy="0"/>
+          <a:chOff x="0" y="0"/>
+          <a:chExt cx="0" cy="0"/>
+        </a:xfrm>
+      </p:grpSpPr>
+      <p:sp>
+        <p:nvSpPr>
+          <p:cNvPr id="2" name="Slide Image Placeholder 1"/>
+          <p:cNvSpPr>
+            <a:spLocks noGrp="1" noRot="1" noChangeAspect="1"/>
+          </p:cNvSpPr>
+          <p:nvPr>
+            <p:ph type="sldImg"/>
+          </p:nvPr>
+        </p:nvSpPr>
+        <p:spPr/>
+      </p:sp>
+      <p:sp>
+        <p:nvSpPr>
+          <p:cNvPr id="3" name="Notes Placeholder 2"/>
+          <p:cNvSpPr>
+            <a:spLocks noGrp="1"/>
+          </p:cNvSpPr>
+          <p:nvPr>
+            <p:ph type="body" idx="1"/>
+          </p:nvPr>
+        </p:nvSpPr>
+        <p:spPr/>
+        <p:txBody>
+          <a:bodyPr/>
+          <a:lstStyle/>
+          <a:p>
+            <a:r>
+              <a:rPr lang="en-US" dirty="0"/>
+              <a:t/>
+            </a:r>
+            <a:endParaRPr lang="en-US" dirty="0"/>
+          </a:p>
+        </p:txBody>
+      </p:sp>
+      <p:sp>
+        <p:nvSpPr>
+          <p:cNvPr id="4" name="Slide Number Placeholder 3"/>
+          <p:cNvSpPr>
+            <a:spLocks noGrp="1"/>
+          </p:cNvSpPr>
+          <p:nvPr>
+            <p:ph type="sldNum" sz="quarter" idx="10"/>
+          </p:nvPr>
+        </p:nvSpPr>
+        <p:spPr/>
+        <p:txBody>
+          <a:bodyPr/>
+          <a:lstStyle/>
+          <a:p>
+            <a:fld id="{F7021451-1387-4CA6-816F-3879F97B5CBC}" type="slidenum">
+              <a:rPr lang="en-US"/>
+              <a:t>15</a:t>
             </a:fld>
             <a:endParaRPr lang="en-US"/>
           </a:p>
@@ -10535,6 +10802,2918 @@
 </p:sld>
 </file>
 
+<file path=ppt/slides/slide13.xml><?xml version="1.0" encoding="utf-8"?>
+<p:sld xmlns:a="http://schemas.openxmlformats.org/drawingml/2006/main" xmlns:r="http://schemas.openxmlformats.org/officeDocument/2006/relationships" xmlns:p="http://schemas.openxmlformats.org/presentationml/2006/main">
+  <p:cSld name="Slide 13">
+    <p:bg>
+      <p:bgPr>
+        <a:solidFill>
+          <a:srgbClr val="FFFFFF"/>
+        </a:solidFill>
+      </p:bgPr>
+    </p:bg>
+    <p:spTree>
+      <p:nvGrpSpPr>
+        <p:cNvPr id="1" name=""/>
+        <p:cNvGrpSpPr/>
+        <p:nvPr/>
+      </p:nvGrpSpPr>
+      <p:grpSpPr>
+        <a:xfrm>
+          <a:off x="0" y="0"/>
+          <a:ext cx="0" cy="0"/>
+          <a:chOff x="0" y="0"/>
+          <a:chExt cx="0" cy="0"/>
+        </a:xfrm>
+      </p:grpSpPr>
+      <p:sp>
+        <p:nvSpPr>
+          <p:cNvPr id="2" name="Text 0"/>
+          <p:cNvSpPr/>
+          <p:nvPr/>
+        </p:nvSpPr>
+        <p:spPr>
+          <a:xfrm>
+            <a:off x="548640" y="365760"/>
+            <a:ext cx="11064240" cy="594360"/>
+          </a:xfrm>
+          <a:prstGeom prst="rect">
+            <a:avLst/>
+          </a:prstGeom>
+          <a:noFill/>
+          <a:ln/>
+        </p:spPr>
+        <p:txBody>
+          <a:bodyPr wrap="square" rtlCol="0" anchor="ctr"/>
+          <a:lstStyle/>
+          <a:p>
+            <a:pPr indent="0" marL="0">
+              <a:buNone/>
+            </a:pPr>
+            <a:r>
+              <a:rPr lang="en-US" sz="3000" b="1" dirty="0">
+                <a:solidFill>
+                  <a:srgbClr val="1E2761"/>
+                </a:solidFill>
+                <a:latin typeface="Cambria" pitchFamily="34" charset="0"/>
+                <a:ea typeface="Cambria" pitchFamily="34" charset="-122"/>
+                <a:cs typeface="Cambria" pitchFamily="34" charset="-120"/>
+              </a:rPr>
+              <a:t>Annexure 1 — intake API, five scenarios</a:t>
+            </a:r>
+            <a:endParaRPr lang="en-US" sz="3000" dirty="0"/>
+          </a:p>
+        </p:txBody>
+      </p:sp>
+      <p:sp>
+        <p:nvSpPr>
+          <p:cNvPr id="3" name="Text 1"/>
+          <p:cNvSpPr/>
+          <p:nvPr/>
+        </p:nvSpPr>
+        <p:spPr>
+          <a:xfrm>
+            <a:off x="566928" y="969264"/>
+            <a:ext cx="10972800" cy="365760"/>
+          </a:xfrm>
+          <a:prstGeom prst="rect">
+            <a:avLst/>
+          </a:prstGeom>
+          <a:noFill/>
+          <a:ln/>
+        </p:spPr>
+        <p:txBody>
+          <a:bodyPr wrap="square" rtlCol="0" anchor="ctr"/>
+          <a:lstStyle/>
+          <a:p>
+            <a:pPr indent="0" marL="0">
+              <a:buNone/>
+            </a:pPr>
+            <a:r>
+              <a:rPr lang="en-US" sz="1400" i="1" dirty="0">
+                <a:solidFill>
+                  <a:srgbClr val="5A6172"/>
+                </a:solidFill>
+                <a:latin typeface="Calibri" pitchFamily="34" charset="0"/>
+                <a:ea typeface="Calibri" pitchFamily="34" charset="-122"/>
+                <a:cs typeface="Calibri" pitchFamily="34" charset="-120"/>
+              </a:rPr>
+              <a:t>POST /score/intake — real request/response pairs against the served bundle (calibrated). Misses shown as-is.</a:t>
+            </a:r>
+            <a:endParaRPr lang="en-US" sz="1400" dirty="0"/>
+          </a:p>
+        </p:txBody>
+      </p:sp>
+      <p:graphicFrame>
+        <p:nvGraphicFramePr>
+          <p:cNvPr id="14" name="Table 0"/>
+          <p:cNvGraphicFramePr>
+            <a:graphicFrameLocks noGrp="1"/>
+          </p:cNvGraphicFramePr>
+          <p:nvPr>
+            <p:extLst>
+              <p:ext uri="{D42A27DB-BD31-4B8C-83A1-F6EECF244321}">
+                <p14:modId xmlns:p14="http://schemas.microsoft.com/office/powerpoint/2010/main" val="1579011935"/>
+              </p:ext>
+            </p:extLst>
+          </p:nvPr>
+        </p:nvGraphicFramePr>
+        <p:xfrm>
+          <a:off x="457200" y="1645920"/>
+          <a:ext cx="11274552" cy="914400"/>
+        </p:xfrm>
+        <a:graphic>
+          <a:graphicData uri="http://schemas.openxmlformats.org/drawingml/2006/table">
+            <a:tbl>
+              <a:tblPr/>
+              <a:tblGrid>
+                <a:gridCol w="4480560"/>
+                <a:gridCol w="4206240"/>
+                <a:gridCol w="2587752"/>
+              </a:tblGrid>
+              <a:tr h="658368">
+                <a:tc>
+                  <a:txBody>
+                    <a:bodyPr/>
+                    <a:lstStyle/>
+                    <a:p>
+                      <a:pPr indent="0" marL="0">
+                        <a:buNone/>
+                      </a:pPr>
+                      <a:r>
+                        <a:rPr lang="en-US" sz="1050" b="1" dirty="0">
+                          <a:solidFill>
+                            <a:srgbClr val="FFFFFF"/>
+                          </a:solidFill>
+                          <a:latin typeface="Calibri" pitchFamily="34" charset="0"/>
+                          <a:ea typeface="Calibri" pitchFamily="34" charset="-122"/>
+                          <a:cs typeface="Calibri" pitchFamily="34" charset="-120"/>
+                        </a:rPr>
+                        <a:t>Scenario</a:t>
+                      </a:r>
+                      <a:endParaRPr lang="en-US" sz="1050" dirty="0">
+                        <a:latin typeface="Calibri" charset="0"/>
+                        <a:ea typeface="Calibri" charset="0"/>
+                        <a:cs typeface="Calibri" charset="0"/>
+                      </a:endParaRPr>
+                    </a:p>
+                  </a:txBody>
+                  <a:tcPr marL="91440" marR="91440" marT="45720" marB="45720" anchor="ctr">
+                    <a:lnL w="12700" cap="flat" cmpd="sng" algn="ctr">
+                      <a:solidFill>
+                        <a:srgbClr val="D8DEEC"/>
+                      </a:solidFill>
+                      <a:prstDash val="solid"/>
+                      <a:round/>
+                      <a:headEnd type="none" w="med" len="med"/>
+                      <a:tailEnd type="none" w="med" len="med"/>
+                    </a:lnL>
+                    <a:lnR w="12700" cap="flat" cmpd="sng" algn="ctr">
+                      <a:solidFill>
+                        <a:srgbClr val="D8DEEC"/>
+                      </a:solidFill>
+                      <a:prstDash val="solid"/>
+                      <a:round/>
+                      <a:headEnd type="none" w="med" len="med"/>
+                      <a:tailEnd type="none" w="med" len="med"/>
+                    </a:lnR>
+                    <a:lnT w="12700" cap="flat" cmpd="sng" algn="ctr">
+                      <a:solidFill>
+                        <a:srgbClr val="D8DEEC"/>
+                      </a:solidFill>
+                      <a:prstDash val="solid"/>
+                      <a:round/>
+                      <a:headEnd type="none" w="med" len="med"/>
+                      <a:tailEnd type="none" w="med" len="med"/>
+                    </a:lnT>
+                    <a:lnB w="12700" cap="flat" cmpd="sng" algn="ctr">
+                      <a:solidFill>
+                        <a:srgbClr val="D8DEEC"/>
+                      </a:solidFill>
+                      <a:prstDash val="solid"/>
+                      <a:round/>
+                      <a:headEnd type="none" w="med" len="med"/>
+                      <a:tailEnd type="none" w="med" len="med"/>
+                    </a:lnB>
+                    <a:solidFill>
+                      <a:srgbClr val="1E2761"/>
+                    </a:solidFill>
+                  </a:tcPr>
+                </a:tc>
+                <a:tc>
+                  <a:txBody>
+                    <a:bodyPr/>
+                    <a:lstStyle/>
+                    <a:p>
+                      <a:pPr indent="0" marL="0">
+                        <a:buNone/>
+                      </a:pPr>
+                      <a:r>
+                        <a:rPr lang="en-US" sz="1050" b="1" dirty="0">
+                          <a:solidFill>
+                            <a:srgbClr val="FFFFFF"/>
+                          </a:solidFill>
+                          <a:latin typeface="Calibri" pitchFamily="34" charset="0"/>
+                          <a:ea typeface="Calibri" pitchFamily="34" charset="-122"/>
+                          <a:cs typeface="Calibri" pitchFamily="34" charset="-120"/>
+                        </a:rPr>
+                        <a:t>Returned</a:t>
+                      </a:r>
+                      <a:endParaRPr lang="en-US" sz="1050" dirty="0">
+                        <a:latin typeface="Calibri" charset="0"/>
+                        <a:ea typeface="Calibri" charset="0"/>
+                        <a:cs typeface="Calibri" charset="0"/>
+                      </a:endParaRPr>
+                    </a:p>
+                  </a:txBody>
+                  <a:tcPr marL="91440" marR="91440" marT="45720" marB="45720" anchor="ctr">
+                    <a:lnL w="12700" cap="flat" cmpd="sng" algn="ctr">
+                      <a:solidFill>
+                        <a:srgbClr val="D8DEEC"/>
+                      </a:solidFill>
+                      <a:prstDash val="solid"/>
+                      <a:round/>
+                      <a:headEnd type="none" w="med" len="med"/>
+                      <a:tailEnd type="none" w="med" len="med"/>
+                    </a:lnL>
+                    <a:lnR w="12700" cap="flat" cmpd="sng" algn="ctr">
+                      <a:solidFill>
+                        <a:srgbClr val="D8DEEC"/>
+                      </a:solidFill>
+                      <a:prstDash val="solid"/>
+                      <a:round/>
+                      <a:headEnd type="none" w="med" len="med"/>
+                      <a:tailEnd type="none" w="med" len="med"/>
+                    </a:lnR>
+                    <a:lnT w="12700" cap="flat" cmpd="sng" algn="ctr">
+                      <a:solidFill>
+                        <a:srgbClr val="D8DEEC"/>
+                      </a:solidFill>
+                      <a:prstDash val="solid"/>
+                      <a:round/>
+                      <a:headEnd type="none" w="med" len="med"/>
+                      <a:tailEnd type="none" w="med" len="med"/>
+                    </a:lnT>
+                    <a:lnB w="12700" cap="flat" cmpd="sng" algn="ctr">
+                      <a:solidFill>
+                        <a:srgbClr val="D8DEEC"/>
+                      </a:solidFill>
+                      <a:prstDash val="solid"/>
+                      <a:round/>
+                      <a:headEnd type="none" w="med" len="med"/>
+                      <a:tailEnd type="none" w="med" len="med"/>
+                    </a:lnB>
+                    <a:solidFill>
+                      <a:srgbClr val="1E2761"/>
+                    </a:solidFill>
+                  </a:tcPr>
+                </a:tc>
+                <a:tc>
+                  <a:txBody>
+                    <a:bodyPr/>
+                    <a:lstStyle/>
+                    <a:p>
+                      <a:pPr indent="0" marL="0">
+                        <a:buNone/>
+                      </a:pPr>
+                      <a:r>
+                        <a:rPr lang="en-US" sz="1050" b="1" dirty="0">
+                          <a:solidFill>
+                            <a:srgbClr val="FFFFFF"/>
+                          </a:solidFill>
+                          <a:latin typeface="Calibri" pitchFamily="34" charset="0"/>
+                          <a:ea typeface="Calibri" pitchFamily="34" charset="-122"/>
+                          <a:cs typeface="Calibri" pitchFamily="34" charset="-120"/>
+                        </a:rPr>
+                        <a:t>Reading</a:t>
+                      </a:r>
+                      <a:endParaRPr lang="en-US" sz="1050" dirty="0">
+                        <a:latin typeface="Calibri" charset="0"/>
+                        <a:ea typeface="Calibri" charset="0"/>
+                        <a:cs typeface="Calibri" charset="0"/>
+                      </a:endParaRPr>
+                    </a:p>
+                  </a:txBody>
+                  <a:tcPr marL="91440" marR="91440" marT="45720" marB="45720" anchor="ctr">
+                    <a:lnL w="12700" cap="flat" cmpd="sng" algn="ctr">
+                      <a:solidFill>
+                        <a:srgbClr val="D8DEEC"/>
+                      </a:solidFill>
+                      <a:prstDash val="solid"/>
+                      <a:round/>
+                      <a:headEnd type="none" w="med" len="med"/>
+                      <a:tailEnd type="none" w="med" len="med"/>
+                    </a:lnL>
+                    <a:lnR w="12700" cap="flat" cmpd="sng" algn="ctr">
+                      <a:solidFill>
+                        <a:srgbClr val="D8DEEC"/>
+                      </a:solidFill>
+                      <a:prstDash val="solid"/>
+                      <a:round/>
+                      <a:headEnd type="none" w="med" len="med"/>
+                      <a:tailEnd type="none" w="med" len="med"/>
+                    </a:lnR>
+                    <a:lnT w="12700" cap="flat" cmpd="sng" algn="ctr">
+                      <a:solidFill>
+                        <a:srgbClr val="D8DEEC"/>
+                      </a:solidFill>
+                      <a:prstDash val="solid"/>
+                      <a:round/>
+                      <a:headEnd type="none" w="med" len="med"/>
+                      <a:tailEnd type="none" w="med" len="med"/>
+                    </a:lnT>
+                    <a:lnB w="12700" cap="flat" cmpd="sng" algn="ctr">
+                      <a:solidFill>
+                        <a:srgbClr val="D8DEEC"/>
+                      </a:solidFill>
+                      <a:prstDash val="solid"/>
+                      <a:round/>
+                      <a:headEnd type="none" w="med" len="med"/>
+                      <a:tailEnd type="none" w="med" len="med"/>
+                    </a:lnB>
+                    <a:solidFill>
+                      <a:srgbClr val="1E2761"/>
+                    </a:solidFill>
+                  </a:tcPr>
+                </a:tc>
+              </a:tr>
+              <a:tr h="658368">
+                <a:tc>
+                  <a:txBody>
+                    <a:bodyPr/>
+                    <a:lstStyle/>
+                    <a:p>
+                      <a:pPr indent="0" marL="0">
+                        <a:buNone/>
+                      </a:pPr>
+                      <a:r>
+                        <a:rPr lang="en-US" sz="1050" dirty="0">
+                          <a:solidFill>
+                            <a:srgbClr val="1A1A2E"/>
+                          </a:solidFill>
+                          <a:latin typeface="Calibri" pitchFamily="34" charset="0"/>
+                          <a:ea typeface="Calibri" pitchFamily="34" charset="-122"/>
+                          <a:cs typeface="Calibri" pitchFamily="34" charset="-120"/>
+                        </a:rPr>
+                        <a:t>UC-1  ₹833 domestic, known accounts (true: IMPS, STP)</a:t>
+                      </a:r>
+                      <a:endParaRPr lang="en-US" sz="1050" dirty="0">
+                        <a:latin typeface="Calibri" charset="0"/>
+                        <a:ea typeface="Calibri" charset="0"/>
+                        <a:cs typeface="Calibri" charset="0"/>
+                      </a:endParaRPr>
+                    </a:p>
+                  </a:txBody>
+                  <a:tcPr marL="91440" marR="91440" marT="45720" marB="45720" anchor="ctr">
+                    <a:lnL w="12700" cap="flat" cmpd="sng" algn="ctr">
+                      <a:solidFill>
+                        <a:srgbClr val="D8DEEC"/>
+                      </a:solidFill>
+                      <a:prstDash val="solid"/>
+                      <a:round/>
+                      <a:headEnd type="none" w="med" len="med"/>
+                      <a:tailEnd type="none" w="med" len="med"/>
+                    </a:lnL>
+                    <a:lnR w="12700" cap="flat" cmpd="sng" algn="ctr">
+                      <a:solidFill>
+                        <a:srgbClr val="D8DEEC"/>
+                      </a:solidFill>
+                      <a:prstDash val="solid"/>
+                      <a:round/>
+                      <a:headEnd type="none" w="med" len="med"/>
+                      <a:tailEnd type="none" w="med" len="med"/>
+                    </a:lnR>
+                    <a:lnT w="12700" cap="flat" cmpd="sng" algn="ctr">
+                      <a:solidFill>
+                        <a:srgbClr val="D8DEEC"/>
+                      </a:solidFill>
+                      <a:prstDash val="solid"/>
+                      <a:round/>
+                      <a:headEnd type="none" w="med" len="med"/>
+                      <a:tailEnd type="none" w="med" len="med"/>
+                    </a:lnT>
+                    <a:lnB w="12700" cap="flat" cmpd="sng" algn="ctr">
+                      <a:solidFill>
+                        <a:srgbClr val="D8DEEC"/>
+                      </a:solidFill>
+                      <a:prstDash val="solid"/>
+                      <a:round/>
+                      <a:headEnd type="none" w="med" len="med"/>
+                      <a:tailEnd type="none" w="med" len="med"/>
+                    </a:lnB>
+                  </a:tcPr>
+                </a:tc>
+                <a:tc>
+                  <a:txBody>
+                    <a:bodyPr/>
+                    <a:lstStyle/>
+                    <a:p>
+                      <a:pPr indent="0" marL="0">
+                        <a:buNone/>
+                      </a:pPr>
+                      <a:r>
+                        <a:rPr lang="en-US" sz="1050" dirty="0">
+                          <a:solidFill>
+                            <a:srgbClr val="1A1A2E"/>
+                          </a:solidFill>
+                          <a:latin typeface="Calibri" pitchFamily="34" charset="0"/>
+                          <a:ea typeface="Calibri" pitchFamily="34" charset="-122"/>
+                          <a:cs typeface="Calibri" pitchFamily="34" charset="-120"/>
+                        </a:rPr>
+                        <a:t>IMPS (0.624) · STP · ETA 0m · risk Low</a:t>
+                      </a:r>
+                      <a:endParaRPr lang="en-US" sz="1050" dirty="0">
+                        <a:latin typeface="Calibri" charset="0"/>
+                        <a:ea typeface="Calibri" charset="0"/>
+                        <a:cs typeface="Calibri" charset="0"/>
+                      </a:endParaRPr>
+                    </a:p>
+                  </a:txBody>
+                  <a:tcPr marL="91440" marR="91440" marT="45720" marB="45720" anchor="ctr">
+                    <a:lnL w="12700" cap="flat" cmpd="sng" algn="ctr">
+                      <a:solidFill>
+                        <a:srgbClr val="D8DEEC"/>
+                      </a:solidFill>
+                      <a:prstDash val="solid"/>
+                      <a:round/>
+                      <a:headEnd type="none" w="med" len="med"/>
+                      <a:tailEnd type="none" w="med" len="med"/>
+                    </a:lnL>
+                    <a:lnR w="12700" cap="flat" cmpd="sng" algn="ctr">
+                      <a:solidFill>
+                        <a:srgbClr val="D8DEEC"/>
+                      </a:solidFill>
+                      <a:prstDash val="solid"/>
+                      <a:round/>
+                      <a:headEnd type="none" w="med" len="med"/>
+                      <a:tailEnd type="none" w="med" len="med"/>
+                    </a:lnR>
+                    <a:lnT w="12700" cap="flat" cmpd="sng" algn="ctr">
+                      <a:solidFill>
+                        <a:srgbClr val="D8DEEC"/>
+                      </a:solidFill>
+                      <a:prstDash val="solid"/>
+                      <a:round/>
+                      <a:headEnd type="none" w="med" len="med"/>
+                      <a:tailEnd type="none" w="med" len="med"/>
+                    </a:lnT>
+                    <a:lnB w="12700" cap="flat" cmpd="sng" algn="ctr">
+                      <a:solidFill>
+                        <a:srgbClr val="D8DEEC"/>
+                      </a:solidFill>
+                      <a:prstDash val="solid"/>
+                      <a:round/>
+                      <a:headEnd type="none" w="med" len="med"/>
+                      <a:tailEnd type="none" w="med" len="med"/>
+                    </a:lnB>
+                  </a:tcPr>
+                </a:tc>
+                <a:tc>
+                  <a:txBody>
+                    <a:bodyPr/>
+                    <a:lstStyle/>
+                    <a:p>
+                      <a:pPr indent="0" marL="0">
+                        <a:buNone/>
+                      </a:pPr>
+                      <a:r>
+                        <a:rPr lang="en-US" sz="1050" b="1" dirty="0">
+                          <a:solidFill>
+                            <a:srgbClr val="2E7D32"/>
+                          </a:solidFill>
+                          <a:latin typeface="Calibri" pitchFamily="34" charset="0"/>
+                          <a:ea typeface="Calibri" pitchFamily="34" charset="-122"/>
+                          <a:cs typeface="Calibri" pitchFamily="34" charset="-120"/>
+                        </a:rPr>
+                        <a:t>Both correct</a:t>
+                      </a:r>
+                      <a:endParaRPr lang="en-US" sz="1050" dirty="0">
+                        <a:latin typeface="Calibri" charset="0"/>
+                        <a:ea typeface="Calibri" charset="0"/>
+                        <a:cs typeface="Calibri" charset="0"/>
+                      </a:endParaRPr>
+                    </a:p>
+                  </a:txBody>
+                  <a:tcPr marL="91440" marR="91440" marT="45720" marB="45720" anchor="ctr">
+                    <a:lnL w="12700" cap="flat" cmpd="sng" algn="ctr">
+                      <a:solidFill>
+                        <a:srgbClr val="D8DEEC"/>
+                      </a:solidFill>
+                      <a:prstDash val="solid"/>
+                      <a:round/>
+                      <a:headEnd type="none" w="med" len="med"/>
+                      <a:tailEnd type="none" w="med" len="med"/>
+                    </a:lnL>
+                    <a:lnR w="12700" cap="flat" cmpd="sng" algn="ctr">
+                      <a:solidFill>
+                        <a:srgbClr val="D8DEEC"/>
+                      </a:solidFill>
+                      <a:prstDash val="solid"/>
+                      <a:round/>
+                      <a:headEnd type="none" w="med" len="med"/>
+                      <a:tailEnd type="none" w="med" len="med"/>
+                    </a:lnR>
+                    <a:lnT w="12700" cap="flat" cmpd="sng" algn="ctr">
+                      <a:solidFill>
+                        <a:srgbClr val="D8DEEC"/>
+                      </a:solidFill>
+                      <a:prstDash val="solid"/>
+                      <a:round/>
+                      <a:headEnd type="none" w="med" len="med"/>
+                      <a:tailEnd type="none" w="med" len="med"/>
+                    </a:lnT>
+                    <a:lnB w="12700" cap="flat" cmpd="sng" algn="ctr">
+                      <a:solidFill>
+                        <a:srgbClr val="D8DEEC"/>
+                      </a:solidFill>
+                      <a:prstDash val="solid"/>
+                      <a:round/>
+                      <a:headEnd type="none" w="med" len="med"/>
+                      <a:tailEnd type="none" w="med" len="med"/>
+                    </a:lnB>
+                  </a:tcPr>
+                </a:tc>
+              </a:tr>
+              <a:tr h="658368">
+                <a:tc>
+                  <a:txBody>
+                    <a:bodyPr/>
+                    <a:lstStyle/>
+                    <a:p>
+                      <a:pPr indent="0" marL="0">
+                        <a:buNone/>
+                      </a:pPr>
+                      <a:r>
+                        <a:rPr lang="en-US" sz="1050" dirty="0">
+                          <a:solidFill>
+                            <a:srgbClr val="1A1A2E"/>
+                          </a:solidFill>
+                          <a:latin typeface="Calibri" pitchFamily="34" charset="0"/>
+                          <a:ea typeface="Calibri" pitchFamily="34" charset="-122"/>
+                          <a:cs typeface="Calibri" pitchFamily="34" charset="-120"/>
+                        </a:rPr>
+                        <a:t>UC-2  ₹2,50,799 high-value (true: RTGS, STP)</a:t>
+                      </a:r>
+                      <a:endParaRPr lang="en-US" sz="1050" dirty="0">
+                        <a:latin typeface="Calibri" charset="0"/>
+                        <a:ea typeface="Calibri" charset="0"/>
+                        <a:cs typeface="Calibri" charset="0"/>
+                      </a:endParaRPr>
+                    </a:p>
+                  </a:txBody>
+                  <a:tcPr marL="91440" marR="91440" marT="45720" marB="45720" anchor="ctr">
+                    <a:lnL w="12700" cap="flat" cmpd="sng" algn="ctr">
+                      <a:solidFill>
+                        <a:srgbClr val="D8DEEC"/>
+                      </a:solidFill>
+                      <a:prstDash val="solid"/>
+                      <a:round/>
+                      <a:headEnd type="none" w="med" len="med"/>
+                      <a:tailEnd type="none" w="med" len="med"/>
+                    </a:lnL>
+                    <a:lnR w="12700" cap="flat" cmpd="sng" algn="ctr">
+                      <a:solidFill>
+                        <a:srgbClr val="D8DEEC"/>
+                      </a:solidFill>
+                      <a:prstDash val="solid"/>
+                      <a:round/>
+                      <a:headEnd type="none" w="med" len="med"/>
+                      <a:tailEnd type="none" w="med" len="med"/>
+                    </a:lnR>
+                    <a:lnT w="12700" cap="flat" cmpd="sng" algn="ctr">
+                      <a:solidFill>
+                        <a:srgbClr val="D8DEEC"/>
+                      </a:solidFill>
+                      <a:prstDash val="solid"/>
+                      <a:round/>
+                      <a:headEnd type="none" w="med" len="med"/>
+                      <a:tailEnd type="none" w="med" len="med"/>
+                    </a:lnT>
+                    <a:lnB w="12700" cap="flat" cmpd="sng" algn="ctr">
+                      <a:solidFill>
+                        <a:srgbClr val="D8DEEC"/>
+                      </a:solidFill>
+                      <a:prstDash val="solid"/>
+                      <a:round/>
+                      <a:headEnd type="none" w="med" len="med"/>
+                      <a:tailEnd type="none" w="med" len="med"/>
+                    </a:lnB>
+                  </a:tcPr>
+                </a:tc>
+                <a:tc>
+                  <a:txBody>
+                    <a:bodyPr/>
+                    <a:lstStyle/>
+                    <a:p>
+                      <a:pPr indent="0" marL="0">
+                        <a:buNone/>
+                      </a:pPr>
+                      <a:r>
+                        <a:rPr lang="en-US" sz="1050" dirty="0">
+                          <a:solidFill>
+                            <a:srgbClr val="1A1A2E"/>
+                          </a:solidFill>
+                          <a:latin typeface="Calibri" pitchFamily="34" charset="0"/>
+                          <a:ea typeface="Calibri" pitchFamily="34" charset="-122"/>
+                          <a:cs typeface="Calibri" pitchFamily="34" charset="-120"/>
+                        </a:rPr>
+                        <a:t>RTGS (0.812) · REJECTED · risk High</a:t>
+                      </a:r>
+                      <a:endParaRPr lang="en-US" sz="1050" dirty="0">
+                        <a:latin typeface="Calibri" charset="0"/>
+                        <a:ea typeface="Calibri" charset="0"/>
+                        <a:cs typeface="Calibri" charset="0"/>
+                      </a:endParaRPr>
+                    </a:p>
+                  </a:txBody>
+                  <a:tcPr marL="91440" marR="91440" marT="45720" marB="45720" anchor="ctr">
+                    <a:lnL w="12700" cap="flat" cmpd="sng" algn="ctr">
+                      <a:solidFill>
+                        <a:srgbClr val="D8DEEC"/>
+                      </a:solidFill>
+                      <a:prstDash val="solid"/>
+                      <a:round/>
+                      <a:headEnd type="none" w="med" len="med"/>
+                      <a:tailEnd type="none" w="med" len="med"/>
+                    </a:lnL>
+                    <a:lnR w="12700" cap="flat" cmpd="sng" algn="ctr">
+                      <a:solidFill>
+                        <a:srgbClr val="D8DEEC"/>
+                      </a:solidFill>
+                      <a:prstDash val="solid"/>
+                      <a:round/>
+                      <a:headEnd type="none" w="med" len="med"/>
+                      <a:tailEnd type="none" w="med" len="med"/>
+                    </a:lnR>
+                    <a:lnT w="12700" cap="flat" cmpd="sng" algn="ctr">
+                      <a:solidFill>
+                        <a:srgbClr val="D8DEEC"/>
+                      </a:solidFill>
+                      <a:prstDash val="solid"/>
+                      <a:round/>
+                      <a:headEnd type="none" w="med" len="med"/>
+                      <a:tailEnd type="none" w="med" len="med"/>
+                    </a:lnT>
+                    <a:lnB w="12700" cap="flat" cmpd="sng" algn="ctr">
+                      <a:solidFill>
+                        <a:srgbClr val="D8DEEC"/>
+                      </a:solidFill>
+                      <a:prstDash val="solid"/>
+                      <a:round/>
+                      <a:headEnd type="none" w="med" len="med"/>
+                      <a:tailEnd type="none" w="med" len="med"/>
+                    </a:lnB>
+                  </a:tcPr>
+                </a:tc>
+                <a:tc>
+                  <a:txBody>
+                    <a:bodyPr/>
+                    <a:lstStyle/>
+                    <a:p>
+                      <a:pPr indent="0" marL="0">
+                        <a:buNone/>
+                      </a:pPr>
+                      <a:r>
+                        <a:rPr lang="en-US" sz="1050" b="1" dirty="0">
+                          <a:solidFill>
+                            <a:srgbClr val="B3261E"/>
+                          </a:solidFill>
+                          <a:latin typeface="Calibri" pitchFamily="34" charset="0"/>
+                          <a:ea typeface="Calibri" pitchFamily="34" charset="-122"/>
+                          <a:cs typeface="Calibri" pitchFamily="34" charset="-120"/>
+                        </a:rPr>
+                        <a:t>Rail + risk right; status wrong — the weak head, shown failing</a:t>
+                      </a:r>
+                      <a:endParaRPr lang="en-US" sz="1050" dirty="0">
+                        <a:latin typeface="Calibri" charset="0"/>
+                        <a:ea typeface="Calibri" charset="0"/>
+                        <a:cs typeface="Calibri" charset="0"/>
+                      </a:endParaRPr>
+                    </a:p>
+                  </a:txBody>
+                  <a:tcPr marL="91440" marR="91440" marT="45720" marB="45720" anchor="ctr">
+                    <a:lnL w="12700" cap="flat" cmpd="sng" algn="ctr">
+                      <a:solidFill>
+                        <a:srgbClr val="D8DEEC"/>
+                      </a:solidFill>
+                      <a:prstDash val="solid"/>
+                      <a:round/>
+                      <a:headEnd type="none" w="med" len="med"/>
+                      <a:tailEnd type="none" w="med" len="med"/>
+                    </a:lnL>
+                    <a:lnR w="12700" cap="flat" cmpd="sng" algn="ctr">
+                      <a:solidFill>
+                        <a:srgbClr val="D8DEEC"/>
+                      </a:solidFill>
+                      <a:prstDash val="solid"/>
+                      <a:round/>
+                      <a:headEnd type="none" w="med" len="med"/>
+                      <a:tailEnd type="none" w="med" len="med"/>
+                    </a:lnR>
+                    <a:lnT w="12700" cap="flat" cmpd="sng" algn="ctr">
+                      <a:solidFill>
+                        <a:srgbClr val="D8DEEC"/>
+                      </a:solidFill>
+                      <a:prstDash val="solid"/>
+                      <a:round/>
+                      <a:headEnd type="none" w="med" len="med"/>
+                      <a:tailEnd type="none" w="med" len="med"/>
+                    </a:lnT>
+                    <a:lnB w="12700" cap="flat" cmpd="sng" algn="ctr">
+                      <a:solidFill>
+                        <a:srgbClr val="D8DEEC"/>
+                      </a:solidFill>
+                      <a:prstDash val="solid"/>
+                      <a:round/>
+                      <a:headEnd type="none" w="med" len="med"/>
+                      <a:tailEnd type="none" w="med" len="med"/>
+                    </a:lnB>
+                  </a:tcPr>
+                </a:tc>
+              </a:tr>
+              <a:tr h="658368">
+                <a:tc>
+                  <a:txBody>
+                    <a:bodyPr/>
+                    <a:lstStyle/>
+                    <a:p>
+                      <a:pPr indent="0" marL="0">
+                        <a:buNone/>
+                      </a:pPr>
+                      <a:r>
+                        <a:rPr lang="en-US" sz="1050" dirty="0">
+                          <a:solidFill>
+                            <a:srgbClr val="1A1A2E"/>
+                          </a:solidFill>
+                          <a:latin typeface="Calibri" pitchFamily="34" charset="0"/>
+                          <a:ea typeface="Calibri" pitchFamily="34" charset="-122"/>
+                          <a:cs typeface="Calibri" pitchFamily="34" charset="-120"/>
+                        </a:rPr>
+                        <a:t>UC-3  cross-border BIC/IBAN, IN→BR (true settle 1,140m)</a:t>
+                      </a:r>
+                      <a:endParaRPr lang="en-US" sz="1050" dirty="0">
+                        <a:latin typeface="Calibri" charset="0"/>
+                        <a:ea typeface="Calibri" charset="0"/>
+                        <a:cs typeface="Calibri" charset="0"/>
+                      </a:endParaRPr>
+                    </a:p>
+                  </a:txBody>
+                  <a:tcPr marL="91440" marR="91440" marT="45720" marB="45720" anchor="ctr">
+                    <a:lnL w="12700" cap="flat" cmpd="sng" algn="ctr">
+                      <a:solidFill>
+                        <a:srgbClr val="D8DEEC"/>
+                      </a:solidFill>
+                      <a:prstDash val="solid"/>
+                      <a:round/>
+                      <a:headEnd type="none" w="med" len="med"/>
+                      <a:tailEnd type="none" w="med" len="med"/>
+                    </a:lnL>
+                    <a:lnR w="12700" cap="flat" cmpd="sng" algn="ctr">
+                      <a:solidFill>
+                        <a:srgbClr val="D8DEEC"/>
+                      </a:solidFill>
+                      <a:prstDash val="solid"/>
+                      <a:round/>
+                      <a:headEnd type="none" w="med" len="med"/>
+                      <a:tailEnd type="none" w="med" len="med"/>
+                    </a:lnR>
+                    <a:lnT w="12700" cap="flat" cmpd="sng" algn="ctr">
+                      <a:solidFill>
+                        <a:srgbClr val="D8DEEC"/>
+                      </a:solidFill>
+                      <a:prstDash val="solid"/>
+                      <a:round/>
+                      <a:headEnd type="none" w="med" len="med"/>
+                      <a:tailEnd type="none" w="med" len="med"/>
+                    </a:lnT>
+                    <a:lnB w="12700" cap="flat" cmpd="sng" algn="ctr">
+                      <a:solidFill>
+                        <a:srgbClr val="D8DEEC"/>
+                      </a:solidFill>
+                      <a:prstDash val="solid"/>
+                      <a:round/>
+                      <a:headEnd type="none" w="med" len="med"/>
+                      <a:tailEnd type="none" w="med" len="med"/>
+                    </a:lnB>
+                  </a:tcPr>
+                </a:tc>
+                <a:tc>
+                  <a:txBody>
+                    <a:bodyPr/>
+                    <a:lstStyle/>
+                    <a:p>
+                      <a:pPr indent="0" marL="0">
+                        <a:buNone/>
+                      </a:pPr>
+                      <a:r>
+                        <a:rPr lang="en-US" sz="1050" dirty="0">
+                          <a:solidFill>
+                            <a:srgbClr val="1A1A2E"/>
+                          </a:solidFill>
+                          <a:latin typeface="Calibri" pitchFamily="34" charset="0"/>
+                          <a:ea typeface="Calibri" pitchFamily="34" charset="-122"/>
+                          <a:cs typeface="Calibri" pitchFamily="34" charset="-120"/>
+                        </a:rPr>
+                        <a:t>SWIFT (1) · ETA 878.2m · risk High · top exc sanctions_hit</a:t>
+                      </a:r>
+                      <a:endParaRPr lang="en-US" sz="1050" dirty="0">
+                        <a:latin typeface="Calibri" charset="0"/>
+                        <a:ea typeface="Calibri" charset="0"/>
+                        <a:cs typeface="Calibri" charset="0"/>
+                      </a:endParaRPr>
+                    </a:p>
+                  </a:txBody>
+                  <a:tcPr marL="91440" marR="91440" marT="45720" marB="45720" anchor="ctr">
+                    <a:lnL w="12700" cap="flat" cmpd="sng" algn="ctr">
+                      <a:solidFill>
+                        <a:srgbClr val="D8DEEC"/>
+                      </a:solidFill>
+                      <a:prstDash val="solid"/>
+                      <a:round/>
+                      <a:headEnd type="none" w="med" len="med"/>
+                      <a:tailEnd type="none" w="med" len="med"/>
+                    </a:lnL>
+                    <a:lnR w="12700" cap="flat" cmpd="sng" algn="ctr">
+                      <a:solidFill>
+                        <a:srgbClr val="D8DEEC"/>
+                      </a:solidFill>
+                      <a:prstDash val="solid"/>
+                      <a:round/>
+                      <a:headEnd type="none" w="med" len="med"/>
+                      <a:tailEnd type="none" w="med" len="med"/>
+                    </a:lnR>
+                    <a:lnT w="12700" cap="flat" cmpd="sng" algn="ctr">
+                      <a:solidFill>
+                        <a:srgbClr val="D8DEEC"/>
+                      </a:solidFill>
+                      <a:prstDash val="solid"/>
+                      <a:round/>
+                      <a:headEnd type="none" w="med" len="med"/>
+                      <a:tailEnd type="none" w="med" len="med"/>
+                    </a:lnT>
+                    <a:lnB w="12700" cap="flat" cmpd="sng" algn="ctr">
+                      <a:solidFill>
+                        <a:srgbClr val="D8DEEC"/>
+                      </a:solidFill>
+                      <a:prstDash val="solid"/>
+                      <a:round/>
+                      <a:headEnd type="none" w="med" len="med"/>
+                      <a:tailEnd type="none" w="med" len="med"/>
+                    </a:lnB>
+                  </a:tcPr>
+                </a:tc>
+                <a:tc>
+                  <a:txBody>
+                    <a:bodyPr/>
+                    <a:lstStyle/>
+                    <a:p>
+                      <a:pPr indent="0" marL="0">
+                        <a:buNone/>
+                      </a:pPr>
+                      <a:r>
+                        <a:rPr lang="en-US" sz="1050" b="1" dirty="0">
+                          <a:solidFill>
+                            <a:srgbClr val="2E7D32"/>
+                          </a:solidFill>
+                          <a:latin typeface="Calibri" pitchFamily="34" charset="0"/>
+                          <a:ea typeface="Calibri" pitchFamily="34" charset="-122"/>
+                          <a:cs typeface="Calibri" pitchFamily="34" charset="-120"/>
+                        </a:rPr>
+                        <a:t>Confidence 1.00 on scope</a:t>
+                      </a:r>
+                      <a:endParaRPr lang="en-US" sz="1050" dirty="0">
+                        <a:latin typeface="Calibri" charset="0"/>
+                        <a:ea typeface="Calibri" charset="0"/>
+                        <a:cs typeface="Calibri" charset="0"/>
+                      </a:endParaRPr>
+                    </a:p>
+                  </a:txBody>
+                  <a:tcPr marL="91440" marR="91440" marT="45720" marB="45720" anchor="ctr">
+                    <a:lnL w="12700" cap="flat" cmpd="sng" algn="ctr">
+                      <a:solidFill>
+                        <a:srgbClr val="D8DEEC"/>
+                      </a:solidFill>
+                      <a:prstDash val="solid"/>
+                      <a:round/>
+                      <a:headEnd type="none" w="med" len="med"/>
+                      <a:tailEnd type="none" w="med" len="med"/>
+                    </a:lnL>
+                    <a:lnR w="12700" cap="flat" cmpd="sng" algn="ctr">
+                      <a:solidFill>
+                        <a:srgbClr val="D8DEEC"/>
+                      </a:solidFill>
+                      <a:prstDash val="solid"/>
+                      <a:round/>
+                      <a:headEnd type="none" w="med" len="med"/>
+                      <a:tailEnd type="none" w="med" len="med"/>
+                    </a:lnR>
+                    <a:lnT w="12700" cap="flat" cmpd="sng" algn="ctr">
+                      <a:solidFill>
+                        <a:srgbClr val="D8DEEC"/>
+                      </a:solidFill>
+                      <a:prstDash val="solid"/>
+                      <a:round/>
+                      <a:headEnd type="none" w="med" len="med"/>
+                      <a:tailEnd type="none" w="med" len="med"/>
+                    </a:lnT>
+                    <a:lnB w="12700" cap="flat" cmpd="sng" algn="ctr">
+                      <a:solidFill>
+                        <a:srgbClr val="D8DEEC"/>
+                      </a:solidFill>
+                      <a:prstDash val="solid"/>
+                      <a:round/>
+                      <a:headEnd type="none" w="med" len="med"/>
+                      <a:tailEnd type="none" w="med" len="med"/>
+                    </a:lnB>
+                  </a:tcPr>
+                </a:tc>
+              </a:tr>
+              <a:tr h="658368">
+                <a:tc>
+                  <a:txBody>
+                    <a:bodyPr/>
+                    <a:lstStyle/>
+                    <a:p>
+                      <a:pPr indent="0" marL="0">
+                        <a:buNone/>
+                      </a:pPr>
+                      <a:r>
+                        <a:rPr lang="en-US" sz="1050" dirty="0">
+                          <a:solidFill>
+                            <a:srgbClr val="1A1A2E"/>
+                          </a:solidFill>
+                          <a:latin typeface="Calibri" pitchFamily="34" charset="0"/>
+                          <a:ea typeface="Calibri" pitchFamily="34" charset="-122"/>
+                          <a:cs typeface="Calibri" pitchFamily="34" charset="-120"/>
+                        </a:rPr>
+                        <a:t>UC-4  ₹7,410 arrives tagged RTGS — below the ₹2L floor (true: REJECTED)</a:t>
+                      </a:r>
+                      <a:endParaRPr lang="en-US" sz="1050" dirty="0">
+                        <a:latin typeface="Calibri" charset="0"/>
+                        <a:ea typeface="Calibri" charset="0"/>
+                        <a:cs typeface="Calibri" charset="0"/>
+                      </a:endParaRPr>
+                    </a:p>
+                  </a:txBody>
+                  <a:tcPr marL="91440" marR="91440" marT="45720" marB="45720" anchor="ctr">
+                    <a:lnL w="12700" cap="flat" cmpd="sng" algn="ctr">
+                      <a:solidFill>
+                        <a:srgbClr val="D8DEEC"/>
+                      </a:solidFill>
+                      <a:prstDash val="solid"/>
+                      <a:round/>
+                      <a:headEnd type="none" w="med" len="med"/>
+                      <a:tailEnd type="none" w="med" len="med"/>
+                    </a:lnL>
+                    <a:lnR w="12700" cap="flat" cmpd="sng" algn="ctr">
+                      <a:solidFill>
+                        <a:srgbClr val="D8DEEC"/>
+                      </a:solidFill>
+                      <a:prstDash val="solid"/>
+                      <a:round/>
+                      <a:headEnd type="none" w="med" len="med"/>
+                      <a:tailEnd type="none" w="med" len="med"/>
+                    </a:lnR>
+                    <a:lnT w="12700" cap="flat" cmpd="sng" algn="ctr">
+                      <a:solidFill>
+                        <a:srgbClr val="D8DEEC"/>
+                      </a:solidFill>
+                      <a:prstDash val="solid"/>
+                      <a:round/>
+                      <a:headEnd type="none" w="med" len="med"/>
+                      <a:tailEnd type="none" w="med" len="med"/>
+                    </a:lnT>
+                    <a:lnB w="12700" cap="flat" cmpd="sng" algn="ctr">
+                      <a:solidFill>
+                        <a:srgbClr val="D8DEEC"/>
+                      </a:solidFill>
+                      <a:prstDash val="solid"/>
+                      <a:round/>
+                      <a:headEnd type="none" w="med" len="med"/>
+                      <a:tailEnd type="none" w="med" len="med"/>
+                    </a:lnB>
+                  </a:tcPr>
+                </a:tc>
+                <a:tc>
+                  <a:txBody>
+                    <a:bodyPr/>
+                    <a:lstStyle/>
+                    <a:p>
+                      <a:pPr indent="0" marL="0">
+                        <a:buNone/>
+                      </a:pPr>
+                      <a:r>
+                        <a:rPr lang="en-US" sz="1050" dirty="0">
+                          <a:solidFill>
+                            <a:srgbClr val="1A1A2E"/>
+                          </a:solidFill>
+                          <a:latin typeface="Calibri" pitchFamily="34" charset="0"/>
+                          <a:ea typeface="Calibri" pitchFamily="34" charset="-122"/>
+                          <a:cs typeface="Calibri" pitchFamily="34" charset="-120"/>
+                        </a:rPr>
+                        <a:t>re-routes to NEFT (0.631) · REJECTED</a:t>
+                      </a:r>
+                      <a:endParaRPr lang="en-US" sz="1050" dirty="0">
+                        <a:latin typeface="Calibri" charset="0"/>
+                        <a:ea typeface="Calibri" charset="0"/>
+                        <a:cs typeface="Calibri" charset="0"/>
+                      </a:endParaRPr>
+                    </a:p>
+                  </a:txBody>
+                  <a:tcPr marL="91440" marR="91440" marT="45720" marB="45720" anchor="ctr">
+                    <a:lnL w="12700" cap="flat" cmpd="sng" algn="ctr">
+                      <a:solidFill>
+                        <a:srgbClr val="D8DEEC"/>
+                      </a:solidFill>
+                      <a:prstDash val="solid"/>
+                      <a:round/>
+                      <a:headEnd type="none" w="med" len="med"/>
+                      <a:tailEnd type="none" w="med" len="med"/>
+                    </a:lnL>
+                    <a:lnR w="12700" cap="flat" cmpd="sng" algn="ctr">
+                      <a:solidFill>
+                        <a:srgbClr val="D8DEEC"/>
+                      </a:solidFill>
+                      <a:prstDash val="solid"/>
+                      <a:round/>
+                      <a:headEnd type="none" w="med" len="med"/>
+                      <a:tailEnd type="none" w="med" len="med"/>
+                    </a:lnR>
+                    <a:lnT w="12700" cap="flat" cmpd="sng" algn="ctr">
+                      <a:solidFill>
+                        <a:srgbClr val="D8DEEC"/>
+                      </a:solidFill>
+                      <a:prstDash val="solid"/>
+                      <a:round/>
+                      <a:headEnd type="none" w="med" len="med"/>
+                      <a:tailEnd type="none" w="med" len="med"/>
+                    </a:lnT>
+                    <a:lnB w="12700" cap="flat" cmpd="sng" algn="ctr">
+                      <a:solidFill>
+                        <a:srgbClr val="D8DEEC"/>
+                      </a:solidFill>
+                      <a:prstDash val="solid"/>
+                      <a:round/>
+                      <a:headEnd type="none" w="med" len="med"/>
+                      <a:tailEnd type="none" w="med" len="med"/>
+                    </a:lnB>
+                  </a:tcPr>
+                </a:tc>
+                <a:tc>
+                  <a:txBody>
+                    <a:bodyPr/>
+                    <a:lstStyle/>
+                    <a:p>
+                      <a:pPr indent="0" marL="0">
+                        <a:buNone/>
+                      </a:pPr>
+                      <a:r>
+                        <a:rPr lang="en-US" sz="1050" b="1" dirty="0">
+                          <a:solidFill>
+                            <a:srgbClr val="2E7D32"/>
+                          </a:solidFill>
+                          <a:latin typeface="Calibri" pitchFamily="34" charset="0"/>
+                          <a:ea typeface="Calibri" pitchFamily="34" charset="-122"/>
+                          <a:cs typeface="Calibri" pitchFamily="34" charset="-120"/>
+                        </a:rPr>
+                        <a:t>Catches the mis-route AND the reject</a:t>
+                      </a:r>
+                      <a:endParaRPr lang="en-US" sz="1050" dirty="0">
+                        <a:latin typeface="Calibri" charset="0"/>
+                        <a:ea typeface="Calibri" charset="0"/>
+                        <a:cs typeface="Calibri" charset="0"/>
+                      </a:endParaRPr>
+                    </a:p>
+                  </a:txBody>
+                  <a:tcPr marL="91440" marR="91440" marT="45720" marB="45720" anchor="ctr">
+                    <a:lnL w="12700" cap="flat" cmpd="sng" algn="ctr">
+                      <a:solidFill>
+                        <a:srgbClr val="D8DEEC"/>
+                      </a:solidFill>
+                      <a:prstDash val="solid"/>
+                      <a:round/>
+                      <a:headEnd type="none" w="med" len="med"/>
+                      <a:tailEnd type="none" w="med" len="med"/>
+                    </a:lnL>
+                    <a:lnR w="12700" cap="flat" cmpd="sng" algn="ctr">
+                      <a:solidFill>
+                        <a:srgbClr val="D8DEEC"/>
+                      </a:solidFill>
+                      <a:prstDash val="solid"/>
+                      <a:round/>
+                      <a:headEnd type="none" w="med" len="med"/>
+                      <a:tailEnd type="none" w="med" len="med"/>
+                    </a:lnR>
+                    <a:lnT w="12700" cap="flat" cmpd="sng" algn="ctr">
+                      <a:solidFill>
+                        <a:srgbClr val="D8DEEC"/>
+                      </a:solidFill>
+                      <a:prstDash val="solid"/>
+                      <a:round/>
+                      <a:headEnd type="none" w="med" len="med"/>
+                      <a:tailEnd type="none" w="med" len="med"/>
+                    </a:lnT>
+                    <a:lnB w="12700" cap="flat" cmpd="sng" algn="ctr">
+                      <a:solidFill>
+                        <a:srgbClr val="D8DEEC"/>
+                      </a:solidFill>
+                      <a:prstDash val="solid"/>
+                      <a:round/>
+                      <a:headEnd type="none" w="med" len="med"/>
+                      <a:tailEnd type="none" w="med" len="med"/>
+                    </a:lnB>
+                  </a:tcPr>
+                </a:tc>
+              </a:tr>
+              <a:tr h="658368">
+                <a:tc>
+                  <a:txBody>
+                    <a:bodyPr/>
+                    <a:lstStyle/>
+                    <a:p>
+                      <a:pPr indent="0" marL="0">
+                        <a:buNone/>
+                      </a:pPr>
+                      <a:r>
+                        <a:rPr lang="en-US" sz="1050" dirty="0">
+                          <a:solidFill>
+                            <a:srgbClr val="1A1A2E"/>
+                          </a:solidFill>
+                          <a:latin typeface="Calibri" pitchFamily="34" charset="0"/>
+                          <a:ea typeface="Calibri" pitchFamily="34" charset="-122"/>
+                          <a:cs typeface="Calibri" pitchFamily="34" charset="-120"/>
+                        </a:rPr>
+                        <a:t>UC-5  cold start — all account ids brand new</a:t>
+                      </a:r>
+                      <a:endParaRPr lang="en-US" sz="1050" dirty="0">
+                        <a:latin typeface="Calibri" charset="0"/>
+                        <a:ea typeface="Calibri" charset="0"/>
+                        <a:cs typeface="Calibri" charset="0"/>
+                      </a:endParaRPr>
+                    </a:p>
+                  </a:txBody>
+                  <a:tcPr marL="91440" marR="91440" marT="45720" marB="45720" anchor="ctr">
+                    <a:lnL w="12700" cap="flat" cmpd="sng" algn="ctr">
+                      <a:solidFill>
+                        <a:srgbClr val="D8DEEC"/>
+                      </a:solidFill>
+                      <a:prstDash val="solid"/>
+                      <a:round/>
+                      <a:headEnd type="none" w="med" len="med"/>
+                      <a:tailEnd type="none" w="med" len="med"/>
+                    </a:lnL>
+                    <a:lnR w="12700" cap="flat" cmpd="sng" algn="ctr">
+                      <a:solidFill>
+                        <a:srgbClr val="D8DEEC"/>
+                      </a:solidFill>
+                      <a:prstDash val="solid"/>
+                      <a:round/>
+                      <a:headEnd type="none" w="med" len="med"/>
+                      <a:tailEnd type="none" w="med" len="med"/>
+                    </a:lnR>
+                    <a:lnT w="12700" cap="flat" cmpd="sng" algn="ctr">
+                      <a:solidFill>
+                        <a:srgbClr val="D8DEEC"/>
+                      </a:solidFill>
+                      <a:prstDash val="solid"/>
+                      <a:round/>
+                      <a:headEnd type="none" w="med" len="med"/>
+                      <a:tailEnd type="none" w="med" len="med"/>
+                    </a:lnT>
+                    <a:lnB w="12700" cap="flat" cmpd="sng" algn="ctr">
+                      <a:solidFill>
+                        <a:srgbClr val="D8DEEC"/>
+                      </a:solidFill>
+                      <a:prstDash val="solid"/>
+                      <a:round/>
+                      <a:headEnd type="none" w="med" len="med"/>
+                      <a:tailEnd type="none" w="med" len="med"/>
+                    </a:lnB>
+                  </a:tcPr>
+                </a:tc>
+                <a:tc>
+                  <a:txBody>
+                    <a:bodyPr/>
+                    <a:lstStyle/>
+                    <a:p>
+                      <a:pPr indent="0" marL="0">
+                        <a:buNone/>
+                      </a:pPr>
+                      <a:r>
+                        <a:rPr lang="en-US" sz="1050" dirty="0">
+                          <a:solidFill>
+                            <a:srgbClr val="1A1A2E"/>
+                          </a:solidFill>
+                          <a:latin typeface="Calibri" pitchFamily="34" charset="0"/>
+                          <a:ea typeface="Calibri" pitchFamily="34" charset="-122"/>
+                          <a:cs typeface="Calibri" pitchFamily="34" charset="-120"/>
+                        </a:rPr>
+                        <a:t>NEFT (0.001) · REPAIRED</a:t>
+                      </a:r>
+                      <a:endParaRPr lang="en-US" sz="1050" dirty="0">
+                        <a:latin typeface="Calibri" charset="0"/>
+                        <a:ea typeface="Calibri" charset="0"/>
+                        <a:cs typeface="Calibri" charset="0"/>
+                      </a:endParaRPr>
+                    </a:p>
+                  </a:txBody>
+                  <a:tcPr marL="91440" marR="91440" marT="45720" marB="45720" anchor="ctr">
+                    <a:lnL w="12700" cap="flat" cmpd="sng" algn="ctr">
+                      <a:solidFill>
+                        <a:srgbClr val="D8DEEC"/>
+                      </a:solidFill>
+                      <a:prstDash val="solid"/>
+                      <a:round/>
+                      <a:headEnd type="none" w="med" len="med"/>
+                      <a:tailEnd type="none" w="med" len="med"/>
+                    </a:lnL>
+                    <a:lnR w="12700" cap="flat" cmpd="sng" algn="ctr">
+                      <a:solidFill>
+                        <a:srgbClr val="D8DEEC"/>
+                      </a:solidFill>
+                      <a:prstDash val="solid"/>
+                      <a:round/>
+                      <a:headEnd type="none" w="med" len="med"/>
+                      <a:tailEnd type="none" w="med" len="med"/>
+                    </a:lnR>
+                    <a:lnT w="12700" cap="flat" cmpd="sng" algn="ctr">
+                      <a:solidFill>
+                        <a:srgbClr val="D8DEEC"/>
+                      </a:solidFill>
+                      <a:prstDash val="solid"/>
+                      <a:round/>
+                      <a:headEnd type="none" w="med" len="med"/>
+                      <a:tailEnd type="none" w="med" len="med"/>
+                    </a:lnT>
+                    <a:lnB w="12700" cap="flat" cmpd="sng" algn="ctr">
+                      <a:solidFill>
+                        <a:srgbClr val="D8DEEC"/>
+                      </a:solidFill>
+                      <a:prstDash val="solid"/>
+                      <a:round/>
+                      <a:headEnd type="none" w="med" len="med"/>
+                      <a:tailEnd type="none" w="med" len="med"/>
+                    </a:lnB>
+                  </a:tcPr>
+                </a:tc>
+                <a:tc>
+                  <a:txBody>
+                    <a:bodyPr/>
+                    <a:lstStyle/>
+                    <a:p>
+                      <a:pPr indent="0" marL="0">
+                        <a:buNone/>
+                      </a:pPr>
+                      <a:r>
+                        <a:rPr lang="en-US" sz="1050" b="1" dirty="0">
+                          <a:solidFill>
+                            <a:srgbClr val="C98A00"/>
+                          </a:solidFill>
+                          <a:latin typeface="Calibri" pitchFamily="34" charset="0"/>
+                          <a:ea typeface="Calibri" pitchFamily="34" charset="-122"/>
+                          <a:cs typeface="Calibri" pitchFamily="34" charset="-120"/>
+                        </a:rPr>
+                        <a:t>Confidence collapses to 0.001 — documented, gateway should distrust</a:t>
+                      </a:r>
+                      <a:endParaRPr lang="en-US" sz="1050" dirty="0">
+                        <a:latin typeface="Calibri" charset="0"/>
+                        <a:ea typeface="Calibri" charset="0"/>
+                        <a:cs typeface="Calibri" charset="0"/>
+                      </a:endParaRPr>
+                    </a:p>
+                  </a:txBody>
+                  <a:tcPr marL="91440" marR="91440" marT="45720" marB="45720" anchor="ctr">
+                    <a:lnL w="12700" cap="flat" cmpd="sng" algn="ctr">
+                      <a:solidFill>
+                        <a:srgbClr val="D8DEEC"/>
+                      </a:solidFill>
+                      <a:prstDash val="solid"/>
+                      <a:round/>
+                      <a:headEnd type="none" w="med" len="med"/>
+                      <a:tailEnd type="none" w="med" len="med"/>
+                    </a:lnL>
+                    <a:lnR w="12700" cap="flat" cmpd="sng" algn="ctr">
+                      <a:solidFill>
+                        <a:srgbClr val="D8DEEC"/>
+                      </a:solidFill>
+                      <a:prstDash val="solid"/>
+                      <a:round/>
+                      <a:headEnd type="none" w="med" len="med"/>
+                      <a:tailEnd type="none" w="med" len="med"/>
+                    </a:lnR>
+                    <a:lnT w="12700" cap="flat" cmpd="sng" algn="ctr">
+                      <a:solidFill>
+                        <a:srgbClr val="D8DEEC"/>
+                      </a:solidFill>
+                      <a:prstDash val="solid"/>
+                      <a:round/>
+                      <a:headEnd type="none" w="med" len="med"/>
+                      <a:tailEnd type="none" w="med" len="med"/>
+                    </a:lnT>
+                    <a:lnB w="12700" cap="flat" cmpd="sng" algn="ctr">
+                      <a:solidFill>
+                        <a:srgbClr val="D8DEEC"/>
+                      </a:solidFill>
+                      <a:prstDash val="solid"/>
+                      <a:round/>
+                      <a:headEnd type="none" w="med" len="med"/>
+                      <a:tailEnd type="none" w="med" len="med"/>
+                    </a:lnB>
+                  </a:tcPr>
+                </a:tc>
+              </a:tr>
+            </a:tbl>
+          </a:graphicData>
+        </a:graphic>
+      </p:graphicFrame>
+      <p:sp>
+        <p:nvSpPr>
+          <p:cNvPr id="5" name="Text 2"/>
+          <p:cNvSpPr/>
+          <p:nvPr/>
+        </p:nvSpPr>
+        <p:spPr>
+          <a:xfrm>
+            <a:off x="457200" y="6035040"/>
+            <a:ext cx="11274552" cy="365760"/>
+          </a:xfrm>
+          <a:prstGeom prst="rect">
+            <a:avLst/>
+          </a:prstGeom>
+          <a:noFill/>
+          <a:ln/>
+        </p:spPr>
+        <p:txBody>
+          <a:bodyPr wrap="square" rtlCol="0" anchor="ctr"/>
+          <a:lstStyle/>
+          <a:p>
+            <a:pPr indent="0" marL="0">
+              <a:buNone/>
+            </a:pPr>
+            <a:r>
+              <a:rPr lang="en-US" sz="1100" i="1" dirty="0">
+                <a:solidFill>
+                  <a:srgbClr val="5A6172"/>
+                </a:solidFill>
+                <a:latin typeface="Calibri" pitchFamily="34" charset="0"/>
+                <a:ea typeface="Calibri" pitchFamily="34" charset="-122"/>
+                <a:cs typeface="Calibri" pitchFamily="34" charset="-120"/>
+              </a:rPr>
+              <a:t>Full JSON: docs/annex_capture.json · paper Annexure A · regenerate against any bundle with the capture script.</a:t>
+            </a:r>
+            <a:endParaRPr lang="en-US" sz="1100" dirty="0"/>
+          </a:p>
+        </p:txBody>
+      </p:sp>
+    </p:spTree>
+  </p:cSld>
+  <p:clrMapOvr>
+    <a:masterClrMapping/>
+  </p:clrMapOvr>
+</p:sld>
+</file>
+
+<file path=ppt/slides/slide14.xml><?xml version="1.0" encoding="utf-8"?>
+<p:sld xmlns:a="http://schemas.openxmlformats.org/drawingml/2006/main" xmlns:r="http://schemas.openxmlformats.org/officeDocument/2006/relationships" xmlns:p="http://schemas.openxmlformats.org/presentationml/2006/main">
+  <p:cSld name="Slide 14">
+    <p:bg>
+      <p:bgPr>
+        <a:solidFill>
+          <a:srgbClr val="FFFFFF"/>
+        </a:solidFill>
+      </p:bgPr>
+    </p:bg>
+    <p:spTree>
+      <p:nvGrpSpPr>
+        <p:cNvPr id="1" name=""/>
+        <p:cNvGrpSpPr/>
+        <p:nvPr/>
+      </p:nvGrpSpPr>
+      <p:grpSpPr>
+        <a:xfrm>
+          <a:off x="0" y="0"/>
+          <a:ext cx="0" cy="0"/>
+          <a:chOff x="0" y="0"/>
+          <a:chExt cx="0" cy="0"/>
+        </a:xfrm>
+      </p:grpSpPr>
+      <p:sp>
+        <p:nvSpPr>
+          <p:cNvPr id="2" name="Text 0"/>
+          <p:cNvSpPr/>
+          <p:nvPr/>
+        </p:nvSpPr>
+        <p:spPr>
+          <a:xfrm>
+            <a:off x="548640" y="365760"/>
+            <a:ext cx="11064240" cy="594360"/>
+          </a:xfrm>
+          <a:prstGeom prst="rect">
+            <a:avLst/>
+          </a:prstGeom>
+          <a:noFill/>
+          <a:ln/>
+        </p:spPr>
+        <p:txBody>
+          <a:bodyPr wrap="square" rtlCol="0" anchor="ctr"/>
+          <a:lstStyle/>
+          <a:p>
+            <a:pPr indent="0" marL="0">
+              <a:buNone/>
+            </a:pPr>
+            <a:r>
+              <a:rPr lang="en-US" sz="3000" b="1" dirty="0">
+                <a:solidFill>
+                  <a:srgbClr val="1E2761"/>
+                </a:solidFill>
+                <a:latin typeface="Cambria" pitchFamily="34" charset="0"/>
+                <a:ea typeface="Cambria" pitchFamily="34" charset="-122"/>
+                <a:cs typeface="Cambria" pitchFamily="34" charset="-120"/>
+              </a:rPr>
+              <a:t>Annexure 2 — in-flight lifecycle &amp; explanations</a:t>
+            </a:r>
+            <a:endParaRPr lang="en-US" sz="3000" dirty="0"/>
+          </a:p>
+        </p:txBody>
+      </p:sp>
+      <p:sp>
+        <p:nvSpPr>
+          <p:cNvPr id="3" name="Text 1"/>
+          <p:cNvSpPr/>
+          <p:nvPr/>
+        </p:nvSpPr>
+        <p:spPr>
+          <a:xfrm>
+            <a:off x="566928" y="969264"/>
+            <a:ext cx="10972800" cy="365760"/>
+          </a:xfrm>
+          <a:prstGeom prst="rect">
+            <a:avLst/>
+          </a:prstGeom>
+          <a:noFill/>
+          <a:ln/>
+        </p:spPr>
+        <p:txBody>
+          <a:bodyPr wrap="square" rtlCol="0" anchor="ctr"/>
+          <a:lstStyle/>
+          <a:p>
+            <a:pPr indent="0" marL="0">
+              <a:buNone/>
+            </a:pPr>
+            <a:r>
+              <a:rPr lang="en-US" sz="1400" i="1" dirty="0">
+                <a:solidFill>
+                  <a:srgbClr val="5A6172"/>
+                </a:solidFill>
+                <a:latin typeface="Calibri" pitchFamily="34" charset="0"/>
+                <a:ea typeface="Calibri" pitchFamily="34" charset="-122"/>
+                <a:cs typeface="Calibri" pitchFamily="34" charset="-120"/>
+              </a:rPr>
+              <a:t>POST /score/inflight — the same payment object, scored as its message trail grows.</a:t>
+            </a:r>
+            <a:endParaRPr lang="en-US" sz="1400" dirty="0"/>
+          </a:p>
+        </p:txBody>
+      </p:sp>
+      <p:sp>
+        <p:nvSpPr>
+          <p:cNvPr id="4" name="Shape 2"/>
+          <p:cNvSpPr/>
+          <p:nvPr/>
+        </p:nvSpPr>
+        <p:spPr>
+          <a:xfrm>
+            <a:off x="548640" y="1645920"/>
+            <a:ext cx="5440680" cy="3017520"/>
+          </a:xfrm>
+          <a:prstGeom prst="roundRect">
+            <a:avLst>
+              <a:gd name="adj" fmla="val 2424"/>
+            </a:avLst>
+          </a:prstGeom>
+          <a:solidFill>
+            <a:srgbClr val="F2F5FC"/>
+          </a:solidFill>
+          <a:ln w="12700">
+            <a:solidFill>
+              <a:srgbClr val="CADCFC"/>
+            </a:solidFill>
+            <a:prstDash val="solid"/>
+          </a:ln>
+        </p:spPr>
+      </p:sp>
+      <p:sp>
+        <p:nvSpPr>
+          <p:cNvPr id="5" name="Text 3"/>
+          <p:cNvSpPr/>
+          <p:nvPr/>
+        </p:nvSpPr>
+        <p:spPr>
+          <a:xfrm>
+            <a:off x="777240" y="1783080"/>
+            <a:ext cx="5029200" cy="365760"/>
+          </a:xfrm>
+          <a:prstGeom prst="rect">
+            <a:avLst/>
+          </a:prstGeom>
+          <a:noFill/>
+          <a:ln/>
+        </p:spPr>
+        <p:txBody>
+          <a:bodyPr wrap="square" rtlCol="0" anchor="ctr"/>
+          <a:lstStyle/>
+          <a:p>
+            <a:pPr indent="0" marL="0">
+              <a:buNone/>
+            </a:pPr>
+            <a:r>
+              <a:rPr lang="en-US" sz="1500" b="1" dirty="0">
+                <a:solidFill>
+                  <a:srgbClr val="2E7D32"/>
+                </a:solidFill>
+                <a:latin typeface="Cambria" pitchFamily="34" charset="0"/>
+                <a:ea typeface="Cambria" pitchFamily="34" charset="-122"/>
+                <a:cs typeface="Cambria" pitchFamily="34" charset="-120"/>
+              </a:rPr>
+              <a:t>UC-7 · healthy, first message only</a:t>
+            </a:r>
+            <a:endParaRPr lang="en-US" sz="1500" dirty="0"/>
+          </a:p>
+        </p:txBody>
+      </p:sp>
+      <p:sp>
+        <p:nvSpPr>
+          <p:cNvPr id="6" name="Text 4"/>
+          <p:cNvSpPr/>
+          <p:nvPr/>
+        </p:nvSpPr>
+        <p:spPr>
+          <a:xfrm>
+            <a:off x="777240" y="2194560"/>
+            <a:ext cx="5029200" cy="365760"/>
+          </a:xfrm>
+          <a:prstGeom prst="rect">
+            <a:avLst/>
+          </a:prstGeom>
+          <a:noFill/>
+          <a:ln/>
+        </p:spPr>
+        <p:txBody>
+          <a:bodyPr wrap="square" rtlCol="0" anchor="ctr"/>
+          <a:lstStyle/>
+          <a:p>
+            <a:pPr indent="0" marL="0">
+              <a:buNone/>
+            </a:pPr>
+            <a:r>
+              <a:rPr lang="en-US" sz="950" dirty="0">
+                <a:solidFill>
+                  <a:srgbClr val="5A6172"/>
+                </a:solidFill>
+                <a:latin typeface="Courier New" pitchFamily="34" charset="0"/>
+                <a:ea typeface="Courier New" pitchFamily="34" charset="-122"/>
+                <a:cs typeface="Courier New" pitchFamily="34" charset="-120"/>
+              </a:rPr>
+              <a:t>pacs.008</a:t>
+            </a:r>
+            <a:endParaRPr lang="en-US" sz="950" dirty="0"/>
+          </a:p>
+        </p:txBody>
+      </p:sp>
+      <p:sp>
+        <p:nvSpPr>
+          <p:cNvPr id="7" name="Text 5"/>
+          <p:cNvSpPr/>
+          <p:nvPr/>
+        </p:nvSpPr>
+        <p:spPr>
+          <a:xfrm>
+            <a:off x="777240" y="2651760"/>
+            <a:ext cx="5029200" cy="1828800"/>
+          </a:xfrm>
+          <a:prstGeom prst="rect">
+            <a:avLst/>
+          </a:prstGeom>
+          <a:noFill/>
+          <a:ln/>
+        </p:spPr>
+        <p:txBody>
+          <a:bodyPr wrap="square" rtlCol="0" anchor="ctr"/>
+          <a:lstStyle/>
+          <a:p>
+            <a:pPr indent="0" marL="0">
+              <a:buNone/>
+            </a:pPr>
+            <a:r>
+              <a:rPr lang="en-US" sz="1300" b="1" dirty="0">
+                <a:solidFill>
+                  <a:srgbClr val="1E2761"/>
+                </a:solidFill>
+                <a:latin typeface="Calibri" pitchFamily="34" charset="0"/>
+                <a:ea typeface="Calibri" pitchFamily="34" charset="-122"/>
+                <a:cs typeface="Calibri" pitchFamily="34" charset="-120"/>
+              </a:rPr>
+              <a:t>booked 0.9571   </a:t>
+            </a:r>
+            <a:pPr indent="0" marL="0">
+              <a:buNone/>
+            </a:pPr>
+            <a:r>
+              <a:rPr lang="en-US" sz="1300" dirty="0">
+                <a:solidFill>
+                  <a:srgbClr val="1A1A2E"/>
+                </a:solidFill>
+                <a:latin typeface="Calibri" pitchFamily="34" charset="0"/>
+                <a:ea typeface="Calibri" pitchFamily="34" charset="-122"/>
+                <a:cs typeface="Calibri" pitchFamily="34" charset="-120"/>
+              </a:rPr>
+              <a:t>STP 0.7475 · REJ 0.0248
+</a:t>
+            </a:r>
+            <a:pPr indent="0" marL="0">
+              <a:buNone/>
+            </a:pPr>
+            <a:r>
+              <a:rPr lang="en-US" sz="1300" dirty="0">
+                <a:solidFill>
+                  <a:srgbClr val="1A1A2E"/>
+                </a:solidFill>
+                <a:latin typeface="Calibri" pitchFamily="34" charset="0"/>
+                <a:ea typeface="Calibri" pitchFamily="34" charset="-122"/>
+                <a:cs typeface="Calibri" pitchFamily="34" charset="-120"/>
+              </a:rPr>
+              <a:t>cancel 0.0259 · return 0.0063
+</a:t>
+            </a:r>
+            <a:pPr indent="0" marL="0">
+              <a:buNone/>
+            </a:pPr>
+            <a:r>
+              <a:rPr lang="en-US" sz="1300" dirty="0">
+                <a:solidFill>
+                  <a:srgbClr val="5A6172"/>
+                </a:solidFill>
+                <a:latin typeface="Calibri" pitchFamily="34" charset="0"/>
+                <a:ea typeface="Calibri" pitchFamily="34" charset="-122"/>
+                <a:cs typeface="Calibri" pitchFamily="34" charset="-120"/>
+              </a:rPr>
+              <a:t>if it fails: ED05 @ 0.5882</a:t>
+            </a:r>
+            <a:endParaRPr lang="en-US" sz="1300" dirty="0"/>
+          </a:p>
+        </p:txBody>
+      </p:sp>
+      <p:sp>
+        <p:nvSpPr>
+          <p:cNvPr id="8" name="Shape 6"/>
+          <p:cNvSpPr/>
+          <p:nvPr/>
+        </p:nvSpPr>
+        <p:spPr>
+          <a:xfrm>
+            <a:off x="6199632" y="1645920"/>
+            <a:ext cx="5440680" cy="3017520"/>
+          </a:xfrm>
+          <a:prstGeom prst="roundRect">
+            <a:avLst>
+              <a:gd name="adj" fmla="val 2424"/>
+            </a:avLst>
+          </a:prstGeom>
+          <a:solidFill>
+            <a:srgbClr val="F2F5FC"/>
+          </a:solidFill>
+          <a:ln w="12700">
+            <a:solidFill>
+              <a:srgbClr val="CADCFC"/>
+            </a:solidFill>
+            <a:prstDash val="solid"/>
+          </a:ln>
+        </p:spPr>
+      </p:sp>
+      <p:sp>
+        <p:nvSpPr>
+          <p:cNvPr id="9" name="Text 7"/>
+          <p:cNvSpPr/>
+          <p:nvPr/>
+        </p:nvSpPr>
+        <p:spPr>
+          <a:xfrm>
+            <a:off x="6428232" y="1783080"/>
+            <a:ext cx="5029200" cy="365760"/>
+          </a:xfrm>
+          <a:prstGeom prst="rect">
+            <a:avLst/>
+          </a:prstGeom>
+          <a:noFill/>
+          <a:ln/>
+        </p:spPr>
+        <p:txBody>
+          <a:bodyPr wrap="square" rtlCol="0" anchor="ctr"/>
+          <a:lstStyle/>
+          <a:p>
+            <a:pPr indent="0" marL="0">
+              <a:buNone/>
+            </a:pPr>
+            <a:r>
+              <a:rPr lang="en-US" sz="1500" b="1" dirty="0">
+                <a:solidFill>
+                  <a:srgbClr val="B3261E"/>
+                </a:solidFill>
+                <a:latin typeface="Cambria" pitchFamily="34" charset="0"/>
+                <a:ea typeface="Cambria" pitchFamily="34" charset="-122"/>
+                <a:cs typeface="Cambria" pitchFamily="34" charset="-120"/>
+              </a:rPr>
+              <a:t>UC-8 · recalled &amp; returned</a:t>
+            </a:r>
+            <a:endParaRPr lang="en-US" sz="1500" dirty="0"/>
+          </a:p>
+        </p:txBody>
+      </p:sp>
+      <p:sp>
+        <p:nvSpPr>
+          <p:cNvPr id="10" name="Text 8"/>
+          <p:cNvSpPr/>
+          <p:nvPr/>
+        </p:nvSpPr>
+        <p:spPr>
+          <a:xfrm>
+            <a:off x="6428232" y="2194560"/>
+            <a:ext cx="5029200" cy="365760"/>
+          </a:xfrm>
+          <a:prstGeom prst="rect">
+            <a:avLst/>
+          </a:prstGeom>
+          <a:noFill/>
+          <a:ln/>
+        </p:spPr>
+        <p:txBody>
+          <a:bodyPr wrap="square" rtlCol="0" anchor="ctr"/>
+          <a:lstStyle/>
+          <a:p>
+            <a:pPr indent="0" marL="0">
+              <a:buNone/>
+            </a:pPr>
+            <a:r>
+              <a:rPr lang="en-US" sz="950" dirty="0">
+                <a:solidFill>
+                  <a:srgbClr val="5A6172"/>
+                </a:solidFill>
+                <a:latin typeface="Courier New" pitchFamily="34" charset="0"/>
+                <a:ea typeface="Courier New" pitchFamily="34" charset="-122"/>
+                <a:cs typeface="Courier New" pitchFamily="34" charset="-120"/>
+              </a:rPr>
+              <a:t>pacs.008→pacs.002→camt.054→camt.056→camt.029→pacs.004</a:t>
+            </a:r>
+            <a:endParaRPr lang="en-US" sz="950" dirty="0"/>
+          </a:p>
+        </p:txBody>
+      </p:sp>
+      <p:sp>
+        <p:nvSpPr>
+          <p:cNvPr id="11" name="Text 9"/>
+          <p:cNvSpPr/>
+          <p:nvPr/>
+        </p:nvSpPr>
+        <p:spPr>
+          <a:xfrm>
+            <a:off x="6428232" y="2651760"/>
+            <a:ext cx="5029200" cy="1828800"/>
+          </a:xfrm>
+          <a:prstGeom prst="rect">
+            <a:avLst/>
+          </a:prstGeom>
+          <a:noFill/>
+          <a:ln/>
+        </p:spPr>
+        <p:txBody>
+          <a:bodyPr wrap="square" rtlCol="0" anchor="ctr"/>
+          <a:lstStyle/>
+          <a:p>
+            <a:pPr indent="0" marL="0">
+              <a:buNone/>
+            </a:pPr>
+            <a:r>
+              <a:rPr lang="en-US" sz="1300" b="1" dirty="0">
+                <a:solidFill>
+                  <a:srgbClr val="1E2761"/>
+                </a:solidFill>
+                <a:latin typeface="Calibri" pitchFamily="34" charset="0"/>
+                <a:ea typeface="Calibri" pitchFamily="34" charset="-122"/>
+                <a:cs typeface="Calibri" pitchFamily="34" charset="-120"/>
+              </a:rPr>
+              <a:t>booked 0.8522   </a:t>
+            </a:r>
+            <a:pPr indent="0" marL="0">
+              <a:buNone/>
+            </a:pPr>
+            <a:r>
+              <a:rPr lang="en-US" sz="1300" dirty="0">
+                <a:solidFill>
+                  <a:srgbClr val="1A1A2E"/>
+                </a:solidFill>
+                <a:latin typeface="Calibri" pitchFamily="34" charset="0"/>
+                <a:ea typeface="Calibri" pitchFamily="34" charset="-122"/>
+                <a:cs typeface="Calibri" pitchFamily="34" charset="-120"/>
+              </a:rPr>
+              <a:t>STP 0.808 · REJ 0.0575
+</a:t>
+            </a:r>
+            <a:pPr indent="0" marL="0">
+              <a:buNone/>
+            </a:pPr>
+            <a:r>
+              <a:rPr lang="en-US" sz="1300" dirty="0">
+                <a:solidFill>
+                  <a:srgbClr val="1A1A2E"/>
+                </a:solidFill>
+                <a:latin typeface="Calibri" pitchFamily="34" charset="0"/>
+                <a:ea typeface="Calibri" pitchFamily="34" charset="-122"/>
+                <a:cs typeface="Calibri" pitchFamily="34" charset="-120"/>
+              </a:rPr>
+              <a:t>cancel 0.044 · return 0.0625
+</a:t>
+            </a:r>
+            <a:pPr indent="0" marL="0">
+              <a:buNone/>
+            </a:pPr>
+            <a:r>
+              <a:rPr lang="en-US" sz="1300" dirty="0">
+                <a:solidFill>
+                  <a:srgbClr val="5A6172"/>
+                </a:solidFill>
+                <a:latin typeface="Calibri" pitchFamily="34" charset="0"/>
+                <a:ea typeface="Calibri" pitchFamily="34" charset="-122"/>
+                <a:cs typeface="Calibri" pitchFamily="34" charset="-120"/>
+              </a:rPr>
+              <a:t>if it fails: AC04 @ 0.9665</a:t>
+            </a:r>
+            <a:endParaRPr lang="en-US" sz="1300" dirty="0"/>
+          </a:p>
+        </p:txBody>
+      </p:sp>
+      <p:sp>
+        <p:nvSpPr>
+          <p:cNvPr id="12" name="Text 10"/>
+          <p:cNvSpPr/>
+          <p:nvPr/>
+        </p:nvSpPr>
+        <p:spPr>
+          <a:xfrm>
+            <a:off x="548640" y="4846320"/>
+            <a:ext cx="11064240" cy="457200"/>
+          </a:xfrm>
+          <a:prstGeom prst="rect">
+            <a:avLst/>
+          </a:prstGeom>
+          <a:noFill/>
+          <a:ln/>
+        </p:spPr>
+        <p:txBody>
+          <a:bodyPr wrap="square" rtlCol="0" anchor="ctr"/>
+          <a:lstStyle/>
+          <a:p>
+            <a:pPr indent="0" marL="0">
+              <a:buNone/>
+            </a:pPr>
+            <a:r>
+              <a:rPr lang="en-US" sz="1250" b="1" dirty="0">
+                <a:solidFill>
+                  <a:srgbClr val="1E2761"/>
+                </a:solidFill>
+                <a:latin typeface="Calibri" pitchFamily="34" charset="0"/>
+                <a:ea typeface="Calibri" pitchFamily="34" charset="-122"/>
+                <a:cs typeface="Calibri" pitchFamily="34" charset="-120"/>
+              </a:rPr>
+              <a:t>Return probability rises 10× (0.0063 → 0.0625) and the conditional reject reason snaps to AC04 (account closed) at 0.97 once the recall/return trail lands.</a:t>
+            </a:r>
+            <a:endParaRPr lang="en-US" sz="1250" dirty="0"/>
+          </a:p>
+        </p:txBody>
+      </p:sp>
+      <p:sp>
+        <p:nvSpPr>
+          <p:cNvPr id="13" name="Text 11"/>
+          <p:cNvSpPr/>
+          <p:nvPr/>
+        </p:nvSpPr>
+        <p:spPr>
+          <a:xfrm>
+            <a:off x="548640" y="5440680"/>
+            <a:ext cx="11064240" cy="548640"/>
+          </a:xfrm>
+          <a:prstGeom prst="rect">
+            <a:avLst/>
+          </a:prstGeom>
+          <a:noFill/>
+          <a:ln/>
+        </p:spPr>
+        <p:txBody>
+          <a:bodyPr wrap="square" rtlCol="0" anchor="ctr"/>
+          <a:lstStyle/>
+          <a:p>
+            <a:pPr indent="0" marL="0">
+              <a:buNone/>
+            </a:pPr>
+            <a:r>
+              <a:rPr lang="en-US" sz="1150" i="1" dirty="0">
+                <a:solidFill>
+                  <a:srgbClr val="5A6172"/>
+                </a:solidFill>
+                <a:latin typeface="Calibri" pitchFamily="34" charset="0"/>
+                <a:ea typeface="Calibri" pitchFamily="34" charset="-122"/>
+                <a:cs typeface="Calibri" pitchFamily="34" charset="-120"/>
+              </a:rPr>
+              <a:t>explain:true on UC-3 — occlusion drivers: identifier_type (risk +0.5831, rail +0.2905)  ·  Ccy (risk -0.2017, rail +0.4739)  ·  IntrBkSttlmAmt (risk +0.5572, rail -0.0059)</a:t>
+            </a:r>
+            <a:endParaRPr lang="en-US" sz="1150" dirty="0"/>
+          </a:p>
+        </p:txBody>
+      </p:sp>
+    </p:spTree>
+  </p:cSld>
+  <p:clrMapOvr>
+    <a:masterClrMapping/>
+  </p:clrMapOvr>
+</p:sld>
+</file>
+
+<file path=ppt/slides/slide15.xml><?xml version="1.0" encoding="utf-8"?>
+<p:sld xmlns:a="http://schemas.openxmlformats.org/drawingml/2006/main" xmlns:r="http://schemas.openxmlformats.org/officeDocument/2006/relationships" xmlns:p="http://schemas.openxmlformats.org/presentationml/2006/main">
+  <p:cSld name="Slide 15">
+    <p:bg>
+      <p:bgPr>
+        <a:solidFill>
+          <a:srgbClr val="FFFFFF"/>
+        </a:solidFill>
+      </p:bgPr>
+    </p:bg>
+    <p:spTree>
+      <p:nvGrpSpPr>
+        <p:cNvPr id="1" name=""/>
+        <p:cNvGrpSpPr/>
+        <p:nvPr/>
+      </p:nvGrpSpPr>
+      <p:grpSpPr>
+        <a:xfrm>
+          <a:off x="0" y="0"/>
+          <a:ext cx="0" cy="0"/>
+          <a:chOff x="0" y="0"/>
+          <a:chExt cx="0" cy="0"/>
+        </a:xfrm>
+      </p:grpSpPr>
+      <p:sp>
+        <p:nvSpPr>
+          <p:cNvPr id="2" name="Text 0"/>
+          <p:cNvSpPr/>
+          <p:nvPr/>
+        </p:nvSpPr>
+        <p:spPr>
+          <a:xfrm>
+            <a:off x="548640" y="365760"/>
+            <a:ext cx="11064240" cy="594360"/>
+          </a:xfrm>
+          <a:prstGeom prst="rect">
+            <a:avLst/>
+          </a:prstGeom>
+          <a:noFill/>
+          <a:ln/>
+        </p:spPr>
+        <p:txBody>
+          <a:bodyPr wrap="square" rtlCol="0" anchor="ctr"/>
+          <a:lstStyle/>
+          <a:p>
+            <a:pPr indent="0" marL="0">
+              <a:buNone/>
+            </a:pPr>
+            <a:r>
+              <a:rPr lang="en-US" sz="3000" b="1" dirty="0">
+                <a:solidFill>
+                  <a:srgbClr val="1E2761"/>
+                </a:solidFill>
+                <a:latin typeface="Cambria" pitchFamily="34" charset="0"/>
+                <a:ea typeface="Cambria" pitchFamily="34" charset="-122"/>
+                <a:cs typeface="Cambria" pitchFamily="34" charset="-120"/>
+              </a:rPr>
+              <a:t>Annexure 3 — behaviour &amp; treasury APIs</a:t>
+            </a:r>
+            <a:endParaRPr lang="en-US" sz="3000" dirty="0"/>
+          </a:p>
+        </p:txBody>
+      </p:sp>
+      <p:sp>
+        <p:nvSpPr>
+          <p:cNvPr id="3" name="Text 1"/>
+          <p:cNvSpPr/>
+          <p:nvPr/>
+        </p:nvSpPr>
+        <p:spPr>
+          <a:xfrm>
+            <a:off x="566928" y="969264"/>
+            <a:ext cx="10972800" cy="365760"/>
+          </a:xfrm>
+          <a:prstGeom prst="rect">
+            <a:avLst/>
+          </a:prstGeom>
+          <a:noFill/>
+          <a:ln/>
+        </p:spPr>
+        <p:txBody>
+          <a:bodyPr wrap="square" rtlCol="0" anchor="ctr"/>
+          <a:lstStyle/>
+          <a:p>
+            <a:pPr indent="0" marL="0">
+              <a:buNone/>
+            </a:pPr>
+            <a:r>
+              <a:rPr lang="en-US" sz="1400" i="1" dirty="0">
+                <a:solidFill>
+                  <a:srgbClr val="5A6172"/>
+                </a:solidFill>
+                <a:latin typeface="Calibri" pitchFamily="34" charset="0"/>
+                <a:ea typeface="Calibri" pitchFamily="34" charset="-122"/>
+                <a:cs typeface="Calibri" pitchFamily="34" charset="-120"/>
+              </a:rPr>
+              <a:t>Velocity, next-payment forecast, and the liquidity curve — engine sends history, PULSE returns calibrated numbers.</a:t>
+            </a:r>
+            <a:endParaRPr lang="en-US" sz="1400" dirty="0"/>
+          </a:p>
+        </p:txBody>
+      </p:sp>
+      <p:graphicFrame>
+        <p:nvGraphicFramePr>
+          <p:cNvPr id="16" name="Table 0"/>
+          <p:cNvGraphicFramePr>
+            <a:graphicFrameLocks noGrp="1"/>
+          </p:cNvGraphicFramePr>
+          <p:nvPr>
+            <p:extLst>
+              <p:ext uri="{D42A27DB-BD31-4B8C-83A1-F6EECF244321}">
+                <p14:modId xmlns:p14="http://schemas.microsoft.com/office/powerpoint/2010/main" val="1579011935"/>
+              </p:ext>
+            </p:extLst>
+          </p:nvPr>
+        </p:nvGraphicFramePr>
+        <p:xfrm>
+          <a:off x="457200" y="1737360"/>
+          <a:ext cx="11274552" cy="914400"/>
+        </p:xfrm>
+        <a:graphic>
+          <a:graphicData uri="http://schemas.openxmlformats.org/drawingml/2006/table">
+            <a:tbl>
+              <a:tblPr/>
+              <a:tblGrid>
+                <a:gridCol w="2377440"/>
+                <a:gridCol w="3566160"/>
+                <a:gridCol w="5330952"/>
+              </a:tblGrid>
+              <a:tr h="868680">
+                <a:tc>
+                  <a:txBody>
+                    <a:bodyPr/>
+                    <a:lstStyle/>
+                    <a:p>
+                      <a:pPr indent="0" marL="0">
+                        <a:buNone/>
+                      </a:pPr>
+                      <a:r>
+                        <a:rPr lang="en-US" sz="1050" b="1" dirty="0">
+                          <a:solidFill>
+                            <a:srgbClr val="FFFFFF"/>
+                          </a:solidFill>
+                          <a:latin typeface="Calibri" pitchFamily="34" charset="0"/>
+                          <a:ea typeface="Calibri" pitchFamily="34" charset="-122"/>
+                          <a:cs typeface="Calibri" pitchFamily="34" charset="-120"/>
+                        </a:rPr>
+                        <a:t>Endpoint</a:t>
+                      </a:r>
+                      <a:endParaRPr lang="en-US" sz="1050" dirty="0">
+                        <a:latin typeface="Calibri" charset="0"/>
+                        <a:ea typeface="Calibri" charset="0"/>
+                        <a:cs typeface="Calibri" charset="0"/>
+                      </a:endParaRPr>
+                    </a:p>
+                  </a:txBody>
+                  <a:tcPr marL="91440" marR="91440" marT="45720" marB="45720" anchor="ctr">
+                    <a:lnL w="12700" cap="flat" cmpd="sng" algn="ctr">
+                      <a:solidFill>
+                        <a:srgbClr val="D8DEEC"/>
+                      </a:solidFill>
+                      <a:prstDash val="solid"/>
+                      <a:round/>
+                      <a:headEnd type="none" w="med" len="med"/>
+                      <a:tailEnd type="none" w="med" len="med"/>
+                    </a:lnL>
+                    <a:lnR w="12700" cap="flat" cmpd="sng" algn="ctr">
+                      <a:solidFill>
+                        <a:srgbClr val="D8DEEC"/>
+                      </a:solidFill>
+                      <a:prstDash val="solid"/>
+                      <a:round/>
+                      <a:headEnd type="none" w="med" len="med"/>
+                      <a:tailEnd type="none" w="med" len="med"/>
+                    </a:lnR>
+                    <a:lnT w="12700" cap="flat" cmpd="sng" algn="ctr">
+                      <a:solidFill>
+                        <a:srgbClr val="D8DEEC"/>
+                      </a:solidFill>
+                      <a:prstDash val="solid"/>
+                      <a:round/>
+                      <a:headEnd type="none" w="med" len="med"/>
+                      <a:tailEnd type="none" w="med" len="med"/>
+                    </a:lnT>
+                    <a:lnB w="12700" cap="flat" cmpd="sng" algn="ctr">
+                      <a:solidFill>
+                        <a:srgbClr val="D8DEEC"/>
+                      </a:solidFill>
+                      <a:prstDash val="solid"/>
+                      <a:round/>
+                      <a:headEnd type="none" w="med" len="med"/>
+                      <a:tailEnd type="none" w="med" len="med"/>
+                    </a:lnB>
+                    <a:solidFill>
+                      <a:srgbClr val="1E2761"/>
+                    </a:solidFill>
+                  </a:tcPr>
+                </a:tc>
+                <a:tc>
+                  <a:txBody>
+                    <a:bodyPr/>
+                    <a:lstStyle/>
+                    <a:p>
+                      <a:pPr indent="0" marL="0">
+                        <a:buNone/>
+                      </a:pPr>
+                      <a:r>
+                        <a:rPr lang="en-US" sz="1050" b="1" dirty="0">
+                          <a:solidFill>
+                            <a:srgbClr val="FFFFFF"/>
+                          </a:solidFill>
+                          <a:latin typeface="Calibri" pitchFamily="34" charset="0"/>
+                          <a:ea typeface="Calibri" pitchFamily="34" charset="-122"/>
+                          <a:cs typeface="Calibri" pitchFamily="34" charset="-120"/>
+                        </a:rPr>
+                        <a:t>Sent</a:t>
+                      </a:r>
+                      <a:endParaRPr lang="en-US" sz="1050" dirty="0">
+                        <a:latin typeface="Calibri" charset="0"/>
+                        <a:ea typeface="Calibri" charset="0"/>
+                        <a:cs typeface="Calibri" charset="0"/>
+                      </a:endParaRPr>
+                    </a:p>
+                  </a:txBody>
+                  <a:tcPr marL="91440" marR="91440" marT="45720" marB="45720" anchor="ctr">
+                    <a:lnL w="12700" cap="flat" cmpd="sng" algn="ctr">
+                      <a:solidFill>
+                        <a:srgbClr val="D8DEEC"/>
+                      </a:solidFill>
+                      <a:prstDash val="solid"/>
+                      <a:round/>
+                      <a:headEnd type="none" w="med" len="med"/>
+                      <a:tailEnd type="none" w="med" len="med"/>
+                    </a:lnL>
+                    <a:lnR w="12700" cap="flat" cmpd="sng" algn="ctr">
+                      <a:solidFill>
+                        <a:srgbClr val="D8DEEC"/>
+                      </a:solidFill>
+                      <a:prstDash val="solid"/>
+                      <a:round/>
+                      <a:headEnd type="none" w="med" len="med"/>
+                      <a:tailEnd type="none" w="med" len="med"/>
+                    </a:lnR>
+                    <a:lnT w="12700" cap="flat" cmpd="sng" algn="ctr">
+                      <a:solidFill>
+                        <a:srgbClr val="D8DEEC"/>
+                      </a:solidFill>
+                      <a:prstDash val="solid"/>
+                      <a:round/>
+                      <a:headEnd type="none" w="med" len="med"/>
+                      <a:tailEnd type="none" w="med" len="med"/>
+                    </a:lnT>
+                    <a:lnB w="12700" cap="flat" cmpd="sng" algn="ctr">
+                      <a:solidFill>
+                        <a:srgbClr val="D8DEEC"/>
+                      </a:solidFill>
+                      <a:prstDash val="solid"/>
+                      <a:round/>
+                      <a:headEnd type="none" w="med" len="med"/>
+                      <a:tailEnd type="none" w="med" len="med"/>
+                    </a:lnB>
+                    <a:solidFill>
+                      <a:srgbClr val="1E2761"/>
+                    </a:solidFill>
+                  </a:tcPr>
+                </a:tc>
+                <a:tc>
+                  <a:txBody>
+                    <a:bodyPr/>
+                    <a:lstStyle/>
+                    <a:p>
+                      <a:pPr indent="0" marL="0">
+                        <a:buNone/>
+                      </a:pPr>
+                      <a:r>
+                        <a:rPr lang="en-US" sz="1050" b="1" dirty="0">
+                          <a:solidFill>
+                            <a:srgbClr val="FFFFFF"/>
+                          </a:solidFill>
+                          <a:latin typeface="Calibri" pitchFamily="34" charset="0"/>
+                          <a:ea typeface="Calibri" pitchFamily="34" charset="-122"/>
+                          <a:cs typeface="Calibri" pitchFamily="34" charset="-120"/>
+                        </a:rPr>
+                        <a:t>Returned</a:t>
+                      </a:r>
+                      <a:endParaRPr lang="en-US" sz="1050" dirty="0">
+                        <a:latin typeface="Calibri" charset="0"/>
+                        <a:ea typeface="Calibri" charset="0"/>
+                        <a:cs typeface="Calibri" charset="0"/>
+                      </a:endParaRPr>
+                    </a:p>
+                  </a:txBody>
+                  <a:tcPr marL="91440" marR="91440" marT="45720" marB="45720" anchor="ctr">
+                    <a:lnL w="12700" cap="flat" cmpd="sng" algn="ctr">
+                      <a:solidFill>
+                        <a:srgbClr val="D8DEEC"/>
+                      </a:solidFill>
+                      <a:prstDash val="solid"/>
+                      <a:round/>
+                      <a:headEnd type="none" w="med" len="med"/>
+                      <a:tailEnd type="none" w="med" len="med"/>
+                    </a:lnL>
+                    <a:lnR w="12700" cap="flat" cmpd="sng" algn="ctr">
+                      <a:solidFill>
+                        <a:srgbClr val="D8DEEC"/>
+                      </a:solidFill>
+                      <a:prstDash val="solid"/>
+                      <a:round/>
+                      <a:headEnd type="none" w="med" len="med"/>
+                      <a:tailEnd type="none" w="med" len="med"/>
+                    </a:lnR>
+                    <a:lnT w="12700" cap="flat" cmpd="sng" algn="ctr">
+                      <a:solidFill>
+                        <a:srgbClr val="D8DEEC"/>
+                      </a:solidFill>
+                      <a:prstDash val="solid"/>
+                      <a:round/>
+                      <a:headEnd type="none" w="med" len="med"/>
+                      <a:tailEnd type="none" w="med" len="med"/>
+                    </a:lnT>
+                    <a:lnB w="12700" cap="flat" cmpd="sng" algn="ctr">
+                      <a:solidFill>
+                        <a:srgbClr val="D8DEEC"/>
+                      </a:solidFill>
+                      <a:prstDash val="solid"/>
+                      <a:round/>
+                      <a:headEnd type="none" w="med" len="med"/>
+                      <a:tailEnd type="none" w="med" len="med"/>
+                    </a:lnB>
+                    <a:solidFill>
+                      <a:srgbClr val="1E2761"/>
+                    </a:solidFill>
+                  </a:tcPr>
+                </a:tc>
+              </a:tr>
+              <a:tr h="868680">
+                <a:tc>
+                  <a:txBody>
+                    <a:bodyPr/>
+                    <a:lstStyle/>
+                    <a:p>
+                      <a:pPr indent="0" marL="0">
+                        <a:buNone/>
+                      </a:pPr>
+                      <a:r>
+                        <a:rPr lang="en-US" sz="1050" dirty="0">
+                          <a:solidFill>
+                            <a:srgbClr val="1A1A2E"/>
+                          </a:solidFill>
+                          <a:latin typeface="Calibri" pitchFamily="34" charset="0"/>
+                          <a:ea typeface="Calibri" pitchFamily="34" charset="-122"/>
+                          <a:cs typeface="Calibri" pitchFamily="34" charset="-120"/>
+                        </a:rPr>
+                        <a:t>POST /score/velocity</a:t>
+                      </a:r>
+                      <a:endParaRPr lang="en-US" sz="1050" dirty="0">
+                        <a:latin typeface="Calibri" charset="0"/>
+                        <a:ea typeface="Calibri" charset="0"/>
+                        <a:cs typeface="Calibri" charset="0"/>
+                      </a:endParaRPr>
+                    </a:p>
+                  </a:txBody>
+                  <a:tcPr marL="91440" marR="91440" marT="45720" marB="45720" anchor="ctr">
+                    <a:lnL w="12700" cap="flat" cmpd="sng" algn="ctr">
+                      <a:solidFill>
+                        <a:srgbClr val="D8DEEC"/>
+                      </a:solidFill>
+                      <a:prstDash val="solid"/>
+                      <a:round/>
+                      <a:headEnd type="none" w="med" len="med"/>
+                      <a:tailEnd type="none" w="med" len="med"/>
+                    </a:lnL>
+                    <a:lnR w="12700" cap="flat" cmpd="sng" algn="ctr">
+                      <a:solidFill>
+                        <a:srgbClr val="D8DEEC"/>
+                      </a:solidFill>
+                      <a:prstDash val="solid"/>
+                      <a:round/>
+                      <a:headEnd type="none" w="med" len="med"/>
+                      <a:tailEnd type="none" w="med" len="med"/>
+                    </a:lnR>
+                    <a:lnT w="12700" cap="flat" cmpd="sng" algn="ctr">
+                      <a:solidFill>
+                        <a:srgbClr val="D8DEEC"/>
+                      </a:solidFill>
+                      <a:prstDash val="solid"/>
+                      <a:round/>
+                      <a:headEnd type="none" w="med" len="med"/>
+                      <a:tailEnd type="none" w="med" len="med"/>
+                    </a:lnT>
+                    <a:lnB w="12700" cap="flat" cmpd="sng" algn="ctr">
+                      <a:solidFill>
+                        <a:srgbClr val="D8DEEC"/>
+                      </a:solidFill>
+                      <a:prstDash val="solid"/>
+                      <a:round/>
+                      <a:headEnd type="none" w="med" len="med"/>
+                      <a:tailEnd type="none" w="med" len="med"/>
+                    </a:lnB>
+                  </a:tcPr>
+                </a:tc>
+                <a:tc>
+                  <a:txBody>
+                    <a:bodyPr/>
+                    <a:lstStyle/>
+                    <a:p>
+                      <a:pPr indent="0" marL="0">
+                        <a:buNone/>
+                      </a:pPr>
+                      <a:r>
+                        <a:rPr lang="en-US" sz="1050" dirty="0">
+                          <a:solidFill>
+                            <a:srgbClr val="1A1A2E"/>
+                          </a:solidFill>
+                          <a:latin typeface="Calibri" pitchFamily="34" charset="0"/>
+                          <a:ea typeface="Calibri" pitchFamily="34" charset="-122"/>
+                          <a:cs typeface="Calibri" pitchFamily="34" charset="-120"/>
+                        </a:rPr>
+                        <a:t>two account histories (6 txns each)</a:t>
+                      </a:r>
+                      <a:endParaRPr lang="en-US" sz="1050" dirty="0">
+                        <a:latin typeface="Calibri" charset="0"/>
+                        <a:ea typeface="Calibri" charset="0"/>
+                        <a:cs typeface="Calibri" charset="0"/>
+                      </a:endParaRPr>
+                    </a:p>
+                  </a:txBody>
+                  <a:tcPr marL="91440" marR="91440" marT="45720" marB="45720" anchor="ctr">
+                    <a:lnL w="12700" cap="flat" cmpd="sng" algn="ctr">
+                      <a:solidFill>
+                        <a:srgbClr val="D8DEEC"/>
+                      </a:solidFill>
+                      <a:prstDash val="solid"/>
+                      <a:round/>
+                      <a:headEnd type="none" w="med" len="med"/>
+                      <a:tailEnd type="none" w="med" len="med"/>
+                    </a:lnL>
+                    <a:lnR w="12700" cap="flat" cmpd="sng" algn="ctr">
+                      <a:solidFill>
+                        <a:srgbClr val="D8DEEC"/>
+                      </a:solidFill>
+                      <a:prstDash val="solid"/>
+                      <a:round/>
+                      <a:headEnd type="none" w="med" len="med"/>
+                      <a:tailEnd type="none" w="med" len="med"/>
+                    </a:lnR>
+                    <a:lnT w="12700" cap="flat" cmpd="sng" algn="ctr">
+                      <a:solidFill>
+                        <a:srgbClr val="D8DEEC"/>
+                      </a:solidFill>
+                      <a:prstDash val="solid"/>
+                      <a:round/>
+                      <a:headEnd type="none" w="med" len="med"/>
+                      <a:tailEnd type="none" w="med" len="med"/>
+                    </a:lnT>
+                    <a:lnB w="12700" cap="flat" cmpd="sng" algn="ctr">
+                      <a:solidFill>
+                        <a:srgbClr val="D8DEEC"/>
+                      </a:solidFill>
+                      <a:prstDash val="solid"/>
+                      <a:round/>
+                      <a:headEnd type="none" w="med" len="med"/>
+                      <a:tailEnd type="none" w="med" len="med"/>
+                    </a:lnB>
+                  </a:tcPr>
+                </a:tc>
+                <a:tc>
+                  <a:txBody>
+                    <a:bodyPr/>
+                    <a:lstStyle/>
+                    <a:p>
+                      <a:pPr indent="0" marL="0">
+                        <a:buNone/>
+                      </a:pPr>
+                      <a:r>
+                        <a:rPr lang="en-US" sz="1050" dirty="0">
+                          <a:solidFill>
+                            <a:srgbClr val="1A1A2E"/>
+                          </a:solidFill>
+                          <a:latin typeface="Calibri" pitchFamily="34" charset="0"/>
+                          <a:ea typeface="Calibri" pitchFamily="34" charset="-122"/>
+                          <a:cs typeface="Calibri" pitchFamily="34" charset="-120"/>
+                        </a:rPr>
+                        <a:t>bursting acct 1RR9184S: burst_proba 0.5 · quiet acct: 0</a:t>
+                      </a:r>
+                      <a:endParaRPr lang="en-US" sz="1050" dirty="0">
+                        <a:latin typeface="Calibri" charset="0"/>
+                        <a:ea typeface="Calibri" charset="0"/>
+                        <a:cs typeface="Calibri" charset="0"/>
+                      </a:endParaRPr>
+                    </a:p>
+                  </a:txBody>
+                  <a:tcPr marL="91440" marR="91440" marT="45720" marB="45720" anchor="ctr">
+                    <a:lnL w="12700" cap="flat" cmpd="sng" algn="ctr">
+                      <a:solidFill>
+                        <a:srgbClr val="D8DEEC"/>
+                      </a:solidFill>
+                      <a:prstDash val="solid"/>
+                      <a:round/>
+                      <a:headEnd type="none" w="med" len="med"/>
+                      <a:tailEnd type="none" w="med" len="med"/>
+                    </a:lnL>
+                    <a:lnR w="12700" cap="flat" cmpd="sng" algn="ctr">
+                      <a:solidFill>
+                        <a:srgbClr val="D8DEEC"/>
+                      </a:solidFill>
+                      <a:prstDash val="solid"/>
+                      <a:round/>
+                      <a:headEnd type="none" w="med" len="med"/>
+                      <a:tailEnd type="none" w="med" len="med"/>
+                    </a:lnR>
+                    <a:lnT w="12700" cap="flat" cmpd="sng" algn="ctr">
+                      <a:solidFill>
+                        <a:srgbClr val="D8DEEC"/>
+                      </a:solidFill>
+                      <a:prstDash val="solid"/>
+                      <a:round/>
+                      <a:headEnd type="none" w="med" len="med"/>
+                      <a:tailEnd type="none" w="med" len="med"/>
+                    </a:lnT>
+                    <a:lnB w="12700" cap="flat" cmpd="sng" algn="ctr">
+                      <a:solidFill>
+                        <a:srgbClr val="D8DEEC"/>
+                      </a:solidFill>
+                      <a:prstDash val="solid"/>
+                      <a:round/>
+                      <a:headEnd type="none" w="med" len="med"/>
+                      <a:tailEnd type="none" w="med" len="med"/>
+                    </a:lnB>
+                  </a:tcPr>
+                </a:tc>
+              </a:tr>
+              <a:tr h="868680">
+                <a:tc>
+                  <a:txBody>
+                    <a:bodyPr/>
+                    <a:lstStyle/>
+                    <a:p>
+                      <a:pPr indent="0" marL="0">
+                        <a:buNone/>
+                      </a:pPr>
+                      <a:r>
+                        <a:rPr lang="en-US" sz="1050" dirty="0">
+                          <a:solidFill>
+                            <a:srgbClr val="1A1A2E"/>
+                          </a:solidFill>
+                          <a:latin typeface="Calibri" pitchFamily="34" charset="0"/>
+                          <a:ea typeface="Calibri" pitchFamily="34" charset="-122"/>
+                          <a:cs typeface="Calibri" pitchFamily="34" charset="-120"/>
+                        </a:rPr>
+                        <a:t>POST /forecast/next</a:t>
+                      </a:r>
+                      <a:endParaRPr lang="en-US" sz="1050" dirty="0">
+                        <a:latin typeface="Calibri" charset="0"/>
+                        <a:ea typeface="Calibri" charset="0"/>
+                        <a:cs typeface="Calibri" charset="0"/>
+                      </a:endParaRPr>
+                    </a:p>
+                  </a:txBody>
+                  <a:tcPr marL="91440" marR="91440" marT="45720" marB="45720" anchor="ctr">
+                    <a:lnL w="12700" cap="flat" cmpd="sng" algn="ctr">
+                      <a:solidFill>
+                        <a:srgbClr val="D8DEEC"/>
+                      </a:solidFill>
+                      <a:prstDash val="solid"/>
+                      <a:round/>
+                      <a:headEnd type="none" w="med" len="med"/>
+                      <a:tailEnd type="none" w="med" len="med"/>
+                    </a:lnL>
+                    <a:lnR w="12700" cap="flat" cmpd="sng" algn="ctr">
+                      <a:solidFill>
+                        <a:srgbClr val="D8DEEC"/>
+                      </a:solidFill>
+                      <a:prstDash val="solid"/>
+                      <a:round/>
+                      <a:headEnd type="none" w="med" len="med"/>
+                      <a:tailEnd type="none" w="med" len="med"/>
+                    </a:lnR>
+                    <a:lnT w="12700" cap="flat" cmpd="sng" algn="ctr">
+                      <a:solidFill>
+                        <a:srgbClr val="D8DEEC"/>
+                      </a:solidFill>
+                      <a:prstDash val="solid"/>
+                      <a:round/>
+                      <a:headEnd type="none" w="med" len="med"/>
+                      <a:tailEnd type="none" w="med" len="med"/>
+                    </a:lnT>
+                    <a:lnB w="12700" cap="flat" cmpd="sng" algn="ctr">
+                      <a:solidFill>
+                        <a:srgbClr val="D8DEEC"/>
+                      </a:solidFill>
+                      <a:prstDash val="solid"/>
+                      <a:round/>
+                      <a:headEnd type="none" w="med" len="med"/>
+                      <a:tailEnd type="none" w="med" len="med"/>
+                    </a:lnB>
+                  </a:tcPr>
+                </a:tc>
+                <a:tc>
+                  <a:txBody>
+                    <a:bodyPr/>
+                    <a:lstStyle/>
+                    <a:p>
+                      <a:pPr indent="0" marL="0">
+                        <a:buNone/>
+                      </a:pPr>
+                      <a:r>
+                        <a:rPr lang="en-US" sz="1050" dirty="0">
+                          <a:solidFill>
+                            <a:srgbClr val="1A1A2E"/>
+                          </a:solidFill>
+                          <a:latin typeface="Calibri" pitchFamily="34" charset="0"/>
+                          <a:ea typeface="Calibri" pitchFamily="34" charset="-122"/>
+                          <a:cs typeface="Calibri" pitchFamily="34" charset="-120"/>
+                        </a:rPr>
+                        <a:t>salaried customer (20 payments) + irregular (12)</a:t>
+                      </a:r>
+                      <a:endParaRPr lang="en-US" sz="1050" dirty="0">
+                        <a:latin typeface="Calibri" charset="0"/>
+                        <a:ea typeface="Calibri" charset="0"/>
+                        <a:cs typeface="Calibri" charset="0"/>
+                      </a:endParaRPr>
+                    </a:p>
+                  </a:txBody>
+                  <a:tcPr marL="91440" marR="91440" marT="45720" marB="45720" anchor="ctr">
+                    <a:lnL w="12700" cap="flat" cmpd="sng" algn="ctr">
+                      <a:solidFill>
+                        <a:srgbClr val="D8DEEC"/>
+                      </a:solidFill>
+                      <a:prstDash val="solid"/>
+                      <a:round/>
+                      <a:headEnd type="none" w="med" len="med"/>
+                      <a:tailEnd type="none" w="med" len="med"/>
+                    </a:lnL>
+                    <a:lnR w="12700" cap="flat" cmpd="sng" algn="ctr">
+                      <a:solidFill>
+                        <a:srgbClr val="D8DEEC"/>
+                      </a:solidFill>
+                      <a:prstDash val="solid"/>
+                      <a:round/>
+                      <a:headEnd type="none" w="med" len="med"/>
+                      <a:tailEnd type="none" w="med" len="med"/>
+                    </a:lnR>
+                    <a:lnT w="12700" cap="flat" cmpd="sng" algn="ctr">
+                      <a:solidFill>
+                        <a:srgbClr val="D8DEEC"/>
+                      </a:solidFill>
+                      <a:prstDash val="solid"/>
+                      <a:round/>
+                      <a:headEnd type="none" w="med" len="med"/>
+                      <a:tailEnd type="none" w="med" len="med"/>
+                    </a:lnT>
+                    <a:lnB w="12700" cap="flat" cmpd="sng" algn="ctr">
+                      <a:solidFill>
+                        <a:srgbClr val="D8DEEC"/>
+                      </a:solidFill>
+                      <a:prstDash val="solid"/>
+                      <a:round/>
+                      <a:headEnd type="none" w="med" len="med"/>
+                      <a:tailEnd type="none" w="med" len="med"/>
+                    </a:lnB>
+                  </a:tcPr>
+                </a:tc>
+                <a:tc>
+                  <a:txBody>
+                    <a:bodyPr/>
+                    <a:lstStyle/>
+                    <a:p>
+                      <a:pPr indent="0" marL="0">
+                        <a:buNone/>
+                      </a:pPr>
+                      <a:r>
+                        <a:rPr lang="en-US" sz="1050" dirty="0">
+                          <a:solidFill>
+                            <a:srgbClr val="1A1A2E"/>
+                          </a:solidFill>
+                          <a:latin typeface="Calibri" pitchFamily="34" charset="0"/>
+                          <a:ea typeface="Calibri" pitchFamily="34" charset="-122"/>
+                          <a:cs typeface="Calibri" pitchFamily="34" charset="-120"/>
+                        </a:rPr>
+                        <a:t>salary: P(next≤35d) 0.75, gap 9.9d · irregular: 0.6103, gap 26.1d</a:t>
+                      </a:r>
+                      <a:endParaRPr lang="en-US" sz="1050" dirty="0">
+                        <a:latin typeface="Calibri" charset="0"/>
+                        <a:ea typeface="Calibri" charset="0"/>
+                        <a:cs typeface="Calibri" charset="0"/>
+                      </a:endParaRPr>
+                    </a:p>
+                  </a:txBody>
+                  <a:tcPr marL="91440" marR="91440" marT="45720" marB="45720" anchor="ctr">
+                    <a:lnL w="12700" cap="flat" cmpd="sng" algn="ctr">
+                      <a:solidFill>
+                        <a:srgbClr val="D8DEEC"/>
+                      </a:solidFill>
+                      <a:prstDash val="solid"/>
+                      <a:round/>
+                      <a:headEnd type="none" w="med" len="med"/>
+                      <a:tailEnd type="none" w="med" len="med"/>
+                    </a:lnL>
+                    <a:lnR w="12700" cap="flat" cmpd="sng" algn="ctr">
+                      <a:solidFill>
+                        <a:srgbClr val="D8DEEC"/>
+                      </a:solidFill>
+                      <a:prstDash val="solid"/>
+                      <a:round/>
+                      <a:headEnd type="none" w="med" len="med"/>
+                      <a:tailEnd type="none" w="med" len="med"/>
+                    </a:lnR>
+                    <a:lnT w="12700" cap="flat" cmpd="sng" algn="ctr">
+                      <a:solidFill>
+                        <a:srgbClr val="D8DEEC"/>
+                      </a:solidFill>
+                      <a:prstDash val="solid"/>
+                      <a:round/>
+                      <a:headEnd type="none" w="med" len="med"/>
+                      <a:tailEnd type="none" w="med" len="med"/>
+                    </a:lnT>
+                    <a:lnB w="12700" cap="flat" cmpd="sng" algn="ctr">
+                      <a:solidFill>
+                        <a:srgbClr val="D8DEEC"/>
+                      </a:solidFill>
+                      <a:prstDash val="solid"/>
+                      <a:round/>
+                      <a:headEnd type="none" w="med" len="med"/>
+                      <a:tailEnd type="none" w="med" len="med"/>
+                    </a:lnB>
+                  </a:tcPr>
+                </a:tc>
+              </a:tr>
+              <a:tr h="868680">
+                <a:tc>
+                  <a:txBody>
+                    <a:bodyPr/>
+                    <a:lstStyle/>
+                    <a:p>
+                      <a:pPr indent="0" marL="0">
+                        <a:buNone/>
+                      </a:pPr>
+                      <a:r>
+                        <a:rPr lang="en-US" sz="1050" dirty="0">
+                          <a:solidFill>
+                            <a:srgbClr val="1A1A2E"/>
+                          </a:solidFill>
+                          <a:latin typeface="Calibri" pitchFamily="34" charset="0"/>
+                          <a:ea typeface="Calibri" pitchFamily="34" charset="-122"/>
+                          <a:cs typeface="Calibri" pitchFamily="34" charset="-120"/>
+                        </a:rPr>
+                        <a:t>POST /forecast/liquidity</a:t>
+                      </a:r>
+                      <a:endParaRPr lang="en-US" sz="1050" dirty="0">
+                        <a:latin typeface="Calibri" charset="0"/>
+                        <a:ea typeface="Calibri" charset="0"/>
+                        <a:cs typeface="Calibri" charset="0"/>
+                      </a:endParaRPr>
+                    </a:p>
+                  </a:txBody>
+                  <a:tcPr marL="91440" marR="91440" marT="45720" marB="45720" anchor="ctr">
+                    <a:lnL w="12700" cap="flat" cmpd="sng" algn="ctr">
+                      <a:solidFill>
+                        <a:srgbClr val="D8DEEC"/>
+                      </a:solidFill>
+                      <a:prstDash val="solid"/>
+                      <a:round/>
+                      <a:headEnd type="none" w="med" len="med"/>
+                      <a:tailEnd type="none" w="med" len="med"/>
+                    </a:lnL>
+                    <a:lnR w="12700" cap="flat" cmpd="sng" algn="ctr">
+                      <a:solidFill>
+                        <a:srgbClr val="D8DEEC"/>
+                      </a:solidFill>
+                      <a:prstDash val="solid"/>
+                      <a:round/>
+                      <a:headEnd type="none" w="med" len="med"/>
+                      <a:tailEnd type="none" w="med" len="med"/>
+                    </a:lnR>
+                    <a:lnT w="12700" cap="flat" cmpd="sng" algn="ctr">
+                      <a:solidFill>
+                        <a:srgbClr val="D8DEEC"/>
+                      </a:solidFill>
+                      <a:prstDash val="solid"/>
+                      <a:round/>
+                      <a:headEnd type="none" w="med" len="med"/>
+                      <a:tailEnd type="none" w="med" len="med"/>
+                    </a:lnT>
+                    <a:lnB w="12700" cap="flat" cmpd="sng" algn="ctr">
+                      <a:solidFill>
+                        <a:srgbClr val="D8DEEC"/>
+                      </a:solidFill>
+                      <a:prstDash val="solid"/>
+                      <a:round/>
+                      <a:headEnd type="none" w="med" len="med"/>
+                      <a:tailEnd type="none" w="med" len="med"/>
+                    </a:lnB>
+                  </a:tcPr>
+                </a:tc>
+                <a:tc>
+                  <a:txBody>
+                    <a:bodyPr/>
+                    <a:lstStyle/>
+                    <a:p>
+                      <a:pPr indent="0" marL="0">
+                        <a:buNone/>
+                      </a:pPr>
+                      <a:r>
+                        <a:rPr lang="en-US" sz="1050" dirty="0">
+                          <a:solidFill>
+                            <a:srgbClr val="1A1A2E"/>
+                          </a:solidFill>
+                          <a:latin typeface="Calibri" pitchFamily="34" charset="0"/>
+                          <a:ea typeface="Calibri" pitchFamily="34" charset="-122"/>
+                          <a:cs typeface="Calibri" pitchFamily="34" charset="-120"/>
+                        </a:rPr>
+                        <a:t>the day's book — 100 outward payments, ₹36.6L</a:t>
+                      </a:r>
+                      <a:endParaRPr lang="en-US" sz="1050" dirty="0">
+                        <a:latin typeface="Calibri" charset="0"/>
+                        <a:ea typeface="Calibri" charset="0"/>
+                        <a:cs typeface="Calibri" charset="0"/>
+                      </a:endParaRPr>
+                    </a:p>
+                  </a:txBody>
+                  <a:tcPr marL="91440" marR="91440" marT="45720" marB="45720" anchor="ctr">
+                    <a:lnL w="12700" cap="flat" cmpd="sng" algn="ctr">
+                      <a:solidFill>
+                        <a:srgbClr val="D8DEEC"/>
+                      </a:solidFill>
+                      <a:prstDash val="solid"/>
+                      <a:round/>
+                      <a:headEnd type="none" w="med" len="med"/>
+                      <a:tailEnd type="none" w="med" len="med"/>
+                    </a:lnL>
+                    <a:lnR w="12700" cap="flat" cmpd="sng" algn="ctr">
+                      <a:solidFill>
+                        <a:srgbClr val="D8DEEC"/>
+                      </a:solidFill>
+                      <a:prstDash val="solid"/>
+                      <a:round/>
+                      <a:headEnd type="none" w="med" len="med"/>
+                      <a:tailEnd type="none" w="med" len="med"/>
+                    </a:lnR>
+                    <a:lnT w="12700" cap="flat" cmpd="sng" algn="ctr">
+                      <a:solidFill>
+                        <a:srgbClr val="D8DEEC"/>
+                      </a:solidFill>
+                      <a:prstDash val="solid"/>
+                      <a:round/>
+                      <a:headEnd type="none" w="med" len="med"/>
+                      <a:tailEnd type="none" w="med" len="med"/>
+                    </a:lnT>
+                    <a:lnB w="12700" cap="flat" cmpd="sng" algn="ctr">
+                      <a:solidFill>
+                        <a:srgbClr val="D8DEEC"/>
+                      </a:solidFill>
+                      <a:prstDash val="solid"/>
+                      <a:round/>
+                      <a:headEnd type="none" w="med" len="med"/>
+                      <a:tailEnd type="none" w="med" len="med"/>
+                    </a:lnB>
+                  </a:tcPr>
+                </a:tc>
+                <a:tc>
+                  <a:txBody>
+                    <a:bodyPr/>
+                    <a:lstStyle/>
+                    <a:p>
+                      <a:pPr indent="0" marL="0">
+                        <a:buNone/>
+                      </a:pPr>
+                      <a:r>
+                        <a:rPr lang="en-US" sz="1050" dirty="0">
+                          <a:solidFill>
+                            <a:srgbClr val="1A1A2E"/>
+                          </a:solidFill>
+                          <a:latin typeface="Calibri" pitchFamily="34" charset="0"/>
+                          <a:ea typeface="Calibri" pitchFamily="34" charset="-122"/>
+                          <a:cs typeface="Calibri" pitchFamily="34" charset="-120"/>
+                        </a:rPr>
+                        <a:t>outflow by bucket: &lt;1m ₹151k · 1-15m ₹179k · 15-60m ₹255k · 1-4h ₹69k · 4-24h ₹2309k · &gt;24h ₹696k</a:t>
+                      </a:r>
+                      <a:endParaRPr lang="en-US" sz="1050" dirty="0">
+                        <a:latin typeface="Calibri" charset="0"/>
+                        <a:ea typeface="Calibri" charset="0"/>
+                        <a:cs typeface="Calibri" charset="0"/>
+                      </a:endParaRPr>
+                    </a:p>
+                  </a:txBody>
+                  <a:tcPr marL="91440" marR="91440" marT="45720" marB="45720" anchor="ctr">
+                    <a:lnL w="12700" cap="flat" cmpd="sng" algn="ctr">
+                      <a:solidFill>
+                        <a:srgbClr val="D8DEEC"/>
+                      </a:solidFill>
+                      <a:prstDash val="solid"/>
+                      <a:round/>
+                      <a:headEnd type="none" w="med" len="med"/>
+                      <a:tailEnd type="none" w="med" len="med"/>
+                    </a:lnL>
+                    <a:lnR w="12700" cap="flat" cmpd="sng" algn="ctr">
+                      <a:solidFill>
+                        <a:srgbClr val="D8DEEC"/>
+                      </a:solidFill>
+                      <a:prstDash val="solid"/>
+                      <a:round/>
+                      <a:headEnd type="none" w="med" len="med"/>
+                      <a:tailEnd type="none" w="med" len="med"/>
+                    </a:lnR>
+                    <a:lnT w="12700" cap="flat" cmpd="sng" algn="ctr">
+                      <a:solidFill>
+                        <a:srgbClr val="D8DEEC"/>
+                      </a:solidFill>
+                      <a:prstDash val="solid"/>
+                      <a:round/>
+                      <a:headEnd type="none" w="med" len="med"/>
+                      <a:tailEnd type="none" w="med" len="med"/>
+                    </a:lnT>
+                    <a:lnB w="12700" cap="flat" cmpd="sng" algn="ctr">
+                      <a:solidFill>
+                        <a:srgbClr val="D8DEEC"/>
+                      </a:solidFill>
+                      <a:prstDash val="solid"/>
+                      <a:round/>
+                      <a:headEnd type="none" w="med" len="med"/>
+                      <a:tailEnd type="none" w="med" len="med"/>
+                    </a:lnB>
+                  </a:tcPr>
+                </a:tc>
+              </a:tr>
+            </a:tbl>
+          </a:graphicData>
+        </a:graphic>
+      </p:graphicFrame>
+      <p:sp>
+        <p:nvSpPr>
+          <p:cNvPr id="5" name="Text 2"/>
+          <p:cNvSpPr/>
+          <p:nvPr/>
+        </p:nvSpPr>
+        <p:spPr>
+          <a:xfrm>
+            <a:off x="457200" y="4937760"/>
+            <a:ext cx="11274552" cy="548640"/>
+          </a:xfrm>
+          <a:prstGeom prst="rect">
+            <a:avLst/>
+          </a:prstGeom>
+          <a:noFill/>
+          <a:ln/>
+        </p:spPr>
+        <p:txBody>
+          <a:bodyPr wrap="square" rtlCol="0" anchor="ctr"/>
+          <a:lstStyle/>
+          <a:p>
+            <a:pPr indent="0" marL="0">
+              <a:buNone/>
+            </a:pPr>
+            <a:r>
+              <a:rPr lang="en-US" sz="1200" i="1" dirty="0">
+                <a:solidFill>
+                  <a:srgbClr val="5A6172"/>
+                </a:solidFill>
+                <a:latin typeface="Calibri" pitchFamily="34" charset="0"/>
+                <a:ea typeface="Calibri" pitchFamily="34" charset="-122"/>
+                <a:cs typeface="Calibri" pitchFamily="34" charset="-120"/>
+              </a:rPr>
+              <a:t>The salaried account earns the higher occurrence probability and the shorter gap — cadence read from history alone. Liquidity buckets are amount-conserving: they sum to the book total.</a:t>
+            </a:r>
+            <a:endParaRPr lang="en-US" sz="1200" dirty="0"/>
+          </a:p>
+        </p:txBody>
+      </p:sp>
+    </p:spTree>
+  </p:cSld>
+  <p:clrMapOvr>
+    <a:masterClrMapping/>
+  </p:clrMapOvr>
+</p:sld>
+</file>
+
 <file path=ppt/slides/slide2.xml><?xml version="1.0" encoding="utf-8"?>
 <p:sld xmlns:a="http://schemas.openxmlformats.org/drawingml/2006/main" xmlns:r="http://schemas.openxmlformats.org/officeDocument/2006/relationships" xmlns:p="http://schemas.openxmlformats.org/presentationml/2006/main">
   <p:cSld name="Slide 2">

</xml_diff>

<commit_message>
Deck: adapter-architecture diagram + data slide; paper: Sec. 3.4/3.5 on data
The deck gains the redrawn frozen-backbone/adapter figure (with the measured
C5 verdict beside it) and a data slide: serving contract per endpoint on the
left, the five-step synthetic-generation recipe on the right. The paper gains
Sec. 3.4 (how the generators work) and 3.5 (what a deployment must supply).
architecture_adapter.png is rendered from build_paper.design_drawing.

Co-Authored-By: Claude Fable 5 <noreply@anthropic.com>
</commit_message>
<xml_diff>
--- a/docs/txn_repr_evidence.pptx
+++ b/docs/txn_repr_evidence.pptx
@@ -20,9 +20,11 @@
     <p:sldId id="268" r:id="rId14"/>
     <p:sldId id="269" r:id="rId15"/>
     <p:sldId id="270" r:id="rId16"/>
+    <p:sldId id="271" r:id="rId17"/>
+    <p:sldId id="272" r:id="rId18"/>
   </p:sldIdLst>
   <p:notesMasterIdLst>
-    <p:notesMasterId r:id="rId17"/>
+    <p:notesMasterId r:id="rId19"/>
   </p:notesMasterIdLst>
   <p:sldSz cx="12188952" cy="6858000"/>
   <p:notesSz cx="6858000" cy="12188952"/>
@@ -1068,6 +1070,182 @@
             <a:fld id="{F7021451-1387-4CA6-816F-3879F97B5CBC}" type="slidenum">
               <a:rPr lang="en-US"/>
               <a:t>15</a:t>
+            </a:fld>
+            <a:endParaRPr lang="en-US"/>
+          </a:p>
+        </p:txBody>
+      </p:sp>
+    </p:spTree>
+    <p:extLst>
+      <p:ext uri="{BB962C8B-B14F-4D97-AF65-F5344CB8AC3E}">
+        <p14:creationId xmlns:p14="http://schemas.microsoft.com/office/powerpoint/2010/main" val="1024086991"/>
+      </p:ext>
+    </p:extLst>
+  </p:cSld>
+  <p:clrMapOvr>
+    <a:masterClrMapping/>
+  </p:clrMapOvr>
+</p:notes>
+</file>
+
+<file path=ppt/notesSlides/notesSlide16.xml><?xml version="1.0" encoding="utf-8"?>
+<p:notes xmlns:a="http://schemas.openxmlformats.org/drawingml/2006/main" xmlns:r="http://schemas.openxmlformats.org/officeDocument/2006/relationships" xmlns:p="http://schemas.openxmlformats.org/presentationml/2006/main">
+  <p:cSld>
+    <p:spTree>
+      <p:nvGrpSpPr>
+        <p:cNvPr id="1" name=""/>
+        <p:cNvGrpSpPr/>
+        <p:nvPr/>
+      </p:nvGrpSpPr>
+      <p:grpSpPr>
+        <a:xfrm>
+          <a:off x="0" y="0"/>
+          <a:ext cx="0" cy="0"/>
+          <a:chOff x="0" y="0"/>
+          <a:chExt cx="0" cy="0"/>
+        </a:xfrm>
+      </p:grpSpPr>
+      <p:sp>
+        <p:nvSpPr>
+          <p:cNvPr id="2" name="Slide Image Placeholder 1"/>
+          <p:cNvSpPr>
+            <a:spLocks noGrp="1" noRot="1" noChangeAspect="1"/>
+          </p:cNvSpPr>
+          <p:nvPr>
+            <p:ph type="sldImg"/>
+          </p:nvPr>
+        </p:nvSpPr>
+        <p:spPr/>
+      </p:sp>
+      <p:sp>
+        <p:nvSpPr>
+          <p:cNvPr id="3" name="Notes Placeholder 2"/>
+          <p:cNvSpPr>
+            <a:spLocks noGrp="1"/>
+          </p:cNvSpPr>
+          <p:nvPr>
+            <p:ph type="body" idx="1"/>
+          </p:nvPr>
+        </p:nvSpPr>
+        <p:spPr/>
+        <p:txBody>
+          <a:bodyPr/>
+          <a:lstStyle/>
+          <a:p>
+            <a:r>
+              <a:rPr lang="en-US" dirty="0"/>
+              <a:t/>
+            </a:r>
+            <a:endParaRPr lang="en-US" dirty="0"/>
+          </a:p>
+        </p:txBody>
+      </p:sp>
+      <p:sp>
+        <p:nvSpPr>
+          <p:cNvPr id="4" name="Slide Number Placeholder 3"/>
+          <p:cNvSpPr>
+            <a:spLocks noGrp="1"/>
+          </p:cNvSpPr>
+          <p:nvPr>
+            <p:ph type="sldNum" sz="quarter" idx="10"/>
+          </p:nvPr>
+        </p:nvSpPr>
+        <p:spPr/>
+        <p:txBody>
+          <a:bodyPr/>
+          <a:lstStyle/>
+          <a:p>
+            <a:fld id="{F7021451-1387-4CA6-816F-3879F97B5CBC}" type="slidenum">
+              <a:rPr lang="en-US"/>
+              <a:t>16</a:t>
+            </a:fld>
+            <a:endParaRPr lang="en-US"/>
+          </a:p>
+        </p:txBody>
+      </p:sp>
+    </p:spTree>
+    <p:extLst>
+      <p:ext uri="{BB962C8B-B14F-4D97-AF65-F5344CB8AC3E}">
+        <p14:creationId xmlns:p14="http://schemas.microsoft.com/office/powerpoint/2010/main" val="1024086991"/>
+      </p:ext>
+    </p:extLst>
+  </p:cSld>
+  <p:clrMapOvr>
+    <a:masterClrMapping/>
+  </p:clrMapOvr>
+</p:notes>
+</file>
+
+<file path=ppt/notesSlides/notesSlide17.xml><?xml version="1.0" encoding="utf-8"?>
+<p:notes xmlns:a="http://schemas.openxmlformats.org/drawingml/2006/main" xmlns:r="http://schemas.openxmlformats.org/officeDocument/2006/relationships" xmlns:p="http://schemas.openxmlformats.org/presentationml/2006/main">
+  <p:cSld>
+    <p:spTree>
+      <p:nvGrpSpPr>
+        <p:cNvPr id="1" name=""/>
+        <p:cNvGrpSpPr/>
+        <p:nvPr/>
+      </p:nvGrpSpPr>
+      <p:grpSpPr>
+        <a:xfrm>
+          <a:off x="0" y="0"/>
+          <a:ext cx="0" cy="0"/>
+          <a:chOff x="0" y="0"/>
+          <a:chExt cx="0" cy="0"/>
+        </a:xfrm>
+      </p:grpSpPr>
+      <p:sp>
+        <p:nvSpPr>
+          <p:cNvPr id="2" name="Slide Image Placeholder 1"/>
+          <p:cNvSpPr>
+            <a:spLocks noGrp="1" noRot="1" noChangeAspect="1"/>
+          </p:cNvSpPr>
+          <p:nvPr>
+            <p:ph type="sldImg"/>
+          </p:nvPr>
+        </p:nvSpPr>
+        <p:spPr/>
+      </p:sp>
+      <p:sp>
+        <p:nvSpPr>
+          <p:cNvPr id="3" name="Notes Placeholder 2"/>
+          <p:cNvSpPr>
+            <a:spLocks noGrp="1"/>
+          </p:cNvSpPr>
+          <p:nvPr>
+            <p:ph type="body" idx="1"/>
+          </p:nvPr>
+        </p:nvSpPr>
+        <p:spPr/>
+        <p:txBody>
+          <a:bodyPr/>
+          <a:lstStyle/>
+          <a:p>
+            <a:r>
+              <a:rPr lang="en-US" dirty="0"/>
+              <a:t/>
+            </a:r>
+            <a:endParaRPr lang="en-US" dirty="0"/>
+          </a:p>
+        </p:txBody>
+      </p:sp>
+      <p:sp>
+        <p:nvSpPr>
+          <p:cNvPr id="4" name="Slide Number Placeholder 3"/>
+          <p:cNvSpPr>
+            <a:spLocks noGrp="1"/>
+          </p:cNvSpPr>
+          <p:nvPr>
+            <p:ph type="sldNum" sz="quarter" idx="10"/>
+          </p:nvPr>
+        </p:nvSpPr>
+        <p:spPr/>
+        <p:txBody>
+          <a:bodyPr/>
+          <a:lstStyle/>
+          <a:p>
+            <a:fld id="{F7021451-1387-4CA6-816F-3879F97B5CBC}" type="slidenum">
+              <a:rPr lang="en-US"/>
+              <a:t>17</a:t>
             </a:fld>
             <a:endParaRPr lang="en-US"/>
           </a:p>
@@ -2672,6 +2850,2380 @@
                 <a:ea typeface="Cambria" pitchFamily="34" charset="-122"/>
                 <a:cs typeface="Cambria" pitchFamily="34" charset="-120"/>
               </a:rPr>
+              <a:t>The data — what PULSE needs</a:t>
+            </a:r>
+            <a:endParaRPr lang="en-US" sz="3000" dirty="0"/>
+          </a:p>
+        </p:txBody>
+      </p:sp>
+      <p:sp>
+        <p:nvSpPr>
+          <p:cNvPr id="3" name="Text 1"/>
+          <p:cNvSpPr/>
+          <p:nvPr/>
+        </p:nvSpPr>
+        <p:spPr>
+          <a:xfrm>
+            <a:off x="566928" y="969264"/>
+            <a:ext cx="10972800" cy="365760"/>
+          </a:xfrm>
+          <a:prstGeom prst="rect">
+            <a:avLst/>
+          </a:prstGeom>
+          <a:noFill/>
+          <a:ln/>
+        </p:spPr>
+        <p:txBody>
+          <a:bodyPr wrap="square" rtlCol="0" anchor="ctr"/>
+          <a:lstStyle/>
+          <a:p>
+            <a:pPr indent="0" marL="0">
+              <a:buNone/>
+            </a:pPr>
+            <a:r>
+              <a:rPr lang="en-US" sz="1400" i="1" dirty="0">
+                <a:solidFill>
+                  <a:srgbClr val="5A6172"/>
+                </a:solidFill>
+                <a:latin typeface="Calibri" pitchFamily="34" charset="0"/>
+                <a:ea typeface="Calibri" pitchFamily="34" charset="-122"/>
+                <a:cs typeface="Calibri" pitchFamily="34" charset="-120"/>
+              </a:rPr>
+              <a:t>Left: the serving contract per endpoint. Right: how the synthetic training data is generated (all seeded — same command, same bytes).</a:t>
+            </a:r>
+            <a:endParaRPr lang="en-US" sz="1400" dirty="0"/>
+          </a:p>
+        </p:txBody>
+      </p:sp>
+      <p:graphicFrame>
+        <p:nvGraphicFramePr>
+          <p:cNvPr id="11" name="Table 0"/>
+          <p:cNvGraphicFramePr>
+            <a:graphicFrameLocks noGrp="1"/>
+          </p:cNvGraphicFramePr>
+          <p:nvPr>
+            <p:extLst>
+              <p:ext uri="{D42A27DB-BD31-4B8C-83A1-F6EECF244321}">
+                <p14:modId xmlns:p14="http://schemas.microsoft.com/office/powerpoint/2010/main" val="1579011935"/>
+              </p:ext>
+            </p:extLst>
+          </p:nvPr>
+        </p:nvGraphicFramePr>
+        <p:xfrm>
+          <a:off x="457200" y="1691640"/>
+          <a:ext cx="5852160" cy="914400"/>
+        </p:xfrm>
+        <a:graphic>
+          <a:graphicData uri="http://schemas.openxmlformats.org/drawingml/2006/table">
+            <a:tbl>
+              <a:tblPr/>
+              <a:tblGrid>
+                <a:gridCol w="1554480"/>
+                <a:gridCol w="4297680"/>
+              </a:tblGrid>
+              <a:tr h="566928">
+                <a:tc>
+                  <a:txBody>
+                    <a:bodyPr/>
+                    <a:lstStyle/>
+                    <a:p>
+                      <a:pPr indent="0" marL="0">
+                        <a:buNone/>
+                      </a:pPr>
+                      <a:r>
+                        <a:rPr lang="en-US" sz="1000" b="1" dirty="0">
+                          <a:solidFill>
+                            <a:srgbClr val="FFFFFF"/>
+                          </a:solidFill>
+                          <a:latin typeface="Calibri" pitchFamily="34" charset="0"/>
+                          <a:ea typeface="Calibri" pitchFamily="34" charset="-122"/>
+                          <a:cs typeface="Calibri" pitchFamily="34" charset="-120"/>
+                        </a:rPr>
+                        <a:t>Endpoint</a:t>
+                      </a:r>
+                      <a:endParaRPr lang="en-US" sz="1000" dirty="0">
+                        <a:latin typeface="Calibri" charset="0"/>
+                        <a:ea typeface="Calibri" charset="0"/>
+                        <a:cs typeface="Calibri" charset="0"/>
+                      </a:endParaRPr>
+                    </a:p>
+                  </a:txBody>
+                  <a:tcPr marL="91440" marR="91440" marT="45720" marB="45720" anchor="ctr">
+                    <a:lnL w="12700" cap="flat" cmpd="sng" algn="ctr">
+                      <a:solidFill>
+                        <a:srgbClr val="D8DEEC"/>
+                      </a:solidFill>
+                      <a:prstDash val="solid"/>
+                      <a:round/>
+                      <a:headEnd type="none" w="med" len="med"/>
+                      <a:tailEnd type="none" w="med" len="med"/>
+                    </a:lnL>
+                    <a:lnR w="12700" cap="flat" cmpd="sng" algn="ctr">
+                      <a:solidFill>
+                        <a:srgbClr val="D8DEEC"/>
+                      </a:solidFill>
+                      <a:prstDash val="solid"/>
+                      <a:round/>
+                      <a:headEnd type="none" w="med" len="med"/>
+                      <a:tailEnd type="none" w="med" len="med"/>
+                    </a:lnR>
+                    <a:lnT w="12700" cap="flat" cmpd="sng" algn="ctr">
+                      <a:solidFill>
+                        <a:srgbClr val="D8DEEC"/>
+                      </a:solidFill>
+                      <a:prstDash val="solid"/>
+                      <a:round/>
+                      <a:headEnd type="none" w="med" len="med"/>
+                      <a:tailEnd type="none" w="med" len="med"/>
+                    </a:lnT>
+                    <a:lnB w="12700" cap="flat" cmpd="sng" algn="ctr">
+                      <a:solidFill>
+                        <a:srgbClr val="D8DEEC"/>
+                      </a:solidFill>
+                      <a:prstDash val="solid"/>
+                      <a:round/>
+                      <a:headEnd type="none" w="med" len="med"/>
+                      <a:tailEnd type="none" w="med" len="med"/>
+                    </a:lnB>
+                    <a:solidFill>
+                      <a:srgbClr val="1E2761"/>
+                    </a:solidFill>
+                  </a:tcPr>
+                </a:tc>
+                <a:tc>
+                  <a:txBody>
+                    <a:bodyPr/>
+                    <a:lstStyle/>
+                    <a:p>
+                      <a:pPr indent="0" marL="0">
+                        <a:buNone/>
+                      </a:pPr>
+                      <a:r>
+                        <a:rPr lang="en-US" sz="1000" b="1" dirty="0">
+                          <a:solidFill>
+                            <a:srgbClr val="FFFFFF"/>
+                          </a:solidFill>
+                          <a:latin typeface="Calibri" pitchFamily="34" charset="0"/>
+                          <a:ea typeface="Calibri" pitchFamily="34" charset="-122"/>
+                          <a:cs typeface="Calibri" pitchFamily="34" charset="-120"/>
+                        </a:rPr>
+                        <a:t>Required data</a:t>
+                      </a:r>
+                      <a:endParaRPr lang="en-US" sz="1000" dirty="0">
+                        <a:latin typeface="Calibri" charset="0"/>
+                        <a:ea typeface="Calibri" charset="0"/>
+                        <a:cs typeface="Calibri" charset="0"/>
+                      </a:endParaRPr>
+                    </a:p>
+                  </a:txBody>
+                  <a:tcPr marL="91440" marR="91440" marT="45720" marB="45720" anchor="ctr">
+                    <a:lnL w="12700" cap="flat" cmpd="sng" algn="ctr">
+                      <a:solidFill>
+                        <a:srgbClr val="D8DEEC"/>
+                      </a:solidFill>
+                      <a:prstDash val="solid"/>
+                      <a:round/>
+                      <a:headEnd type="none" w="med" len="med"/>
+                      <a:tailEnd type="none" w="med" len="med"/>
+                    </a:lnL>
+                    <a:lnR w="12700" cap="flat" cmpd="sng" algn="ctr">
+                      <a:solidFill>
+                        <a:srgbClr val="D8DEEC"/>
+                      </a:solidFill>
+                      <a:prstDash val="solid"/>
+                      <a:round/>
+                      <a:headEnd type="none" w="med" len="med"/>
+                      <a:tailEnd type="none" w="med" len="med"/>
+                    </a:lnR>
+                    <a:lnT w="12700" cap="flat" cmpd="sng" algn="ctr">
+                      <a:solidFill>
+                        <a:srgbClr val="D8DEEC"/>
+                      </a:solidFill>
+                      <a:prstDash val="solid"/>
+                      <a:round/>
+                      <a:headEnd type="none" w="med" len="med"/>
+                      <a:tailEnd type="none" w="med" len="med"/>
+                    </a:lnT>
+                    <a:lnB w="12700" cap="flat" cmpd="sng" algn="ctr">
+                      <a:solidFill>
+                        <a:srgbClr val="D8DEEC"/>
+                      </a:solidFill>
+                      <a:prstDash val="solid"/>
+                      <a:round/>
+                      <a:headEnd type="none" w="med" len="med"/>
+                      <a:tailEnd type="none" w="med" len="med"/>
+                    </a:lnB>
+                    <a:solidFill>
+                      <a:srgbClr val="1E2761"/>
+                    </a:solidFill>
+                  </a:tcPr>
+                </a:tc>
+              </a:tr>
+              <a:tr h="566928">
+                <a:tc>
+                  <a:txBody>
+                    <a:bodyPr/>
+                    <a:lstStyle/>
+                    <a:p>
+                      <a:pPr indent="0" marL="0">
+                        <a:buNone/>
+                      </a:pPr>
+                      <a:r>
+                        <a:rPr lang="en-US" sz="1000" dirty="0">
+                          <a:solidFill>
+                            <a:srgbClr val="1A1A2E"/>
+                          </a:solidFill>
+                          <a:latin typeface="Calibri" pitchFamily="34" charset="0"/>
+                          <a:ea typeface="Calibri" pitchFamily="34" charset="-122"/>
+                          <a:cs typeface="Calibri" pitchFamily="34" charset="-120"/>
+                        </a:rPr>
+                        <a:t>/score/intake</a:t>
+                      </a:r>
+                      <a:endParaRPr lang="en-US" sz="1000" dirty="0">
+                        <a:latin typeface="Calibri" charset="0"/>
+                        <a:ea typeface="Calibri" charset="0"/>
+                        <a:cs typeface="Calibri" charset="0"/>
+                      </a:endParaRPr>
+                    </a:p>
+                  </a:txBody>
+                  <a:tcPr marL="91440" marR="91440" marT="45720" marB="45720" anchor="ctr">
+                    <a:lnL w="12700" cap="flat" cmpd="sng" algn="ctr">
+                      <a:solidFill>
+                        <a:srgbClr val="D8DEEC"/>
+                      </a:solidFill>
+                      <a:prstDash val="solid"/>
+                      <a:round/>
+                      <a:headEnd type="none" w="med" len="med"/>
+                      <a:tailEnd type="none" w="med" len="med"/>
+                    </a:lnL>
+                    <a:lnR w="12700" cap="flat" cmpd="sng" algn="ctr">
+                      <a:solidFill>
+                        <a:srgbClr val="D8DEEC"/>
+                      </a:solidFill>
+                      <a:prstDash val="solid"/>
+                      <a:round/>
+                      <a:headEnd type="none" w="med" len="med"/>
+                      <a:tailEnd type="none" w="med" len="med"/>
+                    </a:lnR>
+                    <a:lnT w="12700" cap="flat" cmpd="sng" algn="ctr">
+                      <a:solidFill>
+                        <a:srgbClr val="D8DEEC"/>
+                      </a:solidFill>
+                      <a:prstDash val="solid"/>
+                      <a:round/>
+                      <a:headEnd type="none" w="med" len="med"/>
+                      <a:tailEnd type="none" w="med" len="med"/>
+                    </a:lnT>
+                    <a:lnB w="12700" cap="flat" cmpd="sng" algn="ctr">
+                      <a:solidFill>
+                        <a:srgbClr val="D8DEEC"/>
+                      </a:solidFill>
+                      <a:prstDash val="solid"/>
+                      <a:round/>
+                      <a:headEnd type="none" w="med" len="med"/>
+                      <a:tailEnd type="none" w="med" len="med"/>
+                    </a:lnB>
+                  </a:tcPr>
+                </a:tc>
+                <a:tc>
+                  <a:txBody>
+                    <a:bodyPr/>
+                    <a:lstStyle/>
+                    <a:p>
+                      <a:pPr indent="0" marL="0">
+                        <a:buNone/>
+                      </a:pPr>
+                      <a:r>
+                        <a:rPr lang="en-US" sz="1000" dirty="0">
+                          <a:solidFill>
+                            <a:srgbClr val="1A1A2E"/>
+                          </a:solidFill>
+                          <a:latin typeface="Calibri" pitchFamily="34" charset="0"/>
+                          <a:ea typeface="Calibri" pitchFamily="34" charset="-122"/>
+                          <a:cs typeface="Calibri" pitchFamily="34" charset="-120"/>
+                        </a:rPr>
+                        <a:t>19 payment fields: accounts &amp; ultimate parties, amount + currency, settlement date &amp; method, identifier type, names, countries, industries</a:t>
+                      </a:r>
+                      <a:endParaRPr lang="en-US" sz="1000" dirty="0">
+                        <a:latin typeface="Calibri" charset="0"/>
+                        <a:ea typeface="Calibri" charset="0"/>
+                        <a:cs typeface="Calibri" charset="0"/>
+                      </a:endParaRPr>
+                    </a:p>
+                  </a:txBody>
+                  <a:tcPr marL="91440" marR="91440" marT="45720" marB="45720" anchor="ctr">
+                    <a:lnL w="12700" cap="flat" cmpd="sng" algn="ctr">
+                      <a:solidFill>
+                        <a:srgbClr val="D8DEEC"/>
+                      </a:solidFill>
+                      <a:prstDash val="solid"/>
+                      <a:round/>
+                      <a:headEnd type="none" w="med" len="med"/>
+                      <a:tailEnd type="none" w="med" len="med"/>
+                    </a:lnL>
+                    <a:lnR w="12700" cap="flat" cmpd="sng" algn="ctr">
+                      <a:solidFill>
+                        <a:srgbClr val="D8DEEC"/>
+                      </a:solidFill>
+                      <a:prstDash val="solid"/>
+                      <a:round/>
+                      <a:headEnd type="none" w="med" len="med"/>
+                      <a:tailEnd type="none" w="med" len="med"/>
+                    </a:lnR>
+                    <a:lnT w="12700" cap="flat" cmpd="sng" algn="ctr">
+                      <a:solidFill>
+                        <a:srgbClr val="D8DEEC"/>
+                      </a:solidFill>
+                      <a:prstDash val="solid"/>
+                      <a:round/>
+                      <a:headEnd type="none" w="med" len="med"/>
+                      <a:tailEnd type="none" w="med" len="med"/>
+                    </a:lnT>
+                    <a:lnB w="12700" cap="flat" cmpd="sng" algn="ctr">
+                      <a:solidFill>
+                        <a:srgbClr val="D8DEEC"/>
+                      </a:solidFill>
+                      <a:prstDash val="solid"/>
+                      <a:round/>
+                      <a:headEnd type="none" w="med" len="med"/>
+                      <a:tailEnd type="none" w="med" len="med"/>
+                    </a:lnB>
+                  </a:tcPr>
+                </a:tc>
+              </a:tr>
+              <a:tr h="566928">
+                <a:tc>
+                  <a:txBody>
+                    <a:bodyPr/>
+                    <a:lstStyle/>
+                    <a:p>
+                      <a:pPr indent="0" marL="0">
+                        <a:buNone/>
+                      </a:pPr>
+                      <a:r>
+                        <a:rPr lang="en-US" sz="1000" dirty="0">
+                          <a:solidFill>
+                            <a:srgbClr val="1A1A2E"/>
+                          </a:solidFill>
+                          <a:latin typeface="Calibri" pitchFamily="34" charset="0"/>
+                          <a:ea typeface="Calibri" pitchFamily="34" charset="-122"/>
+                          <a:cs typeface="Calibri" pitchFamily="34" charset="-120"/>
+                        </a:rPr>
+                        <a:t>/score/inflight</a:t>
+                      </a:r>
+                      <a:endParaRPr lang="en-US" sz="1000" dirty="0">
+                        <a:latin typeface="Calibri" charset="0"/>
+                        <a:ea typeface="Calibri" charset="0"/>
+                        <a:cs typeface="Calibri" charset="0"/>
+                      </a:endParaRPr>
+                    </a:p>
+                  </a:txBody>
+                  <a:tcPr marL="91440" marR="91440" marT="45720" marB="45720" anchor="ctr">
+                    <a:lnL w="12700" cap="flat" cmpd="sng" algn="ctr">
+                      <a:solidFill>
+                        <a:srgbClr val="D8DEEC"/>
+                      </a:solidFill>
+                      <a:prstDash val="solid"/>
+                      <a:round/>
+                      <a:headEnd type="none" w="med" len="med"/>
+                      <a:tailEnd type="none" w="med" len="med"/>
+                    </a:lnL>
+                    <a:lnR w="12700" cap="flat" cmpd="sng" algn="ctr">
+                      <a:solidFill>
+                        <a:srgbClr val="D8DEEC"/>
+                      </a:solidFill>
+                      <a:prstDash val="solid"/>
+                      <a:round/>
+                      <a:headEnd type="none" w="med" len="med"/>
+                      <a:tailEnd type="none" w="med" len="med"/>
+                    </a:lnR>
+                    <a:lnT w="12700" cap="flat" cmpd="sng" algn="ctr">
+                      <a:solidFill>
+                        <a:srgbClr val="D8DEEC"/>
+                      </a:solidFill>
+                      <a:prstDash val="solid"/>
+                      <a:round/>
+                      <a:headEnd type="none" w="med" len="med"/>
+                      <a:tailEnd type="none" w="med" len="med"/>
+                    </a:lnT>
+                    <a:lnB w="12700" cap="flat" cmpd="sng" algn="ctr">
+                      <a:solidFill>
+                        <a:srgbClr val="D8DEEC"/>
+                      </a:solidFill>
+                      <a:prstDash val="solid"/>
+                      <a:round/>
+                      <a:headEnd type="none" w="med" len="med"/>
+                      <a:tailEnd type="none" w="med" len="med"/>
+                    </a:lnB>
+                  </a:tcPr>
+                </a:tc>
+                <a:tc>
+                  <a:txBody>
+                    <a:bodyPr/>
+                    <a:lstStyle/>
+                    <a:p>
+                      <a:pPr indent="0" marL="0">
+                        <a:buNone/>
+                      </a:pPr>
+                      <a:r>
+                        <a:rPr lang="en-US" sz="1000" dirty="0">
+                          <a:solidFill>
+                            <a:srgbClr val="1A1A2E"/>
+                          </a:solidFill>
+                          <a:latin typeface="Calibri" pitchFamily="34" charset="0"/>
+                          <a:ea typeface="Calibri" pitchFamily="34" charset="-122"/>
+                          <a:cs typeface="Calibri" pitchFamily="34" charset="-120"/>
+                        </a:rPr>
+                        <a:t>the message trail so far: end_to_end_id, seq, msg_type, tx_sts, minutes offset + the payment fields</a:t>
+                      </a:r>
+                      <a:endParaRPr lang="en-US" sz="1000" dirty="0">
+                        <a:latin typeface="Calibri" charset="0"/>
+                        <a:ea typeface="Calibri" charset="0"/>
+                        <a:cs typeface="Calibri" charset="0"/>
+                      </a:endParaRPr>
+                    </a:p>
+                  </a:txBody>
+                  <a:tcPr marL="91440" marR="91440" marT="45720" marB="45720" anchor="ctr">
+                    <a:lnL w="12700" cap="flat" cmpd="sng" algn="ctr">
+                      <a:solidFill>
+                        <a:srgbClr val="D8DEEC"/>
+                      </a:solidFill>
+                      <a:prstDash val="solid"/>
+                      <a:round/>
+                      <a:headEnd type="none" w="med" len="med"/>
+                      <a:tailEnd type="none" w="med" len="med"/>
+                    </a:lnL>
+                    <a:lnR w="12700" cap="flat" cmpd="sng" algn="ctr">
+                      <a:solidFill>
+                        <a:srgbClr val="D8DEEC"/>
+                      </a:solidFill>
+                      <a:prstDash val="solid"/>
+                      <a:round/>
+                      <a:headEnd type="none" w="med" len="med"/>
+                      <a:tailEnd type="none" w="med" len="med"/>
+                    </a:lnR>
+                    <a:lnT w="12700" cap="flat" cmpd="sng" algn="ctr">
+                      <a:solidFill>
+                        <a:srgbClr val="D8DEEC"/>
+                      </a:solidFill>
+                      <a:prstDash val="solid"/>
+                      <a:round/>
+                      <a:headEnd type="none" w="med" len="med"/>
+                      <a:tailEnd type="none" w="med" len="med"/>
+                    </a:lnT>
+                    <a:lnB w="12700" cap="flat" cmpd="sng" algn="ctr">
+                      <a:solidFill>
+                        <a:srgbClr val="D8DEEC"/>
+                      </a:solidFill>
+                      <a:prstDash val="solid"/>
+                      <a:round/>
+                      <a:headEnd type="none" w="med" len="med"/>
+                      <a:tailEnd type="none" w="med" len="med"/>
+                    </a:lnB>
+                  </a:tcPr>
+                </a:tc>
+              </a:tr>
+              <a:tr h="566928">
+                <a:tc>
+                  <a:txBody>
+                    <a:bodyPr/>
+                    <a:lstStyle/>
+                    <a:p>
+                      <a:pPr indent="0" marL="0">
+                        <a:buNone/>
+                      </a:pPr>
+                      <a:r>
+                        <a:rPr lang="en-US" sz="1000" dirty="0">
+                          <a:solidFill>
+                            <a:srgbClr val="1A1A2E"/>
+                          </a:solidFill>
+                          <a:latin typeface="Calibri" pitchFamily="34" charset="0"/>
+                          <a:ea typeface="Calibri" pitchFamily="34" charset="-122"/>
+                          <a:cs typeface="Calibri" pitchFamily="34" charset="-120"/>
+                        </a:rPr>
+                        <a:t>/score/velocity</a:t>
+                      </a:r>
+                      <a:endParaRPr lang="en-US" sz="1000" dirty="0">
+                        <a:latin typeface="Calibri" charset="0"/>
+                        <a:ea typeface="Calibri" charset="0"/>
+                        <a:cs typeface="Calibri" charset="0"/>
+                      </a:endParaRPr>
+                    </a:p>
+                  </a:txBody>
+                  <a:tcPr marL="91440" marR="91440" marT="45720" marB="45720" anchor="ctr">
+                    <a:lnL w="12700" cap="flat" cmpd="sng" algn="ctr">
+                      <a:solidFill>
+                        <a:srgbClr val="D8DEEC"/>
+                      </a:solidFill>
+                      <a:prstDash val="solid"/>
+                      <a:round/>
+                      <a:headEnd type="none" w="med" len="med"/>
+                      <a:tailEnd type="none" w="med" len="med"/>
+                    </a:lnL>
+                    <a:lnR w="12700" cap="flat" cmpd="sng" algn="ctr">
+                      <a:solidFill>
+                        <a:srgbClr val="D8DEEC"/>
+                      </a:solidFill>
+                      <a:prstDash val="solid"/>
+                      <a:round/>
+                      <a:headEnd type="none" w="med" len="med"/>
+                      <a:tailEnd type="none" w="med" len="med"/>
+                    </a:lnR>
+                    <a:lnT w="12700" cap="flat" cmpd="sng" algn="ctr">
+                      <a:solidFill>
+                        <a:srgbClr val="D8DEEC"/>
+                      </a:solidFill>
+                      <a:prstDash val="solid"/>
+                      <a:round/>
+                      <a:headEnd type="none" w="med" len="med"/>
+                      <a:tailEnd type="none" w="med" len="med"/>
+                    </a:lnT>
+                    <a:lnB w="12700" cap="flat" cmpd="sng" algn="ctr">
+                      <a:solidFill>
+                        <a:srgbClr val="D8DEEC"/>
+                      </a:solidFill>
+                      <a:prstDash val="solid"/>
+                      <a:round/>
+                      <a:headEnd type="none" w="med" len="med"/>
+                      <a:tailEnd type="none" w="med" len="med"/>
+                    </a:lnB>
+                  </a:tcPr>
+                </a:tc>
+                <a:tc>
+                  <a:txBody>
+                    <a:bodyPr/>
+                    <a:lstStyle/>
+                    <a:p>
+                      <a:pPr indent="0" marL="0">
+                        <a:buNone/>
+                      </a:pPr>
+                      <a:r>
+                        <a:rPr lang="en-US" sz="1000" dirty="0">
+                          <a:solidFill>
+                            <a:srgbClr val="1A1A2E"/>
+                          </a:solidFill>
+                          <a:latin typeface="Calibri" pitchFamily="34" charset="0"/>
+                          <a:ea typeface="Calibri" pitchFamily="34" charset="-122"/>
+                          <a:cs typeface="Calibri" pitchFamily="34" charset="-120"/>
+                        </a:rPr>
+                        <a:t>per-account history (≥2 rows): account id, dates + feature columns — engine-supplied, stateless</a:t>
+                      </a:r>
+                      <a:endParaRPr lang="en-US" sz="1000" dirty="0">
+                        <a:latin typeface="Calibri" charset="0"/>
+                        <a:ea typeface="Calibri" charset="0"/>
+                        <a:cs typeface="Calibri" charset="0"/>
+                      </a:endParaRPr>
+                    </a:p>
+                  </a:txBody>
+                  <a:tcPr marL="91440" marR="91440" marT="45720" marB="45720" anchor="ctr">
+                    <a:lnL w="12700" cap="flat" cmpd="sng" algn="ctr">
+                      <a:solidFill>
+                        <a:srgbClr val="D8DEEC"/>
+                      </a:solidFill>
+                      <a:prstDash val="solid"/>
+                      <a:round/>
+                      <a:headEnd type="none" w="med" len="med"/>
+                      <a:tailEnd type="none" w="med" len="med"/>
+                    </a:lnL>
+                    <a:lnR w="12700" cap="flat" cmpd="sng" algn="ctr">
+                      <a:solidFill>
+                        <a:srgbClr val="D8DEEC"/>
+                      </a:solidFill>
+                      <a:prstDash val="solid"/>
+                      <a:round/>
+                      <a:headEnd type="none" w="med" len="med"/>
+                      <a:tailEnd type="none" w="med" len="med"/>
+                    </a:lnR>
+                    <a:lnT w="12700" cap="flat" cmpd="sng" algn="ctr">
+                      <a:solidFill>
+                        <a:srgbClr val="D8DEEC"/>
+                      </a:solidFill>
+                      <a:prstDash val="solid"/>
+                      <a:round/>
+                      <a:headEnd type="none" w="med" len="med"/>
+                      <a:tailEnd type="none" w="med" len="med"/>
+                    </a:lnT>
+                    <a:lnB w="12700" cap="flat" cmpd="sng" algn="ctr">
+                      <a:solidFill>
+                        <a:srgbClr val="D8DEEC"/>
+                      </a:solidFill>
+                      <a:prstDash val="solid"/>
+                      <a:round/>
+                      <a:headEnd type="none" w="med" len="med"/>
+                      <a:tailEnd type="none" w="med" len="med"/>
+                    </a:lnB>
+                  </a:tcPr>
+                </a:tc>
+              </a:tr>
+              <a:tr h="566928">
+                <a:tc>
+                  <a:txBody>
+                    <a:bodyPr/>
+                    <a:lstStyle/>
+                    <a:p>
+                      <a:pPr indent="0" marL="0">
+                        <a:buNone/>
+                      </a:pPr>
+                      <a:r>
+                        <a:rPr lang="en-US" sz="1000" dirty="0">
+                          <a:solidFill>
+                            <a:srgbClr val="1A1A2E"/>
+                          </a:solidFill>
+                          <a:latin typeface="Calibri" pitchFamily="34" charset="0"/>
+                          <a:ea typeface="Calibri" pitchFamily="34" charset="-122"/>
+                          <a:cs typeface="Calibri" pitchFamily="34" charset="-120"/>
+                        </a:rPr>
+                        <a:t>/forecast/next</a:t>
+                      </a:r>
+                      <a:endParaRPr lang="en-US" sz="1000" dirty="0">
+                        <a:latin typeface="Calibri" charset="0"/>
+                        <a:ea typeface="Calibri" charset="0"/>
+                        <a:cs typeface="Calibri" charset="0"/>
+                      </a:endParaRPr>
+                    </a:p>
+                  </a:txBody>
+                  <a:tcPr marL="91440" marR="91440" marT="45720" marB="45720" anchor="ctr">
+                    <a:lnL w="12700" cap="flat" cmpd="sng" algn="ctr">
+                      <a:solidFill>
+                        <a:srgbClr val="D8DEEC"/>
+                      </a:solidFill>
+                      <a:prstDash val="solid"/>
+                      <a:round/>
+                      <a:headEnd type="none" w="med" len="med"/>
+                      <a:tailEnd type="none" w="med" len="med"/>
+                    </a:lnL>
+                    <a:lnR w="12700" cap="flat" cmpd="sng" algn="ctr">
+                      <a:solidFill>
+                        <a:srgbClr val="D8DEEC"/>
+                      </a:solidFill>
+                      <a:prstDash val="solid"/>
+                      <a:round/>
+                      <a:headEnd type="none" w="med" len="med"/>
+                      <a:tailEnd type="none" w="med" len="med"/>
+                    </a:lnR>
+                    <a:lnT w="12700" cap="flat" cmpd="sng" algn="ctr">
+                      <a:solidFill>
+                        <a:srgbClr val="D8DEEC"/>
+                      </a:solidFill>
+                      <a:prstDash val="solid"/>
+                      <a:round/>
+                      <a:headEnd type="none" w="med" len="med"/>
+                      <a:tailEnd type="none" w="med" len="med"/>
+                    </a:lnT>
+                    <a:lnB w="12700" cap="flat" cmpd="sng" algn="ctr">
+                      <a:solidFill>
+                        <a:srgbClr val="D8DEEC"/>
+                      </a:solidFill>
+                      <a:prstDash val="solid"/>
+                      <a:round/>
+                      <a:headEnd type="none" w="med" len="med"/>
+                      <a:tailEnd type="none" w="med" len="med"/>
+                    </a:lnB>
+                  </a:tcPr>
+                </a:tc>
+                <a:tc>
+                  <a:txBody>
+                    <a:bodyPr/>
+                    <a:lstStyle/>
+                    <a:p>
+                      <a:pPr indent="0" marL="0">
+                        <a:buNone/>
+                      </a:pPr>
+                      <a:r>
+                        <a:rPr lang="en-US" sz="1000" dirty="0">
+                          <a:solidFill>
+                            <a:srgbClr val="1A1A2E"/>
+                          </a:solidFill>
+                          <a:latin typeface="Calibri" pitchFamily="34" charset="0"/>
+                          <a:ea typeface="Calibri" pitchFamily="34" charset="-122"/>
+                          <a:cs typeface="Calibri" pitchFamily="34" charset="-120"/>
+                        </a:rPr>
+                        <a:t>per-account history (≥3 rows) incl. counterparty ids</a:t>
+                      </a:r>
+                      <a:endParaRPr lang="en-US" sz="1000" dirty="0">
+                        <a:latin typeface="Calibri" charset="0"/>
+                        <a:ea typeface="Calibri" charset="0"/>
+                        <a:cs typeface="Calibri" charset="0"/>
+                      </a:endParaRPr>
+                    </a:p>
+                  </a:txBody>
+                  <a:tcPr marL="91440" marR="91440" marT="45720" marB="45720" anchor="ctr">
+                    <a:lnL w="12700" cap="flat" cmpd="sng" algn="ctr">
+                      <a:solidFill>
+                        <a:srgbClr val="D8DEEC"/>
+                      </a:solidFill>
+                      <a:prstDash val="solid"/>
+                      <a:round/>
+                      <a:headEnd type="none" w="med" len="med"/>
+                      <a:tailEnd type="none" w="med" len="med"/>
+                    </a:lnL>
+                    <a:lnR w="12700" cap="flat" cmpd="sng" algn="ctr">
+                      <a:solidFill>
+                        <a:srgbClr val="D8DEEC"/>
+                      </a:solidFill>
+                      <a:prstDash val="solid"/>
+                      <a:round/>
+                      <a:headEnd type="none" w="med" len="med"/>
+                      <a:tailEnd type="none" w="med" len="med"/>
+                    </a:lnR>
+                    <a:lnT w="12700" cap="flat" cmpd="sng" algn="ctr">
+                      <a:solidFill>
+                        <a:srgbClr val="D8DEEC"/>
+                      </a:solidFill>
+                      <a:prstDash val="solid"/>
+                      <a:round/>
+                      <a:headEnd type="none" w="med" len="med"/>
+                      <a:tailEnd type="none" w="med" len="med"/>
+                    </a:lnT>
+                    <a:lnB w="12700" cap="flat" cmpd="sng" algn="ctr">
+                      <a:solidFill>
+                        <a:srgbClr val="D8DEEC"/>
+                      </a:solidFill>
+                      <a:prstDash val="solid"/>
+                      <a:round/>
+                      <a:headEnd type="none" w="med" len="med"/>
+                      <a:tailEnd type="none" w="med" len="med"/>
+                    </a:lnB>
+                  </a:tcPr>
+                </a:tc>
+              </a:tr>
+              <a:tr h="566928">
+                <a:tc>
+                  <a:txBody>
+                    <a:bodyPr/>
+                    <a:lstStyle/>
+                    <a:p>
+                      <a:pPr indent="0" marL="0">
+                        <a:buNone/>
+                      </a:pPr>
+                      <a:r>
+                        <a:rPr lang="en-US" sz="1000" dirty="0">
+                          <a:solidFill>
+                            <a:srgbClr val="1A1A2E"/>
+                          </a:solidFill>
+                          <a:latin typeface="Calibri" pitchFamily="34" charset="0"/>
+                          <a:ea typeface="Calibri" pitchFamily="34" charset="-122"/>
+                          <a:cs typeface="Calibri" pitchFamily="34" charset="-120"/>
+                        </a:rPr>
+                        <a:t>/forecast/liquidity</a:t>
+                      </a:r>
+                      <a:endParaRPr lang="en-US" sz="1000" dirty="0">
+                        <a:latin typeface="Calibri" charset="0"/>
+                        <a:ea typeface="Calibri" charset="0"/>
+                        <a:cs typeface="Calibri" charset="0"/>
+                      </a:endParaRPr>
+                    </a:p>
+                  </a:txBody>
+                  <a:tcPr marL="91440" marR="91440" marT="45720" marB="45720" anchor="ctr">
+                    <a:lnL w="12700" cap="flat" cmpd="sng" algn="ctr">
+                      <a:solidFill>
+                        <a:srgbClr val="D8DEEC"/>
+                      </a:solidFill>
+                      <a:prstDash val="solid"/>
+                      <a:round/>
+                      <a:headEnd type="none" w="med" len="med"/>
+                      <a:tailEnd type="none" w="med" len="med"/>
+                    </a:lnL>
+                    <a:lnR w="12700" cap="flat" cmpd="sng" algn="ctr">
+                      <a:solidFill>
+                        <a:srgbClr val="D8DEEC"/>
+                      </a:solidFill>
+                      <a:prstDash val="solid"/>
+                      <a:round/>
+                      <a:headEnd type="none" w="med" len="med"/>
+                      <a:tailEnd type="none" w="med" len="med"/>
+                    </a:lnR>
+                    <a:lnT w="12700" cap="flat" cmpd="sng" algn="ctr">
+                      <a:solidFill>
+                        <a:srgbClr val="D8DEEC"/>
+                      </a:solidFill>
+                      <a:prstDash val="solid"/>
+                      <a:round/>
+                      <a:headEnd type="none" w="med" len="med"/>
+                      <a:tailEnd type="none" w="med" len="med"/>
+                    </a:lnT>
+                    <a:lnB w="12700" cap="flat" cmpd="sng" algn="ctr">
+                      <a:solidFill>
+                        <a:srgbClr val="D8DEEC"/>
+                      </a:solidFill>
+                      <a:prstDash val="solid"/>
+                      <a:round/>
+                      <a:headEnd type="none" w="med" len="med"/>
+                      <a:tailEnd type="none" w="med" len="med"/>
+                    </a:lnB>
+                  </a:tcPr>
+                </a:tc>
+                <a:tc>
+                  <a:txBody>
+                    <a:bodyPr/>
+                    <a:lstStyle/>
+                    <a:p>
+                      <a:pPr indent="0" marL="0">
+                        <a:buNone/>
+                      </a:pPr>
+                      <a:r>
+                        <a:rPr lang="en-US" sz="1000" dirty="0">
+                          <a:solidFill>
+                            <a:srgbClr val="1A1A2E"/>
+                          </a:solidFill>
+                          <a:latin typeface="Calibri" pitchFamily="34" charset="0"/>
+                          <a:ea typeface="Calibri" pitchFamily="34" charset="-122"/>
+                          <a:cs typeface="Calibri" pitchFamily="34" charset="-120"/>
+                        </a:rPr>
+                        <a:t>the day's outward book (intake fields)</a:t>
+                      </a:r>
+                      <a:endParaRPr lang="en-US" sz="1000" dirty="0">
+                        <a:latin typeface="Calibri" charset="0"/>
+                        <a:ea typeface="Calibri" charset="0"/>
+                        <a:cs typeface="Calibri" charset="0"/>
+                      </a:endParaRPr>
+                    </a:p>
+                  </a:txBody>
+                  <a:tcPr marL="91440" marR="91440" marT="45720" marB="45720" anchor="ctr">
+                    <a:lnL w="12700" cap="flat" cmpd="sng" algn="ctr">
+                      <a:solidFill>
+                        <a:srgbClr val="D8DEEC"/>
+                      </a:solidFill>
+                      <a:prstDash val="solid"/>
+                      <a:round/>
+                      <a:headEnd type="none" w="med" len="med"/>
+                      <a:tailEnd type="none" w="med" len="med"/>
+                    </a:lnL>
+                    <a:lnR w="12700" cap="flat" cmpd="sng" algn="ctr">
+                      <a:solidFill>
+                        <a:srgbClr val="D8DEEC"/>
+                      </a:solidFill>
+                      <a:prstDash val="solid"/>
+                      <a:round/>
+                      <a:headEnd type="none" w="med" len="med"/>
+                      <a:tailEnd type="none" w="med" len="med"/>
+                    </a:lnR>
+                    <a:lnT w="12700" cap="flat" cmpd="sng" algn="ctr">
+                      <a:solidFill>
+                        <a:srgbClr val="D8DEEC"/>
+                      </a:solidFill>
+                      <a:prstDash val="solid"/>
+                      <a:round/>
+                      <a:headEnd type="none" w="med" len="med"/>
+                      <a:tailEnd type="none" w="med" len="med"/>
+                    </a:lnT>
+                    <a:lnB w="12700" cap="flat" cmpd="sng" algn="ctr">
+                      <a:solidFill>
+                        <a:srgbClr val="D8DEEC"/>
+                      </a:solidFill>
+                      <a:prstDash val="solid"/>
+                      <a:round/>
+                      <a:headEnd type="none" w="med" len="med"/>
+                      <a:tailEnd type="none" w="med" len="med"/>
+                    </a:lnB>
+                  </a:tcPr>
+                </a:tc>
+              </a:tr>
+              <a:tr h="566928">
+                <a:tc>
+                  <a:txBody>
+                    <a:bodyPr/>
+                    <a:lstStyle/>
+                    <a:p>
+                      <a:pPr indent="0" marL="0">
+                        <a:buNone/>
+                      </a:pPr>
+                      <a:r>
+                        <a:rPr lang="en-US" sz="1000" dirty="0">
+                          <a:solidFill>
+                            <a:srgbClr val="1A1A2E"/>
+                          </a:solidFill>
+                          <a:latin typeface="Calibri" pitchFamily="34" charset="0"/>
+                          <a:ea typeface="Calibri" pitchFamily="34" charset="-122"/>
+                          <a:cs typeface="Calibri" pitchFamily="34" charset="-120"/>
+                        </a:rPr>
+                        <a:t>origination fusion</a:t>
+                      </a:r>
+                      <a:endParaRPr lang="en-US" sz="1000" dirty="0">
+                        <a:latin typeface="Calibri" charset="0"/>
+                        <a:ea typeface="Calibri" charset="0"/>
+                        <a:cs typeface="Calibri" charset="0"/>
+                      </a:endParaRPr>
+                    </a:p>
+                  </a:txBody>
+                  <a:tcPr marL="91440" marR="91440" marT="45720" marB="45720" anchor="ctr">
+                    <a:lnL w="12700" cap="flat" cmpd="sng" algn="ctr">
+                      <a:solidFill>
+                        <a:srgbClr val="D8DEEC"/>
+                      </a:solidFill>
+                      <a:prstDash val="solid"/>
+                      <a:round/>
+                      <a:headEnd type="none" w="med" len="med"/>
+                      <a:tailEnd type="none" w="med" len="med"/>
+                    </a:lnL>
+                    <a:lnR w="12700" cap="flat" cmpd="sng" algn="ctr">
+                      <a:solidFill>
+                        <a:srgbClr val="D8DEEC"/>
+                      </a:solidFill>
+                      <a:prstDash val="solid"/>
+                      <a:round/>
+                      <a:headEnd type="none" w="med" len="med"/>
+                      <a:tailEnd type="none" w="med" len="med"/>
+                    </a:lnR>
+                    <a:lnT w="12700" cap="flat" cmpd="sng" algn="ctr">
+                      <a:solidFill>
+                        <a:srgbClr val="D8DEEC"/>
+                      </a:solidFill>
+                      <a:prstDash val="solid"/>
+                      <a:round/>
+                      <a:headEnd type="none" w="med" len="med"/>
+                      <a:tailEnd type="none" w="med" len="med"/>
+                    </a:lnT>
+                    <a:lnB w="12700" cap="flat" cmpd="sng" algn="ctr">
+                      <a:solidFill>
+                        <a:srgbClr val="D8DEEC"/>
+                      </a:solidFill>
+                      <a:prstDash val="solid"/>
+                      <a:round/>
+                      <a:headEnd type="none" w="med" len="med"/>
+                      <a:tailEnd type="none" w="med" len="med"/>
+                    </a:lnB>
+                  </a:tcPr>
+                </a:tc>
+                <a:tc>
+                  <a:txBody>
+                    <a:bodyPr/>
+                    <a:lstStyle/>
+                    <a:p>
+                      <a:pPr indent="0" marL="0">
+                        <a:buNone/>
+                      </a:pPr>
+                      <a:r>
+                        <a:rPr lang="en-US" sz="1000" dirty="0">
+                          <a:solidFill>
+                            <a:srgbClr val="1A1A2E"/>
+                          </a:solidFill>
+                          <a:latin typeface="Calibri" pitchFamily="34" charset="0"/>
+                          <a:ea typeface="Calibri" pitchFamily="34" charset="-122"/>
+                          <a:cs typeface="Calibri" pitchFamily="34" charset="-120"/>
+                        </a:rPr>
+                        <a:t>pain.001 channel context at t=0: channel, device, session, auth attributes (bank-internal, pre-ISO)</a:t>
+                      </a:r>
+                      <a:endParaRPr lang="en-US" sz="1000" dirty="0">
+                        <a:latin typeface="Calibri" charset="0"/>
+                        <a:ea typeface="Calibri" charset="0"/>
+                        <a:cs typeface="Calibri" charset="0"/>
+                      </a:endParaRPr>
+                    </a:p>
+                  </a:txBody>
+                  <a:tcPr marL="91440" marR="91440" marT="45720" marB="45720" anchor="ctr">
+                    <a:lnL w="12700" cap="flat" cmpd="sng" algn="ctr">
+                      <a:solidFill>
+                        <a:srgbClr val="D8DEEC"/>
+                      </a:solidFill>
+                      <a:prstDash val="solid"/>
+                      <a:round/>
+                      <a:headEnd type="none" w="med" len="med"/>
+                      <a:tailEnd type="none" w="med" len="med"/>
+                    </a:lnL>
+                    <a:lnR w="12700" cap="flat" cmpd="sng" algn="ctr">
+                      <a:solidFill>
+                        <a:srgbClr val="D8DEEC"/>
+                      </a:solidFill>
+                      <a:prstDash val="solid"/>
+                      <a:round/>
+                      <a:headEnd type="none" w="med" len="med"/>
+                      <a:tailEnd type="none" w="med" len="med"/>
+                    </a:lnR>
+                    <a:lnT w="12700" cap="flat" cmpd="sng" algn="ctr">
+                      <a:solidFill>
+                        <a:srgbClr val="D8DEEC"/>
+                      </a:solidFill>
+                      <a:prstDash val="solid"/>
+                      <a:round/>
+                      <a:headEnd type="none" w="med" len="med"/>
+                      <a:tailEnd type="none" w="med" len="med"/>
+                    </a:lnT>
+                    <a:lnB w="12700" cap="flat" cmpd="sng" algn="ctr">
+                      <a:solidFill>
+                        <a:srgbClr val="D8DEEC"/>
+                      </a:solidFill>
+                      <a:prstDash val="solid"/>
+                      <a:round/>
+                      <a:headEnd type="none" w="med" len="med"/>
+                      <a:tailEnd type="none" w="med" len="med"/>
+                    </a:lnB>
+                  </a:tcPr>
+                </a:tc>
+              </a:tr>
+            </a:tbl>
+          </a:graphicData>
+        </a:graphic>
+      </p:graphicFrame>
+      <p:sp>
+        <p:nvSpPr>
+          <p:cNvPr id="5" name="Shape 2"/>
+          <p:cNvSpPr/>
+          <p:nvPr/>
+        </p:nvSpPr>
+        <p:spPr>
+          <a:xfrm>
+            <a:off x="6537960" y="1691640"/>
+            <a:ext cx="5120640" cy="841248"/>
+          </a:xfrm>
+          <a:prstGeom prst="roundRect">
+            <a:avLst>
+              <a:gd name="adj" fmla="val 6522"/>
+            </a:avLst>
+          </a:prstGeom>
+          <a:solidFill>
+            <a:srgbClr val="F2F5FC"/>
+          </a:solidFill>
+          <a:ln w="12700">
+            <a:solidFill>
+              <a:srgbClr val="CADCFC"/>
+            </a:solidFill>
+            <a:prstDash val="solid"/>
+          </a:ln>
+        </p:spPr>
+      </p:sp>
+      <p:sp>
+        <p:nvSpPr>
+          <p:cNvPr id="6" name="Text 3"/>
+          <p:cNvSpPr/>
+          <p:nvPr/>
+        </p:nvSpPr>
+        <p:spPr>
+          <a:xfrm>
+            <a:off x="6720840" y="1746504"/>
+            <a:ext cx="4754880" cy="274320"/>
+          </a:xfrm>
+          <a:prstGeom prst="rect">
+            <a:avLst/>
+          </a:prstGeom>
+          <a:noFill/>
+          <a:ln/>
+        </p:spPr>
+        <p:txBody>
+          <a:bodyPr wrap="square" rtlCol="0" anchor="ctr"/>
+          <a:lstStyle/>
+          <a:p>
+            <a:pPr indent="0" marL="0">
+              <a:buNone/>
+            </a:pPr>
+            <a:r>
+              <a:rPr lang="en-US" sz="1150" b="1" dirty="0">
+                <a:solidFill>
+                  <a:srgbClr val="1E2761"/>
+                </a:solidFill>
+                <a:latin typeface="Cambria" pitchFamily="34" charset="0"/>
+                <a:ea typeface="Cambria" pitchFamily="34" charset="-122"/>
+                <a:cs typeface="Cambria" pitchFamily="34" charset="-120"/>
+              </a:rPr>
+              <a:t>1  Account universe</a:t>
+            </a:r>
+            <a:endParaRPr lang="en-US" sz="1150" dirty="0"/>
+          </a:p>
+        </p:txBody>
+      </p:sp>
+      <p:sp>
+        <p:nvSpPr>
+          <p:cNvPr id="7" name="Text 4"/>
+          <p:cNvSpPr/>
+          <p:nvPr/>
+        </p:nvSpPr>
+        <p:spPr>
+          <a:xfrm>
+            <a:off x="6720840" y="2020824"/>
+            <a:ext cx="4800600" cy="502920"/>
+          </a:xfrm>
+          <a:prstGeom prst="rect">
+            <a:avLst/>
+          </a:prstGeom>
+          <a:noFill/>
+          <a:ln/>
+        </p:spPr>
+        <p:txBody>
+          <a:bodyPr wrap="square" rtlCol="0" anchor="ctr"/>
+          <a:lstStyle/>
+          <a:p>
+            <a:pPr indent="0" marL="0">
+              <a:buNone/>
+            </a:pPr>
+            <a:r>
+              <a:rPr lang="en-US" sz="950" dirty="0">
+                <a:solidFill>
+                  <a:srgbClr val="1A1A2E"/>
+                </a:solidFill>
+                <a:latin typeface="Calibri" pitchFamily="34" charset="0"/>
+                <a:ea typeface="Calibri" pitchFamily="34" charset="-122"/>
+                <a:cs typeface="Calibri" pitchFamily="34" charset="-120"/>
+              </a:rPr>
+              <a:t>4,000 synthetic corporates: industries, countries, account / IFSC / BIC identifiers</a:t>
+            </a:r>
+            <a:endParaRPr lang="en-US" sz="950" dirty="0"/>
+          </a:p>
+        </p:txBody>
+      </p:sp>
+      <p:sp>
+        <p:nvSpPr>
+          <p:cNvPr id="8" name="Shape 5"/>
+          <p:cNvSpPr/>
+          <p:nvPr/>
+        </p:nvSpPr>
+        <p:spPr>
+          <a:xfrm>
+            <a:off x="6537960" y="2624328"/>
+            <a:ext cx="5120640" cy="841248"/>
+          </a:xfrm>
+          <a:prstGeom prst="roundRect">
+            <a:avLst>
+              <a:gd name="adj" fmla="val 6522"/>
+            </a:avLst>
+          </a:prstGeom>
+          <a:solidFill>
+            <a:srgbClr val="F2F5FC"/>
+          </a:solidFill>
+          <a:ln w="12700">
+            <a:solidFill>
+              <a:srgbClr val="CADCFC"/>
+            </a:solidFill>
+            <a:prstDash val="solid"/>
+          </a:ln>
+        </p:spPr>
+      </p:sp>
+      <p:sp>
+        <p:nvSpPr>
+          <p:cNvPr id="9" name="Text 6"/>
+          <p:cNvSpPr/>
+          <p:nvPr/>
+        </p:nvSpPr>
+        <p:spPr>
+          <a:xfrm>
+            <a:off x="6720840" y="2679192"/>
+            <a:ext cx="4754880" cy="274320"/>
+          </a:xfrm>
+          <a:prstGeom prst="rect">
+            <a:avLst/>
+          </a:prstGeom>
+          <a:noFill/>
+          <a:ln/>
+        </p:spPr>
+        <p:txBody>
+          <a:bodyPr wrap="square" rtlCol="0" anchor="ctr"/>
+          <a:lstStyle/>
+          <a:p>
+            <a:pPr indent="0" marL="0">
+              <a:buNone/>
+            </a:pPr>
+            <a:r>
+              <a:rPr lang="en-US" sz="1150" b="1" dirty="0">
+                <a:solidFill>
+                  <a:srgbClr val="1E2761"/>
+                </a:solidFill>
+                <a:latin typeface="Cambria" pitchFamily="34" charset="0"/>
+                <a:ea typeface="Cambria" pitchFamily="34" charset="-122"/>
+                <a:cs typeface="Cambria" pitchFamily="34" charset="-120"/>
+              </a:rPr>
+              <a:t>2  Payments</a:t>
+            </a:r>
+            <a:endParaRPr lang="en-US" sz="1150" dirty="0"/>
+          </a:p>
+        </p:txBody>
+      </p:sp>
+      <p:sp>
+        <p:nvSpPr>
+          <p:cNvPr id="10" name="Text 7"/>
+          <p:cNvSpPr/>
+          <p:nvPr/>
+        </p:nvSpPr>
+        <p:spPr>
+          <a:xfrm>
+            <a:off x="6720840" y="2953512"/>
+            <a:ext cx="4800600" cy="502920"/>
+          </a:xfrm>
+          <a:prstGeom prst="rect">
+            <a:avLst/>
+          </a:prstGeom>
+          <a:noFill/>
+          <a:ln/>
+        </p:spPr>
+        <p:txBody>
+          <a:bodyPr wrap="square" rtlCol="0" anchor="ctr"/>
+          <a:lstStyle/>
+          <a:p>
+            <a:pPr indent="0" marL="0">
+              <a:buNone/>
+            </a:pPr>
+            <a:r>
+              <a:rPr lang="en-US" sz="950" dirty="0">
+                <a:solidFill>
+                  <a:srgbClr val="1A1A2E"/>
+                </a:solidFill>
+                <a:latin typeface="Calibri" pitchFamily="34" charset="0"/>
+                <a:ea typeface="Calibri" pitchFamily="34" charset="-122"/>
+                <a:cs typeface="Calibri" pitchFamily="34" charset="-120"/>
+              </a:rPr>
+              <a:t>amounts + scope pick the eligible rail: ≥₹2L unlocks RTGS, ≤₹5L allows IMPS, cross-border → SWIFT; a slice arrives deliberately mis-routed</a:t>
+            </a:r>
+            <a:endParaRPr lang="en-US" sz="950" dirty="0"/>
+          </a:p>
+        </p:txBody>
+      </p:sp>
+      <p:sp>
+        <p:nvSpPr>
+          <p:cNvPr id="11" name="Shape 8"/>
+          <p:cNvSpPr/>
+          <p:nvPr/>
+        </p:nvSpPr>
+        <p:spPr>
+          <a:xfrm>
+            <a:off x="6537960" y="3557016"/>
+            <a:ext cx="5120640" cy="841248"/>
+          </a:xfrm>
+          <a:prstGeom prst="roundRect">
+            <a:avLst>
+              <a:gd name="adj" fmla="val 6522"/>
+            </a:avLst>
+          </a:prstGeom>
+          <a:solidFill>
+            <a:srgbClr val="F2F5FC"/>
+          </a:solidFill>
+          <a:ln w="12700">
+            <a:solidFill>
+              <a:srgbClr val="CADCFC"/>
+            </a:solidFill>
+            <a:prstDash val="solid"/>
+          </a:ln>
+        </p:spPr>
+      </p:sp>
+      <p:sp>
+        <p:nvSpPr>
+          <p:cNvPr id="12" name="Text 9"/>
+          <p:cNvSpPr/>
+          <p:nvPr/>
+        </p:nvSpPr>
+        <p:spPr>
+          <a:xfrm>
+            <a:off x="6720840" y="3611880"/>
+            <a:ext cx="4754880" cy="274320"/>
+          </a:xfrm>
+          <a:prstGeom prst="rect">
+            <a:avLst/>
+          </a:prstGeom>
+          <a:noFill/>
+          <a:ln/>
+        </p:spPr>
+        <p:txBody>
+          <a:bodyPr wrap="square" rtlCol="0" anchor="ctr"/>
+          <a:lstStyle/>
+          <a:p>
+            <a:pPr indent="0" marL="0">
+              <a:buNone/>
+            </a:pPr>
+            <a:r>
+              <a:rPr lang="en-US" sz="1150" b="1" dirty="0">
+                <a:solidFill>
+                  <a:srgbClr val="1E2761"/>
+                </a:solidFill>
+                <a:latin typeface="Cambria" pitchFamily="34" charset="0"/>
+                <a:ea typeface="Cambria" pitchFamily="34" charset="-122"/>
+                <a:cs typeface="Cambria" pitchFamily="34" charset="-120"/>
+              </a:rPr>
+              <a:t>3  Exceptions</a:t>
+            </a:r>
+            <a:endParaRPr lang="en-US" sz="1150" dirty="0"/>
+          </a:p>
+        </p:txBody>
+      </p:sp>
+      <p:sp>
+        <p:nvSpPr>
+          <p:cNvPr id="13" name="Text 10"/>
+          <p:cNvSpPr/>
+          <p:nvPr/>
+        </p:nvSpPr>
+        <p:spPr>
+          <a:xfrm>
+            <a:off x="6720840" y="3886200"/>
+            <a:ext cx="4800600" cy="502920"/>
+          </a:xfrm>
+          <a:prstGeom prst="rect">
+            <a:avLst/>
+          </a:prstGeom>
+          <a:noFill/>
+          <a:ln/>
+        </p:spPr>
+        <p:txBody>
+          <a:bodyPr wrap="square" rtlCol="0" anchor="ctr"/>
+          <a:lstStyle/>
+          <a:p>
+            <a:pPr indent="0" marL="0">
+              <a:buNone/>
+            </a:pPr>
+            <a:r>
+              <a:rPr lang="en-US" sz="950" dirty="0">
+                <a:solidFill>
+                  <a:srgbClr val="1A1A2E"/>
+                </a:solidFill>
+                <a:latin typeface="Calibri" pitchFamily="34" charset="0"/>
+                <a:ea typeface="Calibri" pitchFamily="34" charset="-122"/>
+                <a:cs typeface="Calibri" pitchFamily="34" charset="-120"/>
+              </a:rPr>
+              <a:t>a hazard model injects 16 exception types (sanctions, liquidity, format…) at lifecycle steps → terminal status, settle time, charges</a:t>
+            </a:r>
+            <a:endParaRPr lang="en-US" sz="950" dirty="0"/>
+          </a:p>
+        </p:txBody>
+      </p:sp>
+      <p:sp>
+        <p:nvSpPr>
+          <p:cNvPr id="14" name="Shape 11"/>
+          <p:cNvSpPr/>
+          <p:nvPr/>
+        </p:nvSpPr>
+        <p:spPr>
+          <a:xfrm>
+            <a:off x="6537960" y="4489704"/>
+            <a:ext cx="5120640" cy="841248"/>
+          </a:xfrm>
+          <a:prstGeom prst="roundRect">
+            <a:avLst>
+              <a:gd name="adj" fmla="val 6522"/>
+            </a:avLst>
+          </a:prstGeom>
+          <a:solidFill>
+            <a:srgbClr val="F2F5FC"/>
+          </a:solidFill>
+          <a:ln w="12700">
+            <a:solidFill>
+              <a:srgbClr val="CADCFC"/>
+            </a:solidFill>
+            <a:prstDash val="solid"/>
+          </a:ln>
+        </p:spPr>
+      </p:sp>
+      <p:sp>
+        <p:nvSpPr>
+          <p:cNvPr id="15" name="Text 12"/>
+          <p:cNvSpPr/>
+          <p:nvPr/>
+        </p:nvSpPr>
+        <p:spPr>
+          <a:xfrm>
+            <a:off x="6720840" y="4544568"/>
+            <a:ext cx="4754880" cy="274320"/>
+          </a:xfrm>
+          <a:prstGeom prst="rect">
+            <a:avLst/>
+          </a:prstGeom>
+          <a:noFill/>
+          <a:ln/>
+        </p:spPr>
+        <p:txBody>
+          <a:bodyPr wrap="square" rtlCol="0" anchor="ctr"/>
+          <a:lstStyle/>
+          <a:p>
+            <a:pPr indent="0" marL="0">
+              <a:buNone/>
+            </a:pPr>
+            <a:r>
+              <a:rPr lang="en-US" sz="1150" b="1" dirty="0">
+                <a:solidFill>
+                  <a:srgbClr val="1E2761"/>
+                </a:solidFill>
+                <a:latin typeface="Cambria" pitchFamily="34" charset="0"/>
+                <a:ea typeface="Cambria" pitchFamily="34" charset="-122"/>
+                <a:cs typeface="Cambria" pitchFamily="34" charset="-120"/>
+              </a:rPr>
+              <a:t>4  Lifecycle expansion</a:t>
+            </a:r>
+            <a:endParaRPr lang="en-US" sz="1150" dirty="0"/>
+          </a:p>
+        </p:txBody>
+      </p:sp>
+      <p:sp>
+        <p:nvSpPr>
+          <p:cNvPr id="16" name="Text 13"/>
+          <p:cNvSpPr/>
+          <p:nvPr/>
+        </p:nvSpPr>
+        <p:spPr>
+          <a:xfrm>
+            <a:off x="6720840" y="4818888"/>
+            <a:ext cx="4800600" cy="502920"/>
+          </a:xfrm>
+          <a:prstGeom prst="rect">
+            <a:avLst/>
+          </a:prstGeom>
+          <a:noFill/>
+          <a:ln/>
+        </p:spPr>
+        <p:txBody>
+          <a:bodyPr wrap="square" rtlCol="0" anchor="ctr"/>
+          <a:lstStyle/>
+          <a:p>
+            <a:pPr indent="0" marL="0">
+              <a:buNone/>
+            </a:pPr>
+            <a:r>
+              <a:rPr lang="en-US" sz="950" dirty="0">
+                <a:solidFill>
+                  <a:srgbClr val="1A1A2E"/>
+                </a:solidFill>
+                <a:latin typeface="Calibri" pitchFamily="34" charset="0"/>
+                <a:ea typeface="Calibri" pitchFamily="34" charset="-122"/>
+                <a:cs typeface="Calibri" pitchFamily="34" charset="-120"/>
+              </a:rPr>
+              <a:t>each payment becomes its ISO trail — pain.001→pacs.008→pacs.002→camt.054, recalls (camt.056) &amp; returns (pacs.004) — timestamps anchored to the events</a:t>
+            </a:r>
+            <a:endParaRPr lang="en-US" sz="950" dirty="0"/>
+          </a:p>
+        </p:txBody>
+      </p:sp>
+      <p:sp>
+        <p:nvSpPr>
+          <p:cNvPr id="17" name="Shape 14"/>
+          <p:cNvSpPr/>
+          <p:nvPr/>
+        </p:nvSpPr>
+        <p:spPr>
+          <a:xfrm>
+            <a:off x="6537960" y="5422392"/>
+            <a:ext cx="5120640" cy="841248"/>
+          </a:xfrm>
+          <a:prstGeom prst="roundRect">
+            <a:avLst>
+              <a:gd name="adj" fmla="val 6522"/>
+            </a:avLst>
+          </a:prstGeom>
+          <a:solidFill>
+            <a:srgbClr val="F2F5FC"/>
+          </a:solidFill>
+          <a:ln w="12700">
+            <a:solidFill>
+              <a:srgbClr val="CADCFC"/>
+            </a:solidFill>
+            <a:prstDash val="solid"/>
+          </a:ln>
+        </p:spPr>
+      </p:sp>
+      <p:sp>
+        <p:nvSpPr>
+          <p:cNvPr id="18" name="Text 15"/>
+          <p:cNvSpPr/>
+          <p:nvPr/>
+        </p:nvSpPr>
+        <p:spPr>
+          <a:xfrm>
+            <a:off x="6720840" y="5477256"/>
+            <a:ext cx="4754880" cy="274320"/>
+          </a:xfrm>
+          <a:prstGeom prst="rect">
+            <a:avLst/>
+          </a:prstGeom>
+          <a:noFill/>
+          <a:ln/>
+        </p:spPr>
+        <p:txBody>
+          <a:bodyPr wrap="square" rtlCol="0" anchor="ctr"/>
+          <a:lstStyle/>
+          <a:p>
+            <a:pPr indent="0" marL="0">
+              <a:buNone/>
+            </a:pPr>
+            <a:r>
+              <a:rPr lang="en-US" sz="1150" b="1" dirty="0">
+                <a:solidFill>
+                  <a:srgbClr val="1E2761"/>
+                </a:solidFill>
+                <a:latin typeface="Cambria" pitchFamily="34" charset="0"/>
+                <a:ea typeface="Cambria" pitchFamily="34" charset="-122"/>
+                <a:cs typeface="Cambria" pitchFamily="34" charset="-120"/>
+              </a:rPr>
+              <a:t>5  Planted couplings</a:t>
+            </a:r>
+            <a:endParaRPr lang="en-US" sz="1150" dirty="0"/>
+          </a:p>
+        </p:txBody>
+      </p:sp>
+      <p:sp>
+        <p:nvSpPr>
+          <p:cNvPr id="19" name="Text 16"/>
+          <p:cNvSpPr/>
+          <p:nvPr/>
+        </p:nvSpPr>
+        <p:spPr>
+          <a:xfrm>
+            <a:off x="6720840" y="5751576"/>
+            <a:ext cx="4800600" cy="502920"/>
+          </a:xfrm>
+          <a:prstGeom prst="rect">
+            <a:avLst/>
+          </a:prstGeom>
+          <a:noFill/>
+          <a:ln/>
+        </p:spPr>
+        <p:txBody>
+          <a:bodyPr wrap="square" rtlCol="0" anchor="ctr"/>
+          <a:lstStyle/>
+          <a:p>
+            <a:pPr indent="0" marL="0">
+              <a:buNone/>
+            </a:pPr>
+            <a:r>
+              <a:rPr lang="en-US" sz="950" dirty="0">
+                <a:solidFill>
+                  <a:srgbClr val="1A1A2E"/>
+                </a:solidFill>
+                <a:latin typeface="Calibri" pitchFamily="34" charset="0"/>
+                <a:ea typeface="Calibri" pitchFamily="34" charset="-122"/>
+                <a:cs typeface="Calibri" pitchFamily="34" charset="-120"/>
+              </a:rPr>
+              <a:t>3% cancellations; origination ATO risk ×8-coupled to later recalls; optional salary/rent/supplier cadences for forecasting</a:t>
+            </a:r>
+            <a:endParaRPr lang="en-US" sz="950" dirty="0"/>
+          </a:p>
+        </p:txBody>
+      </p:sp>
+      <p:sp>
+        <p:nvSpPr>
+          <p:cNvPr id="20" name="Text 17"/>
+          <p:cNvSpPr/>
+          <p:nvPr/>
+        </p:nvSpPr>
+        <p:spPr>
+          <a:xfrm>
+            <a:off x="457200" y="6172200"/>
+            <a:ext cx="11274552" cy="365760"/>
+          </a:xfrm>
+          <a:prstGeom prst="rect">
+            <a:avLst/>
+          </a:prstGeom>
+          <a:noFill/>
+          <a:ln/>
+        </p:spPr>
+        <p:txBody>
+          <a:bodyPr wrap="square" rtlCol="0" anchor="ctr"/>
+          <a:lstStyle/>
+          <a:p>
+            <a:pPr indent="0" marL="0">
+              <a:buNone/>
+            </a:pPr>
+            <a:r>
+              <a:rPr lang="en-US" sz="1150" i="1" dirty="0">
+                <a:solidFill>
+                  <a:srgbClr val="5A6172"/>
+                </a:solidFill>
+                <a:latin typeface="Calibri" pitchFamily="34" charset="0"/>
+                <a:ea typeface="Calibri" pitchFamily="34" charset="-122"/>
+                <a:cs typeface="Calibri" pitchFamily="34" charset="-120"/>
+              </a:rPr>
+              <a:t>No real transaction data anywhere. The generators are the falsifiability tool: labels with known causes let a claim fail loudly.</a:t>
+            </a:r>
+            <a:endParaRPr lang="en-US" sz="1150" dirty="0"/>
+          </a:p>
+        </p:txBody>
+      </p:sp>
+    </p:spTree>
+  </p:cSld>
+  <p:clrMapOvr>
+    <a:masterClrMapping/>
+  </p:clrMapOvr>
+</p:sld>
+</file>
+
+<file path=ppt/slides/slide11.xml><?xml version="1.0" encoding="utf-8"?>
+<p:sld xmlns:a="http://schemas.openxmlformats.org/drawingml/2006/main" xmlns:r="http://schemas.openxmlformats.org/officeDocument/2006/relationships" xmlns:p="http://schemas.openxmlformats.org/presentationml/2006/main">
+  <p:cSld name="Slide 11">
+    <p:bg>
+      <p:bgPr>
+        <a:solidFill>
+          <a:srgbClr val="FFFFFF"/>
+        </a:solidFill>
+      </p:bgPr>
+    </p:bg>
+    <p:spTree>
+      <p:nvGrpSpPr>
+        <p:cNvPr id="1" name=""/>
+        <p:cNvGrpSpPr/>
+        <p:nvPr/>
+      </p:nvGrpSpPr>
+      <p:grpSpPr>
+        <a:xfrm>
+          <a:off x="0" y="0"/>
+          <a:ext cx="0" cy="0"/>
+          <a:chOff x="0" y="0"/>
+          <a:chExt cx="0" cy="0"/>
+        </a:xfrm>
+      </p:grpSpPr>
+      <p:sp>
+        <p:nvSpPr>
+          <p:cNvPr id="2" name="Text 0"/>
+          <p:cNvSpPr/>
+          <p:nvPr/>
+        </p:nvSpPr>
+        <p:spPr>
+          <a:xfrm>
+            <a:off x="548640" y="365760"/>
+            <a:ext cx="11064240" cy="594360"/>
+          </a:xfrm>
+          <a:prstGeom prst="rect">
+            <a:avLst/>
+          </a:prstGeom>
+          <a:noFill/>
+          <a:ln/>
+        </p:spPr>
+        <p:txBody>
+          <a:bodyPr wrap="square" rtlCol="0" anchor="ctr"/>
+          <a:lstStyle/>
+          <a:p>
+            <a:pPr indent="0" marL="0">
+              <a:buNone/>
+            </a:pPr>
+            <a:r>
+              <a:rPr lang="en-US" sz="3000" b="1" dirty="0">
+                <a:solidFill>
+                  <a:srgbClr val="1E2761"/>
+                </a:solidFill>
+                <a:latin typeface="Cambria" pitchFamily="34" charset="0"/>
+                <a:ea typeface="Cambria" pitchFamily="34" charset="-122"/>
+                <a:cs typeface="Cambria" pitchFamily="34" charset="-120"/>
+              </a:rPr>
+              <a:t>Status today — trained on CPU, claims verified on GPU</a:t>
+            </a:r>
+            <a:endParaRPr lang="en-US" sz="3000" dirty="0"/>
+          </a:p>
+        </p:txBody>
+      </p:sp>
+      <p:sp>
+        <p:nvSpPr>
+          <p:cNvPr id="3" name="Text 1"/>
+          <p:cNvSpPr/>
+          <p:nvPr/>
+        </p:nvSpPr>
+        <p:spPr>
+          <a:xfrm>
+            <a:off x="566928" y="969264"/>
+            <a:ext cx="10972800" cy="365760"/>
+          </a:xfrm>
+          <a:prstGeom prst="rect">
+            <a:avLst/>
+          </a:prstGeom>
+          <a:noFill/>
+          <a:ln/>
+        </p:spPr>
+        <p:txBody>
+          <a:bodyPr wrap="square" rtlCol="0" anchor="ctr"/>
+          <a:lstStyle/>
+          <a:p>
+            <a:pPr indent="0" marL="0">
+              <a:buNone/>
+            </a:pPr>
+            <a:r>
+              <a:rPr lang="en-US" sz="1400" i="1" dirty="0">
+                <a:solidFill>
+                  <a:srgbClr val="5A6172"/>
+                </a:solidFill>
+                <a:latin typeface="Calibri" pitchFamily="34" charset="0"/>
+                <a:ea typeface="Calibri" pitchFamily="34" charset="-122"/>
+                <a:cs typeface="Calibri" pitchFamily="34" charset="-120"/>
+              </a:rPr>
+              <a:t>End-to-end on synthetic data; full-scale claim runs reproduced on an H200.</a:t>
+            </a:r>
+            <a:endParaRPr lang="en-US" sz="1400" dirty="0"/>
+          </a:p>
+        </p:txBody>
+      </p:sp>
+      <p:sp>
+        <p:nvSpPr>
+          <p:cNvPr id="4" name="Shape 2"/>
+          <p:cNvSpPr/>
+          <p:nvPr/>
+        </p:nvSpPr>
+        <p:spPr>
+          <a:xfrm>
+            <a:off x="548640" y="1600200"/>
+            <a:ext cx="3520440" cy="1508760"/>
+          </a:xfrm>
+          <a:prstGeom prst="roundRect">
+            <a:avLst>
+              <a:gd name="adj" fmla="val 4848"/>
+            </a:avLst>
+          </a:prstGeom>
+          <a:solidFill>
+            <a:srgbClr val="F2F5FC"/>
+          </a:solidFill>
+          <a:ln w="12700">
+            <a:solidFill>
+              <a:srgbClr val="CADCFC"/>
+            </a:solidFill>
+            <a:prstDash val="solid"/>
+          </a:ln>
+        </p:spPr>
+      </p:sp>
+      <p:sp>
+        <p:nvSpPr>
+          <p:cNvPr id="5" name="Text 3"/>
+          <p:cNvSpPr/>
+          <p:nvPr/>
+        </p:nvSpPr>
+        <p:spPr>
+          <a:xfrm>
+            <a:off x="777240" y="1783080"/>
+            <a:ext cx="3108960" cy="731520"/>
+          </a:xfrm>
+          <a:prstGeom prst="rect">
+            <a:avLst/>
+          </a:prstGeom>
+          <a:noFill/>
+          <a:ln/>
+        </p:spPr>
+        <p:txBody>
+          <a:bodyPr wrap="square" rtlCol="0" anchor="ctr"/>
+          <a:lstStyle/>
+          <a:p>
+            <a:pPr indent="0" marL="0">
+              <a:buNone/>
+            </a:pPr>
+            <a:r>
+              <a:rPr lang="en-US" sz="3200" b="1" dirty="0">
+                <a:solidFill>
+                  <a:srgbClr val="1E2761"/>
+                </a:solidFill>
+                <a:latin typeface="Cambria" pitchFamily="34" charset="0"/>
+                <a:ea typeface="Cambria" pitchFamily="34" charset="-122"/>
+                <a:cs typeface="Cambria" pitchFamily="34" charset="-120"/>
+              </a:rPr>
+              <a:t>20,000</a:t>
+            </a:r>
+            <a:endParaRPr lang="en-US" sz="3200" dirty="0"/>
+          </a:p>
+        </p:txBody>
+      </p:sp>
+      <p:sp>
+        <p:nvSpPr>
+          <p:cNvPr id="6" name="Text 4"/>
+          <p:cNvSpPr/>
+          <p:nvPr/>
+        </p:nvSpPr>
+        <p:spPr>
+          <a:xfrm>
+            <a:off x="777240" y="2542032"/>
+            <a:ext cx="3108960" cy="457200"/>
+          </a:xfrm>
+          <a:prstGeom prst="rect">
+            <a:avLst/>
+          </a:prstGeom>
+          <a:noFill/>
+          <a:ln/>
+        </p:spPr>
+        <p:txBody>
+          <a:bodyPr wrap="square" rtlCol="0" anchor="ctr"/>
+          <a:lstStyle/>
+          <a:p>
+            <a:pPr indent="0" marL="0">
+              <a:buNone/>
+            </a:pPr>
+            <a:r>
+              <a:rPr lang="en-US" sz="1300" dirty="0">
+                <a:solidFill>
+                  <a:srgbClr val="1A1A2E"/>
+                </a:solidFill>
+                <a:latin typeface="Calibri" pitchFamily="34" charset="0"/>
+                <a:ea typeface="Calibri" pitchFamily="34" charset="-122"/>
+                <a:cs typeface="Calibri" pitchFamily="34" charset="-120"/>
+              </a:rPr>
+              <a:t>payments trained</a:t>
+            </a:r>
+            <a:endParaRPr lang="en-US" sz="1300" dirty="0"/>
+          </a:p>
+        </p:txBody>
+      </p:sp>
+      <p:sp>
+        <p:nvSpPr>
+          <p:cNvPr id="7" name="Shape 5"/>
+          <p:cNvSpPr/>
+          <p:nvPr/>
+        </p:nvSpPr>
+        <p:spPr>
+          <a:xfrm>
+            <a:off x="4251960" y="1600200"/>
+            <a:ext cx="3520440" cy="1508760"/>
+          </a:xfrm>
+          <a:prstGeom prst="roundRect">
+            <a:avLst>
+              <a:gd name="adj" fmla="val 4848"/>
+            </a:avLst>
+          </a:prstGeom>
+          <a:solidFill>
+            <a:srgbClr val="F2F5FC"/>
+          </a:solidFill>
+          <a:ln w="12700">
+            <a:solidFill>
+              <a:srgbClr val="CADCFC"/>
+            </a:solidFill>
+            <a:prstDash val="solid"/>
+          </a:ln>
+        </p:spPr>
+      </p:sp>
+      <p:sp>
+        <p:nvSpPr>
+          <p:cNvPr id="8" name="Text 6"/>
+          <p:cNvSpPr/>
+          <p:nvPr/>
+        </p:nvSpPr>
+        <p:spPr>
+          <a:xfrm>
+            <a:off x="4480560" y="1783080"/>
+            <a:ext cx="3108960" cy="731520"/>
+          </a:xfrm>
+          <a:prstGeom prst="rect">
+            <a:avLst/>
+          </a:prstGeom>
+          <a:noFill/>
+          <a:ln/>
+        </p:spPr>
+        <p:txBody>
+          <a:bodyPr wrap="square" rtlCol="0" anchor="ctr"/>
+          <a:lstStyle/>
+          <a:p>
+            <a:pPr indent="0" marL="0">
+              <a:buNone/>
+            </a:pPr>
+            <a:r>
+              <a:rPr lang="en-US" sz="3200" b="1" dirty="0">
+                <a:solidFill>
+                  <a:srgbClr val="1E2761"/>
+                </a:solidFill>
+                <a:latin typeface="Cambria" pitchFamily="34" charset="0"/>
+                <a:ea typeface="Cambria" pitchFamily="34" charset="-122"/>
+                <a:cs typeface="Cambria" pitchFamily="34" charset="-120"/>
+              </a:rPr>
+              <a:t>100</a:t>
+            </a:r>
+            <a:endParaRPr lang="en-US" sz="3200" dirty="0"/>
+          </a:p>
+        </p:txBody>
+      </p:sp>
+      <p:sp>
+        <p:nvSpPr>
+          <p:cNvPr id="9" name="Text 7"/>
+          <p:cNvSpPr/>
+          <p:nvPr/>
+        </p:nvSpPr>
+        <p:spPr>
+          <a:xfrm>
+            <a:off x="4480560" y="2542032"/>
+            <a:ext cx="3108960" cy="457200"/>
+          </a:xfrm>
+          <a:prstGeom prst="rect">
+            <a:avLst/>
+          </a:prstGeom>
+          <a:noFill/>
+          <a:ln/>
+        </p:spPr>
+        <p:txBody>
+          <a:bodyPr wrap="square" rtlCol="0" anchor="ctr"/>
+          <a:lstStyle/>
+          <a:p>
+            <a:pPr indent="0" marL="0">
+              <a:buNone/>
+            </a:pPr>
+            <a:r>
+              <a:rPr lang="en-US" sz="1300" dirty="0">
+                <a:solidFill>
+                  <a:srgbClr val="1A1A2E"/>
+                </a:solidFill>
+                <a:latin typeface="Calibri" pitchFamily="34" charset="0"/>
+                <a:ea typeface="Calibri" pitchFamily="34" charset="-122"/>
+                <a:cs typeface="Calibri" pitchFamily="34" charset="-120"/>
+              </a:rPr>
+              <a:t>held-out test payments scored</a:t>
+            </a:r>
+            <a:endParaRPr lang="en-US" sz="1300" dirty="0"/>
+          </a:p>
+        </p:txBody>
+      </p:sp>
+      <p:sp>
+        <p:nvSpPr>
+          <p:cNvPr id="10" name="Shape 8"/>
+          <p:cNvSpPr/>
+          <p:nvPr/>
+        </p:nvSpPr>
+        <p:spPr>
+          <a:xfrm>
+            <a:off x="7955280" y="1600200"/>
+            <a:ext cx="3520440" cy="1508760"/>
+          </a:xfrm>
+          <a:prstGeom prst="roundRect">
+            <a:avLst>
+              <a:gd name="adj" fmla="val 4848"/>
+            </a:avLst>
+          </a:prstGeom>
+          <a:solidFill>
+            <a:srgbClr val="F2F5FC"/>
+          </a:solidFill>
+          <a:ln w="12700">
+            <a:solidFill>
+              <a:srgbClr val="CADCFC"/>
+            </a:solidFill>
+            <a:prstDash val="solid"/>
+          </a:ln>
+        </p:spPr>
+      </p:sp>
+      <p:sp>
+        <p:nvSpPr>
+          <p:cNvPr id="11" name="Text 9"/>
+          <p:cNvSpPr/>
+          <p:nvPr/>
+        </p:nvSpPr>
+        <p:spPr>
+          <a:xfrm>
+            <a:off x="8183880" y="1783080"/>
+            <a:ext cx="3108960" cy="731520"/>
+          </a:xfrm>
+          <a:prstGeom prst="rect">
+            <a:avLst/>
+          </a:prstGeom>
+          <a:noFill/>
+          <a:ln/>
+        </p:spPr>
+        <p:txBody>
+          <a:bodyPr wrap="square" rtlCol="0" anchor="ctr"/>
+          <a:lstStyle/>
+          <a:p>
+            <a:pPr indent="0" marL="0">
+              <a:buNone/>
+            </a:pPr>
+            <a:r>
+              <a:rPr lang="en-US" sz="3200" b="1" dirty="0">
+                <a:solidFill>
+                  <a:srgbClr val="1E2761"/>
+                </a:solidFill>
+                <a:latin typeface="Cambria" pitchFamily="34" charset="0"/>
+                <a:ea typeface="Cambria" pitchFamily="34" charset="-122"/>
+                <a:cs typeface="Cambria" pitchFamily="34" charset="-120"/>
+              </a:rPr>
+              <a:t>CSV → CSV</a:t>
+            </a:r>
+            <a:endParaRPr lang="en-US" sz="3200" dirty="0"/>
+          </a:p>
+        </p:txBody>
+      </p:sp>
+      <p:sp>
+        <p:nvSpPr>
+          <p:cNvPr id="12" name="Text 10"/>
+          <p:cNvSpPr/>
+          <p:nvPr/>
+        </p:nvSpPr>
+        <p:spPr>
+          <a:xfrm>
+            <a:off x="8183880" y="2542032"/>
+            <a:ext cx="3108960" cy="457200"/>
+          </a:xfrm>
+          <a:prstGeom prst="rect">
+            <a:avLst/>
+          </a:prstGeom>
+          <a:noFill/>
+          <a:ln/>
+        </p:spPr>
+        <p:txBody>
+          <a:bodyPr wrap="square" rtlCol="0" anchor="ctr"/>
+          <a:lstStyle/>
+          <a:p>
+            <a:pPr indent="0" marL="0">
+              <a:buNone/>
+            </a:pPr>
+            <a:r>
+              <a:rPr lang="en-US" sz="1300" dirty="0">
+                <a:solidFill>
+                  <a:srgbClr val="1A1A2E"/>
+                </a:solidFill>
+                <a:latin typeface="Calibri" pitchFamily="34" charset="0"/>
+                <a:ea typeface="Calibri" pitchFamily="34" charset="-122"/>
+                <a:cs typeface="Calibri" pitchFamily="34" charset="-120"/>
+              </a:rPr>
+              <a:t>input and output files</a:t>
+            </a:r>
+            <a:endParaRPr lang="en-US" sz="1300" dirty="0"/>
+          </a:p>
+        </p:txBody>
+      </p:sp>
+      <p:sp>
+        <p:nvSpPr>
+          <p:cNvPr id="13" name="Text 11"/>
+          <p:cNvSpPr/>
+          <p:nvPr/>
+        </p:nvSpPr>
+        <p:spPr>
+          <a:xfrm>
+            <a:off x="548640" y="3383280"/>
+            <a:ext cx="11064240" cy="411480"/>
+          </a:xfrm>
+          <a:prstGeom prst="rect">
+            <a:avLst/>
+          </a:prstGeom>
+          <a:noFill/>
+          <a:ln/>
+        </p:spPr>
+        <p:txBody>
+          <a:bodyPr wrap="square" rtlCol="0" anchor="ctr"/>
+          <a:lstStyle/>
+          <a:p>
+            <a:pPr indent="0" marL="0">
+              <a:buNone/>
+            </a:pPr>
+            <a:r>
+              <a:rPr lang="en-US" sz="1300" b="1" dirty="0">
+                <a:solidFill>
+                  <a:srgbClr val="1E2761"/>
+                </a:solidFill>
+                <a:latin typeface="Calibri" pitchFamily="34" charset="0"/>
+                <a:ea typeface="Calibri" pitchFamily="34" charset="-122"/>
+                <a:cs typeface="Calibri" pitchFamily="34" charset="-120"/>
+              </a:rPr>
+              <a:t>Held-out n=4,000: rail 0.56 probe vs 0.65 tree (4-class, harder without UPI)  ·  ETA 195 min vs 392 naive  ·  status 0.28 (weak — tree territory, reported openly)</a:t>
+            </a:r>
+            <a:endParaRPr lang="en-US" sz="1300" dirty="0"/>
+          </a:p>
+        </p:txBody>
+      </p:sp>
+      <p:sp>
+        <p:nvSpPr>
+          <p:cNvPr id="14" name="Text 12"/>
+          <p:cNvSpPr/>
+          <p:nvPr/>
+        </p:nvSpPr>
+        <p:spPr>
+          <a:xfrm>
+            <a:off x="548640" y="3886200"/>
+            <a:ext cx="11064240" cy="411480"/>
+          </a:xfrm>
+          <a:prstGeom prst="rect">
+            <a:avLst/>
+          </a:prstGeom>
+          <a:noFill/>
+          <a:ln/>
+        </p:spPr>
+        <p:txBody>
+          <a:bodyPr wrap="square" rtlCol="0" anchor="ctr"/>
+          <a:lstStyle/>
+          <a:p>
+            <a:pPr indent="0" marL="0">
+              <a:buNone/>
+            </a:pPr>
+            <a:r>
+              <a:rPr lang="en-US" sz="1300" b="1" dirty="0">
+                <a:solidFill>
+                  <a:srgbClr val="2E7D32"/>
+                </a:solidFill>
+                <a:latin typeface="Calibri" pitchFamily="34" charset="0"/>
+                <a:ea typeface="Calibri" pitchFamily="34" charset="-122"/>
+                <a:cs typeface="Calibri" pitchFamily="34" charset="-120"/>
+              </a:rPr>
+              <a:t>At initiation (pain.001, before clearing): ETA 172 vs 234 naive  ·  charges MAE 117 vs 203  ·  'will it credit' 0.86 → 0.94 as messages arrive.</a:t>
+            </a:r>
+            <a:endParaRPr lang="en-US" sz="1300" dirty="0"/>
+          </a:p>
+        </p:txBody>
+      </p:sp>
+      <p:sp>
+        <p:nvSpPr>
+          <p:cNvPr id="15" name="Shape 13"/>
+          <p:cNvSpPr/>
+          <p:nvPr/>
+        </p:nvSpPr>
+        <p:spPr>
+          <a:xfrm>
+            <a:off x="548640" y="4526280"/>
+            <a:ext cx="3566160" cy="640080"/>
+          </a:xfrm>
+          <a:prstGeom prst="roundRect">
+            <a:avLst>
+              <a:gd name="adj" fmla="val 11429"/>
+            </a:avLst>
+          </a:prstGeom>
+          <a:solidFill>
+            <a:srgbClr val="F2F5FC"/>
+          </a:solidFill>
+          <a:ln w="12700">
+            <a:solidFill>
+              <a:srgbClr val="F2F5FC"/>
+            </a:solidFill>
+            <a:prstDash val="solid"/>
+          </a:ln>
+        </p:spPr>
+      </p:sp>
+      <p:sp>
+        <p:nvSpPr>
+          <p:cNvPr id="16" name="Text 14"/>
+          <p:cNvSpPr/>
+          <p:nvPr/>
+        </p:nvSpPr>
+        <p:spPr>
+          <a:xfrm>
+            <a:off x="594360" y="4526280"/>
+            <a:ext cx="3474720" cy="640080"/>
+          </a:xfrm>
+          <a:prstGeom prst="rect">
+            <a:avLst/>
+          </a:prstGeom>
+          <a:noFill/>
+          <a:ln/>
+        </p:spPr>
+        <p:txBody>
+          <a:bodyPr wrap="square" rtlCol="0" anchor="ctr"/>
+          <a:lstStyle/>
+          <a:p>
+            <a:pPr algn="ctr" indent="0" marL="0">
+              <a:buNone/>
+            </a:pPr>
+            <a:r>
+              <a:rPr lang="en-US" sz="1250" b="1" dirty="0">
+                <a:solidFill>
+                  <a:srgbClr val="1E2761"/>
+                </a:solidFill>
+                <a:latin typeface="Calibri" pitchFamily="34" charset="0"/>
+                <a:ea typeface="Calibri" pitchFamily="34" charset="-122"/>
+                <a:cs typeface="Calibri" pitchFamily="34" charset="-120"/>
+              </a:rPr>
+              <a:t>+ full ISO 20022 lifecycle modeled</a:t>
+            </a:r>
+            <a:endParaRPr lang="en-US" sz="1250" dirty="0"/>
+          </a:p>
+        </p:txBody>
+      </p:sp>
+      <p:sp>
+        <p:nvSpPr>
+          <p:cNvPr id="17" name="Shape 15"/>
+          <p:cNvSpPr/>
+          <p:nvPr/>
+        </p:nvSpPr>
+        <p:spPr>
+          <a:xfrm>
+            <a:off x="4251960" y="4526280"/>
+            <a:ext cx="3566160" cy="640080"/>
+          </a:xfrm>
+          <a:prstGeom prst="roundRect">
+            <a:avLst>
+              <a:gd name="adj" fmla="val 11429"/>
+            </a:avLst>
+          </a:prstGeom>
+          <a:solidFill>
+            <a:srgbClr val="F2F5FC"/>
+          </a:solidFill>
+          <a:ln w="12700">
+            <a:solidFill>
+              <a:srgbClr val="F2F5FC"/>
+            </a:solidFill>
+            <a:prstDash val="solid"/>
+          </a:ln>
+        </p:spPr>
+      </p:sp>
+      <p:sp>
+        <p:nvSpPr>
+          <p:cNvPr id="18" name="Text 16"/>
+          <p:cNvSpPr/>
+          <p:nvPr/>
+        </p:nvSpPr>
+        <p:spPr>
+          <a:xfrm>
+            <a:off x="4297680" y="4526280"/>
+            <a:ext cx="3474720" cy="640080"/>
+          </a:xfrm>
+          <a:prstGeom prst="rect">
+            <a:avLst/>
+          </a:prstGeom>
+          <a:noFill/>
+          <a:ln/>
+        </p:spPr>
+        <p:txBody>
+          <a:bodyPr wrap="square" rtlCol="0" anchor="ctr"/>
+          <a:lstStyle/>
+          <a:p>
+            <a:pPr algn="ctr" indent="0" marL="0">
+              <a:buNone/>
+            </a:pPr>
+            <a:r>
+              <a:rPr lang="en-US" sz="1250" b="1" dirty="0">
+                <a:solidFill>
+                  <a:srgbClr val="1E2761"/>
+                </a:solidFill>
+                <a:latin typeface="Calibri" pitchFamily="34" charset="0"/>
+                <a:ea typeface="Calibri" pitchFamily="34" charset="-122"/>
+                <a:cs typeface="Calibri" pitchFamily="34" charset="-120"/>
+              </a:rPr>
+              <a:t>+ recall &amp; return legs (camt.056/pacs.004)</a:t>
+            </a:r>
+            <a:endParaRPr lang="en-US" sz="1250" dirty="0"/>
+          </a:p>
+        </p:txBody>
+      </p:sp>
+      <p:sp>
+        <p:nvSpPr>
+          <p:cNvPr id="19" name="Shape 17"/>
+          <p:cNvSpPr/>
+          <p:nvPr/>
+        </p:nvSpPr>
+        <p:spPr>
+          <a:xfrm>
+            <a:off x="7955280" y="4526280"/>
+            <a:ext cx="3685032" cy="640080"/>
+          </a:xfrm>
+          <a:prstGeom prst="roundRect">
+            <a:avLst>
+              <a:gd name="adj" fmla="val 11429"/>
+            </a:avLst>
+          </a:prstGeom>
+          <a:solidFill>
+            <a:srgbClr val="F2F5FC"/>
+          </a:solidFill>
+          <a:ln w="12700">
+            <a:solidFill>
+              <a:srgbClr val="F2F5FC"/>
+            </a:solidFill>
+            <a:prstDash val="solid"/>
+          </a:ln>
+        </p:spPr>
+      </p:sp>
+      <p:sp>
+        <p:nvSpPr>
+          <p:cNvPr id="20" name="Text 18"/>
+          <p:cNvSpPr/>
+          <p:nvPr/>
+        </p:nvSpPr>
+        <p:spPr>
+          <a:xfrm>
+            <a:off x="8001000" y="4526280"/>
+            <a:ext cx="3593592" cy="640080"/>
+          </a:xfrm>
+          <a:prstGeom prst="rect">
+            <a:avLst/>
+          </a:prstGeom>
+          <a:noFill/>
+          <a:ln/>
+        </p:spPr>
+        <p:txBody>
+          <a:bodyPr wrap="square" rtlCol="0" anchor="ctr"/>
+          <a:lstStyle/>
+          <a:p>
+            <a:pPr algn="ctr" indent="0" marL="0">
+              <a:buNone/>
+            </a:pPr>
+            <a:r>
+              <a:rPr lang="en-US" sz="1250" b="1" dirty="0">
+                <a:solidFill>
+                  <a:srgbClr val="1E2761"/>
+                </a:solidFill>
+                <a:latin typeface="Calibri" pitchFamily="34" charset="0"/>
+                <a:ea typeface="Calibri" pitchFamily="34" charset="-122"/>
+                <a:cs typeface="Calibri" pitchFamily="34" charset="-120"/>
+              </a:rPr>
+              <a:t>+ charges head · gpi tracker statuses</a:t>
+            </a:r>
+            <a:endParaRPr lang="en-US" sz="1250" dirty="0"/>
+          </a:p>
+        </p:txBody>
+      </p:sp>
+      <p:sp>
+        <p:nvSpPr>
+          <p:cNvPr id="21" name="Text 19"/>
+          <p:cNvSpPr/>
+          <p:nvPr/>
+        </p:nvSpPr>
+        <p:spPr>
+          <a:xfrm>
+            <a:off x="548640" y="5440680"/>
+            <a:ext cx="11064240" cy="685800"/>
+          </a:xfrm>
+          <a:prstGeom prst="rect">
+            <a:avLst/>
+          </a:prstGeom>
+          <a:noFill/>
+          <a:ln/>
+        </p:spPr>
+        <p:txBody>
+          <a:bodyPr wrap="square" rtlCol="0" anchor="ctr"/>
+          <a:lstStyle/>
+          <a:p>
+            <a:pPr indent="0" marL="0">
+              <a:buNone/>
+            </a:pPr>
+            <a:r>
+              <a:rPr lang="en-US" sz="1250" i="1" dirty="0">
+                <a:solidFill>
+                  <a:srgbClr val="5A6172"/>
+                </a:solidFill>
+                <a:latin typeface="Calibri" pitchFamily="34" charset="0"/>
+                <a:ea typeface="Calibri" pitchFamily="34" charset="-122"/>
+                <a:cs typeface="Calibri" pitchFamily="34" charset="-120"/>
+              </a:rPr>
+              <a:t>Maturity: a working prototype on synthetic data. Cold-start caveat: brand-new accounts degrade accuracy (identity features matter) — a known focus for the real-data phase. Next: real transaction data, scale, AML / network-graph.</a:t>
+            </a:r>
+            <a:endParaRPr lang="en-US" sz="1250" dirty="0"/>
+          </a:p>
+        </p:txBody>
+      </p:sp>
+    </p:spTree>
+  </p:cSld>
+  <p:clrMapOvr>
+    <a:masterClrMapping/>
+  </p:clrMapOvr>
+</p:sld>
+</file>
+
+<file path=ppt/slides/slide12.xml><?xml version="1.0" encoding="utf-8"?>
+<p:sld xmlns:a="http://schemas.openxmlformats.org/drawingml/2006/main" xmlns:r="http://schemas.openxmlformats.org/officeDocument/2006/relationships" xmlns:p="http://schemas.openxmlformats.org/presentationml/2006/main">
+  <p:cSld name="Slide 12">
+    <p:bg>
+      <p:bgPr>
+        <a:solidFill>
+          <a:srgbClr val="FFFFFF"/>
+        </a:solidFill>
+      </p:bgPr>
+    </p:bg>
+    <p:spTree>
+      <p:nvGrpSpPr>
+        <p:cNvPr id="1" name=""/>
+        <p:cNvGrpSpPr/>
+        <p:nvPr/>
+      </p:nvGrpSpPr>
+      <p:grpSpPr>
+        <a:xfrm>
+          <a:off x="0" y="0"/>
+          <a:ext cx="0" cy="0"/>
+          <a:chOff x="0" y="0"/>
+          <a:chExt cx="0" cy="0"/>
+        </a:xfrm>
+      </p:grpSpPr>
+      <p:sp>
+        <p:nvSpPr>
+          <p:cNvPr id="2" name="Text 0"/>
+          <p:cNvSpPr/>
+          <p:nvPr/>
+        </p:nvSpPr>
+        <p:spPr>
+          <a:xfrm>
+            <a:off x="548640" y="365760"/>
+            <a:ext cx="11064240" cy="594360"/>
+          </a:xfrm>
+          <a:prstGeom prst="rect">
+            <a:avLst/>
+          </a:prstGeom>
+          <a:noFill/>
+          <a:ln/>
+        </p:spPr>
+        <p:txBody>
+          <a:bodyPr wrap="square" rtlCol="0" anchor="ctr"/>
+          <a:lstStyle/>
+          <a:p>
+            <a:pPr indent="0" marL="0">
+              <a:buNone/>
+            </a:pPr>
+            <a:r>
+              <a:rPr lang="en-US" sz="3000" b="1" dirty="0">
+                <a:solidFill>
+                  <a:srgbClr val="1E2761"/>
+                </a:solidFill>
+                <a:latin typeface="Cambria" pitchFamily="34" charset="0"/>
+                <a:ea typeface="Cambria" pitchFamily="34" charset="-122"/>
+                <a:cs typeface="Cambria" pitchFamily="34" charset="-120"/>
+              </a:rPr>
               <a:t>Every prediction, measured</a:t>
             </a:r>
             <a:endParaRPr lang="en-US" sz="3000" dirty="0"/>
@@ -2719,7 +5271,7 @@
       </p:sp>
       <p:graphicFrame>
         <p:nvGraphicFramePr>
-          <p:cNvPr id="11" name="Table 0"/>
+          <p:cNvPr id="13" name="Table 0"/>
           <p:cNvGraphicFramePr>
             <a:graphicFrameLocks noGrp="1"/>
           </p:cNvGraphicFramePr>
@@ -7000,9 +9552,9 @@
 </p:sld>
 </file>
 
-<file path=ppt/slides/slide11.xml><?xml version="1.0" encoding="utf-8"?>
+<file path=ppt/slides/slide13.xml><?xml version="1.0" encoding="utf-8"?>
 <p:sld xmlns:a="http://schemas.openxmlformats.org/drawingml/2006/main" xmlns:r="http://schemas.openxmlformats.org/officeDocument/2006/relationships" xmlns:p="http://schemas.openxmlformats.org/presentationml/2006/main">
-  <p:cSld name="Slide 11">
+  <p:cSld name="Slide 13">
     <p:bg>
       <p:bgPr>
         <a:solidFill>
@@ -7104,7 +9656,7 @@
       </p:sp>
       <p:graphicFrame>
         <p:nvGraphicFramePr>
-          <p:cNvPr id="12" name="Table 0"/>
+          <p:cNvPr id="14" name="Table 0"/>
           <p:cNvGraphicFramePr>
             <a:graphicFrameLocks noGrp="1"/>
           </p:cNvGraphicFramePr>
@@ -10380,9 +12932,9 @@
 </p:sld>
 </file>
 
-<file path=ppt/slides/slide12.xml><?xml version="1.0" encoding="utf-8"?>
+<file path=ppt/slides/slide14.xml><?xml version="1.0" encoding="utf-8"?>
 <p:sld xmlns:a="http://schemas.openxmlformats.org/drawingml/2006/main" xmlns:r="http://schemas.openxmlformats.org/officeDocument/2006/relationships" xmlns:p="http://schemas.openxmlformats.org/presentationml/2006/main">
-  <p:cSld name="Slide 12">
+  <p:cSld name="Slide 14">
     <p:bg>
       <p:bgPr>
         <a:solidFill>
@@ -10802,9 +13354,9 @@
 </p:sld>
 </file>
 
-<file path=ppt/slides/slide13.xml><?xml version="1.0" encoding="utf-8"?>
+<file path=ppt/slides/slide15.xml><?xml version="1.0" encoding="utf-8"?>
 <p:sld xmlns:a="http://schemas.openxmlformats.org/drawingml/2006/main" xmlns:r="http://schemas.openxmlformats.org/officeDocument/2006/relationships" xmlns:p="http://schemas.openxmlformats.org/presentationml/2006/main">
-  <p:cSld name="Slide 13">
+  <p:cSld name="Slide 15">
     <p:bg>
       <p:bgPr>
         <a:solidFill>
@@ -10906,7 +13458,7 @@
       </p:sp>
       <p:graphicFrame>
         <p:nvGraphicFramePr>
-          <p:cNvPr id="14" name="Table 0"/>
+          <p:cNvPr id="16" name="Table 0"/>
           <p:cNvGraphicFramePr>
             <a:graphicFrameLocks noGrp="1"/>
           </p:cNvGraphicFramePr>
@@ -12173,9 +14725,9 @@
 </p:sld>
 </file>
 
-<file path=ppt/slides/slide14.xml><?xml version="1.0" encoding="utf-8"?>
+<file path=ppt/slides/slide16.xml><?xml version="1.0" encoding="utf-8"?>
 <p:sld xmlns:a="http://schemas.openxmlformats.org/drawingml/2006/main" xmlns:r="http://schemas.openxmlformats.org/officeDocument/2006/relationships" xmlns:p="http://schemas.openxmlformats.org/presentationml/2006/main">
-  <p:cSld name="Slide 14">
+  <p:cSld name="Slide 16">
     <p:bg>
       <p:bgPr>
         <a:solidFill>
@@ -12737,9 +15289,9 @@
 </p:sld>
 </file>
 
-<file path=ppt/slides/slide15.xml><?xml version="1.0" encoding="utf-8"?>
+<file path=ppt/slides/slide17.xml><?xml version="1.0" encoding="utf-8"?>
 <p:sld xmlns:a="http://schemas.openxmlformats.org/drawingml/2006/main" xmlns:r="http://schemas.openxmlformats.org/officeDocument/2006/relationships" xmlns:p="http://schemas.openxmlformats.org/presentationml/2006/main">
-  <p:cSld name="Slide 15">
+  <p:cSld name="Slide 17">
     <p:bg>
       <p:bgPr>
         <a:solidFill>
@@ -12841,7 +15393,7 @@
       </p:sp>
       <p:graphicFrame>
         <p:nvGraphicFramePr>
-          <p:cNvPr id="16" name="Table 0"/>
+          <p:cNvPr id="18" name="Table 0"/>
           <p:cNvGraphicFramePr>
             <a:graphicFrameLocks noGrp="1"/>
           </p:cNvGraphicFramePr>
@@ -19103,7 +21655,7 @@
                 <a:ea typeface="Cambria" pitchFamily="34" charset="-122"/>
                 <a:cs typeface="Cambria" pitchFamily="34" charset="-120"/>
               </a:rPr>
-              <a:t>Status today — trained on CPU, claims verified on GPU</a:t>
+              <a:t>Under the hood — pretrained adapters on a frozen backbone</a:t>
             </a:r>
             <a:endParaRPr lang="en-US" sz="3000" dirty="0"/>
           </a:p>
@@ -19142,49 +21694,46 @@
                 <a:ea typeface="Calibri" pitchFamily="34" charset="-122"/>
                 <a:cs typeface="Calibri" pitchFamily="34" charset="-120"/>
               </a:rPr>
-              <a:t>End-to-end on synthetic data; full-scale claim runs reproduced on an H200.</a:t>
+              <a:t>Redrawn from Raman et al. (arXiv:2410.07851, §4 / Eq. 5). Grey never trains; blue is the ~7.64M-parameter adapter trio.</a:t>
             </a:r>
             <a:endParaRPr lang="en-US" sz="1400" dirty="0"/>
           </a:p>
         </p:txBody>
       </p:sp>
-      <p:sp>
-        <p:nvSpPr>
-          <p:cNvPr id="4" name="Shape 2"/>
-          <p:cNvSpPr/>
-          <p:nvPr/>
-        </p:nvSpPr>
-        <p:spPr>
-          <a:xfrm>
-            <a:off x="548640" y="1600200"/>
-            <a:ext cx="3520440" cy="1508760"/>
-          </a:xfrm>
-          <a:prstGeom prst="roundRect">
-            <a:avLst>
-              <a:gd name="adj" fmla="val 4848"/>
-            </a:avLst>
-          </a:prstGeom>
-          <a:solidFill>
-            <a:srgbClr val="F2F5FC"/>
-          </a:solidFill>
-          <a:ln w="12700">
-            <a:solidFill>
-              <a:srgbClr val="CADCFC"/>
-            </a:solidFill>
-            <a:prstDash val="solid"/>
-          </a:ln>
-        </p:spPr>
-      </p:sp>
-      <p:sp>
-        <p:nvSpPr>
-          <p:cNvPr id="5" name="Text 3"/>
-          <p:cNvSpPr/>
-          <p:nvPr/>
-        </p:nvSpPr>
-        <p:spPr>
-          <a:xfrm>
-            <a:off x="777240" y="1783080"/>
-            <a:ext cx="3108960" cy="731520"/>
+      <p:pic>
+        <p:nvPicPr>
+          <p:cNvPr id="4" name="Image 0" descr="C:/Users/BHATTACHARYAMrSUBRAT/AVD5/txn-repr-poc/docs/architecture_adapter.png">    </p:cNvPr>
+          <p:cNvPicPr>
+            <a:picLocks noChangeAspect="1"/>
+          </p:cNvPicPr>
+          <p:nvPr/>
+        </p:nvPicPr>
+        <p:blipFill>
+          <a:blip r:embed="rId1"/>
+          <a:stretch>
+            <a:fillRect/>
+          </a:stretch>
+        </p:blipFill>
+        <p:spPr>
+          <a:xfrm>
+            <a:off x="1737360" y="1554480"/>
+            <a:ext cx="6583680" cy="4572000"/>
+          </a:xfrm>
+          <a:prstGeom prst="rect">
+            <a:avLst/>
+          </a:prstGeom>
+        </p:spPr>
+      </p:pic>
+      <p:sp>
+        <p:nvSpPr>
+          <p:cNvPr id="5" name="Text 2"/>
+          <p:cNvSpPr/>
+          <p:nvPr/>
+        </p:nvSpPr>
+        <p:spPr>
+          <a:xfrm>
+            <a:off x="8503920" y="2377440"/>
+            <a:ext cx="3200400" cy="2926080"/>
           </a:xfrm>
           <a:prstGeom prst="rect">
             <a:avLst/>
@@ -19197,399 +21746,6 @@
           <a:lstStyle/>
           <a:p>
             <a:pPr indent="0" marL="0">
-              <a:buNone/>
-            </a:pPr>
-            <a:r>
-              <a:rPr lang="en-US" sz="3200" b="1" dirty="0">
-                <a:solidFill>
-                  <a:srgbClr val="1E2761"/>
-                </a:solidFill>
-                <a:latin typeface="Cambria" pitchFamily="34" charset="0"/>
-                <a:ea typeface="Cambria" pitchFamily="34" charset="-122"/>
-                <a:cs typeface="Cambria" pitchFamily="34" charset="-120"/>
-              </a:rPr>
-              <a:t>20,000</a:t>
-            </a:r>
-            <a:endParaRPr lang="en-US" sz="3200" dirty="0"/>
-          </a:p>
-        </p:txBody>
-      </p:sp>
-      <p:sp>
-        <p:nvSpPr>
-          <p:cNvPr id="6" name="Text 4"/>
-          <p:cNvSpPr/>
-          <p:nvPr/>
-        </p:nvSpPr>
-        <p:spPr>
-          <a:xfrm>
-            <a:off x="777240" y="2542032"/>
-            <a:ext cx="3108960" cy="457200"/>
-          </a:xfrm>
-          <a:prstGeom prst="rect">
-            <a:avLst/>
-          </a:prstGeom>
-          <a:noFill/>
-          <a:ln/>
-        </p:spPr>
-        <p:txBody>
-          <a:bodyPr wrap="square" rtlCol="0" anchor="ctr"/>
-          <a:lstStyle/>
-          <a:p>
-            <a:pPr indent="0" marL="0">
-              <a:buNone/>
-            </a:pPr>
-            <a:r>
-              <a:rPr lang="en-US" sz="1300" dirty="0">
-                <a:solidFill>
-                  <a:srgbClr val="1A1A2E"/>
-                </a:solidFill>
-                <a:latin typeface="Calibri" pitchFamily="34" charset="0"/>
-                <a:ea typeface="Calibri" pitchFamily="34" charset="-122"/>
-                <a:cs typeface="Calibri" pitchFamily="34" charset="-120"/>
-              </a:rPr>
-              <a:t>payments trained</a:t>
-            </a:r>
-            <a:endParaRPr lang="en-US" sz="1300" dirty="0"/>
-          </a:p>
-        </p:txBody>
-      </p:sp>
-      <p:sp>
-        <p:nvSpPr>
-          <p:cNvPr id="7" name="Shape 5"/>
-          <p:cNvSpPr/>
-          <p:nvPr/>
-        </p:nvSpPr>
-        <p:spPr>
-          <a:xfrm>
-            <a:off x="4251960" y="1600200"/>
-            <a:ext cx="3520440" cy="1508760"/>
-          </a:xfrm>
-          <a:prstGeom prst="roundRect">
-            <a:avLst>
-              <a:gd name="adj" fmla="val 4848"/>
-            </a:avLst>
-          </a:prstGeom>
-          <a:solidFill>
-            <a:srgbClr val="F2F5FC"/>
-          </a:solidFill>
-          <a:ln w="12700">
-            <a:solidFill>
-              <a:srgbClr val="CADCFC"/>
-            </a:solidFill>
-            <a:prstDash val="solid"/>
-          </a:ln>
-        </p:spPr>
-      </p:sp>
-      <p:sp>
-        <p:nvSpPr>
-          <p:cNvPr id="8" name="Text 6"/>
-          <p:cNvSpPr/>
-          <p:nvPr/>
-        </p:nvSpPr>
-        <p:spPr>
-          <a:xfrm>
-            <a:off x="4480560" y="1783080"/>
-            <a:ext cx="3108960" cy="731520"/>
-          </a:xfrm>
-          <a:prstGeom prst="rect">
-            <a:avLst/>
-          </a:prstGeom>
-          <a:noFill/>
-          <a:ln/>
-        </p:spPr>
-        <p:txBody>
-          <a:bodyPr wrap="square" rtlCol="0" anchor="ctr"/>
-          <a:lstStyle/>
-          <a:p>
-            <a:pPr indent="0" marL="0">
-              <a:buNone/>
-            </a:pPr>
-            <a:r>
-              <a:rPr lang="en-US" sz="3200" b="1" dirty="0">
-                <a:solidFill>
-                  <a:srgbClr val="1E2761"/>
-                </a:solidFill>
-                <a:latin typeface="Cambria" pitchFamily="34" charset="0"/>
-                <a:ea typeface="Cambria" pitchFamily="34" charset="-122"/>
-                <a:cs typeface="Cambria" pitchFamily="34" charset="-120"/>
-              </a:rPr>
-              <a:t>100</a:t>
-            </a:r>
-            <a:endParaRPr lang="en-US" sz="3200" dirty="0"/>
-          </a:p>
-        </p:txBody>
-      </p:sp>
-      <p:sp>
-        <p:nvSpPr>
-          <p:cNvPr id="9" name="Text 7"/>
-          <p:cNvSpPr/>
-          <p:nvPr/>
-        </p:nvSpPr>
-        <p:spPr>
-          <a:xfrm>
-            <a:off x="4480560" y="2542032"/>
-            <a:ext cx="3108960" cy="457200"/>
-          </a:xfrm>
-          <a:prstGeom prst="rect">
-            <a:avLst/>
-          </a:prstGeom>
-          <a:noFill/>
-          <a:ln/>
-        </p:spPr>
-        <p:txBody>
-          <a:bodyPr wrap="square" rtlCol="0" anchor="ctr"/>
-          <a:lstStyle/>
-          <a:p>
-            <a:pPr indent="0" marL="0">
-              <a:buNone/>
-            </a:pPr>
-            <a:r>
-              <a:rPr lang="en-US" sz="1300" dirty="0">
-                <a:solidFill>
-                  <a:srgbClr val="1A1A2E"/>
-                </a:solidFill>
-                <a:latin typeface="Calibri" pitchFamily="34" charset="0"/>
-                <a:ea typeface="Calibri" pitchFamily="34" charset="-122"/>
-                <a:cs typeface="Calibri" pitchFamily="34" charset="-120"/>
-              </a:rPr>
-              <a:t>held-out test payments scored</a:t>
-            </a:r>
-            <a:endParaRPr lang="en-US" sz="1300" dirty="0"/>
-          </a:p>
-        </p:txBody>
-      </p:sp>
-      <p:sp>
-        <p:nvSpPr>
-          <p:cNvPr id="10" name="Shape 8"/>
-          <p:cNvSpPr/>
-          <p:nvPr/>
-        </p:nvSpPr>
-        <p:spPr>
-          <a:xfrm>
-            <a:off x="7955280" y="1600200"/>
-            <a:ext cx="3520440" cy="1508760"/>
-          </a:xfrm>
-          <a:prstGeom prst="roundRect">
-            <a:avLst>
-              <a:gd name="adj" fmla="val 4848"/>
-            </a:avLst>
-          </a:prstGeom>
-          <a:solidFill>
-            <a:srgbClr val="F2F5FC"/>
-          </a:solidFill>
-          <a:ln w="12700">
-            <a:solidFill>
-              <a:srgbClr val="CADCFC"/>
-            </a:solidFill>
-            <a:prstDash val="solid"/>
-          </a:ln>
-        </p:spPr>
-      </p:sp>
-      <p:sp>
-        <p:nvSpPr>
-          <p:cNvPr id="11" name="Text 9"/>
-          <p:cNvSpPr/>
-          <p:nvPr/>
-        </p:nvSpPr>
-        <p:spPr>
-          <a:xfrm>
-            <a:off x="8183880" y="1783080"/>
-            <a:ext cx="3108960" cy="731520"/>
-          </a:xfrm>
-          <a:prstGeom prst="rect">
-            <a:avLst/>
-          </a:prstGeom>
-          <a:noFill/>
-          <a:ln/>
-        </p:spPr>
-        <p:txBody>
-          <a:bodyPr wrap="square" rtlCol="0" anchor="ctr"/>
-          <a:lstStyle/>
-          <a:p>
-            <a:pPr indent="0" marL="0">
-              <a:buNone/>
-            </a:pPr>
-            <a:r>
-              <a:rPr lang="en-US" sz="3200" b="1" dirty="0">
-                <a:solidFill>
-                  <a:srgbClr val="1E2761"/>
-                </a:solidFill>
-                <a:latin typeface="Cambria" pitchFamily="34" charset="0"/>
-                <a:ea typeface="Cambria" pitchFamily="34" charset="-122"/>
-                <a:cs typeface="Cambria" pitchFamily="34" charset="-120"/>
-              </a:rPr>
-              <a:t>CSV → CSV</a:t>
-            </a:r>
-            <a:endParaRPr lang="en-US" sz="3200" dirty="0"/>
-          </a:p>
-        </p:txBody>
-      </p:sp>
-      <p:sp>
-        <p:nvSpPr>
-          <p:cNvPr id="12" name="Text 10"/>
-          <p:cNvSpPr/>
-          <p:nvPr/>
-        </p:nvSpPr>
-        <p:spPr>
-          <a:xfrm>
-            <a:off x="8183880" y="2542032"/>
-            <a:ext cx="3108960" cy="457200"/>
-          </a:xfrm>
-          <a:prstGeom prst="rect">
-            <a:avLst/>
-          </a:prstGeom>
-          <a:noFill/>
-          <a:ln/>
-        </p:spPr>
-        <p:txBody>
-          <a:bodyPr wrap="square" rtlCol="0" anchor="ctr"/>
-          <a:lstStyle/>
-          <a:p>
-            <a:pPr indent="0" marL="0">
-              <a:buNone/>
-            </a:pPr>
-            <a:r>
-              <a:rPr lang="en-US" sz="1300" dirty="0">
-                <a:solidFill>
-                  <a:srgbClr val="1A1A2E"/>
-                </a:solidFill>
-                <a:latin typeface="Calibri" pitchFamily="34" charset="0"/>
-                <a:ea typeface="Calibri" pitchFamily="34" charset="-122"/>
-                <a:cs typeface="Calibri" pitchFamily="34" charset="-120"/>
-              </a:rPr>
-              <a:t>input and output files</a:t>
-            </a:r>
-            <a:endParaRPr lang="en-US" sz="1300" dirty="0"/>
-          </a:p>
-        </p:txBody>
-      </p:sp>
-      <p:sp>
-        <p:nvSpPr>
-          <p:cNvPr id="13" name="Text 11"/>
-          <p:cNvSpPr/>
-          <p:nvPr/>
-        </p:nvSpPr>
-        <p:spPr>
-          <a:xfrm>
-            <a:off x="548640" y="3383280"/>
-            <a:ext cx="11064240" cy="411480"/>
-          </a:xfrm>
-          <a:prstGeom prst="rect">
-            <a:avLst/>
-          </a:prstGeom>
-          <a:noFill/>
-          <a:ln/>
-        </p:spPr>
-        <p:txBody>
-          <a:bodyPr wrap="square" rtlCol="0" anchor="ctr"/>
-          <a:lstStyle/>
-          <a:p>
-            <a:pPr indent="0" marL="0">
-              <a:buNone/>
-            </a:pPr>
-            <a:r>
-              <a:rPr lang="en-US" sz="1300" b="1" dirty="0">
-                <a:solidFill>
-                  <a:srgbClr val="1E2761"/>
-                </a:solidFill>
-                <a:latin typeface="Calibri" pitchFamily="34" charset="0"/>
-                <a:ea typeface="Calibri" pitchFamily="34" charset="-122"/>
-                <a:cs typeface="Calibri" pitchFamily="34" charset="-120"/>
-              </a:rPr>
-              <a:t>Held-out n=4,000: rail 0.56 probe vs 0.65 tree (4-class, harder without UPI)  ·  ETA 195 min vs 392 naive  ·  status 0.28 (weak — tree territory, reported openly)</a:t>
-            </a:r>
-            <a:endParaRPr lang="en-US" sz="1300" dirty="0"/>
-          </a:p>
-        </p:txBody>
-      </p:sp>
-      <p:sp>
-        <p:nvSpPr>
-          <p:cNvPr id="14" name="Text 12"/>
-          <p:cNvSpPr/>
-          <p:nvPr/>
-        </p:nvSpPr>
-        <p:spPr>
-          <a:xfrm>
-            <a:off x="548640" y="3886200"/>
-            <a:ext cx="11064240" cy="411480"/>
-          </a:xfrm>
-          <a:prstGeom prst="rect">
-            <a:avLst/>
-          </a:prstGeom>
-          <a:noFill/>
-          <a:ln/>
-        </p:spPr>
-        <p:txBody>
-          <a:bodyPr wrap="square" rtlCol="0" anchor="ctr"/>
-          <a:lstStyle/>
-          <a:p>
-            <a:pPr indent="0" marL="0">
-              <a:buNone/>
-            </a:pPr>
-            <a:r>
-              <a:rPr lang="en-US" sz="1300" b="1" dirty="0">
-                <a:solidFill>
-                  <a:srgbClr val="2E7D32"/>
-                </a:solidFill>
-                <a:latin typeface="Calibri" pitchFamily="34" charset="0"/>
-                <a:ea typeface="Calibri" pitchFamily="34" charset="-122"/>
-                <a:cs typeface="Calibri" pitchFamily="34" charset="-120"/>
-              </a:rPr>
-              <a:t>At initiation (pain.001, before clearing): ETA 172 vs 234 naive  ·  charges MAE 117 vs 203  ·  'will it credit' 0.86 → 0.94 as messages arrive.</a:t>
-            </a:r>
-            <a:endParaRPr lang="en-US" sz="1300" dirty="0"/>
-          </a:p>
-        </p:txBody>
-      </p:sp>
-      <p:sp>
-        <p:nvSpPr>
-          <p:cNvPr id="15" name="Shape 13"/>
-          <p:cNvSpPr/>
-          <p:nvPr/>
-        </p:nvSpPr>
-        <p:spPr>
-          <a:xfrm>
-            <a:off x="548640" y="4526280"/>
-            <a:ext cx="3566160" cy="640080"/>
-          </a:xfrm>
-          <a:prstGeom prst="roundRect">
-            <a:avLst>
-              <a:gd name="adj" fmla="val 11429"/>
-            </a:avLst>
-          </a:prstGeom>
-          <a:solidFill>
-            <a:srgbClr val="F2F5FC"/>
-          </a:solidFill>
-          <a:ln w="12700">
-            <a:solidFill>
-              <a:srgbClr val="F2F5FC"/>
-            </a:solidFill>
-            <a:prstDash val="solid"/>
-          </a:ln>
-        </p:spPr>
-      </p:sp>
-      <p:sp>
-        <p:nvSpPr>
-          <p:cNvPr id="16" name="Text 14"/>
-          <p:cNvSpPr/>
-          <p:nvPr/>
-        </p:nvSpPr>
-        <p:spPr>
-          <a:xfrm>
-            <a:off x="594360" y="4526280"/>
-            <a:ext cx="3474720" cy="640080"/>
-          </a:xfrm>
-          <a:prstGeom prst="rect">
-            <a:avLst/>
-          </a:prstGeom>
-          <a:noFill/>
-          <a:ln/>
-        </p:spPr>
-        <p:txBody>
-          <a:bodyPr wrap="square" rtlCol="0" anchor="ctr"/>
-          <a:lstStyle/>
-          <a:p>
-            <a:pPr algn="ctr" indent="0" marL="0">
               <a:buNone/>
             </a:pPr>
             <a:r>
@@ -19601,178 +21757,21 @@
                 <a:ea typeface="Calibri" pitchFamily="34" charset="-122"/>
                 <a:cs typeface="Calibri" pitchFamily="34" charset="-120"/>
               </a:rPr>
-              <a:t>+ full ISO 20022 lifecycle modeled</a:t>
+              <a:t>The verdict (C5, measured): </a:t>
             </a:r>
-            <a:endParaRPr lang="en-US" sz="1250" dirty="0"/>
-          </a:p>
-        </p:txBody>
-      </p:sp>
-      <p:sp>
-        <p:nvSpPr>
-          <p:cNvPr id="17" name="Shape 15"/>
-          <p:cNvSpPr/>
-          <p:nvPr/>
-        </p:nvSpPr>
-        <p:spPr>
-          <a:xfrm>
-            <a:off x="4251960" y="4526280"/>
-            <a:ext cx="3566160" cy="640080"/>
-          </a:xfrm>
-          <a:prstGeom prst="roundRect">
-            <a:avLst>
-              <a:gd name="adj" fmla="val 11429"/>
-            </a:avLst>
-          </a:prstGeom>
-          <a:solidFill>
-            <a:srgbClr val="F2F5FC"/>
-          </a:solidFill>
-          <a:ln w="12700">
-            <a:solidFill>
-              <a:srgbClr val="F2F5FC"/>
-            </a:solidFill>
-            <a:prstDash val="solid"/>
-          </a:ln>
-        </p:spPr>
-      </p:sp>
-      <p:sp>
-        <p:nvSpPr>
-          <p:cNvPr id="18" name="Text 16"/>
-          <p:cNvSpPr/>
-          <p:nvPr/>
-        </p:nvSpPr>
-        <p:spPr>
-          <a:xfrm>
-            <a:off x="4297680" y="4526280"/>
-            <a:ext cx="3474720" cy="640080"/>
-          </a:xfrm>
-          <a:prstGeom prst="rect">
-            <a:avLst/>
-          </a:prstGeom>
-          <a:noFill/>
-          <a:ln/>
-        </p:spPr>
-        <p:txBody>
-          <a:bodyPr wrap="square" rtlCol="0" anchor="ctr"/>
-          <a:lstStyle/>
-          <a:p>
-            <a:pPr algn="ctr" indent="0" marL="0">
+            <a:pPr indent="0" marL="0">
               <a:buNone/>
             </a:pPr>
             <a:r>
-              <a:rPr lang="en-US" sz="1250" b="1" dirty="0">
+              <a:rPr lang="en-US" sz="1250" dirty="0">
                 <a:solidFill>
-                  <a:srgbClr val="1E2761"/>
+                  <a:srgbClr val="1A1A2E"/>
                 </a:solidFill>
                 <a:latin typeface="Calibri" pitchFamily="34" charset="0"/>
                 <a:ea typeface="Calibri" pitchFamily="34" charset="-122"/>
                 <a:cs typeface="Calibri" pitchFamily="34" charset="-120"/>
               </a:rPr>
-              <a:t>+ recall &amp; return legs (camt.056/pacs.004)</a:t>
-            </a:r>
-            <a:endParaRPr lang="en-US" sz="1250" dirty="0"/>
-          </a:p>
-        </p:txBody>
-      </p:sp>
-      <p:sp>
-        <p:nvSpPr>
-          <p:cNvPr id="19" name="Shape 17"/>
-          <p:cNvSpPr/>
-          <p:nvPr/>
-        </p:nvSpPr>
-        <p:spPr>
-          <a:xfrm>
-            <a:off x="7955280" y="4526280"/>
-            <a:ext cx="3685032" cy="640080"/>
-          </a:xfrm>
-          <a:prstGeom prst="roundRect">
-            <a:avLst>
-              <a:gd name="adj" fmla="val 11429"/>
-            </a:avLst>
-          </a:prstGeom>
-          <a:solidFill>
-            <a:srgbClr val="F2F5FC"/>
-          </a:solidFill>
-          <a:ln w="12700">
-            <a:solidFill>
-              <a:srgbClr val="F2F5FC"/>
-            </a:solidFill>
-            <a:prstDash val="solid"/>
-          </a:ln>
-        </p:spPr>
-      </p:sp>
-      <p:sp>
-        <p:nvSpPr>
-          <p:cNvPr id="20" name="Text 18"/>
-          <p:cNvSpPr/>
-          <p:nvPr/>
-        </p:nvSpPr>
-        <p:spPr>
-          <a:xfrm>
-            <a:off x="8001000" y="4526280"/>
-            <a:ext cx="3593592" cy="640080"/>
-          </a:xfrm>
-          <a:prstGeom prst="rect">
-            <a:avLst/>
-          </a:prstGeom>
-          <a:noFill/>
-          <a:ln/>
-        </p:spPr>
-        <p:txBody>
-          <a:bodyPr wrap="square" rtlCol="0" anchor="ctr"/>
-          <a:lstStyle/>
-          <a:p>
-            <a:pPr algn="ctr" indent="0" marL="0">
-              <a:buNone/>
-            </a:pPr>
-            <a:r>
-              <a:rPr lang="en-US" sz="1250" b="1" dirty="0">
-                <a:solidFill>
-                  <a:srgbClr val="1E2761"/>
-                </a:solidFill>
-                <a:latin typeface="Calibri" pitchFamily="34" charset="0"/>
-                <a:ea typeface="Calibri" pitchFamily="34" charset="-122"/>
-                <a:cs typeface="Calibri" pitchFamily="34" charset="-120"/>
-              </a:rPr>
-              <a:t>+ charges head · gpi tracker statuses</a:t>
-            </a:r>
-            <a:endParaRPr lang="en-US" sz="1250" dirty="0"/>
-          </a:p>
-        </p:txBody>
-      </p:sp>
-      <p:sp>
-        <p:nvSpPr>
-          <p:cNvPr id="21" name="Text 19"/>
-          <p:cNvSpPr/>
-          <p:nvPr/>
-        </p:nvSpPr>
-        <p:spPr>
-          <a:xfrm>
-            <a:off x="548640" y="5440680"/>
-            <a:ext cx="11064240" cy="685800"/>
-          </a:xfrm>
-          <a:prstGeom prst="rect">
-            <a:avLst/>
-          </a:prstGeom>
-          <a:noFill/>
-          <a:ln/>
-        </p:spPr>
-        <p:txBody>
-          <a:bodyPr wrap="square" rtlCol="0" anchor="ctr"/>
-          <a:lstStyle/>
-          <a:p>
-            <a:pPr indent="0" marL="0">
-              <a:buNone/>
-            </a:pPr>
-            <a:r>
-              <a:rPr lang="en-US" sz="1250" i="1" dirty="0">
-                <a:solidFill>
-                  <a:srgbClr val="5A6172"/>
-                </a:solidFill>
-                <a:latin typeface="Calibri" pitchFamily="34" charset="0"/>
-                <a:ea typeface="Calibri" pitchFamily="34" charset="-122"/>
-                <a:cs typeface="Calibri" pitchFamily="34" charset="-120"/>
-              </a:rPr>
-              <a:t>Maturity: a working prototype on synthetic data. Cold-start caveat: brand-new accounts degrade accuracy (identity features matter) — a known focus for the real-data phase. Next: real transaction data, scale, AML / network-graph.</a:t>
+              <a:t>this LLM path scores 0.932 vs the linear probe's 0.919 — +1.3pp for a 1.3B-parameter forward pass. PULSE serves the probe; the diagram path exists because we measured it, then retired it.</a:t>
             </a:r>
             <a:endParaRPr lang="en-US" sz="1250" dirty="0"/>
           </a:p>

</xml_diff>

<commit_message>
Paper + deck updated with the C9/C10 verdicts
Table 1 gains the C9/C10 rows; new Sec. 5.4 (what the freeze costs, what
bandwidth buys) reports the matched pair - LoRA doubles the probe to 0.301
(40.7% closure, FAIL), full-token concat reaches 0.261 (+72%, below LoRA) -
and reads them together: two independent interventions confirm C2's routing
verdict. Abstract and conclusion updated; test count refreshed to 209. Deck's
honest-close slide carries the twice-confirmed tree verdict.

Co-Authored-By: Claude Fable 5 <noreply@anthropic.com>
</commit_message>
<xml_diff>
--- a/docs/txn_repr_evidence.pptx
+++ b/docs/txn_repr_evidence.pptx
@@ -13067,7 +13067,7 @@
                 <a:ea typeface="Calibri" pitchFamily="34" charset="-122"/>
                 <a:cs typeface="Calibri" pitchFamily="34" charset="-120"/>
               </a:rPr>
-              <a:t>197 automated tests green · reproducible · full-scale claims measured on an H200 GPU · independently code-reviewed</a:t>
+              <a:t>209 automated tests green · reproducible · full-scale claims measured on an H200 GPU · independently code-reviewed</a:t>
             </a:r>
             <a:endParaRPr lang="en-US" sz="1500" dirty="0"/>
           </a:p>
@@ -13223,7 +13223,7 @@
                 <a:ea typeface="Calibri" pitchFamily="34" charset="-122"/>
                 <a:cs typeface="Calibri" pitchFamily="34" charset="-120"/>
               </a:rPr>
-              <a:t>plain feature-rule scoring on complete records — we report this openly and route caps/floors to guards, not guesses</a:t>
+              <a:t>feature-rule scoring on complete records — confirmed twice: LoRA adapters close 40.7% of the gap (C9), full-token read-outs +72% (C10), neither reaches the tree. We route those tasks to trees &amp; guards, openly</a:t>
             </a:r>
             <a:endParaRPr lang="en-US" sz="1500" dirty="0"/>
           </a:p>

</xml_diff>